<commit_message>
Record accepted B2 benchmark results
</commit_message>
<xml_diff>
--- a/presentation/ADVLSI2_DRC_CNN_Project_Progress.pptx
+++ b/presentation/ADVLSI2_DRC_CNN_Project_Progress.pptx
@@ -2,38 +2,40 @@
 <file path=ppt/presentation.xml><?xml version="1.0" encoding="utf-8"?>
 <p:presentation xmlns:p="http://schemas.openxmlformats.org/presentationml/2006/main" embedTrueTypeFonts="1" saveSubsetFonts="0">
   <p:sldMasterIdLst>
-    <p:sldMasterId xmlns:r="http://schemas.openxmlformats.org/officeDocument/2006/relationships" id="2147483648" r:id="R34965300c2d748d2"/>
+    <p:sldMasterId xmlns:r="http://schemas.openxmlformats.org/officeDocument/2006/relationships" id="2147483648" r:id="R7ee0d6b4494b44d0"/>
   </p:sldMasterIdLst>
   <p:notesMasterIdLst>
-    <p:notesMasterId xmlns:r="http://schemas.openxmlformats.org/officeDocument/2006/relationships" r:id="R029d55129ee543bc"/>
+    <p:notesMasterId xmlns:r="http://schemas.openxmlformats.org/officeDocument/2006/relationships" r:id="R494e88d4da6b4603"/>
   </p:notesMasterIdLst>
   <p:sldIdLst>
-    <p:sldId xmlns:r="http://schemas.openxmlformats.org/officeDocument/2006/relationships" id="256" r:id="R9f05c99a0b89455e"/>
-    <p:sldId xmlns:r="http://schemas.openxmlformats.org/officeDocument/2006/relationships" id="257" r:id="R8736e19dad3e4e1a"/>
-    <p:sldId xmlns:r="http://schemas.openxmlformats.org/officeDocument/2006/relationships" id="258" r:id="R85fe537961a64793"/>
-    <p:sldId xmlns:r="http://schemas.openxmlformats.org/officeDocument/2006/relationships" id="259" r:id="Re9c1326482da4f83"/>
-    <p:sldId xmlns:r="http://schemas.openxmlformats.org/officeDocument/2006/relationships" id="260" r:id="Rb4424a6d9b014dd2"/>
-    <p:sldId xmlns:r="http://schemas.openxmlformats.org/officeDocument/2006/relationships" id="261" r:id="R6123117c91bb49f3"/>
-    <p:sldId xmlns:r="http://schemas.openxmlformats.org/officeDocument/2006/relationships" id="262" r:id="Rf1c090fae1e24c9e"/>
-    <p:sldId xmlns:r="http://schemas.openxmlformats.org/officeDocument/2006/relationships" id="263" r:id="R8d0b0eb217bb4081"/>
-    <p:sldId xmlns:r="http://schemas.openxmlformats.org/officeDocument/2006/relationships" id="264" r:id="R609403551b894615"/>
-    <p:sldId xmlns:r="http://schemas.openxmlformats.org/officeDocument/2006/relationships" id="265" r:id="R2850db0b9fea4fbe"/>
-    <p:sldId xmlns:r="http://schemas.openxmlformats.org/officeDocument/2006/relationships" id="266" r:id="R93359135d16e44b5"/>
-    <p:sldId xmlns:r="http://schemas.openxmlformats.org/officeDocument/2006/relationships" id="267" r:id="R46de41ad47bc4b88"/>
-    <p:sldId xmlns:r="http://schemas.openxmlformats.org/officeDocument/2006/relationships" id="268" r:id="R1871c2b951f54351"/>
-    <p:sldId xmlns:r="http://schemas.openxmlformats.org/officeDocument/2006/relationships" id="269" r:id="R2a728a3a2db74ede"/>
-    <p:sldId xmlns:r="http://schemas.openxmlformats.org/officeDocument/2006/relationships" id="270" r:id="R196b18471eb24af2"/>
-    <p:sldId xmlns:r="http://schemas.openxmlformats.org/officeDocument/2006/relationships" id="271" r:id="R028b57b3442443ac"/>
-    <p:sldId xmlns:r="http://schemas.openxmlformats.org/officeDocument/2006/relationships" id="272" r:id="R900b5d1698df4b3f"/>
-    <p:sldId xmlns:r="http://schemas.openxmlformats.org/officeDocument/2006/relationships" id="273" r:id="Rd281bf7567874ed1"/>
+    <p:sldId xmlns:r="http://schemas.openxmlformats.org/officeDocument/2006/relationships" id="256" r:id="R0087db5348b04744"/>
+    <p:sldId xmlns:r="http://schemas.openxmlformats.org/officeDocument/2006/relationships" id="257" r:id="R84de356a021f4ff3"/>
+    <p:sldId xmlns:r="http://schemas.openxmlformats.org/officeDocument/2006/relationships" id="258" r:id="Rcb834a4c4c814a99"/>
+    <p:sldId xmlns:r="http://schemas.openxmlformats.org/officeDocument/2006/relationships" id="259" r:id="Rb8876e28c8e64d71"/>
+    <p:sldId xmlns:r="http://schemas.openxmlformats.org/officeDocument/2006/relationships" id="260" r:id="Rbeb4d4d95d244f2b"/>
+    <p:sldId xmlns:r="http://schemas.openxmlformats.org/officeDocument/2006/relationships" id="261" r:id="R51dddc6193264b90"/>
+    <p:sldId xmlns:r="http://schemas.openxmlformats.org/officeDocument/2006/relationships" id="262" r:id="R21501847a1cb4fb2"/>
+    <p:sldId xmlns:r="http://schemas.openxmlformats.org/officeDocument/2006/relationships" id="263" r:id="R7bce9ac495aa449c"/>
+    <p:sldId xmlns:r="http://schemas.openxmlformats.org/officeDocument/2006/relationships" id="264" r:id="R5ed4fc618758490b"/>
+    <p:sldId xmlns:r="http://schemas.openxmlformats.org/officeDocument/2006/relationships" id="265" r:id="R753337aef27349a2"/>
+    <p:sldId xmlns:r="http://schemas.openxmlformats.org/officeDocument/2006/relationships" id="266" r:id="Rc38d48f011794a4b"/>
+    <p:sldId xmlns:r="http://schemas.openxmlformats.org/officeDocument/2006/relationships" id="267" r:id="R517da45aa08d4ab7"/>
+    <p:sldId xmlns:r="http://schemas.openxmlformats.org/officeDocument/2006/relationships" id="268" r:id="R256e82180b1c4bcc"/>
+    <p:sldId xmlns:r="http://schemas.openxmlformats.org/officeDocument/2006/relationships" id="269" r:id="R030a85fcdd7a484a"/>
+    <p:sldId xmlns:r="http://schemas.openxmlformats.org/officeDocument/2006/relationships" id="270" r:id="R12ea6d0614df47de"/>
+    <p:sldId xmlns:r="http://schemas.openxmlformats.org/officeDocument/2006/relationships" id="271" r:id="R96a09dee41a342d5"/>
+    <p:sldId xmlns:r="http://schemas.openxmlformats.org/officeDocument/2006/relationships" id="272" r:id="R52ceb03fd61d417f"/>
+    <p:sldId xmlns:r="http://schemas.openxmlformats.org/officeDocument/2006/relationships" id="273" r:id="R1c0b799c12ab4760"/>
+    <p:sldId xmlns:r="http://schemas.openxmlformats.org/officeDocument/2006/relationships" id="274" r:id="R11dca243b4b24269"/>
+    <p:sldId xmlns:r="http://schemas.openxmlformats.org/officeDocument/2006/relationships" id="275" r:id="Rebf4fb5cbfac4fad"/>
   </p:sldIdLst>
   <p:sldSz cx="12192000" cy="6858000"/>
   <p:notesSz cx="6858000" cy="9144000"/>
   <p:embeddedFontLst>
     <p:embeddedFont>
       <p:font typeface="Play"/>
-      <p:regular xmlns:r="http://schemas.openxmlformats.org/officeDocument/2006/relationships" r:id="Re28b6f89b8754f32"/>
-      <p:bold xmlns:r="http://schemas.openxmlformats.org/officeDocument/2006/relationships" r:id="Rf2619857aac2433a"/>
+      <p:regular xmlns:r="http://schemas.openxmlformats.org/officeDocument/2006/relationships" r:id="Rcea2b98d488a4d81"/>
+      <p:bold xmlns:r="http://schemas.openxmlformats.org/officeDocument/2006/relationships" r:id="R306e2024857c4926"/>
     </p:embeddedFont>
   </p:embeddedFontLst>
   <p:defaultTextStyle>
@@ -1174,7 +1176,49 @@
               <a:buNone/>
             </a:pPr>
             <a:r>
+              <a:t>- results/b2_baselines/summary.json</a:t>
+            </a:r>
+          </a:p>
+          <a:p xmlns:a="http://schemas.openxmlformats.org/drawingml/2006/main">
+            <a:pPr marL="0" indent="0" algn="l">
+              <a:spcBef>
+                <a:spcPts val="0"/>
+              </a:spcBef>
+              <a:spcAft>
+                <a:spcPts val="0"/>
+              </a:spcAft>
+              <a:buNone/>
+            </a:pPr>
+            <a:r>
               <a:t>- Manifest 9deef1271a145198a60abccf291ec499d53226075b4ccfa2061a215afbd01472</a:t>
+            </a:r>
+          </a:p>
+          <a:p xmlns:a="http://schemas.openxmlformats.org/drawingml/2006/main">
+            <a:pPr marL="0" indent="0" algn="l">
+              <a:spcBef>
+                <a:spcPts val="0"/>
+              </a:spcBef>
+              <a:spcAft>
+                <a:spcPts val="0"/>
+              </a:spcAft>
+              <a:buNone/>
+            </a:pPr>
+            <a:r>
+              <a:t/>
+            </a:r>
+          </a:p>
+          <a:p xmlns:a="http://schemas.openxmlformats.org/drawingml/2006/main">
+            <a:pPr marL="0" indent="0" algn="l">
+              <a:spcBef>
+                <a:spcPts val="0"/>
+              </a:spcBef>
+              <a:spcAft>
+                <a:spcPts val="0"/>
+              </a:spcAft>
+              <a:buNone/>
+            </a:pPr>
+            <a:r>
+              <a:t>* B0 and B2 are not like-for-like, so ΔF1 is intentionally not reported.</a:t>
             </a:r>
           </a:p>
         </p:txBody>
@@ -1432,6 +1476,197 @@
 </p:notes>
 </file>
 
+<file path=ppt/notesSlides/notesSlide19.xml><?xml version="1.0" encoding="utf-8"?>
+<p:notes xmlns:p="http://schemas.openxmlformats.org/presentationml/2006/main">
+  <p:cSld>
+    <p:spTree>
+      <p:nvGrpSpPr>
+        <p:cNvPr id="1" name=""/>
+        <p:cNvGrpSpPr/>
+        <p:nvPr/>
+      </p:nvGrpSpPr>
+      <p:grpSpPr>
+        <a:xfrm xmlns:a="http://schemas.openxmlformats.org/drawingml/2006/main"/>
+      </p:grpSpPr>
+      <p:sp>
+        <p:nvSpPr>
+          <p:cNvPr id="2" name="Slide Image Placeholder 1"/>
+          <p:cNvSpPr>
+            <a:spLocks xmlns:a="http://schemas.openxmlformats.org/drawingml/2006/main" noGrp="1"/>
+          </p:cNvSpPr>
+          <p:nvPr>
+            <p:ph type="sldImg" idx="0"/>
+          </p:nvPr>
+        </p:nvSpPr>
+        <p:spPr/>
+      </p:sp>
+      <p:sp>
+        <p:nvSpPr>
+          <p:cNvPr id="3" name="Notes Placeholder 2"/>
+          <p:cNvSpPr>
+            <a:spLocks xmlns:a="http://schemas.openxmlformats.org/drawingml/2006/main" noGrp="1"/>
+          </p:cNvSpPr>
+          <p:nvPr>
+            <p:ph type="body" idx="1"/>
+          </p:nvPr>
+        </p:nvSpPr>
+        <p:spPr/>
+        <p:txBody>
+          <a:bodyPr xmlns:a="http://schemas.openxmlformats.org/drawingml/2006/main"/>
+          <a:lstStyle xmlns:a="http://schemas.openxmlformats.org/drawingml/2006/main"/>
+          <a:p xmlns:a="http://schemas.openxmlformats.org/drawingml/2006/main">
+            <a:pPr marL="0" indent="0" algn="l">
+              <a:spcBef>
+                <a:spcPts val="0"/>
+              </a:spcBef>
+              <a:spcAft>
+                <a:spcPts val="0"/>
+              </a:spcAft>
+              <a:buNone/>
+            </a:pPr>
+            <a:r>
+              <a:t>[Sources]</a:t>
+            </a:r>
+          </a:p>
+          <a:p xmlns:a="http://schemas.openxmlformats.org/drawingml/2006/main">
+            <a:pPr marL="0" indent="0" algn="l">
+              <a:spcBef>
+                <a:spcPts val="0"/>
+              </a:spcBef>
+              <a:spcAft>
+                <a:spcPts val="0"/>
+              </a:spcAft>
+              <a:buNone/>
+            </a:pPr>
+            <a:r>
+              <a:t>- results/b2_baselines/summary.json</a:t>
+            </a:r>
+          </a:p>
+          <a:p xmlns:a="http://schemas.openxmlformats.org/drawingml/2006/main">
+            <a:pPr marL="0" indent="0" algn="l">
+              <a:spcBef>
+                <a:spcPts val="0"/>
+              </a:spcBef>
+              <a:spcAft>
+                <a:spcPts val="0"/>
+              </a:spcAft>
+              <a:buNone/>
+            </a:pPr>
+            <a:r>
+              <a:t>- results/b2_baselines/runs/tile_random_reference_seed_42.json</a:t>
+            </a:r>
+          </a:p>
+          <a:p xmlns:a="http://schemas.openxmlformats.org/drawingml/2006/main">
+            <a:pPr marL="0" indent="0" algn="l">
+              <a:spcBef>
+                <a:spcPts val="0"/>
+              </a:spcBef>
+              <a:spcAft>
+                <a:spcPts val="0"/>
+              </a:spcAft>
+              <a:buNone/>
+            </a:pPr>
+            <a:r>
+              <a:t>- results/b2_baselines/runs/tile_random_reference_seed_43.json</a:t>
+            </a:r>
+          </a:p>
+          <a:p xmlns:a="http://schemas.openxmlformats.org/drawingml/2006/main">
+            <a:pPr marL="0" indent="0" algn="l">
+              <a:spcBef>
+                <a:spcPts val="0"/>
+              </a:spcBef>
+              <a:spcAft>
+                <a:spcPts val="0"/>
+              </a:spcAft>
+              <a:buNone/>
+            </a:pPr>
+            <a:r>
+              <a:t>- results/b2_baselines/runs/tile_random_reference_seed_44.json</a:t>
+            </a:r>
+          </a:p>
+          <a:p xmlns:a="http://schemas.openxmlformats.org/drawingml/2006/main">
+            <a:pPr marL="0" indent="0" algn="l">
+              <a:spcBef>
+                <a:spcPts val="0"/>
+              </a:spcBef>
+              <a:spcAft>
+                <a:spcPts val="0"/>
+              </a:spcAft>
+              <a:buNone/>
+            </a:pPr>
+            <a:r>
+              <a:t>- results/b2_baselines/runs/unseen_layout_v1_seed_42.json</a:t>
+            </a:r>
+          </a:p>
+          <a:p xmlns:a="http://schemas.openxmlformats.org/drawingml/2006/main">
+            <a:pPr marL="0" indent="0" algn="l">
+              <a:spcBef>
+                <a:spcPts val="0"/>
+              </a:spcBef>
+              <a:spcAft>
+                <a:spcPts val="0"/>
+              </a:spcAft>
+              <a:buNone/>
+            </a:pPr>
+            <a:r>
+              <a:t>- results/b2_baselines/runs/unseen_layout_v1_seed_43.json</a:t>
+            </a:r>
+          </a:p>
+          <a:p xmlns:a="http://schemas.openxmlformats.org/drawingml/2006/main">
+            <a:pPr marL="0" indent="0" algn="l">
+              <a:spcBef>
+                <a:spcPts val="0"/>
+              </a:spcBef>
+              <a:spcAft>
+                <a:spcPts val="0"/>
+              </a:spcAft>
+              <a:buNone/>
+            </a:pPr>
+            <a:r>
+              <a:t>- results/b2_baselines/runs/unseen_layout_v1_seed_44.json</a:t>
+            </a:r>
+          </a:p>
+          <a:p xmlns:a="http://schemas.openxmlformats.org/drawingml/2006/main">
+            <a:pPr marL="0" indent="0" algn="l">
+              <a:spcBef>
+                <a:spcPts val="0"/>
+              </a:spcBef>
+              <a:spcAft>
+                <a:spcPts val="0"/>
+              </a:spcAft>
+              <a:buNone/>
+            </a:pPr>
+            <a:r>
+              <a:t>- Configuration d7fa939a1212; manifest 9deef1271a14</a:t>
+            </a:r>
+          </a:p>
+        </p:txBody>
+      </p:sp>
+      <p:sp>
+        <p:nvSpPr>
+          <p:cNvPr id="4" name="Slide Number Placeholder 3"/>
+          <p:cNvSpPr>
+            <a:spLocks xmlns:a="http://schemas.openxmlformats.org/drawingml/2006/main" noGrp="1"/>
+          </p:cNvSpPr>
+          <p:nvPr>
+            <p:ph type="sldNum" idx="5"/>
+          </p:nvPr>
+        </p:nvSpPr>
+        <p:spPr/>
+        <p:txBody>
+          <a:bodyPr xmlns:a="http://schemas.openxmlformats.org/drawingml/2006/main"/>
+          <a:lstStyle xmlns:a="http://schemas.openxmlformats.org/drawingml/2006/main"/>
+          <a:p xmlns:a="http://schemas.openxmlformats.org/drawingml/2006/main"/>
+        </p:txBody>
+      </p:sp>
+    </p:spTree>
+  </p:cSld>
+  <p:clrMapOvr>
+    <a:masterClrMapping xmlns:a="http://schemas.openxmlformats.org/drawingml/2006/main"/>
+  </p:clrMapOvr>
+</p:notes>
+</file>
+
 <file path=ppt/notesSlides/notesSlide2.xml><?xml version="1.0" encoding="utf-8"?>
 <p:notes xmlns:p="http://schemas.openxmlformats.org/presentationml/2006/main">
   <p:cSld>
@@ -1482,6 +1717,127 @@
             </a:pPr>
             <a:r>
               <a:t/>
+            </a:r>
+          </a:p>
+        </p:txBody>
+      </p:sp>
+      <p:sp>
+        <p:nvSpPr>
+          <p:cNvPr id="4" name="Slide Number Placeholder 3"/>
+          <p:cNvSpPr>
+            <a:spLocks xmlns:a="http://schemas.openxmlformats.org/drawingml/2006/main" noGrp="1"/>
+          </p:cNvSpPr>
+          <p:nvPr>
+            <p:ph type="sldNum" idx="5"/>
+          </p:nvPr>
+        </p:nvSpPr>
+        <p:spPr/>
+        <p:txBody>
+          <a:bodyPr xmlns:a="http://schemas.openxmlformats.org/drawingml/2006/main"/>
+          <a:lstStyle xmlns:a="http://schemas.openxmlformats.org/drawingml/2006/main"/>
+          <a:p xmlns:a="http://schemas.openxmlformats.org/drawingml/2006/main"/>
+        </p:txBody>
+      </p:sp>
+    </p:spTree>
+  </p:cSld>
+  <p:clrMapOvr>
+    <a:masterClrMapping xmlns:a="http://schemas.openxmlformats.org/drawingml/2006/main"/>
+  </p:clrMapOvr>
+</p:notes>
+</file>
+
+<file path=ppt/notesSlides/notesSlide20.xml><?xml version="1.0" encoding="utf-8"?>
+<p:notes xmlns:p="http://schemas.openxmlformats.org/presentationml/2006/main">
+  <p:cSld>
+    <p:spTree>
+      <p:nvGrpSpPr>
+        <p:cNvPr id="1" name=""/>
+        <p:cNvGrpSpPr/>
+        <p:nvPr/>
+      </p:nvGrpSpPr>
+      <p:grpSpPr>
+        <a:xfrm xmlns:a="http://schemas.openxmlformats.org/drawingml/2006/main"/>
+      </p:grpSpPr>
+      <p:sp>
+        <p:nvSpPr>
+          <p:cNvPr id="2" name="Slide Image Placeholder 1"/>
+          <p:cNvSpPr>
+            <a:spLocks xmlns:a="http://schemas.openxmlformats.org/drawingml/2006/main" noGrp="1"/>
+          </p:cNvSpPr>
+          <p:nvPr>
+            <p:ph type="sldImg" idx="0"/>
+          </p:nvPr>
+        </p:nvSpPr>
+        <p:spPr/>
+      </p:sp>
+      <p:sp>
+        <p:nvSpPr>
+          <p:cNvPr id="3" name="Notes Placeholder 2"/>
+          <p:cNvSpPr>
+            <a:spLocks xmlns:a="http://schemas.openxmlformats.org/drawingml/2006/main" noGrp="1"/>
+          </p:cNvSpPr>
+          <p:nvPr>
+            <p:ph type="body" idx="1"/>
+          </p:nvPr>
+        </p:nvSpPr>
+        <p:spPr/>
+        <p:txBody>
+          <a:bodyPr xmlns:a="http://schemas.openxmlformats.org/drawingml/2006/main"/>
+          <a:lstStyle xmlns:a="http://schemas.openxmlformats.org/drawingml/2006/main"/>
+          <a:p xmlns:a="http://schemas.openxmlformats.org/drawingml/2006/main">
+            <a:pPr marL="0" indent="0" algn="l">
+              <a:spcBef>
+                <a:spcPts val="0"/>
+              </a:spcBef>
+              <a:spcAft>
+                <a:spcPts val="0"/>
+              </a:spcAft>
+              <a:buNone/>
+            </a:pPr>
+            <a:r>
+              <a:t>[Sources]</a:t>
+            </a:r>
+          </a:p>
+          <a:p xmlns:a="http://schemas.openxmlformats.org/drawingml/2006/main">
+            <a:pPr marL="0" indent="0" algn="l">
+              <a:spcBef>
+                <a:spcPts val="0"/>
+              </a:spcBef>
+              <a:spcAft>
+                <a:spcPts val="0"/>
+              </a:spcAft>
+              <a:buNone/>
+            </a:pPr>
+            <a:r>
+              <a:t>- results/b2_baselines/summary.json</a:t>
+            </a:r>
+          </a:p>
+          <a:p xmlns:a="http://schemas.openxmlformats.org/drawingml/2006/main">
+            <a:pPr marL="0" indent="0" algn="l">
+              <a:spcBef>
+                <a:spcPts val="0"/>
+              </a:spcBef>
+              <a:spcAft>
+                <a:spcPts val="0"/>
+              </a:spcAft>
+              <a:buNone/>
+            </a:pPr>
+            <a:r>
+              <a:t>- Three-seed per-layout aggregation for unseen_layout_v1</a:t>
+            </a:r>
+          </a:p>
+          <a:p xmlns:a="http://schemas.openxmlformats.org/drawingml/2006/main">
+            <a:pPr marL="0" indent="0" algn="l">
+              <a:spcBef>
+                <a:spcPts val="0"/>
+              </a:spcBef>
+              <a:spcAft>
+                <a:spcPts val="0"/>
+              </a:spcAft>
+              <a:buNone/>
+            </a:pPr>
+            <a:r>
+              <a:t>- Manifest 9deef1271a145198a60abccf291ec499d53226075b4ccfa2061a215afbd01472</a:t>
             </a:r>
           </a:p>
         </p:txBody>
@@ -10903,17 +11259,17 @@
   </p:cSld>
   <p:clrMap bg1="lt1" tx1="dk1" bg2="dk2" tx2="lt2" accent1="accent1" accent2="accent2" accent3="accent3" accent4="accent4" accent5="accent5" accent6="accent6" hlink="hlink" folHlink="folHlink"/>
   <p:sldLayoutIdLst>
-    <p:sldLayoutId xmlns:r="http://schemas.openxmlformats.org/officeDocument/2006/relationships" id="2147483649" r:id="R242b33f3ac70404c"/>
-    <p:sldLayoutId xmlns:r="http://schemas.openxmlformats.org/officeDocument/2006/relationships" id="2147483650" r:id="Rf6119d4ec7554bd1"/>
-    <p:sldLayoutId xmlns:r="http://schemas.openxmlformats.org/officeDocument/2006/relationships" id="2147483651" r:id="Rd9679adc31004bae"/>
-    <p:sldLayoutId xmlns:r="http://schemas.openxmlformats.org/officeDocument/2006/relationships" id="2147483652" r:id="R1f420c3352814748"/>
-    <p:sldLayoutId xmlns:r="http://schemas.openxmlformats.org/officeDocument/2006/relationships" id="2147483653" r:id="Redd87b50704f4f59"/>
-    <p:sldLayoutId xmlns:r="http://schemas.openxmlformats.org/officeDocument/2006/relationships" id="2147483654" r:id="R70169d950a5f4c86"/>
-    <p:sldLayoutId xmlns:r="http://schemas.openxmlformats.org/officeDocument/2006/relationships" id="2147483655" r:id="R3dd90a09b9a040d2"/>
-    <p:sldLayoutId xmlns:r="http://schemas.openxmlformats.org/officeDocument/2006/relationships" id="2147483656" r:id="R2f9078055587499b"/>
-    <p:sldLayoutId xmlns:r="http://schemas.openxmlformats.org/officeDocument/2006/relationships" id="2147483657" r:id="R7acdd0b93f264fd9"/>
-    <p:sldLayoutId xmlns:r="http://schemas.openxmlformats.org/officeDocument/2006/relationships" id="2147483658" r:id="R57c9ea43b71945bb"/>
-    <p:sldLayoutId xmlns:r="http://schemas.openxmlformats.org/officeDocument/2006/relationships" id="2147483659" r:id="R5e23e26de3a843bf"/>
+    <p:sldLayoutId xmlns:r="http://schemas.openxmlformats.org/officeDocument/2006/relationships" id="2147483649" r:id="R52c3c8c3c35545ad"/>
+    <p:sldLayoutId xmlns:r="http://schemas.openxmlformats.org/officeDocument/2006/relationships" id="2147483650" r:id="R6a7be90c369443d4"/>
+    <p:sldLayoutId xmlns:r="http://schemas.openxmlformats.org/officeDocument/2006/relationships" id="2147483651" r:id="Ra4fa746f652c48f5"/>
+    <p:sldLayoutId xmlns:r="http://schemas.openxmlformats.org/officeDocument/2006/relationships" id="2147483652" r:id="R781a836fa0fe4f5c"/>
+    <p:sldLayoutId xmlns:r="http://schemas.openxmlformats.org/officeDocument/2006/relationships" id="2147483653" r:id="Rc2cc4d32fa864084"/>
+    <p:sldLayoutId xmlns:r="http://schemas.openxmlformats.org/officeDocument/2006/relationships" id="2147483654" r:id="R17207320ae6b4db2"/>
+    <p:sldLayoutId xmlns:r="http://schemas.openxmlformats.org/officeDocument/2006/relationships" id="2147483655" r:id="Rf85c373d90174fe9"/>
+    <p:sldLayoutId xmlns:r="http://schemas.openxmlformats.org/officeDocument/2006/relationships" id="2147483656" r:id="R4e25f2f4602e48cc"/>
+    <p:sldLayoutId xmlns:r="http://schemas.openxmlformats.org/officeDocument/2006/relationships" id="2147483657" r:id="R2351a5b64a3c4b62"/>
+    <p:sldLayoutId xmlns:r="http://schemas.openxmlformats.org/officeDocument/2006/relationships" id="2147483658" r:id="R1ed6199fdea54bf4"/>
+    <p:sldLayoutId xmlns:r="http://schemas.openxmlformats.org/officeDocument/2006/relationships" id="2147483659" r:id="Rb9c48ca0a2254c82"/>
   </p:sldLayoutIdLst>
   <p:hf sldNum="0" hdr="0" ftr="0" dt="0"/>
   <p:txStyles>
@@ -11865,7 +12221,7 @@
               <a:buNone/>
             </a:pPr>
             <a:r>
-              <a:t>CNN-based Design Rule Checking | B0 + B1 complete · B2 next</a:t>
+              <a:t>CNN-based DRC | B0–B2 complete · B3 next</a:t>
             </a:r>
           </a:p>
         </p:txBody>
@@ -12145,7 +12501,7 @@
               <a:buChar char="●"/>
             </a:pPr>
             <a:r>
-              <a:t>Comparable paper-aligned classification</a:t>
+              <a:t>Competitive clean / dirty classification</a:t>
             </a:r>
           </a:p>
           <a:p xmlns:a="http://schemas.openxmlformats.org/drawingml/2006/main">
@@ -14754,7 +15110,7 @@
               <a:buChar char="●"/>
             </a:pPr>
             <a:r>
-              <a:t>Decision: freeze B0 and redesign evaluation before tuning</a:t>
+              <a:t>Decision: redesign evaluation before tuning</a:t>
             </a:r>
           </a:p>
         </p:txBody>
@@ -15444,7 +15800,7 @@
               <a:buNone/>
             </a:pPr>
             <a:r>
-              <a:t>Paper-aligned track</a:t>
+              <a:t>Tile-random reference</a:t>
             </a:r>
           </a:p>
         </p:txBody>
@@ -15490,7 +15846,7 @@
               <a:buChar char="●"/>
             </a:pPr>
             <a:r>
-              <a:t>Reproduce the original task as closely as possible</a:t>
+              <a:t>Preserve the clean / dirty classification task</a:t>
             </a:r>
           </a:p>
           <a:p xmlns:a="http://schemas.openxmlformats.org/drawingml/2006/main">
@@ -15504,7 +15860,7 @@
               <a:buChar char="●"/>
             </a:pPr>
             <a:r>
-              <a:t>Use matched preprocessing and split assumptions</a:t>
+              <a:t>Keep equivalent content inside one split</a:t>
             </a:r>
           </a:p>
           <a:p xmlns:a="http://schemas.openxmlformats.org/drawingml/2006/main">
@@ -15518,7 +15874,7 @@
               <a:buChar char="●"/>
             </a:pPr>
             <a:r>
-              <a:t>Goal: approach or exceed the reported up-to-92% result</a:t>
+              <a:t>Internal reference; not a direct paper reproduction</a:t>
             </a:r>
           </a:p>
         </p:txBody>
@@ -15766,7 +16122,7 @@
               <a:buChar char="●"/>
             </a:pPr>
             <a:r>
-              <a:t>B2  Establish both credible baselines</a:t>
+              <a:t>B2  Dual classification baselines — complete</a:t>
             </a:r>
           </a:p>
           <a:p xmlns:a="http://schemas.openxmlformats.org/drawingml/2006/main">
@@ -17162,7 +17518,7 @@
                   <a:srgbClr val="262626"/>
                 </a:solidFill>
               </a:rPr>
-              <a:t>Planned</a:t>
+              <a:t>Done</a:t>
             </a:r>
           </a:p>
         </p:txBody>
@@ -17219,7 +17575,7 @@
                   <a:srgbClr val="262626"/>
                 </a:solidFill>
               </a:rPr>
-              <a:t>Paper-aligned + unseen-layout baselines</a:t>
+              <a:t>Three-seed unseen-layout baseline</a:t>
             </a:r>
           </a:p>
         </p:txBody>
@@ -17276,7 +17632,7 @@
                   <a:srgbClr val="262626"/>
                 </a:solidFill>
               </a:rPr>
-              <a:t>—</a:t>
+              <a:t>90.38%</a:t>
             </a:r>
           </a:p>
         </p:txBody>
@@ -17333,7 +17689,7 @@
                   <a:srgbClr val="262626"/>
                 </a:solidFill>
               </a:rPr>
-              <a:t>—</a:t>
+              <a:t>0.909</a:t>
             </a:r>
           </a:p>
         </p:txBody>
@@ -17390,7 +17746,7 @@
                   <a:srgbClr val="262626"/>
                 </a:solidFill>
               </a:rPr>
-              <a:t>—</a:t>
+              <a:t>n/a*</a:t>
             </a:r>
           </a:p>
         </p:txBody>
@@ -18131,7 +18487,7 @@
                   <a:srgbClr val="73400D"/>
                 </a:solidFill>
               </a:rPr>
-              <a:t>Next gate: B2 reruns the unchanged CNN on both frozen protocols across fixed seeds and reports per-layout metrics.</a:t>
+              <a:t>B2 passed: 90.38% ± 0.84% on unseen layouts. Next gate: B3 controlled training improvements on frozen protocols.</a:t>
             </a:r>
           </a:p>
         </p:txBody>
@@ -18481,7 +18837,7 @@
           </p:nvPr>
         </p:nvPicPr>
         <p:blipFill rotWithShape="1">
-          <a:blip xmlns:r="http://schemas.openxmlformats.org/officeDocument/2006/relationships" xmlns:a="http://schemas.openxmlformats.org/drawingml/2006/main" r:embed="Rda7c4a5e61c145b0">
+          <a:blip xmlns:r="http://schemas.openxmlformats.org/officeDocument/2006/relationships" xmlns:a="http://schemas.openxmlformats.org/drawingml/2006/main" r:embed="Rdb67c4574bff401f">
             <a:alphaModFix/>
           </a:blip>
           <a:srcRect xmlns:a="http://schemas.openxmlformats.org/drawingml/2006/main" l="0" t="0" r="0" b="0"/>
@@ -18509,7 +18865,7 @@
           <p:nvPr/>
         </p:nvPicPr>
         <p:blipFill rotWithShape="1">
-          <a:blip xmlns:r="http://schemas.openxmlformats.org/officeDocument/2006/relationships" xmlns:a="http://schemas.openxmlformats.org/drawingml/2006/main" r:embed="R0720be9a46da4657">
+          <a:blip xmlns:r="http://schemas.openxmlformats.org/officeDocument/2006/relationships" xmlns:a="http://schemas.openxmlformats.org/drawingml/2006/main" r:embed="R743fee36e8a54cb6">
             <a:alphaModFix/>
           </a:blip>
           <a:srcRect xmlns:a="http://schemas.openxmlformats.org/drawingml/2006/main" l="0" t="0" r="0" b="0"/>
@@ -18623,7 +18979,7 @@
                 <a:ea typeface="Arial"/>
                 <a:cs typeface="Arial"/>
               </a:rPr>
-              <a:t>This confirms coordinate registration before B2 training; B6 will turn the same geometry into pixel-level segmentation targets.</a:t>
+              <a:t>B1 confirmed coordinate registration; B6 will turn the same geometry into pixel-level segmentation targets.</a:t>
             </a:r>
           </a:p>
         </p:txBody>
@@ -18632,6 +18988,2145 @@
     <p:extLst>
       <p:ext uri="{BB962C8B-B14F-4D97-AF65-F5344CB8AC3E}">
         <p14:creationId xmlns:p14="http://schemas.microsoft.com/office/powerpoint/2010/main" val="302873998"/>
+      </p:ext>
+    </p:extLst>
+  </p:cSld>
+</p:sld>
+</file>
+
+<file path=ppt/slides/slide19.xml><?xml version="1.0" encoding="utf-8"?>
+<p:sld xmlns:p="http://schemas.openxmlformats.org/presentationml/2006/main">
+  <p:cSld>
+    <p:spTree>
+      <p:nvGrpSpPr>
+        <p:cNvPr id="1" name=""/>
+        <p:cNvGrpSpPr/>
+        <p:nvPr/>
+      </p:nvGrpSpPr>
+      <p:grpSpPr>
+        <a:xfrm xmlns:a="http://schemas.openxmlformats.org/drawingml/2006/main"/>
+      </p:grpSpPr>
+      <p:sp>
+        <p:nvSpPr>
+          <p:cNvPr id="220" name="Google Shape;220;p24">
+            <a:extLst xmlns:a="http://schemas.openxmlformats.org/drawingml/2006/main">
+              <a:ext uri="{FF2B5EF4-FFF2-40B4-BE49-F238E27FC236}">
+                <a16:creationId xmlns:a16="http://schemas.microsoft.com/office/drawing/2014/main" id="{07F11CEA-12B3-4DEC-81DE-18CFD6949929}"/>
+              </a:ext>
+            </a:extLst>
+          </p:cNvPr>
+          <p:cNvSpPr>
+            <a:spLocks xmlns:a="http://schemas.openxmlformats.org/drawingml/2006/main" noGrp="1"/>
+          </p:cNvSpPr>
+          <p:nvPr>
+            <p:ph type="title" idx="0"/>
+          </p:nvPr>
+        </p:nvSpPr>
+        <p:spPr>
+          <a:xfrm xmlns:a="http://schemas.openxmlformats.org/drawingml/2006/main">
+            <a:off x="838200" y="365125"/>
+            <a:ext cx="10515600" cy="1325700"/>
+          </a:xfrm>
+          <a:prstGeom xmlns:a="http://schemas.openxmlformats.org/drawingml/2006/main" prst="rect">
+            <a:avLst/>
+          </a:prstGeom>
+        </p:spPr>
+        <p:txBody>
+          <a:bodyPr xmlns:a="http://schemas.openxmlformats.org/drawingml/2006/main" spcFirstLastPara="1" wrap="square" lIns="91425" tIns="45700" rIns="91425" bIns="45700" anchor="ctr">
+            <a:noAutofit/>
+          </a:bodyPr>
+          <a:lstStyle xmlns:a="http://schemas.openxmlformats.org/drawingml/2006/main"/>
+          <a:p xmlns:a="http://schemas.openxmlformats.org/drawingml/2006/main">
+            <a:pPr marL="0" indent="0" algn="l">
+              <a:spcBef>
+                <a:spcPts val="0"/>
+              </a:spcBef>
+              <a:spcAft>
+                <a:spcPts val="0"/>
+              </a:spcAft>
+              <a:buNone/>
+            </a:pPr>
+            <a:r>
+              <a:rPr sz="2800"/>
+              <a:t>B2: the unchanged CNN generalizes across layouts</a:t>
+            </a:r>
+          </a:p>
+        </p:txBody>
+      </p:sp>
+      <p:sp>
+        <p:nvSpPr>
+          <p:cNvPr id="221" name="Google Shape;221;p24">
+            <a:extLst xmlns:a="http://schemas.openxmlformats.org/drawingml/2006/main">
+              <a:ext uri="{FF2B5EF4-FFF2-40B4-BE49-F238E27FC236}">
+                <a16:creationId xmlns:a16="http://schemas.microsoft.com/office/drawing/2014/main" id="{34FFD981-FC0C-4991-AA83-5BDA5E78AAD9}"/>
+              </a:ext>
+            </a:extLst>
+          </p:cNvPr>
+          <p:cNvSpPr>
+            <a:spLocks xmlns:a="http://schemas.openxmlformats.org/drawingml/2006/main" noGrp="1"/>
+          </p:cNvSpPr>
+          <p:nvPr/>
+        </p:nvSpPr>
+        <p:spPr>
+          <a:xfrm xmlns:a="http://schemas.openxmlformats.org/drawingml/2006/main">
+            <a:off x="571500" y="1168400"/>
+            <a:ext cx="2476500" cy="888900"/>
+          </a:xfrm>
+          <a:prstGeom xmlns:a="http://schemas.openxmlformats.org/drawingml/2006/main" prst="roundRect">
+            <a:avLst>
+              <a:gd name="adj" fmla="val 16667"/>
+            </a:avLst>
+          </a:prstGeom>
+          <a:solidFill xmlns:a="http://schemas.openxmlformats.org/drawingml/2006/main">
+            <a:srgbClr val="E5F0FC"/>
+          </a:solidFill>
+          <a:ln xmlns:a="http://schemas.openxmlformats.org/drawingml/2006/main">
+            <a:noFill/>
+          </a:ln>
+        </p:spPr>
+        <p:txBody>
+          <a:bodyPr xmlns:a="http://schemas.openxmlformats.org/drawingml/2006/main" spcFirstLastPara="1" wrap="square" lIns="91425" tIns="91425" rIns="91425" bIns="91425" anchor="ctr">
+            <a:noAutofit/>
+          </a:bodyPr>
+          <a:lstStyle xmlns:a="http://schemas.openxmlformats.org/drawingml/2006/main"/>
+          <a:p xmlns:a="http://schemas.openxmlformats.org/drawingml/2006/main">
+            <a:pPr marL="0" indent="0" algn="ctr">
+              <a:spcBef>
+                <a:spcPts val="0"/>
+              </a:spcBef>
+              <a:spcAft>
+                <a:spcPts val="0"/>
+              </a:spcAft>
+              <a:buNone/>
+            </a:pPr>
+            <a:r>
+              <a:rPr sz="2100" b="1">
+                <a:solidFill>
+                  <a:srgbClr val="2E5496"/>
+                </a:solidFill>
+              </a:rPr>
+              <a:t>92.47% ± 0.61%</a:t>
+            </a:r>
+          </a:p>
+          <a:p xmlns:a="http://schemas.openxmlformats.org/drawingml/2006/main">
+            <a:pPr marL="0" indent="0" algn="ctr">
+              <a:spcBef>
+                <a:spcPts val="0"/>
+              </a:spcBef>
+              <a:spcAft>
+                <a:spcPts val="0"/>
+              </a:spcAft>
+              <a:buNone/>
+            </a:pPr>
+            <a:r>
+              <a:rPr sz="2100" b="1">
+                <a:solidFill>
+                  <a:srgbClr val="2E5496"/>
+                </a:solidFill>
+              </a:rPr>
+              <a:t>Tile accuracy</a:t>
+            </a:r>
+          </a:p>
+        </p:txBody>
+      </p:sp>
+      <p:sp>
+        <p:nvSpPr>
+          <p:cNvPr id="222" name="Google Shape;222;p24">
+            <a:extLst xmlns:a="http://schemas.openxmlformats.org/drawingml/2006/main">
+              <a:ext uri="{FF2B5EF4-FFF2-40B4-BE49-F238E27FC236}">
+                <a16:creationId xmlns:a16="http://schemas.microsoft.com/office/drawing/2014/main" id="{E64DA27B-59AB-4116-88BB-4D9AC154A628}"/>
+              </a:ext>
+            </a:extLst>
+          </p:cNvPr>
+          <p:cNvSpPr>
+            <a:spLocks xmlns:a="http://schemas.openxmlformats.org/drawingml/2006/main" noGrp="1"/>
+          </p:cNvSpPr>
+          <p:nvPr/>
+        </p:nvSpPr>
+        <p:spPr>
+          <a:xfrm xmlns:a="http://schemas.openxmlformats.org/drawingml/2006/main">
+            <a:off x="3429000" y="1168400"/>
+            <a:ext cx="2476500" cy="888900"/>
+          </a:xfrm>
+          <a:prstGeom xmlns:a="http://schemas.openxmlformats.org/drawingml/2006/main" prst="roundRect">
+            <a:avLst>
+              <a:gd name="adj" fmla="val 16667"/>
+            </a:avLst>
+          </a:prstGeom>
+          <a:solidFill xmlns:a="http://schemas.openxmlformats.org/drawingml/2006/main">
+            <a:srgbClr val="E5F0FC"/>
+          </a:solidFill>
+          <a:ln xmlns:a="http://schemas.openxmlformats.org/drawingml/2006/main">
+            <a:noFill/>
+          </a:ln>
+        </p:spPr>
+        <p:txBody>
+          <a:bodyPr xmlns:a="http://schemas.openxmlformats.org/drawingml/2006/main" spcFirstLastPara="1" wrap="square" lIns="91425" tIns="91425" rIns="91425" bIns="91425" anchor="ctr">
+            <a:noAutofit/>
+          </a:bodyPr>
+          <a:lstStyle xmlns:a="http://schemas.openxmlformats.org/drawingml/2006/main"/>
+          <a:p xmlns:a="http://schemas.openxmlformats.org/drawingml/2006/main">
+            <a:pPr marL="0" indent="0" algn="ctr">
+              <a:spcBef>
+                <a:spcPts val="0"/>
+              </a:spcBef>
+              <a:spcAft>
+                <a:spcPts val="0"/>
+              </a:spcAft>
+              <a:buNone/>
+            </a:pPr>
+            <a:r>
+              <a:rPr sz="2100" b="1">
+                <a:solidFill>
+                  <a:srgbClr val="2E5496"/>
+                </a:solidFill>
+              </a:rPr>
+              <a:t>90.38% ± 0.84%</a:t>
+            </a:r>
+          </a:p>
+          <a:p xmlns:a="http://schemas.openxmlformats.org/drawingml/2006/main">
+            <a:pPr marL="0" indent="0" algn="ctr">
+              <a:spcBef>
+                <a:spcPts val="0"/>
+              </a:spcBef>
+              <a:spcAft>
+                <a:spcPts val="0"/>
+              </a:spcAft>
+              <a:buNone/>
+            </a:pPr>
+            <a:r>
+              <a:rPr sz="2100" b="1">
+                <a:solidFill>
+                  <a:srgbClr val="2E5496"/>
+                </a:solidFill>
+              </a:rPr>
+              <a:t>Unseen accuracy</a:t>
+            </a:r>
+          </a:p>
+        </p:txBody>
+      </p:sp>
+      <p:sp>
+        <p:nvSpPr>
+          <p:cNvPr id="223" name="Google Shape;223;p24">
+            <a:extLst xmlns:a="http://schemas.openxmlformats.org/drawingml/2006/main">
+              <a:ext uri="{FF2B5EF4-FFF2-40B4-BE49-F238E27FC236}">
+                <a16:creationId xmlns:a16="http://schemas.microsoft.com/office/drawing/2014/main" id="{B359A0E4-150F-4A91-9EE7-E39ED9CF44AA}"/>
+              </a:ext>
+            </a:extLst>
+          </p:cNvPr>
+          <p:cNvSpPr>
+            <a:spLocks xmlns:a="http://schemas.openxmlformats.org/drawingml/2006/main" noGrp="1"/>
+          </p:cNvSpPr>
+          <p:nvPr/>
+        </p:nvSpPr>
+        <p:spPr>
+          <a:xfrm xmlns:a="http://schemas.openxmlformats.org/drawingml/2006/main">
+            <a:off x="6286500" y="1168400"/>
+            <a:ext cx="2476500" cy="888900"/>
+          </a:xfrm>
+          <a:prstGeom xmlns:a="http://schemas.openxmlformats.org/drawingml/2006/main" prst="roundRect">
+            <a:avLst>
+              <a:gd name="adj" fmla="val 16667"/>
+            </a:avLst>
+          </a:prstGeom>
+          <a:solidFill xmlns:a="http://schemas.openxmlformats.org/drawingml/2006/main">
+            <a:srgbClr val="E5F0FC"/>
+          </a:solidFill>
+          <a:ln xmlns:a="http://schemas.openxmlformats.org/drawingml/2006/main">
+            <a:noFill/>
+          </a:ln>
+        </p:spPr>
+        <p:txBody>
+          <a:bodyPr xmlns:a="http://schemas.openxmlformats.org/drawingml/2006/main" spcFirstLastPara="1" wrap="square" lIns="91425" tIns="91425" rIns="91425" bIns="91425" anchor="ctr">
+            <a:noAutofit/>
+          </a:bodyPr>
+          <a:lstStyle xmlns:a="http://schemas.openxmlformats.org/drawingml/2006/main"/>
+          <a:p xmlns:a="http://schemas.openxmlformats.org/drawingml/2006/main">
+            <a:pPr marL="0" indent="0" algn="ctr">
+              <a:spcBef>
+                <a:spcPts val="0"/>
+              </a:spcBef>
+              <a:spcAft>
+                <a:spcPts val="0"/>
+              </a:spcAft>
+              <a:buNone/>
+            </a:pPr>
+            <a:r>
+              <a:rPr sz="2100" b="1">
+                <a:solidFill>
+                  <a:srgbClr val="2E5496"/>
+                </a:solidFill>
+              </a:rPr>
+              <a:t>0.919 / 0.909</a:t>
+            </a:r>
+          </a:p>
+          <a:p xmlns:a="http://schemas.openxmlformats.org/drawingml/2006/main">
+            <a:pPr marL="0" indent="0" algn="ctr">
+              <a:spcBef>
+                <a:spcPts val="0"/>
+              </a:spcBef>
+              <a:spcAft>
+                <a:spcPts val="0"/>
+              </a:spcAft>
+              <a:buNone/>
+            </a:pPr>
+            <a:r>
+              <a:rPr sz="2100" b="1">
+                <a:solidFill>
+                  <a:srgbClr val="2E5496"/>
+                </a:solidFill>
+              </a:rPr>
+              <a:t>F1: tile / unseen</a:t>
+            </a:r>
+          </a:p>
+        </p:txBody>
+      </p:sp>
+      <p:sp>
+        <p:nvSpPr>
+          <p:cNvPr id="224" name="Google Shape;224;p24">
+            <a:extLst xmlns:a="http://schemas.openxmlformats.org/drawingml/2006/main">
+              <a:ext uri="{FF2B5EF4-FFF2-40B4-BE49-F238E27FC236}">
+                <a16:creationId xmlns:a16="http://schemas.microsoft.com/office/drawing/2014/main" id="{448D1686-F154-4825-8455-21FA62030A03}"/>
+              </a:ext>
+            </a:extLst>
+          </p:cNvPr>
+          <p:cNvSpPr>
+            <a:spLocks xmlns:a="http://schemas.openxmlformats.org/drawingml/2006/main" noGrp="1"/>
+          </p:cNvSpPr>
+          <p:nvPr/>
+        </p:nvSpPr>
+        <p:spPr>
+          <a:xfrm xmlns:a="http://schemas.openxmlformats.org/drawingml/2006/main">
+            <a:off x="9144000" y="1168400"/>
+            <a:ext cx="2476500" cy="888900"/>
+          </a:xfrm>
+          <a:prstGeom xmlns:a="http://schemas.openxmlformats.org/drawingml/2006/main" prst="roundRect">
+            <a:avLst>
+              <a:gd name="adj" fmla="val 16667"/>
+            </a:avLst>
+          </a:prstGeom>
+          <a:solidFill xmlns:a="http://schemas.openxmlformats.org/drawingml/2006/main">
+            <a:srgbClr val="E5F0FC"/>
+          </a:solidFill>
+          <a:ln xmlns:a="http://schemas.openxmlformats.org/drawingml/2006/main">
+            <a:noFill/>
+          </a:ln>
+        </p:spPr>
+        <p:txBody>
+          <a:bodyPr xmlns:a="http://schemas.openxmlformats.org/drawingml/2006/main" spcFirstLastPara="1" wrap="square" lIns="91425" tIns="91425" rIns="91425" bIns="91425" anchor="ctr">
+            <a:noAutofit/>
+          </a:bodyPr>
+          <a:lstStyle xmlns:a="http://schemas.openxmlformats.org/drawingml/2006/main"/>
+          <a:p xmlns:a="http://schemas.openxmlformats.org/drawingml/2006/main">
+            <a:pPr marL="0" indent="0" algn="ctr">
+              <a:spcBef>
+                <a:spcPts val="0"/>
+              </a:spcBef>
+              <a:spcAft>
+                <a:spcPts val="0"/>
+              </a:spcAft>
+              <a:buNone/>
+            </a:pPr>
+            <a:r>
+              <a:rPr sz="2100" b="1">
+                <a:solidFill>
+                  <a:srgbClr val="2E5496"/>
+                </a:solidFill>
+              </a:rPr>
+              <a:t>2.09 pts</a:t>
+            </a:r>
+          </a:p>
+          <a:p xmlns:a="http://schemas.openxmlformats.org/drawingml/2006/main">
+            <a:pPr marL="0" indent="0" algn="ctr">
+              <a:spcBef>
+                <a:spcPts val="0"/>
+              </a:spcBef>
+              <a:spcAft>
+                <a:spcPts val="0"/>
+              </a:spcAft>
+              <a:buNone/>
+            </a:pPr>
+            <a:r>
+              <a:rPr sz="2100" b="1">
+                <a:solidFill>
+                  <a:srgbClr val="2E5496"/>
+                </a:solidFill>
+              </a:rPr>
+              <a:t>Accuracy gap</a:t>
+            </a:r>
+          </a:p>
+        </p:txBody>
+      </p:sp>
+      <p:sp>
+        <p:nvSpPr>
+          <p:cNvPr id="225" name="Google Shape;225;p24">
+            <a:extLst xmlns:a="http://schemas.openxmlformats.org/drawingml/2006/main">
+              <a:ext uri="{FF2B5EF4-FFF2-40B4-BE49-F238E27FC236}">
+                <a16:creationId xmlns:a16="http://schemas.microsoft.com/office/drawing/2014/main" id="{5325D149-BE92-4FD6-B792-AD4BCA70750F}"/>
+              </a:ext>
+            </a:extLst>
+          </p:cNvPr>
+          <p:cNvSpPr>
+            <a:spLocks xmlns:a="http://schemas.openxmlformats.org/drawingml/2006/main" noGrp="1"/>
+          </p:cNvSpPr>
+          <p:nvPr/>
+        </p:nvSpPr>
+        <p:spPr>
+          <a:xfrm xmlns:a="http://schemas.openxmlformats.org/drawingml/2006/main">
+            <a:off x="825500" y="2349500"/>
+            <a:ext cx="4889400" cy="355500"/>
+          </a:xfrm>
+          <a:prstGeom xmlns:a="http://schemas.openxmlformats.org/drawingml/2006/main" prst="rect">
+            <a:avLst/>
+          </a:prstGeom>
+          <a:noFill xmlns:a="http://schemas.openxmlformats.org/drawingml/2006/main"/>
+          <a:ln xmlns:a="http://schemas.openxmlformats.org/drawingml/2006/main">
+            <a:noFill/>
+          </a:ln>
+        </p:spPr>
+        <p:txBody>
+          <a:bodyPr xmlns:a="http://schemas.openxmlformats.org/drawingml/2006/main" spcFirstLastPara="1" wrap="square" lIns="91425" tIns="91425" rIns="91425" bIns="91425" anchor="ctr">
+            <a:noAutofit/>
+          </a:bodyPr>
+          <a:lstStyle xmlns:a="http://schemas.openxmlformats.org/drawingml/2006/main"/>
+          <a:p xmlns:a="http://schemas.openxmlformats.org/drawingml/2006/main">
+            <a:pPr marL="0" indent="0" algn="ctr">
+              <a:spcBef>
+                <a:spcPts val="0"/>
+              </a:spcBef>
+              <a:spcAft>
+                <a:spcPts val="0"/>
+              </a:spcAft>
+              <a:buNone/>
+            </a:pPr>
+            <a:r>
+              <a:rPr sz="1600" b="1">
+                <a:solidFill>
+                  <a:srgbClr val="333333"/>
+                </a:solidFill>
+              </a:rPr>
+              <a:t>Test accuracy across seeds and protocol means</a:t>
+            </a:r>
+          </a:p>
+        </p:txBody>
+      </p:sp>
+      <p:sp>
+        <p:nvSpPr>
+          <p:cNvPr id="226" name="Google Shape;226;p24">
+            <a:extLst xmlns:a="http://schemas.openxmlformats.org/drawingml/2006/main">
+              <a:ext uri="{FF2B5EF4-FFF2-40B4-BE49-F238E27FC236}">
+                <a16:creationId xmlns:a16="http://schemas.microsoft.com/office/drawing/2014/main" id="{60C63560-5372-47FA-82CD-652B71E23330}"/>
+              </a:ext>
+            </a:extLst>
+          </p:cNvPr>
+          <p:cNvSpPr>
+            <a:spLocks xmlns:a="http://schemas.openxmlformats.org/drawingml/2006/main" noGrp="1"/>
+          </p:cNvSpPr>
+          <p:nvPr/>
+        </p:nvSpPr>
+        <p:spPr>
+          <a:xfrm xmlns:a="http://schemas.openxmlformats.org/drawingml/2006/main">
+            <a:off x="6477000" y="2349500"/>
+            <a:ext cx="4889400" cy="355500"/>
+          </a:xfrm>
+          <a:prstGeom xmlns:a="http://schemas.openxmlformats.org/drawingml/2006/main" prst="rect">
+            <a:avLst/>
+          </a:prstGeom>
+          <a:noFill xmlns:a="http://schemas.openxmlformats.org/drawingml/2006/main"/>
+          <a:ln xmlns:a="http://schemas.openxmlformats.org/drawingml/2006/main">
+            <a:noFill/>
+          </a:ln>
+        </p:spPr>
+        <p:txBody>
+          <a:bodyPr xmlns:a="http://schemas.openxmlformats.org/drawingml/2006/main" spcFirstLastPara="1" wrap="square" lIns="91425" tIns="91425" rIns="91425" bIns="91425" anchor="ctr">
+            <a:noAutofit/>
+          </a:bodyPr>
+          <a:lstStyle xmlns:a="http://schemas.openxmlformats.org/drawingml/2006/main"/>
+          <a:p xmlns:a="http://schemas.openxmlformats.org/drawingml/2006/main">
+            <a:pPr marL="0" indent="0" algn="ctr">
+              <a:spcBef>
+                <a:spcPts val="0"/>
+              </a:spcBef>
+              <a:spcAft>
+                <a:spcPts val="0"/>
+              </a:spcAft>
+              <a:buNone/>
+            </a:pPr>
+            <a:r>
+              <a:rPr sz="1600" b="1">
+                <a:solidFill>
+                  <a:srgbClr val="333333"/>
+                </a:solidFill>
+              </a:rPr>
+              <a:t>Dirty F1 across seeds and protocol means</a:t>
+            </a:r>
+          </a:p>
+        </p:txBody>
+      </p:sp>
+      <p:sp>
+        <p:nvSpPr>
+          <p:cNvPr id="227" name="Google Shape;227;p24">
+            <a:extLst xmlns:a="http://schemas.openxmlformats.org/drawingml/2006/main">
+              <a:ext uri="{FF2B5EF4-FFF2-40B4-BE49-F238E27FC236}">
+                <a16:creationId xmlns:a16="http://schemas.microsoft.com/office/drawing/2014/main" id="{D64E7AEF-FADD-4A8F-85AE-1951913F1312}"/>
+              </a:ext>
+            </a:extLst>
+          </p:cNvPr>
+          <p:cNvSpPr>
+            <a:spLocks xmlns:a="http://schemas.openxmlformats.org/drawingml/2006/main" noGrp="1"/>
+          </p:cNvSpPr>
+          <p:nvPr/>
+        </p:nvSpPr>
+        <p:spPr>
+          <a:xfrm xmlns:a="http://schemas.openxmlformats.org/drawingml/2006/main">
+            <a:off x="1016000" y="5791200"/>
+            <a:ext cx="4445100" cy="25500"/>
+          </a:xfrm>
+          <a:prstGeom xmlns:a="http://schemas.openxmlformats.org/drawingml/2006/main" prst="rect">
+            <a:avLst/>
+          </a:prstGeom>
+          <a:solidFill xmlns:a="http://schemas.openxmlformats.org/drawingml/2006/main">
+            <a:srgbClr val="B8B8B8"/>
+          </a:solidFill>
+          <a:ln xmlns:a="http://schemas.openxmlformats.org/drawingml/2006/main">
+            <a:noFill/>
+          </a:ln>
+        </p:spPr>
+        <p:txBody>
+          <a:bodyPr xmlns:a="http://schemas.openxmlformats.org/drawingml/2006/main" spcFirstLastPara="1" wrap="square" lIns="91425" tIns="91425" rIns="91425" bIns="91425" anchor="ctr">
+            <a:noAutofit/>
+          </a:bodyPr>
+          <a:lstStyle xmlns:a="http://schemas.openxmlformats.org/drawingml/2006/main"/>
+          <a:p xmlns:a="http://schemas.openxmlformats.org/drawingml/2006/main">
+            <a:pPr marL="0" indent="0" algn="ctr">
+              <a:spcBef>
+                <a:spcPts val="0"/>
+              </a:spcBef>
+              <a:spcAft>
+                <a:spcPts val="0"/>
+              </a:spcAft>
+              <a:buNone/>
+            </a:pPr>
+            <a:r>
+              <a:t/>
+            </a:r>
+          </a:p>
+        </p:txBody>
+      </p:sp>
+      <p:sp>
+        <p:nvSpPr>
+          <p:cNvPr id="228" name="Google Shape;228;p24">
+            <a:extLst xmlns:a="http://schemas.openxmlformats.org/drawingml/2006/main">
+              <a:ext uri="{FF2B5EF4-FFF2-40B4-BE49-F238E27FC236}">
+                <a16:creationId xmlns:a16="http://schemas.microsoft.com/office/drawing/2014/main" id="{CE3E6F11-AB17-4D0C-A8FF-A896408BA561}"/>
+              </a:ext>
+            </a:extLst>
+          </p:cNvPr>
+          <p:cNvSpPr>
+            <a:spLocks xmlns:a="http://schemas.openxmlformats.org/drawingml/2006/main" noGrp="1"/>
+          </p:cNvSpPr>
+          <p:nvPr/>
+        </p:nvSpPr>
+        <p:spPr>
+          <a:xfrm xmlns:a="http://schemas.openxmlformats.org/drawingml/2006/main">
+            <a:off x="6667500" y="5791200"/>
+            <a:ext cx="4445100" cy="25500"/>
+          </a:xfrm>
+          <a:prstGeom xmlns:a="http://schemas.openxmlformats.org/drawingml/2006/main" prst="rect">
+            <a:avLst/>
+          </a:prstGeom>
+          <a:solidFill xmlns:a="http://schemas.openxmlformats.org/drawingml/2006/main">
+            <a:srgbClr val="B8B8B8"/>
+          </a:solidFill>
+          <a:ln xmlns:a="http://schemas.openxmlformats.org/drawingml/2006/main">
+            <a:noFill/>
+          </a:ln>
+        </p:spPr>
+        <p:txBody>
+          <a:bodyPr xmlns:a="http://schemas.openxmlformats.org/drawingml/2006/main" spcFirstLastPara="1" wrap="square" lIns="91425" tIns="91425" rIns="91425" bIns="91425" anchor="ctr">
+            <a:noAutofit/>
+          </a:bodyPr>
+          <a:lstStyle xmlns:a="http://schemas.openxmlformats.org/drawingml/2006/main"/>
+          <a:p xmlns:a="http://schemas.openxmlformats.org/drawingml/2006/main">
+            <a:pPr marL="0" indent="0" algn="ctr">
+              <a:spcBef>
+                <a:spcPts val="0"/>
+              </a:spcBef>
+              <a:spcAft>
+                <a:spcPts val="0"/>
+              </a:spcAft>
+              <a:buNone/>
+            </a:pPr>
+            <a:r>
+              <a:t/>
+            </a:r>
+          </a:p>
+        </p:txBody>
+      </p:sp>
+      <p:sp>
+        <p:nvSpPr>
+          <p:cNvPr id="229" name="Google Shape;229;p24">
+            <a:extLst xmlns:a="http://schemas.openxmlformats.org/drawingml/2006/main">
+              <a:ext uri="{FF2B5EF4-FFF2-40B4-BE49-F238E27FC236}">
+                <a16:creationId xmlns:a16="http://schemas.microsoft.com/office/drawing/2014/main" id="{2F7AFDFB-F63A-4D6B-8209-6D4E2E931D86}"/>
+              </a:ext>
+            </a:extLst>
+          </p:cNvPr>
+          <p:cNvSpPr>
+            <a:spLocks xmlns:a="http://schemas.openxmlformats.org/drawingml/2006/main" noGrp="1"/>
+          </p:cNvSpPr>
+          <p:nvPr/>
+        </p:nvSpPr>
+        <p:spPr>
+          <a:xfrm xmlns:a="http://schemas.openxmlformats.org/drawingml/2006/main">
+            <a:off x="1206532" y="3623566"/>
+            <a:ext cx="533400" cy="2167634"/>
+          </a:xfrm>
+          <a:prstGeom xmlns:a="http://schemas.openxmlformats.org/drawingml/2006/main" prst="rect">
+            <a:avLst/>
+          </a:prstGeom>
+          <a:solidFill xmlns:a="http://schemas.openxmlformats.org/drawingml/2006/main">
+            <a:srgbClr val="2E5496"/>
+          </a:solidFill>
+          <a:ln xmlns:a="http://schemas.openxmlformats.org/drawingml/2006/main">
+            <a:noFill/>
+          </a:ln>
+        </p:spPr>
+        <p:txBody>
+          <a:bodyPr xmlns:a="http://schemas.openxmlformats.org/drawingml/2006/main" spcFirstLastPara="1" wrap="square" lIns="91425" tIns="91425" rIns="91425" bIns="91425" anchor="ctr">
+            <a:noAutofit/>
+          </a:bodyPr>
+          <a:lstStyle xmlns:a="http://schemas.openxmlformats.org/drawingml/2006/main"/>
+          <a:p xmlns:a="http://schemas.openxmlformats.org/drawingml/2006/main">
+            <a:pPr marL="0" indent="0" algn="ctr">
+              <a:spcBef>
+                <a:spcPts val="0"/>
+              </a:spcBef>
+              <a:spcAft>
+                <a:spcPts val="0"/>
+              </a:spcAft>
+              <a:buNone/>
+            </a:pPr>
+            <a:r>
+              <a:t/>
+            </a:r>
+          </a:p>
+        </p:txBody>
+      </p:sp>
+      <p:sp>
+        <p:nvSpPr>
+          <p:cNvPr id="230" name="Google Shape;230;p24">
+            <a:extLst xmlns:a="http://schemas.openxmlformats.org/drawingml/2006/main">
+              <a:ext uri="{FF2B5EF4-FFF2-40B4-BE49-F238E27FC236}">
+                <a16:creationId xmlns:a16="http://schemas.microsoft.com/office/drawing/2014/main" id="{E2439BC9-CF04-423F-B024-F3872A68ABDA}"/>
+              </a:ext>
+            </a:extLst>
+          </p:cNvPr>
+          <p:cNvSpPr>
+            <a:spLocks xmlns:a="http://schemas.openxmlformats.org/drawingml/2006/main" noGrp="1"/>
+          </p:cNvSpPr>
+          <p:nvPr/>
+        </p:nvSpPr>
+        <p:spPr>
+          <a:xfrm xmlns:a="http://schemas.openxmlformats.org/drawingml/2006/main">
+            <a:off x="1143000" y="3306097"/>
+            <a:ext cx="660273" cy="279273"/>
+          </a:xfrm>
+          <a:prstGeom xmlns:a="http://schemas.openxmlformats.org/drawingml/2006/main" prst="rect">
+            <a:avLst/>
+          </a:prstGeom>
+          <a:noFill xmlns:a="http://schemas.openxmlformats.org/drawingml/2006/main"/>
+          <a:ln xmlns:a="http://schemas.openxmlformats.org/drawingml/2006/main">
+            <a:noFill/>
+          </a:ln>
+        </p:spPr>
+        <p:txBody>
+          <a:bodyPr xmlns:a="http://schemas.openxmlformats.org/drawingml/2006/main" spcFirstLastPara="1" wrap="square" lIns="91425" tIns="91425" rIns="91425" bIns="91425" anchor="ctr">
+            <a:noAutofit/>
+          </a:bodyPr>
+          <a:lstStyle xmlns:a="http://schemas.openxmlformats.org/drawingml/2006/main"/>
+          <a:p xmlns:a="http://schemas.openxmlformats.org/drawingml/2006/main">
+            <a:pPr marL="0" indent="0" algn="ctr">
+              <a:spcBef>
+                <a:spcPts val="0"/>
+              </a:spcBef>
+              <a:spcAft>
+                <a:spcPts val="0"/>
+              </a:spcAft>
+              <a:buNone/>
+            </a:pPr>
+            <a:r>
+              <a:rPr sz="1100" b="1">
+                <a:solidFill>
+                  <a:srgbClr val="333333"/>
+                </a:solidFill>
+              </a:rPr>
+              <a:t>92.89%</a:t>
+            </a:r>
+          </a:p>
+        </p:txBody>
+      </p:sp>
+      <p:sp>
+        <p:nvSpPr>
+          <p:cNvPr id="231" name="Google Shape;231;p24">
+            <a:extLst xmlns:a="http://schemas.openxmlformats.org/drawingml/2006/main">
+              <a:ext uri="{FF2B5EF4-FFF2-40B4-BE49-F238E27FC236}">
+                <a16:creationId xmlns:a16="http://schemas.microsoft.com/office/drawing/2014/main" id="{7F7EE744-7600-4CE7-AC12-9394C81F7561}"/>
+              </a:ext>
+            </a:extLst>
+          </p:cNvPr>
+          <p:cNvSpPr>
+            <a:spLocks xmlns:a="http://schemas.openxmlformats.org/drawingml/2006/main" noGrp="1"/>
+          </p:cNvSpPr>
+          <p:nvPr/>
+        </p:nvSpPr>
+        <p:spPr>
+          <a:xfrm xmlns:a="http://schemas.openxmlformats.org/drawingml/2006/main">
+            <a:off x="1143000" y="5867400"/>
+            <a:ext cx="660273" cy="419100"/>
+          </a:xfrm>
+          <a:prstGeom xmlns:a="http://schemas.openxmlformats.org/drawingml/2006/main" prst="rect">
+            <a:avLst/>
+          </a:prstGeom>
+          <a:noFill xmlns:a="http://schemas.openxmlformats.org/drawingml/2006/main"/>
+          <a:ln xmlns:a="http://schemas.openxmlformats.org/drawingml/2006/main">
+            <a:noFill/>
+          </a:ln>
+        </p:spPr>
+        <p:txBody>
+          <a:bodyPr xmlns:a="http://schemas.openxmlformats.org/drawingml/2006/main" spcFirstLastPara="1" wrap="square" lIns="91425" tIns="91425" rIns="91425" bIns="91425" anchor="ctr">
+            <a:noAutofit/>
+          </a:bodyPr>
+          <a:lstStyle xmlns:a="http://schemas.openxmlformats.org/drawingml/2006/main"/>
+          <a:p xmlns:a="http://schemas.openxmlformats.org/drawingml/2006/main">
+            <a:pPr marL="0" indent="0" algn="ctr">
+              <a:spcBef>
+                <a:spcPts val="0"/>
+              </a:spcBef>
+              <a:spcAft>
+                <a:spcPts val="0"/>
+              </a:spcAft>
+              <a:buNone/>
+            </a:pPr>
+            <a:r>
+              <a:rPr sz="1100">
+                <a:solidFill>
+                  <a:srgbClr val="333333"/>
+                </a:solidFill>
+              </a:rPr>
+              <a:t>T42</a:t>
+            </a:r>
+          </a:p>
+        </p:txBody>
+      </p:sp>
+      <p:sp>
+        <p:nvSpPr>
+          <p:cNvPr id="232" name="Google Shape;232;p24">
+            <a:extLst xmlns:a="http://schemas.openxmlformats.org/drawingml/2006/main">
+              <a:ext uri="{FF2B5EF4-FFF2-40B4-BE49-F238E27FC236}">
+                <a16:creationId xmlns:a16="http://schemas.microsoft.com/office/drawing/2014/main" id="{4259327A-4EE3-4193-B3EA-A049373B1240}"/>
+              </a:ext>
+            </a:extLst>
+          </p:cNvPr>
+          <p:cNvSpPr>
+            <a:spLocks xmlns:a="http://schemas.openxmlformats.org/drawingml/2006/main" noGrp="1"/>
+          </p:cNvSpPr>
+          <p:nvPr/>
+        </p:nvSpPr>
+        <p:spPr>
+          <a:xfrm xmlns:a="http://schemas.openxmlformats.org/drawingml/2006/main">
+            <a:off x="6858000" y="3633297"/>
+            <a:ext cx="533400" cy="2157903"/>
+          </a:xfrm>
+          <a:prstGeom xmlns:a="http://schemas.openxmlformats.org/drawingml/2006/main" prst="rect">
+            <a:avLst/>
+          </a:prstGeom>
+          <a:solidFill xmlns:a="http://schemas.openxmlformats.org/drawingml/2006/main">
+            <a:srgbClr val="ED7D30"/>
+          </a:solidFill>
+          <a:ln xmlns:a="http://schemas.openxmlformats.org/drawingml/2006/main">
+            <a:noFill/>
+          </a:ln>
+        </p:spPr>
+        <p:txBody>
+          <a:bodyPr xmlns:a="http://schemas.openxmlformats.org/drawingml/2006/main" spcFirstLastPara="1" wrap="square" lIns="91425" tIns="91425" rIns="91425" bIns="91425" anchor="ctr">
+            <a:noAutofit/>
+          </a:bodyPr>
+          <a:lstStyle xmlns:a="http://schemas.openxmlformats.org/drawingml/2006/main"/>
+          <a:p xmlns:a="http://schemas.openxmlformats.org/drawingml/2006/main">
+            <a:pPr marL="0" indent="0" algn="ctr">
+              <a:spcBef>
+                <a:spcPts val="0"/>
+              </a:spcBef>
+              <a:spcAft>
+                <a:spcPts val="0"/>
+              </a:spcAft>
+              <a:buNone/>
+            </a:pPr>
+            <a:r>
+              <a:t/>
+            </a:r>
+          </a:p>
+        </p:txBody>
+      </p:sp>
+      <p:sp>
+        <p:nvSpPr>
+          <p:cNvPr id="233" name="Google Shape;233;p24">
+            <a:extLst xmlns:a="http://schemas.openxmlformats.org/drawingml/2006/main">
+              <a:ext uri="{FF2B5EF4-FFF2-40B4-BE49-F238E27FC236}">
+                <a16:creationId xmlns:a16="http://schemas.microsoft.com/office/drawing/2014/main" id="{35E9761B-EBBC-48BE-839C-C6C168A919C8}"/>
+              </a:ext>
+            </a:extLst>
+          </p:cNvPr>
+          <p:cNvSpPr>
+            <a:spLocks xmlns:a="http://schemas.openxmlformats.org/drawingml/2006/main" noGrp="1"/>
+          </p:cNvSpPr>
+          <p:nvPr/>
+        </p:nvSpPr>
+        <p:spPr>
+          <a:xfrm xmlns:a="http://schemas.openxmlformats.org/drawingml/2006/main">
+            <a:off x="6794468" y="3315829"/>
+            <a:ext cx="660273" cy="279273"/>
+          </a:xfrm>
+          <a:prstGeom xmlns:a="http://schemas.openxmlformats.org/drawingml/2006/main" prst="rect">
+            <a:avLst/>
+          </a:prstGeom>
+          <a:noFill xmlns:a="http://schemas.openxmlformats.org/drawingml/2006/main"/>
+          <a:ln xmlns:a="http://schemas.openxmlformats.org/drawingml/2006/main">
+            <a:noFill/>
+          </a:ln>
+        </p:spPr>
+        <p:txBody>
+          <a:bodyPr xmlns:a="http://schemas.openxmlformats.org/drawingml/2006/main" spcFirstLastPara="1" wrap="square" lIns="91425" tIns="91425" rIns="91425" bIns="91425" anchor="ctr">
+            <a:noAutofit/>
+          </a:bodyPr>
+          <a:lstStyle xmlns:a="http://schemas.openxmlformats.org/drawingml/2006/main"/>
+          <a:p xmlns:a="http://schemas.openxmlformats.org/drawingml/2006/main">
+            <a:pPr marL="0" indent="0" algn="ctr">
+              <a:spcBef>
+                <a:spcPts val="0"/>
+              </a:spcBef>
+              <a:spcAft>
+                <a:spcPts val="0"/>
+              </a:spcAft>
+              <a:buNone/>
+            </a:pPr>
+            <a:r>
+              <a:rPr sz="1100" b="1">
+                <a:solidFill>
+                  <a:srgbClr val="333333"/>
+                </a:solidFill>
+              </a:rPr>
+              <a:t>0.925</a:t>
+            </a:r>
+          </a:p>
+        </p:txBody>
+      </p:sp>
+      <p:sp>
+        <p:nvSpPr>
+          <p:cNvPr id="234" name="Google Shape;234;p24">
+            <a:extLst xmlns:a="http://schemas.openxmlformats.org/drawingml/2006/main">
+              <a:ext uri="{FF2B5EF4-FFF2-40B4-BE49-F238E27FC236}">
+                <a16:creationId xmlns:a16="http://schemas.microsoft.com/office/drawing/2014/main" id="{5B0E341C-AE80-41C0-8D3D-2275BBF0ADD2}"/>
+              </a:ext>
+            </a:extLst>
+          </p:cNvPr>
+          <p:cNvSpPr>
+            <a:spLocks xmlns:a="http://schemas.openxmlformats.org/drawingml/2006/main" noGrp="1"/>
+          </p:cNvSpPr>
+          <p:nvPr/>
+        </p:nvSpPr>
+        <p:spPr>
+          <a:xfrm xmlns:a="http://schemas.openxmlformats.org/drawingml/2006/main">
+            <a:off x="6794468" y="5867400"/>
+            <a:ext cx="660273" cy="419100"/>
+          </a:xfrm>
+          <a:prstGeom xmlns:a="http://schemas.openxmlformats.org/drawingml/2006/main" prst="rect">
+            <a:avLst/>
+          </a:prstGeom>
+          <a:noFill xmlns:a="http://schemas.openxmlformats.org/drawingml/2006/main"/>
+          <a:ln xmlns:a="http://schemas.openxmlformats.org/drawingml/2006/main">
+            <a:noFill/>
+          </a:ln>
+        </p:spPr>
+        <p:txBody>
+          <a:bodyPr xmlns:a="http://schemas.openxmlformats.org/drawingml/2006/main" spcFirstLastPara="1" wrap="square" lIns="91425" tIns="91425" rIns="91425" bIns="91425" anchor="ctr">
+            <a:noAutofit/>
+          </a:bodyPr>
+          <a:lstStyle xmlns:a="http://schemas.openxmlformats.org/drawingml/2006/main"/>
+          <a:p xmlns:a="http://schemas.openxmlformats.org/drawingml/2006/main">
+            <a:pPr marL="0" indent="0" algn="ctr">
+              <a:spcBef>
+                <a:spcPts val="0"/>
+              </a:spcBef>
+              <a:spcAft>
+                <a:spcPts val="0"/>
+              </a:spcAft>
+              <a:buNone/>
+            </a:pPr>
+            <a:r>
+              <a:rPr sz="1100">
+                <a:solidFill>
+                  <a:srgbClr val="333333"/>
+                </a:solidFill>
+              </a:rPr>
+              <a:t>T42</a:t>
+            </a:r>
+          </a:p>
+        </p:txBody>
+      </p:sp>
+      <p:sp>
+        <p:nvSpPr>
+          <p:cNvPr id="235" name="Google Shape;235;p24">
+            <a:extLst xmlns:a="http://schemas.openxmlformats.org/drawingml/2006/main">
+              <a:ext uri="{FF2B5EF4-FFF2-40B4-BE49-F238E27FC236}">
+                <a16:creationId xmlns:a16="http://schemas.microsoft.com/office/drawing/2014/main" id="{9D2F9BA8-5E50-4AF8-A708-69B40A34D7DC}"/>
+              </a:ext>
+            </a:extLst>
+          </p:cNvPr>
+          <p:cNvSpPr>
+            <a:spLocks xmlns:a="http://schemas.openxmlformats.org/drawingml/2006/main" noGrp="1"/>
+          </p:cNvSpPr>
+          <p:nvPr/>
+        </p:nvSpPr>
+        <p:spPr>
+          <a:xfrm xmlns:a="http://schemas.openxmlformats.org/drawingml/2006/main">
+            <a:off x="2044732" y="3649609"/>
+            <a:ext cx="533400" cy="2141591"/>
+          </a:xfrm>
+          <a:prstGeom xmlns:a="http://schemas.openxmlformats.org/drawingml/2006/main" prst="rect">
+            <a:avLst/>
+          </a:prstGeom>
+          <a:solidFill xmlns:a="http://schemas.openxmlformats.org/drawingml/2006/main">
+            <a:srgbClr val="2E5496"/>
+          </a:solidFill>
+          <a:ln xmlns:a="http://schemas.openxmlformats.org/drawingml/2006/main">
+            <a:noFill/>
+          </a:ln>
+        </p:spPr>
+        <p:txBody>
+          <a:bodyPr xmlns:a="http://schemas.openxmlformats.org/drawingml/2006/main" spcFirstLastPara="1" wrap="square" lIns="91425" tIns="91425" rIns="91425" bIns="91425" anchor="ctr">
+            <a:noAutofit/>
+          </a:bodyPr>
+          <a:lstStyle xmlns:a="http://schemas.openxmlformats.org/drawingml/2006/main"/>
+          <a:p xmlns:a="http://schemas.openxmlformats.org/drawingml/2006/main">
+            <a:pPr marL="0" indent="0" algn="ctr">
+              <a:spcBef>
+                <a:spcPts val="0"/>
+              </a:spcBef>
+              <a:spcAft>
+                <a:spcPts val="0"/>
+              </a:spcAft>
+              <a:buNone/>
+            </a:pPr>
+            <a:r>
+              <a:t/>
+            </a:r>
+          </a:p>
+        </p:txBody>
+      </p:sp>
+      <p:sp>
+        <p:nvSpPr>
+          <p:cNvPr id="236" name="Google Shape;236;p24">
+            <a:extLst xmlns:a="http://schemas.openxmlformats.org/drawingml/2006/main">
+              <a:ext uri="{FF2B5EF4-FFF2-40B4-BE49-F238E27FC236}">
+                <a16:creationId xmlns:a16="http://schemas.microsoft.com/office/drawing/2014/main" id="{7C852366-3ED7-4301-B0B7-15A5B7E22FF6}"/>
+              </a:ext>
+            </a:extLst>
+          </p:cNvPr>
+          <p:cNvSpPr>
+            <a:spLocks xmlns:a="http://schemas.openxmlformats.org/drawingml/2006/main" noGrp="1"/>
+          </p:cNvSpPr>
+          <p:nvPr/>
+        </p:nvSpPr>
+        <p:spPr>
+          <a:xfrm xmlns:a="http://schemas.openxmlformats.org/drawingml/2006/main">
+            <a:off x="1981200" y="3332141"/>
+            <a:ext cx="660273" cy="279273"/>
+          </a:xfrm>
+          <a:prstGeom xmlns:a="http://schemas.openxmlformats.org/drawingml/2006/main" prst="rect">
+            <a:avLst/>
+          </a:prstGeom>
+          <a:noFill xmlns:a="http://schemas.openxmlformats.org/drawingml/2006/main"/>
+          <a:ln xmlns:a="http://schemas.openxmlformats.org/drawingml/2006/main">
+            <a:noFill/>
+          </a:ln>
+        </p:spPr>
+        <p:txBody>
+          <a:bodyPr xmlns:a="http://schemas.openxmlformats.org/drawingml/2006/main" spcFirstLastPara="1" wrap="square" lIns="91425" tIns="91425" rIns="91425" bIns="91425" anchor="ctr">
+            <a:noAutofit/>
+          </a:bodyPr>
+          <a:lstStyle xmlns:a="http://schemas.openxmlformats.org/drawingml/2006/main"/>
+          <a:p xmlns:a="http://schemas.openxmlformats.org/drawingml/2006/main">
+            <a:pPr marL="0" indent="0" algn="ctr">
+              <a:spcBef>
+                <a:spcPts val="0"/>
+              </a:spcBef>
+              <a:spcAft>
+                <a:spcPts val="0"/>
+              </a:spcAft>
+              <a:buNone/>
+            </a:pPr>
+            <a:r>
+              <a:rPr sz="1100" b="1">
+                <a:solidFill>
+                  <a:srgbClr val="333333"/>
+                </a:solidFill>
+              </a:rPr>
+              <a:t>91.77%</a:t>
+            </a:r>
+          </a:p>
+        </p:txBody>
+      </p:sp>
+      <p:sp>
+        <p:nvSpPr>
+          <p:cNvPr id="237" name="Google Shape;237;p24">
+            <a:extLst xmlns:a="http://schemas.openxmlformats.org/drawingml/2006/main">
+              <a:ext uri="{FF2B5EF4-FFF2-40B4-BE49-F238E27FC236}">
+                <a16:creationId xmlns:a16="http://schemas.microsoft.com/office/drawing/2014/main" id="{54A865A6-9679-4330-9417-8AD67C6FA599}"/>
+              </a:ext>
+            </a:extLst>
+          </p:cNvPr>
+          <p:cNvSpPr>
+            <a:spLocks xmlns:a="http://schemas.openxmlformats.org/drawingml/2006/main" noGrp="1"/>
+          </p:cNvSpPr>
+          <p:nvPr/>
+        </p:nvSpPr>
+        <p:spPr>
+          <a:xfrm xmlns:a="http://schemas.openxmlformats.org/drawingml/2006/main">
+            <a:off x="1981200" y="5867400"/>
+            <a:ext cx="660273" cy="419100"/>
+          </a:xfrm>
+          <a:prstGeom xmlns:a="http://schemas.openxmlformats.org/drawingml/2006/main" prst="rect">
+            <a:avLst/>
+          </a:prstGeom>
+          <a:noFill xmlns:a="http://schemas.openxmlformats.org/drawingml/2006/main"/>
+          <a:ln xmlns:a="http://schemas.openxmlformats.org/drawingml/2006/main">
+            <a:noFill/>
+          </a:ln>
+        </p:spPr>
+        <p:txBody>
+          <a:bodyPr xmlns:a="http://schemas.openxmlformats.org/drawingml/2006/main" spcFirstLastPara="1" wrap="square" lIns="91425" tIns="91425" rIns="91425" bIns="91425" anchor="ctr">
+            <a:noAutofit/>
+          </a:bodyPr>
+          <a:lstStyle xmlns:a="http://schemas.openxmlformats.org/drawingml/2006/main"/>
+          <a:p xmlns:a="http://schemas.openxmlformats.org/drawingml/2006/main">
+            <a:pPr marL="0" indent="0" algn="ctr">
+              <a:spcBef>
+                <a:spcPts val="0"/>
+              </a:spcBef>
+              <a:spcAft>
+                <a:spcPts val="0"/>
+              </a:spcAft>
+              <a:buNone/>
+            </a:pPr>
+            <a:r>
+              <a:rPr sz="1100">
+                <a:solidFill>
+                  <a:srgbClr val="333333"/>
+                </a:solidFill>
+              </a:rPr>
+              <a:t>T43</a:t>
+            </a:r>
+          </a:p>
+        </p:txBody>
+      </p:sp>
+      <p:sp>
+        <p:nvSpPr>
+          <p:cNvPr id="238" name="Google Shape;238;p24">
+            <a:extLst xmlns:a="http://schemas.openxmlformats.org/drawingml/2006/main">
+              <a:ext uri="{FF2B5EF4-FFF2-40B4-BE49-F238E27FC236}">
+                <a16:creationId xmlns:a16="http://schemas.microsoft.com/office/drawing/2014/main" id="{A92C332C-C659-4C97-9748-7ACA7B75102F}"/>
+              </a:ext>
+            </a:extLst>
+          </p:cNvPr>
+          <p:cNvSpPr>
+            <a:spLocks xmlns:a="http://schemas.openxmlformats.org/drawingml/2006/main" noGrp="1"/>
+          </p:cNvSpPr>
+          <p:nvPr/>
+        </p:nvSpPr>
+        <p:spPr>
+          <a:xfrm xmlns:a="http://schemas.openxmlformats.org/drawingml/2006/main">
+            <a:off x="7696200" y="3666434"/>
+            <a:ext cx="533400" cy="2124766"/>
+          </a:xfrm>
+          <a:prstGeom xmlns:a="http://schemas.openxmlformats.org/drawingml/2006/main" prst="rect">
+            <a:avLst/>
+          </a:prstGeom>
+          <a:solidFill xmlns:a="http://schemas.openxmlformats.org/drawingml/2006/main">
+            <a:srgbClr val="ED7D30"/>
+          </a:solidFill>
+          <a:ln xmlns:a="http://schemas.openxmlformats.org/drawingml/2006/main">
+            <a:noFill/>
+          </a:ln>
+        </p:spPr>
+        <p:txBody>
+          <a:bodyPr xmlns:a="http://schemas.openxmlformats.org/drawingml/2006/main" spcFirstLastPara="1" wrap="square" lIns="91425" tIns="91425" rIns="91425" bIns="91425" anchor="ctr">
+            <a:noAutofit/>
+          </a:bodyPr>
+          <a:lstStyle xmlns:a="http://schemas.openxmlformats.org/drawingml/2006/main"/>
+          <a:p xmlns:a="http://schemas.openxmlformats.org/drawingml/2006/main">
+            <a:pPr marL="0" indent="0" algn="ctr">
+              <a:spcBef>
+                <a:spcPts val="0"/>
+              </a:spcBef>
+              <a:spcAft>
+                <a:spcPts val="0"/>
+              </a:spcAft>
+              <a:buNone/>
+            </a:pPr>
+            <a:r>
+              <a:t/>
+            </a:r>
+          </a:p>
+        </p:txBody>
+      </p:sp>
+      <p:sp>
+        <p:nvSpPr>
+          <p:cNvPr id="239" name="Google Shape;239;p24">
+            <a:extLst xmlns:a="http://schemas.openxmlformats.org/drawingml/2006/main">
+              <a:ext uri="{FF2B5EF4-FFF2-40B4-BE49-F238E27FC236}">
+                <a16:creationId xmlns:a16="http://schemas.microsoft.com/office/drawing/2014/main" id="{7ACB9D0F-EBCE-4CA8-8E60-F9B86F2368A3}"/>
+              </a:ext>
+            </a:extLst>
+          </p:cNvPr>
+          <p:cNvSpPr>
+            <a:spLocks xmlns:a="http://schemas.openxmlformats.org/drawingml/2006/main" noGrp="1"/>
+          </p:cNvSpPr>
+          <p:nvPr/>
+        </p:nvSpPr>
+        <p:spPr>
+          <a:xfrm xmlns:a="http://schemas.openxmlformats.org/drawingml/2006/main">
+            <a:off x="7632668" y="3348966"/>
+            <a:ext cx="660273" cy="279273"/>
+          </a:xfrm>
+          <a:prstGeom xmlns:a="http://schemas.openxmlformats.org/drawingml/2006/main" prst="rect">
+            <a:avLst/>
+          </a:prstGeom>
+          <a:noFill xmlns:a="http://schemas.openxmlformats.org/drawingml/2006/main"/>
+          <a:ln xmlns:a="http://schemas.openxmlformats.org/drawingml/2006/main">
+            <a:noFill/>
+          </a:ln>
+        </p:spPr>
+        <p:txBody>
+          <a:bodyPr xmlns:a="http://schemas.openxmlformats.org/drawingml/2006/main" spcFirstLastPara="1" wrap="square" lIns="91425" tIns="91425" rIns="91425" bIns="91425" anchor="ctr">
+            <a:noAutofit/>
+          </a:bodyPr>
+          <a:lstStyle xmlns:a="http://schemas.openxmlformats.org/drawingml/2006/main"/>
+          <a:p xmlns:a="http://schemas.openxmlformats.org/drawingml/2006/main">
+            <a:pPr marL="0" indent="0" algn="ctr">
+              <a:spcBef>
+                <a:spcPts val="0"/>
+              </a:spcBef>
+              <a:spcAft>
+                <a:spcPts val="0"/>
+              </a:spcAft>
+              <a:buNone/>
+            </a:pPr>
+            <a:r>
+              <a:rPr sz="1100" b="1">
+                <a:solidFill>
+                  <a:srgbClr val="333333"/>
+                </a:solidFill>
+              </a:rPr>
+              <a:t>0.910</a:t>
+            </a:r>
+          </a:p>
+        </p:txBody>
+      </p:sp>
+      <p:sp>
+        <p:nvSpPr>
+          <p:cNvPr id="240" name="Google Shape;240;p24">
+            <a:extLst xmlns:a="http://schemas.openxmlformats.org/drawingml/2006/main">
+              <a:ext uri="{FF2B5EF4-FFF2-40B4-BE49-F238E27FC236}">
+                <a16:creationId xmlns:a16="http://schemas.microsoft.com/office/drawing/2014/main" id="{3C4B027B-6184-4E32-8208-F8CA608A533A}"/>
+              </a:ext>
+            </a:extLst>
+          </p:cNvPr>
+          <p:cNvSpPr>
+            <a:spLocks xmlns:a="http://schemas.openxmlformats.org/drawingml/2006/main" noGrp="1"/>
+          </p:cNvSpPr>
+          <p:nvPr/>
+        </p:nvSpPr>
+        <p:spPr>
+          <a:xfrm xmlns:a="http://schemas.openxmlformats.org/drawingml/2006/main">
+            <a:off x="7632668" y="5867400"/>
+            <a:ext cx="660273" cy="419100"/>
+          </a:xfrm>
+          <a:prstGeom xmlns:a="http://schemas.openxmlformats.org/drawingml/2006/main" prst="rect">
+            <a:avLst/>
+          </a:prstGeom>
+          <a:noFill xmlns:a="http://schemas.openxmlformats.org/drawingml/2006/main"/>
+          <a:ln xmlns:a="http://schemas.openxmlformats.org/drawingml/2006/main">
+            <a:noFill/>
+          </a:ln>
+        </p:spPr>
+        <p:txBody>
+          <a:bodyPr xmlns:a="http://schemas.openxmlformats.org/drawingml/2006/main" spcFirstLastPara="1" wrap="square" lIns="91425" tIns="91425" rIns="91425" bIns="91425" anchor="ctr">
+            <a:noAutofit/>
+          </a:bodyPr>
+          <a:lstStyle xmlns:a="http://schemas.openxmlformats.org/drawingml/2006/main"/>
+          <a:p xmlns:a="http://schemas.openxmlformats.org/drawingml/2006/main">
+            <a:pPr marL="0" indent="0" algn="ctr">
+              <a:spcBef>
+                <a:spcPts val="0"/>
+              </a:spcBef>
+              <a:spcAft>
+                <a:spcPts val="0"/>
+              </a:spcAft>
+              <a:buNone/>
+            </a:pPr>
+            <a:r>
+              <a:rPr sz="1100">
+                <a:solidFill>
+                  <a:srgbClr val="333333"/>
+                </a:solidFill>
+              </a:rPr>
+              <a:t>T43</a:t>
+            </a:r>
+          </a:p>
+        </p:txBody>
+      </p:sp>
+      <p:sp>
+        <p:nvSpPr>
+          <p:cNvPr id="241" name="Google Shape;241;p24">
+            <a:extLst xmlns:a="http://schemas.openxmlformats.org/drawingml/2006/main">
+              <a:ext uri="{FF2B5EF4-FFF2-40B4-BE49-F238E27FC236}">
+                <a16:creationId xmlns:a16="http://schemas.microsoft.com/office/drawing/2014/main" id="{BFFD5909-39F1-4DF7-97AE-55B7D5F199B9}"/>
+              </a:ext>
+            </a:extLst>
+          </p:cNvPr>
+          <p:cNvSpPr>
+            <a:spLocks xmlns:a="http://schemas.openxmlformats.org/drawingml/2006/main" noGrp="1"/>
+          </p:cNvSpPr>
+          <p:nvPr/>
+        </p:nvSpPr>
+        <p:spPr>
+          <a:xfrm xmlns:a="http://schemas.openxmlformats.org/drawingml/2006/main">
+            <a:off x="2882932" y="3626809"/>
+            <a:ext cx="533400" cy="2164391"/>
+          </a:xfrm>
+          <a:prstGeom xmlns:a="http://schemas.openxmlformats.org/drawingml/2006/main" prst="rect">
+            <a:avLst/>
+          </a:prstGeom>
+          <a:solidFill xmlns:a="http://schemas.openxmlformats.org/drawingml/2006/main">
+            <a:srgbClr val="2E5496"/>
+          </a:solidFill>
+          <a:ln xmlns:a="http://schemas.openxmlformats.org/drawingml/2006/main">
+            <a:noFill/>
+          </a:ln>
+        </p:spPr>
+        <p:txBody>
+          <a:bodyPr xmlns:a="http://schemas.openxmlformats.org/drawingml/2006/main" spcFirstLastPara="1" wrap="square" lIns="91425" tIns="91425" rIns="91425" bIns="91425" anchor="ctr">
+            <a:noAutofit/>
+          </a:bodyPr>
+          <a:lstStyle xmlns:a="http://schemas.openxmlformats.org/drawingml/2006/main"/>
+          <a:p xmlns:a="http://schemas.openxmlformats.org/drawingml/2006/main">
+            <a:pPr marL="0" indent="0" algn="ctr">
+              <a:spcBef>
+                <a:spcPts val="0"/>
+              </a:spcBef>
+              <a:spcAft>
+                <a:spcPts val="0"/>
+              </a:spcAft>
+              <a:buNone/>
+            </a:pPr>
+            <a:r>
+              <a:t/>
+            </a:r>
+          </a:p>
+        </p:txBody>
+      </p:sp>
+      <p:sp>
+        <p:nvSpPr>
+          <p:cNvPr id="242" name="Google Shape;242;p24">
+            <a:extLst xmlns:a="http://schemas.openxmlformats.org/drawingml/2006/main">
+              <a:ext uri="{FF2B5EF4-FFF2-40B4-BE49-F238E27FC236}">
+                <a16:creationId xmlns:a16="http://schemas.microsoft.com/office/drawing/2014/main" id="{0EDC3AFF-87BC-43A7-ACAA-7C7B506CFF4B}"/>
+              </a:ext>
+            </a:extLst>
+          </p:cNvPr>
+          <p:cNvSpPr>
+            <a:spLocks xmlns:a="http://schemas.openxmlformats.org/drawingml/2006/main" noGrp="1"/>
+          </p:cNvSpPr>
+          <p:nvPr/>
+        </p:nvSpPr>
+        <p:spPr>
+          <a:xfrm xmlns:a="http://schemas.openxmlformats.org/drawingml/2006/main">
+            <a:off x="2819400" y="3309341"/>
+            <a:ext cx="660273" cy="279273"/>
+          </a:xfrm>
+          <a:prstGeom xmlns:a="http://schemas.openxmlformats.org/drawingml/2006/main" prst="rect">
+            <a:avLst/>
+          </a:prstGeom>
+          <a:noFill xmlns:a="http://schemas.openxmlformats.org/drawingml/2006/main"/>
+          <a:ln xmlns:a="http://schemas.openxmlformats.org/drawingml/2006/main">
+            <a:noFill/>
+          </a:ln>
+        </p:spPr>
+        <p:txBody>
+          <a:bodyPr xmlns:a="http://schemas.openxmlformats.org/drawingml/2006/main" spcFirstLastPara="1" wrap="square" lIns="91425" tIns="91425" rIns="91425" bIns="91425" anchor="ctr">
+            <a:noAutofit/>
+          </a:bodyPr>
+          <a:lstStyle xmlns:a="http://schemas.openxmlformats.org/drawingml/2006/main"/>
+          <a:p xmlns:a="http://schemas.openxmlformats.org/drawingml/2006/main">
+            <a:pPr marL="0" indent="0" algn="ctr">
+              <a:spcBef>
+                <a:spcPts val="0"/>
+              </a:spcBef>
+              <a:spcAft>
+                <a:spcPts val="0"/>
+              </a:spcAft>
+              <a:buNone/>
+            </a:pPr>
+            <a:r>
+              <a:rPr sz="1100" b="1">
+                <a:solidFill>
+                  <a:srgbClr val="333333"/>
+                </a:solidFill>
+              </a:rPr>
+              <a:t>92.75%</a:t>
+            </a:r>
+          </a:p>
+        </p:txBody>
+      </p:sp>
+      <p:sp>
+        <p:nvSpPr>
+          <p:cNvPr id="243" name="Google Shape;243;p24">
+            <a:extLst xmlns:a="http://schemas.openxmlformats.org/drawingml/2006/main">
+              <a:ext uri="{FF2B5EF4-FFF2-40B4-BE49-F238E27FC236}">
+                <a16:creationId xmlns:a16="http://schemas.microsoft.com/office/drawing/2014/main" id="{92A8445F-1FB0-4697-9F9D-FF59D9D81A29}"/>
+              </a:ext>
+            </a:extLst>
+          </p:cNvPr>
+          <p:cNvSpPr>
+            <a:spLocks xmlns:a="http://schemas.openxmlformats.org/drawingml/2006/main" noGrp="1"/>
+          </p:cNvSpPr>
+          <p:nvPr/>
+        </p:nvSpPr>
+        <p:spPr>
+          <a:xfrm xmlns:a="http://schemas.openxmlformats.org/drawingml/2006/main">
+            <a:off x="2819400" y="5867400"/>
+            <a:ext cx="660273" cy="419100"/>
+          </a:xfrm>
+          <a:prstGeom xmlns:a="http://schemas.openxmlformats.org/drawingml/2006/main" prst="rect">
+            <a:avLst/>
+          </a:prstGeom>
+          <a:noFill xmlns:a="http://schemas.openxmlformats.org/drawingml/2006/main"/>
+          <a:ln xmlns:a="http://schemas.openxmlformats.org/drawingml/2006/main">
+            <a:noFill/>
+          </a:ln>
+        </p:spPr>
+        <p:txBody>
+          <a:bodyPr xmlns:a="http://schemas.openxmlformats.org/drawingml/2006/main" spcFirstLastPara="1" wrap="square" lIns="91425" tIns="91425" rIns="91425" bIns="91425" anchor="ctr">
+            <a:noAutofit/>
+          </a:bodyPr>
+          <a:lstStyle xmlns:a="http://schemas.openxmlformats.org/drawingml/2006/main"/>
+          <a:p xmlns:a="http://schemas.openxmlformats.org/drawingml/2006/main">
+            <a:pPr marL="0" indent="0" algn="ctr">
+              <a:spcBef>
+                <a:spcPts val="0"/>
+              </a:spcBef>
+              <a:spcAft>
+                <a:spcPts val="0"/>
+              </a:spcAft>
+              <a:buNone/>
+            </a:pPr>
+            <a:r>
+              <a:rPr sz="1100">
+                <a:solidFill>
+                  <a:srgbClr val="333333"/>
+                </a:solidFill>
+              </a:rPr>
+              <a:t>T44</a:t>
+            </a:r>
+          </a:p>
+        </p:txBody>
+      </p:sp>
+      <p:sp>
+        <p:nvSpPr>
+          <p:cNvPr id="244" name="Google Shape;244;p24">
+            <a:extLst xmlns:a="http://schemas.openxmlformats.org/drawingml/2006/main">
+              <a:ext uri="{FF2B5EF4-FFF2-40B4-BE49-F238E27FC236}">
+                <a16:creationId xmlns:a16="http://schemas.microsoft.com/office/drawing/2014/main" id="{7D97596A-3BFB-497A-84E3-7D68FACCA1A5}"/>
+              </a:ext>
+            </a:extLst>
+          </p:cNvPr>
+          <p:cNvSpPr>
+            <a:spLocks xmlns:a="http://schemas.openxmlformats.org/drawingml/2006/main" noGrp="1"/>
+          </p:cNvSpPr>
+          <p:nvPr/>
+        </p:nvSpPr>
+        <p:spPr>
+          <a:xfrm xmlns:a="http://schemas.openxmlformats.org/drawingml/2006/main">
+            <a:off x="8534400" y="3640298"/>
+            <a:ext cx="533400" cy="2150902"/>
+          </a:xfrm>
+          <a:prstGeom xmlns:a="http://schemas.openxmlformats.org/drawingml/2006/main" prst="rect">
+            <a:avLst/>
+          </a:prstGeom>
+          <a:solidFill xmlns:a="http://schemas.openxmlformats.org/drawingml/2006/main">
+            <a:srgbClr val="ED7D30"/>
+          </a:solidFill>
+          <a:ln xmlns:a="http://schemas.openxmlformats.org/drawingml/2006/main">
+            <a:noFill/>
+          </a:ln>
+        </p:spPr>
+        <p:txBody>
+          <a:bodyPr xmlns:a="http://schemas.openxmlformats.org/drawingml/2006/main" spcFirstLastPara="1" wrap="square" lIns="91425" tIns="91425" rIns="91425" bIns="91425" anchor="ctr">
+            <a:noAutofit/>
+          </a:bodyPr>
+          <a:lstStyle xmlns:a="http://schemas.openxmlformats.org/drawingml/2006/main"/>
+          <a:p xmlns:a="http://schemas.openxmlformats.org/drawingml/2006/main">
+            <a:pPr marL="0" indent="0" algn="ctr">
+              <a:spcBef>
+                <a:spcPts val="0"/>
+              </a:spcBef>
+              <a:spcAft>
+                <a:spcPts val="0"/>
+              </a:spcAft>
+              <a:buNone/>
+            </a:pPr>
+            <a:r>
+              <a:t/>
+            </a:r>
+          </a:p>
+        </p:txBody>
+      </p:sp>
+      <p:sp>
+        <p:nvSpPr>
+          <p:cNvPr id="245" name="Google Shape;245;p24">
+            <a:extLst xmlns:a="http://schemas.openxmlformats.org/drawingml/2006/main">
+              <a:ext uri="{FF2B5EF4-FFF2-40B4-BE49-F238E27FC236}">
+                <a16:creationId xmlns:a16="http://schemas.microsoft.com/office/drawing/2014/main" id="{073981FC-B440-4AA1-924E-FD17CE1660DA}"/>
+              </a:ext>
+            </a:extLst>
+          </p:cNvPr>
+          <p:cNvSpPr>
+            <a:spLocks xmlns:a="http://schemas.openxmlformats.org/drawingml/2006/main" noGrp="1"/>
+          </p:cNvSpPr>
+          <p:nvPr/>
+        </p:nvSpPr>
+        <p:spPr>
+          <a:xfrm xmlns:a="http://schemas.openxmlformats.org/drawingml/2006/main">
+            <a:off x="8470868" y="3322830"/>
+            <a:ext cx="660273" cy="279273"/>
+          </a:xfrm>
+          <a:prstGeom xmlns:a="http://schemas.openxmlformats.org/drawingml/2006/main" prst="rect">
+            <a:avLst/>
+          </a:prstGeom>
+          <a:noFill xmlns:a="http://schemas.openxmlformats.org/drawingml/2006/main"/>
+          <a:ln xmlns:a="http://schemas.openxmlformats.org/drawingml/2006/main">
+            <a:noFill/>
+          </a:ln>
+        </p:spPr>
+        <p:txBody>
+          <a:bodyPr xmlns:a="http://schemas.openxmlformats.org/drawingml/2006/main" spcFirstLastPara="1" wrap="square" lIns="91425" tIns="91425" rIns="91425" bIns="91425" anchor="ctr">
+            <a:noAutofit/>
+          </a:bodyPr>
+          <a:lstStyle xmlns:a="http://schemas.openxmlformats.org/drawingml/2006/main"/>
+          <a:p xmlns:a="http://schemas.openxmlformats.org/drawingml/2006/main">
+            <a:pPr marL="0" indent="0" algn="ctr">
+              <a:spcBef>
+                <a:spcPts val="0"/>
+              </a:spcBef>
+              <a:spcAft>
+                <a:spcPts val="0"/>
+              </a:spcAft>
+              <a:buNone/>
+            </a:pPr>
+            <a:r>
+              <a:rPr sz="1100" b="1">
+                <a:solidFill>
+                  <a:srgbClr val="333333"/>
+                </a:solidFill>
+              </a:rPr>
+              <a:t>0.922</a:t>
+            </a:r>
+          </a:p>
+        </p:txBody>
+      </p:sp>
+      <p:sp>
+        <p:nvSpPr>
+          <p:cNvPr id="246" name="Google Shape;246;p24">
+            <a:extLst xmlns:a="http://schemas.openxmlformats.org/drawingml/2006/main">
+              <a:ext uri="{FF2B5EF4-FFF2-40B4-BE49-F238E27FC236}">
+                <a16:creationId xmlns:a16="http://schemas.microsoft.com/office/drawing/2014/main" id="{67912E2C-D43C-462D-8941-AFD494C9023A}"/>
+              </a:ext>
+            </a:extLst>
+          </p:cNvPr>
+          <p:cNvSpPr>
+            <a:spLocks xmlns:a="http://schemas.openxmlformats.org/drawingml/2006/main" noGrp="1"/>
+          </p:cNvSpPr>
+          <p:nvPr/>
+        </p:nvSpPr>
+        <p:spPr>
+          <a:xfrm xmlns:a="http://schemas.openxmlformats.org/drawingml/2006/main">
+            <a:off x="8470868" y="5867400"/>
+            <a:ext cx="660273" cy="419100"/>
+          </a:xfrm>
+          <a:prstGeom xmlns:a="http://schemas.openxmlformats.org/drawingml/2006/main" prst="rect">
+            <a:avLst/>
+          </a:prstGeom>
+          <a:noFill xmlns:a="http://schemas.openxmlformats.org/drawingml/2006/main"/>
+          <a:ln xmlns:a="http://schemas.openxmlformats.org/drawingml/2006/main">
+            <a:noFill/>
+          </a:ln>
+        </p:spPr>
+        <p:txBody>
+          <a:bodyPr xmlns:a="http://schemas.openxmlformats.org/drawingml/2006/main" spcFirstLastPara="1" wrap="square" lIns="91425" tIns="91425" rIns="91425" bIns="91425" anchor="ctr">
+            <a:noAutofit/>
+          </a:bodyPr>
+          <a:lstStyle xmlns:a="http://schemas.openxmlformats.org/drawingml/2006/main"/>
+          <a:p xmlns:a="http://schemas.openxmlformats.org/drawingml/2006/main">
+            <a:pPr marL="0" indent="0" algn="ctr">
+              <a:spcBef>
+                <a:spcPts val="0"/>
+              </a:spcBef>
+              <a:spcAft>
+                <a:spcPts val="0"/>
+              </a:spcAft>
+              <a:buNone/>
+            </a:pPr>
+            <a:r>
+              <a:rPr sz="1100">
+                <a:solidFill>
+                  <a:srgbClr val="333333"/>
+                </a:solidFill>
+              </a:rPr>
+              <a:t>T44</a:t>
+            </a:r>
+          </a:p>
+        </p:txBody>
+      </p:sp>
+      <p:sp>
+        <p:nvSpPr>
+          <p:cNvPr id="247" name="Google Shape;247;p24">
+            <a:extLst xmlns:a="http://schemas.openxmlformats.org/drawingml/2006/main">
+              <a:ext uri="{FF2B5EF4-FFF2-40B4-BE49-F238E27FC236}">
+                <a16:creationId xmlns:a16="http://schemas.microsoft.com/office/drawing/2014/main" id="{6739EDC7-344C-4B71-A3C7-39707247AE88}"/>
+              </a:ext>
+            </a:extLst>
+          </p:cNvPr>
+          <p:cNvSpPr>
+            <a:spLocks xmlns:a="http://schemas.openxmlformats.org/drawingml/2006/main" noGrp="1"/>
+          </p:cNvSpPr>
+          <p:nvPr/>
+        </p:nvSpPr>
+        <p:spPr>
+          <a:xfrm xmlns:a="http://schemas.openxmlformats.org/drawingml/2006/main">
+            <a:off x="3721132" y="3633320"/>
+            <a:ext cx="533400" cy="2157880"/>
+          </a:xfrm>
+          <a:prstGeom xmlns:a="http://schemas.openxmlformats.org/drawingml/2006/main" prst="rect">
+            <a:avLst/>
+          </a:prstGeom>
+          <a:solidFill xmlns:a="http://schemas.openxmlformats.org/drawingml/2006/main">
+            <a:srgbClr val="2E5496"/>
+          </a:solidFill>
+          <a:ln xmlns:a="http://schemas.openxmlformats.org/drawingml/2006/main">
+            <a:noFill/>
+          </a:ln>
+        </p:spPr>
+        <p:txBody>
+          <a:bodyPr xmlns:a="http://schemas.openxmlformats.org/drawingml/2006/main" spcFirstLastPara="1" wrap="square" lIns="91425" tIns="91425" rIns="91425" bIns="91425" anchor="ctr">
+            <a:noAutofit/>
+          </a:bodyPr>
+          <a:lstStyle xmlns:a="http://schemas.openxmlformats.org/drawingml/2006/main"/>
+          <a:p xmlns:a="http://schemas.openxmlformats.org/drawingml/2006/main">
+            <a:pPr marL="0" indent="0" algn="ctr">
+              <a:spcBef>
+                <a:spcPts val="0"/>
+              </a:spcBef>
+              <a:spcAft>
+                <a:spcPts val="0"/>
+              </a:spcAft>
+              <a:buNone/>
+            </a:pPr>
+            <a:r>
+              <a:t/>
+            </a:r>
+          </a:p>
+        </p:txBody>
+      </p:sp>
+      <p:sp>
+        <p:nvSpPr>
+          <p:cNvPr id="248" name="Google Shape;248;p24">
+            <a:extLst xmlns:a="http://schemas.openxmlformats.org/drawingml/2006/main">
+              <a:ext uri="{FF2B5EF4-FFF2-40B4-BE49-F238E27FC236}">
+                <a16:creationId xmlns:a16="http://schemas.microsoft.com/office/drawing/2014/main" id="{32CBA057-F3DF-4116-A45C-91F8FF45B172}"/>
+              </a:ext>
+            </a:extLst>
+          </p:cNvPr>
+          <p:cNvSpPr>
+            <a:spLocks xmlns:a="http://schemas.openxmlformats.org/drawingml/2006/main" noGrp="1"/>
+          </p:cNvSpPr>
+          <p:nvPr/>
+        </p:nvSpPr>
+        <p:spPr>
+          <a:xfrm xmlns:a="http://schemas.openxmlformats.org/drawingml/2006/main">
+            <a:off x="3657600" y="3315852"/>
+            <a:ext cx="660273" cy="279273"/>
+          </a:xfrm>
+          <a:prstGeom xmlns:a="http://schemas.openxmlformats.org/drawingml/2006/main" prst="rect">
+            <a:avLst/>
+          </a:prstGeom>
+          <a:noFill xmlns:a="http://schemas.openxmlformats.org/drawingml/2006/main"/>
+          <a:ln xmlns:a="http://schemas.openxmlformats.org/drawingml/2006/main">
+            <a:noFill/>
+          </a:ln>
+        </p:spPr>
+        <p:txBody>
+          <a:bodyPr xmlns:a="http://schemas.openxmlformats.org/drawingml/2006/main" spcFirstLastPara="1" wrap="square" lIns="91425" tIns="91425" rIns="91425" bIns="91425" anchor="ctr">
+            <a:noAutofit/>
+          </a:bodyPr>
+          <a:lstStyle xmlns:a="http://schemas.openxmlformats.org/drawingml/2006/main"/>
+          <a:p xmlns:a="http://schemas.openxmlformats.org/drawingml/2006/main">
+            <a:pPr marL="0" indent="0" algn="ctr">
+              <a:spcBef>
+                <a:spcPts val="0"/>
+              </a:spcBef>
+              <a:spcAft>
+                <a:spcPts val="0"/>
+              </a:spcAft>
+              <a:buNone/>
+            </a:pPr>
+            <a:r>
+              <a:rPr sz="1100" b="1">
+                <a:solidFill>
+                  <a:srgbClr val="333333"/>
+                </a:solidFill>
+              </a:rPr>
+              <a:t>92.47%</a:t>
+            </a:r>
+          </a:p>
+        </p:txBody>
+      </p:sp>
+      <p:sp>
+        <p:nvSpPr>
+          <p:cNvPr id="249" name="Google Shape;249;p24">
+            <a:extLst xmlns:a="http://schemas.openxmlformats.org/drawingml/2006/main">
+              <a:ext uri="{FF2B5EF4-FFF2-40B4-BE49-F238E27FC236}">
+                <a16:creationId xmlns:a16="http://schemas.microsoft.com/office/drawing/2014/main" id="{7C480CCA-4BBA-499D-9F9D-EFE2E5E5E2AB}"/>
+              </a:ext>
+            </a:extLst>
+          </p:cNvPr>
+          <p:cNvSpPr>
+            <a:spLocks xmlns:a="http://schemas.openxmlformats.org/drawingml/2006/main" noGrp="1"/>
+          </p:cNvSpPr>
+          <p:nvPr/>
+        </p:nvSpPr>
+        <p:spPr>
+          <a:xfrm xmlns:a="http://schemas.openxmlformats.org/drawingml/2006/main">
+            <a:off x="3657600" y="5867400"/>
+            <a:ext cx="660273" cy="419100"/>
+          </a:xfrm>
+          <a:prstGeom xmlns:a="http://schemas.openxmlformats.org/drawingml/2006/main" prst="rect">
+            <a:avLst/>
+          </a:prstGeom>
+          <a:noFill xmlns:a="http://schemas.openxmlformats.org/drawingml/2006/main"/>
+          <a:ln xmlns:a="http://schemas.openxmlformats.org/drawingml/2006/main">
+            <a:noFill/>
+          </a:ln>
+        </p:spPr>
+        <p:txBody>
+          <a:bodyPr xmlns:a="http://schemas.openxmlformats.org/drawingml/2006/main" spcFirstLastPara="1" wrap="square" lIns="91425" tIns="91425" rIns="91425" bIns="91425" anchor="ctr">
+            <a:noAutofit/>
+          </a:bodyPr>
+          <a:lstStyle xmlns:a="http://schemas.openxmlformats.org/drawingml/2006/main"/>
+          <a:p xmlns:a="http://schemas.openxmlformats.org/drawingml/2006/main">
+            <a:pPr marL="0" indent="0" algn="ctr">
+              <a:spcBef>
+                <a:spcPts val="0"/>
+              </a:spcBef>
+              <a:spcAft>
+                <a:spcPts val="0"/>
+              </a:spcAft>
+              <a:buNone/>
+            </a:pPr>
+            <a:r>
+              <a:rPr sz="1100">
+                <a:solidFill>
+                  <a:srgbClr val="333333"/>
+                </a:solidFill>
+              </a:rPr>
+              <a:t>T mean</a:t>
+            </a:r>
+          </a:p>
+        </p:txBody>
+      </p:sp>
+      <p:sp>
+        <p:nvSpPr>
+          <p:cNvPr id="250" name="Google Shape;250;p24">
+            <a:extLst xmlns:a="http://schemas.openxmlformats.org/drawingml/2006/main">
+              <a:ext uri="{FF2B5EF4-FFF2-40B4-BE49-F238E27FC236}">
+                <a16:creationId xmlns:a16="http://schemas.microsoft.com/office/drawing/2014/main" id="{DCEA9562-EA77-4405-83E7-AB9A14F739B9}"/>
+              </a:ext>
+            </a:extLst>
+          </p:cNvPr>
+          <p:cNvSpPr>
+            <a:spLocks xmlns:a="http://schemas.openxmlformats.org/drawingml/2006/main" noGrp="1"/>
+          </p:cNvSpPr>
+          <p:nvPr/>
+        </p:nvSpPr>
+        <p:spPr>
+          <a:xfrm xmlns:a="http://schemas.openxmlformats.org/drawingml/2006/main">
+            <a:off x="9372600" y="3646832"/>
+            <a:ext cx="533400" cy="2144368"/>
+          </a:xfrm>
+          <a:prstGeom xmlns:a="http://schemas.openxmlformats.org/drawingml/2006/main" prst="rect">
+            <a:avLst/>
+          </a:prstGeom>
+          <a:solidFill xmlns:a="http://schemas.openxmlformats.org/drawingml/2006/main">
+            <a:srgbClr val="ED7D30"/>
+          </a:solidFill>
+          <a:ln xmlns:a="http://schemas.openxmlformats.org/drawingml/2006/main">
+            <a:noFill/>
+          </a:ln>
+        </p:spPr>
+        <p:txBody>
+          <a:bodyPr xmlns:a="http://schemas.openxmlformats.org/drawingml/2006/main" spcFirstLastPara="1" wrap="square" lIns="91425" tIns="91425" rIns="91425" bIns="91425" anchor="ctr">
+            <a:noAutofit/>
+          </a:bodyPr>
+          <a:lstStyle xmlns:a="http://schemas.openxmlformats.org/drawingml/2006/main"/>
+          <a:p xmlns:a="http://schemas.openxmlformats.org/drawingml/2006/main">
+            <a:pPr marL="0" indent="0" algn="ctr">
+              <a:spcBef>
+                <a:spcPts val="0"/>
+              </a:spcBef>
+              <a:spcAft>
+                <a:spcPts val="0"/>
+              </a:spcAft>
+              <a:buNone/>
+            </a:pPr>
+            <a:r>
+              <a:t/>
+            </a:r>
+          </a:p>
+        </p:txBody>
+      </p:sp>
+      <p:sp>
+        <p:nvSpPr>
+          <p:cNvPr id="251" name="Google Shape;251;p24">
+            <a:extLst xmlns:a="http://schemas.openxmlformats.org/drawingml/2006/main">
+              <a:ext uri="{FF2B5EF4-FFF2-40B4-BE49-F238E27FC236}">
+                <a16:creationId xmlns:a16="http://schemas.microsoft.com/office/drawing/2014/main" id="{DA67171C-4EF2-48F6-A6F5-4EA64F8CA8CA}"/>
+              </a:ext>
+            </a:extLst>
+          </p:cNvPr>
+          <p:cNvSpPr>
+            <a:spLocks xmlns:a="http://schemas.openxmlformats.org/drawingml/2006/main" noGrp="1"/>
+          </p:cNvSpPr>
+          <p:nvPr/>
+        </p:nvSpPr>
+        <p:spPr>
+          <a:xfrm xmlns:a="http://schemas.openxmlformats.org/drawingml/2006/main">
+            <a:off x="9309068" y="3329364"/>
+            <a:ext cx="660273" cy="279273"/>
+          </a:xfrm>
+          <a:prstGeom xmlns:a="http://schemas.openxmlformats.org/drawingml/2006/main" prst="rect">
+            <a:avLst/>
+          </a:prstGeom>
+          <a:noFill xmlns:a="http://schemas.openxmlformats.org/drawingml/2006/main"/>
+          <a:ln xmlns:a="http://schemas.openxmlformats.org/drawingml/2006/main">
+            <a:noFill/>
+          </a:ln>
+        </p:spPr>
+        <p:txBody>
+          <a:bodyPr xmlns:a="http://schemas.openxmlformats.org/drawingml/2006/main" spcFirstLastPara="1" wrap="square" lIns="91425" tIns="91425" rIns="91425" bIns="91425" anchor="ctr">
+            <a:noAutofit/>
+          </a:bodyPr>
+          <a:lstStyle xmlns:a="http://schemas.openxmlformats.org/drawingml/2006/main"/>
+          <a:p xmlns:a="http://schemas.openxmlformats.org/drawingml/2006/main">
+            <a:pPr marL="0" indent="0" algn="ctr">
+              <a:spcBef>
+                <a:spcPts val="0"/>
+              </a:spcBef>
+              <a:spcAft>
+                <a:spcPts val="0"/>
+              </a:spcAft>
+              <a:buNone/>
+            </a:pPr>
+            <a:r>
+              <a:rPr sz="1100" b="1">
+                <a:solidFill>
+                  <a:srgbClr val="333333"/>
+                </a:solidFill>
+              </a:rPr>
+              <a:t>0.919</a:t>
+            </a:r>
+          </a:p>
+        </p:txBody>
+      </p:sp>
+      <p:sp>
+        <p:nvSpPr>
+          <p:cNvPr id="252" name="Google Shape;252;p24">
+            <a:extLst xmlns:a="http://schemas.openxmlformats.org/drawingml/2006/main">
+              <a:ext uri="{FF2B5EF4-FFF2-40B4-BE49-F238E27FC236}">
+                <a16:creationId xmlns:a16="http://schemas.microsoft.com/office/drawing/2014/main" id="{30CC1582-8A2E-4F2B-A98A-F746E0E295C3}"/>
+              </a:ext>
+            </a:extLst>
+          </p:cNvPr>
+          <p:cNvSpPr>
+            <a:spLocks xmlns:a="http://schemas.openxmlformats.org/drawingml/2006/main" noGrp="1"/>
+          </p:cNvSpPr>
+          <p:nvPr/>
+        </p:nvSpPr>
+        <p:spPr>
+          <a:xfrm xmlns:a="http://schemas.openxmlformats.org/drawingml/2006/main">
+            <a:off x="9309068" y="5867400"/>
+            <a:ext cx="660273" cy="419100"/>
+          </a:xfrm>
+          <a:prstGeom xmlns:a="http://schemas.openxmlformats.org/drawingml/2006/main" prst="rect">
+            <a:avLst/>
+          </a:prstGeom>
+          <a:noFill xmlns:a="http://schemas.openxmlformats.org/drawingml/2006/main"/>
+          <a:ln xmlns:a="http://schemas.openxmlformats.org/drawingml/2006/main">
+            <a:noFill/>
+          </a:ln>
+        </p:spPr>
+        <p:txBody>
+          <a:bodyPr xmlns:a="http://schemas.openxmlformats.org/drawingml/2006/main" spcFirstLastPara="1" wrap="square" lIns="91425" tIns="91425" rIns="91425" bIns="91425" anchor="ctr">
+            <a:noAutofit/>
+          </a:bodyPr>
+          <a:lstStyle xmlns:a="http://schemas.openxmlformats.org/drawingml/2006/main"/>
+          <a:p xmlns:a="http://schemas.openxmlformats.org/drawingml/2006/main">
+            <a:pPr marL="0" indent="0" algn="ctr">
+              <a:spcBef>
+                <a:spcPts val="0"/>
+              </a:spcBef>
+              <a:spcAft>
+                <a:spcPts val="0"/>
+              </a:spcAft>
+              <a:buNone/>
+            </a:pPr>
+            <a:r>
+              <a:rPr sz="1100">
+                <a:solidFill>
+                  <a:srgbClr val="333333"/>
+                </a:solidFill>
+              </a:rPr>
+              <a:t>T mean</a:t>
+            </a:r>
+          </a:p>
+        </p:txBody>
+      </p:sp>
+      <p:sp>
+        <p:nvSpPr>
+          <p:cNvPr id="253" name="Google Shape;253;p24">
+            <a:extLst xmlns:a="http://schemas.openxmlformats.org/drawingml/2006/main">
+              <a:ext uri="{FF2B5EF4-FFF2-40B4-BE49-F238E27FC236}">
+                <a16:creationId xmlns:a16="http://schemas.microsoft.com/office/drawing/2014/main" id="{AFA61B2C-4E1D-4FE9-9E0A-478D3610890C}"/>
+              </a:ext>
+            </a:extLst>
+          </p:cNvPr>
+          <p:cNvSpPr>
+            <a:spLocks xmlns:a="http://schemas.openxmlformats.org/drawingml/2006/main" noGrp="1"/>
+          </p:cNvSpPr>
+          <p:nvPr/>
+        </p:nvSpPr>
+        <p:spPr>
+          <a:xfrm xmlns:a="http://schemas.openxmlformats.org/drawingml/2006/main">
+            <a:off x="4559332" y="3682070"/>
+            <a:ext cx="533400" cy="2109130"/>
+          </a:xfrm>
+          <a:prstGeom xmlns:a="http://schemas.openxmlformats.org/drawingml/2006/main" prst="rect">
+            <a:avLst/>
+          </a:prstGeom>
+          <a:solidFill xmlns:a="http://schemas.openxmlformats.org/drawingml/2006/main">
+            <a:srgbClr val="2E5496"/>
+          </a:solidFill>
+          <a:ln xmlns:a="http://schemas.openxmlformats.org/drawingml/2006/main">
+            <a:noFill/>
+          </a:ln>
+        </p:spPr>
+        <p:txBody>
+          <a:bodyPr xmlns:a="http://schemas.openxmlformats.org/drawingml/2006/main" spcFirstLastPara="1" wrap="square" lIns="91425" tIns="91425" rIns="91425" bIns="91425" anchor="ctr">
+            <a:noAutofit/>
+          </a:bodyPr>
+          <a:lstStyle xmlns:a="http://schemas.openxmlformats.org/drawingml/2006/main"/>
+          <a:p xmlns:a="http://schemas.openxmlformats.org/drawingml/2006/main">
+            <a:pPr marL="0" indent="0" algn="ctr">
+              <a:spcBef>
+                <a:spcPts val="0"/>
+              </a:spcBef>
+              <a:spcAft>
+                <a:spcPts val="0"/>
+              </a:spcAft>
+              <a:buNone/>
+            </a:pPr>
+            <a:r>
+              <a:t/>
+            </a:r>
+          </a:p>
+        </p:txBody>
+      </p:sp>
+      <p:sp>
+        <p:nvSpPr>
+          <p:cNvPr id="254" name="Google Shape;254;p24">
+            <a:extLst xmlns:a="http://schemas.openxmlformats.org/drawingml/2006/main">
+              <a:ext uri="{FF2B5EF4-FFF2-40B4-BE49-F238E27FC236}">
+                <a16:creationId xmlns:a16="http://schemas.microsoft.com/office/drawing/2014/main" id="{096789E1-7160-45E9-AF2B-911612263C54}"/>
+              </a:ext>
+            </a:extLst>
+          </p:cNvPr>
+          <p:cNvSpPr>
+            <a:spLocks xmlns:a="http://schemas.openxmlformats.org/drawingml/2006/main" noGrp="1"/>
+          </p:cNvSpPr>
+          <p:nvPr/>
+        </p:nvSpPr>
+        <p:spPr>
+          <a:xfrm xmlns:a="http://schemas.openxmlformats.org/drawingml/2006/main">
+            <a:off x="4495800" y="3364601"/>
+            <a:ext cx="660273" cy="279273"/>
+          </a:xfrm>
+          <a:prstGeom xmlns:a="http://schemas.openxmlformats.org/drawingml/2006/main" prst="rect">
+            <a:avLst/>
+          </a:prstGeom>
+          <a:noFill xmlns:a="http://schemas.openxmlformats.org/drawingml/2006/main"/>
+          <a:ln xmlns:a="http://schemas.openxmlformats.org/drawingml/2006/main">
+            <a:noFill/>
+          </a:ln>
+        </p:spPr>
+        <p:txBody>
+          <a:bodyPr xmlns:a="http://schemas.openxmlformats.org/drawingml/2006/main" spcFirstLastPara="1" wrap="square" lIns="91425" tIns="91425" rIns="91425" bIns="91425" anchor="ctr">
+            <a:noAutofit/>
+          </a:bodyPr>
+          <a:lstStyle xmlns:a="http://schemas.openxmlformats.org/drawingml/2006/main"/>
+          <a:p xmlns:a="http://schemas.openxmlformats.org/drawingml/2006/main">
+            <a:pPr marL="0" indent="0" algn="ctr">
+              <a:spcBef>
+                <a:spcPts val="0"/>
+              </a:spcBef>
+              <a:spcAft>
+                <a:spcPts val="0"/>
+              </a:spcAft>
+              <a:buNone/>
+            </a:pPr>
+            <a:r>
+              <a:rPr sz="1100" b="1">
+                <a:solidFill>
+                  <a:srgbClr val="333333"/>
+                </a:solidFill>
+              </a:rPr>
+              <a:t>90.38%</a:t>
+            </a:r>
+          </a:p>
+        </p:txBody>
+      </p:sp>
+      <p:sp>
+        <p:nvSpPr>
+          <p:cNvPr id="255" name="Google Shape;255;p24">
+            <a:extLst xmlns:a="http://schemas.openxmlformats.org/drawingml/2006/main">
+              <a:ext uri="{FF2B5EF4-FFF2-40B4-BE49-F238E27FC236}">
+                <a16:creationId xmlns:a16="http://schemas.microsoft.com/office/drawing/2014/main" id="{217B4067-DDE7-49F9-945B-102BDE6C4ED8}"/>
+              </a:ext>
+            </a:extLst>
+          </p:cNvPr>
+          <p:cNvSpPr>
+            <a:spLocks xmlns:a="http://schemas.openxmlformats.org/drawingml/2006/main" noGrp="1"/>
+          </p:cNvSpPr>
+          <p:nvPr/>
+        </p:nvSpPr>
+        <p:spPr>
+          <a:xfrm xmlns:a="http://schemas.openxmlformats.org/drawingml/2006/main">
+            <a:off x="4495800" y="5867400"/>
+            <a:ext cx="660273" cy="419100"/>
+          </a:xfrm>
+          <a:prstGeom xmlns:a="http://schemas.openxmlformats.org/drawingml/2006/main" prst="rect">
+            <a:avLst/>
+          </a:prstGeom>
+          <a:noFill xmlns:a="http://schemas.openxmlformats.org/drawingml/2006/main"/>
+          <a:ln xmlns:a="http://schemas.openxmlformats.org/drawingml/2006/main">
+            <a:noFill/>
+          </a:ln>
+        </p:spPr>
+        <p:txBody>
+          <a:bodyPr xmlns:a="http://schemas.openxmlformats.org/drawingml/2006/main" spcFirstLastPara="1" wrap="square" lIns="91425" tIns="91425" rIns="91425" bIns="91425" anchor="ctr">
+            <a:noAutofit/>
+          </a:bodyPr>
+          <a:lstStyle xmlns:a="http://schemas.openxmlformats.org/drawingml/2006/main"/>
+          <a:p xmlns:a="http://schemas.openxmlformats.org/drawingml/2006/main">
+            <a:pPr marL="0" indent="0" algn="ctr">
+              <a:spcBef>
+                <a:spcPts val="0"/>
+              </a:spcBef>
+              <a:spcAft>
+                <a:spcPts val="0"/>
+              </a:spcAft>
+              <a:buNone/>
+            </a:pPr>
+            <a:r>
+              <a:rPr sz="1100">
+                <a:solidFill>
+                  <a:srgbClr val="333333"/>
+                </a:solidFill>
+              </a:rPr>
+              <a:t>U mean</a:t>
+            </a:r>
+          </a:p>
+        </p:txBody>
+      </p:sp>
+      <p:sp>
+        <p:nvSpPr>
+          <p:cNvPr id="256" name="Google Shape;256;p24">
+            <a:extLst xmlns:a="http://schemas.openxmlformats.org/drawingml/2006/main">
+              <a:ext uri="{FF2B5EF4-FFF2-40B4-BE49-F238E27FC236}">
+                <a16:creationId xmlns:a16="http://schemas.microsoft.com/office/drawing/2014/main" id="{DDC8BE7E-B239-41DC-9951-DD30E5802737}"/>
+              </a:ext>
+            </a:extLst>
+          </p:cNvPr>
+          <p:cNvSpPr>
+            <a:spLocks xmlns:a="http://schemas.openxmlformats.org/drawingml/2006/main" noGrp="1"/>
+          </p:cNvSpPr>
+          <p:nvPr/>
+        </p:nvSpPr>
+        <p:spPr>
+          <a:xfrm xmlns:a="http://schemas.openxmlformats.org/drawingml/2006/main">
+            <a:off x="10210800" y="3669001"/>
+            <a:ext cx="533400" cy="2122199"/>
+          </a:xfrm>
+          <a:prstGeom xmlns:a="http://schemas.openxmlformats.org/drawingml/2006/main" prst="rect">
+            <a:avLst/>
+          </a:prstGeom>
+          <a:solidFill xmlns:a="http://schemas.openxmlformats.org/drawingml/2006/main">
+            <a:srgbClr val="ED7D30"/>
+          </a:solidFill>
+          <a:ln xmlns:a="http://schemas.openxmlformats.org/drawingml/2006/main">
+            <a:noFill/>
+          </a:ln>
+        </p:spPr>
+        <p:txBody>
+          <a:bodyPr xmlns:a="http://schemas.openxmlformats.org/drawingml/2006/main" spcFirstLastPara="1" wrap="square" lIns="91425" tIns="91425" rIns="91425" bIns="91425" anchor="ctr">
+            <a:noAutofit/>
+          </a:bodyPr>
+          <a:lstStyle xmlns:a="http://schemas.openxmlformats.org/drawingml/2006/main"/>
+          <a:p xmlns:a="http://schemas.openxmlformats.org/drawingml/2006/main">
+            <a:pPr marL="0" indent="0" algn="ctr">
+              <a:spcBef>
+                <a:spcPts val="0"/>
+              </a:spcBef>
+              <a:spcAft>
+                <a:spcPts val="0"/>
+              </a:spcAft>
+              <a:buNone/>
+            </a:pPr>
+            <a:r>
+              <a:t/>
+            </a:r>
+          </a:p>
+        </p:txBody>
+      </p:sp>
+      <p:sp>
+        <p:nvSpPr>
+          <p:cNvPr id="257" name="Google Shape;257;p24">
+            <a:extLst xmlns:a="http://schemas.openxmlformats.org/drawingml/2006/main">
+              <a:ext uri="{FF2B5EF4-FFF2-40B4-BE49-F238E27FC236}">
+                <a16:creationId xmlns:a16="http://schemas.microsoft.com/office/drawing/2014/main" id="{6CC6804D-C7C8-4BF3-A2E5-137FEDFED9F5}"/>
+              </a:ext>
+            </a:extLst>
+          </p:cNvPr>
+          <p:cNvSpPr>
+            <a:spLocks xmlns:a="http://schemas.openxmlformats.org/drawingml/2006/main" noGrp="1"/>
+          </p:cNvSpPr>
+          <p:nvPr/>
+        </p:nvSpPr>
+        <p:spPr>
+          <a:xfrm xmlns:a="http://schemas.openxmlformats.org/drawingml/2006/main">
+            <a:off x="10147268" y="3351533"/>
+            <a:ext cx="660273" cy="279273"/>
+          </a:xfrm>
+          <a:prstGeom xmlns:a="http://schemas.openxmlformats.org/drawingml/2006/main" prst="rect">
+            <a:avLst/>
+          </a:prstGeom>
+          <a:noFill xmlns:a="http://schemas.openxmlformats.org/drawingml/2006/main"/>
+          <a:ln xmlns:a="http://schemas.openxmlformats.org/drawingml/2006/main">
+            <a:noFill/>
+          </a:ln>
+        </p:spPr>
+        <p:txBody>
+          <a:bodyPr xmlns:a="http://schemas.openxmlformats.org/drawingml/2006/main" spcFirstLastPara="1" wrap="square" lIns="91425" tIns="91425" rIns="91425" bIns="91425" anchor="ctr">
+            <a:noAutofit/>
+          </a:bodyPr>
+          <a:lstStyle xmlns:a="http://schemas.openxmlformats.org/drawingml/2006/main"/>
+          <a:p xmlns:a="http://schemas.openxmlformats.org/drawingml/2006/main">
+            <a:pPr marL="0" indent="0" algn="ctr">
+              <a:spcBef>
+                <a:spcPts val="0"/>
+              </a:spcBef>
+              <a:spcAft>
+                <a:spcPts val="0"/>
+              </a:spcAft>
+              <a:buNone/>
+            </a:pPr>
+            <a:r>
+              <a:rPr sz="1100" b="1">
+                <a:solidFill>
+                  <a:srgbClr val="333333"/>
+                </a:solidFill>
+              </a:rPr>
+              <a:t>0.909</a:t>
+            </a:r>
+          </a:p>
+        </p:txBody>
+      </p:sp>
+      <p:sp>
+        <p:nvSpPr>
+          <p:cNvPr id="258" name="Google Shape;258;p24">
+            <a:extLst xmlns:a="http://schemas.openxmlformats.org/drawingml/2006/main">
+              <a:ext uri="{FF2B5EF4-FFF2-40B4-BE49-F238E27FC236}">
+                <a16:creationId xmlns:a16="http://schemas.microsoft.com/office/drawing/2014/main" id="{E2A56AA0-A4A5-4CBC-B17F-A51D28D3F167}"/>
+              </a:ext>
+            </a:extLst>
+          </p:cNvPr>
+          <p:cNvSpPr>
+            <a:spLocks xmlns:a="http://schemas.openxmlformats.org/drawingml/2006/main" noGrp="1"/>
+          </p:cNvSpPr>
+          <p:nvPr/>
+        </p:nvSpPr>
+        <p:spPr>
+          <a:xfrm xmlns:a="http://schemas.openxmlformats.org/drawingml/2006/main">
+            <a:off x="10147268" y="5867400"/>
+            <a:ext cx="660273" cy="419100"/>
+          </a:xfrm>
+          <a:prstGeom xmlns:a="http://schemas.openxmlformats.org/drawingml/2006/main" prst="rect">
+            <a:avLst/>
+          </a:prstGeom>
+          <a:noFill xmlns:a="http://schemas.openxmlformats.org/drawingml/2006/main"/>
+          <a:ln xmlns:a="http://schemas.openxmlformats.org/drawingml/2006/main">
+            <a:noFill/>
+          </a:ln>
+        </p:spPr>
+        <p:txBody>
+          <a:bodyPr xmlns:a="http://schemas.openxmlformats.org/drawingml/2006/main" spcFirstLastPara="1" wrap="square" lIns="91425" tIns="91425" rIns="91425" bIns="91425" anchor="ctr">
+            <a:noAutofit/>
+          </a:bodyPr>
+          <a:lstStyle xmlns:a="http://schemas.openxmlformats.org/drawingml/2006/main"/>
+          <a:p xmlns:a="http://schemas.openxmlformats.org/drawingml/2006/main">
+            <a:pPr marL="0" indent="0" algn="ctr">
+              <a:spcBef>
+                <a:spcPts val="0"/>
+              </a:spcBef>
+              <a:spcAft>
+                <a:spcPts val="0"/>
+              </a:spcAft>
+              <a:buNone/>
+            </a:pPr>
+            <a:r>
+              <a:rPr sz="1100">
+                <a:solidFill>
+                  <a:srgbClr val="333333"/>
+                </a:solidFill>
+              </a:rPr>
+              <a:t>U mean</a:t>
+            </a:r>
+          </a:p>
+        </p:txBody>
+      </p:sp>
+    </p:spTree>
+    <p:extLst>
+      <p:ext uri="{BB962C8B-B14F-4D97-AF65-F5344CB8AC3E}">
+        <p14:creationId xmlns:p14="http://schemas.microsoft.com/office/powerpoint/2010/main" val="2007162193"/>
       </p:ext>
     </p:extLst>
   </p:cSld>
@@ -18901,6 +21396,250 @@
 </p:sld>
 </file>
 
+<file path=ppt/slides/slide20.xml><?xml version="1.0" encoding="utf-8"?>
+<p:sld xmlns:p="http://schemas.openxmlformats.org/presentationml/2006/main">
+  <p:cSld>
+    <p:spTree>
+      <p:nvGrpSpPr>
+        <p:cNvPr id="1" name=""/>
+        <p:cNvGrpSpPr/>
+        <p:nvPr/>
+      </p:nvGrpSpPr>
+      <p:grpSpPr>
+        <a:xfrm xmlns:a="http://schemas.openxmlformats.org/drawingml/2006/main"/>
+      </p:grpSpPr>
+      <p:sp>
+        <p:nvSpPr>
+          <p:cNvPr id="212" name="Google Shape;212;p23">
+            <a:extLst xmlns:a="http://schemas.openxmlformats.org/drawingml/2006/main">
+              <a:ext uri="{FF2B5EF4-FFF2-40B4-BE49-F238E27FC236}">
+                <a16:creationId xmlns:a16="http://schemas.microsoft.com/office/drawing/2014/main" id="{CEA2EDDF-A2CD-44CF-98BB-801657D2DD0E}"/>
+              </a:ext>
+            </a:extLst>
+          </p:cNvPr>
+          <p:cNvSpPr>
+            <a:spLocks xmlns:a="http://schemas.openxmlformats.org/drawingml/2006/main" noGrp="1"/>
+          </p:cNvSpPr>
+          <p:nvPr>
+            <p:ph type="title" idx="0"/>
+          </p:nvPr>
+        </p:nvSpPr>
+        <p:spPr>
+          <a:xfrm xmlns:a="http://schemas.openxmlformats.org/drawingml/2006/main">
+            <a:off x="838200" y="365125"/>
+            <a:ext cx="10515600" cy="1325700"/>
+          </a:xfrm>
+          <a:prstGeom xmlns:a="http://schemas.openxmlformats.org/drawingml/2006/main" prst="rect">
+            <a:avLst/>
+          </a:prstGeom>
+        </p:spPr>
+        <p:txBody>
+          <a:bodyPr xmlns:a="http://schemas.openxmlformats.org/drawingml/2006/main" spcFirstLastPara="1" wrap="square" lIns="91425" tIns="45700" rIns="91425" bIns="45700" anchor="ctr">
+            <a:noAutofit/>
+          </a:bodyPr>
+          <a:lstStyle xmlns:a="http://schemas.openxmlformats.org/drawingml/2006/main"/>
+          <a:p xmlns:a="http://schemas.openxmlformats.org/drawingml/2006/main">
+            <a:pPr marL="0" indent="0" algn="l">
+              <a:spcBef>
+                <a:spcPts val="0"/>
+              </a:spcBef>
+              <a:spcAft>
+                <a:spcPts val="0"/>
+              </a:spcAft>
+              <a:buNone/>
+            </a:pPr>
+            <a:r>
+              <a:t>B2: 90.38% on unseen layout families</a:t>
+            </a:r>
+          </a:p>
+        </p:txBody>
+      </p:sp>
+      <p:sp>
+        <p:nvSpPr>
+          <p:cNvPr id="213" name="Google Shape;213;p23">
+            <a:extLst xmlns:a="http://schemas.openxmlformats.org/drawingml/2006/main">
+              <a:ext uri="{FF2B5EF4-FFF2-40B4-BE49-F238E27FC236}">
+                <a16:creationId xmlns:a16="http://schemas.microsoft.com/office/drawing/2014/main" id="{DF709342-A5A8-450D-BE61-4B8EA771B374}"/>
+              </a:ext>
+            </a:extLst>
+          </p:cNvPr>
+          <p:cNvSpPr>
+            <a:spLocks xmlns:a="http://schemas.openxmlformats.org/drawingml/2006/main" noGrp="1"/>
+          </p:cNvSpPr>
+          <p:nvPr>
+            <p:ph type="body" idx="1"/>
+          </p:nvPr>
+        </p:nvSpPr>
+        <p:spPr>
+          <a:xfrm xmlns:a="http://schemas.openxmlformats.org/drawingml/2006/main">
+            <a:off x="838200" y="1825625"/>
+            <a:ext cx="5181600" cy="4351200"/>
+          </a:xfrm>
+          <a:prstGeom xmlns:a="http://schemas.openxmlformats.org/drawingml/2006/main" prst="rect">
+            <a:avLst/>
+          </a:prstGeom>
+        </p:spPr>
+        <p:txBody>
+          <a:bodyPr xmlns:a="http://schemas.openxmlformats.org/drawingml/2006/main" spcFirstLastPara="1" wrap="square" lIns="91425" tIns="45700" rIns="91425" bIns="45700" anchor="t">
+            <a:noAutofit/>
+          </a:bodyPr>
+          <a:lstStyle xmlns:a="http://schemas.openxmlformats.org/drawingml/2006/main"/>
+          <a:p xmlns:a="http://schemas.openxmlformats.org/drawingml/2006/main">
+            <a:pPr marL="457200" indent="-342900" algn="l">
+              <a:spcBef>
+                <a:spcPts val="1000"/>
+              </a:spcBef>
+              <a:spcAft>
+                <a:spcPts val="0"/>
+              </a:spcAft>
+              <a:buChar char="●"/>
+            </a:pPr>
+            <a:r>
+              <a:t>Bingyao FCOTA: 92.91% accuracy / 0.940 F1</a:t>
+            </a:r>
+          </a:p>
+          <a:p xmlns:a="http://schemas.openxmlformats.org/drawingml/2006/main">
+            <a:pPr marL="457200" indent="-342900" algn="l">
+              <a:spcBef>
+                <a:spcPts val="0"/>
+              </a:spcBef>
+              <a:spcAft>
+                <a:spcPts val="0"/>
+              </a:spcAft>
+              <a:buChar char="●"/>
+            </a:pPr>
+            <a:r>
+              <a:t>VGA game: 89.76% accuracy / 0.887 F1</a:t>
+            </a:r>
+          </a:p>
+          <a:p xmlns:a="http://schemas.openxmlformats.org/drawingml/2006/main">
+            <a:pPr marL="457200" indent="-342900" algn="l">
+              <a:spcBef>
+                <a:spcPts val="0"/>
+              </a:spcBef>
+              <a:spcAft>
+                <a:spcPts val="0"/>
+              </a:spcAft>
+              <a:buChar char="●"/>
+            </a:pPr>
+            <a:r>
+              <a:t>SRAM direct: 88.97% accuracy / 0.907 F1</a:t>
+            </a:r>
+          </a:p>
+          <a:p xmlns:a="http://schemas.openxmlformats.org/drawingml/2006/main">
+            <a:pPr marL="457200" indent="-342900" algn="l">
+              <a:spcBef>
+                <a:spcPts val="0"/>
+              </a:spcBef>
+              <a:spcAft>
+                <a:spcPts val="0"/>
+              </a:spcAft>
+              <a:buChar char="●"/>
+            </a:pPr>
+            <a:r>
+              <a:t>All values are mean results across three fixed seeds</a:t>
+            </a:r>
+          </a:p>
+        </p:txBody>
+      </p:sp>
+      <p:sp>
+        <p:nvSpPr>
+          <p:cNvPr id="214" name="Google Shape;214;p23">
+            <a:extLst xmlns:a="http://schemas.openxmlformats.org/drawingml/2006/main">
+              <a:ext uri="{FF2B5EF4-FFF2-40B4-BE49-F238E27FC236}">
+                <a16:creationId xmlns:a16="http://schemas.microsoft.com/office/drawing/2014/main" id="{391DC8AD-B282-472F-BADA-EE209EE8D6C2}"/>
+              </a:ext>
+            </a:extLst>
+          </p:cNvPr>
+          <p:cNvSpPr>
+            <a:spLocks xmlns:a="http://schemas.openxmlformats.org/drawingml/2006/main" noGrp="1"/>
+          </p:cNvSpPr>
+          <p:nvPr>
+            <p:ph type="body" idx="2"/>
+          </p:nvPr>
+        </p:nvSpPr>
+        <p:spPr>
+          <a:xfrm xmlns:a="http://schemas.openxmlformats.org/drawingml/2006/main">
+            <a:off x="6172200" y="1825625"/>
+            <a:ext cx="5181600" cy="4351200"/>
+          </a:xfrm>
+          <a:prstGeom xmlns:a="http://schemas.openxmlformats.org/drawingml/2006/main" prst="rect">
+            <a:avLst/>
+          </a:prstGeom>
+        </p:spPr>
+        <p:txBody>
+          <a:bodyPr xmlns:a="http://schemas.openxmlformats.org/drawingml/2006/main" spcFirstLastPara="1" wrap="square" lIns="91425" tIns="45700" rIns="91425" bIns="45700" anchor="t">
+            <a:noAutofit/>
+          </a:bodyPr>
+          <a:lstStyle xmlns:a="http://schemas.openxmlformats.org/drawingml/2006/main"/>
+          <a:p xmlns:a="http://schemas.openxmlformats.org/drawingml/2006/main">
+            <a:pPr marL="457200" indent="-342900" algn="l">
+              <a:spcBef>
+                <a:spcPts val="1000"/>
+              </a:spcBef>
+              <a:spcAft>
+                <a:spcPts val="0"/>
+              </a:spcAft>
+              <a:buChar char="●"/>
+            </a:pPr>
+            <a:r>
+              <a:t>All three test families were unseen during training</a:t>
+            </a:r>
+          </a:p>
+          <a:p xmlns:a="http://schemas.openxmlformats.org/drawingml/2006/main">
+            <a:pPr marL="457200" indent="-342900" algn="l">
+              <a:spcBef>
+                <a:spcPts val="0"/>
+              </a:spcBef>
+              <a:spcAft>
+                <a:spcPts val="0"/>
+              </a:spcAft>
+              <a:buChar char="●"/>
+            </a:pPr>
+            <a:r>
+              <a:t>Only 2.09 accuracy points below tile-random</a:t>
+            </a:r>
+          </a:p>
+          <a:p xmlns:a="http://schemas.openxmlformats.org/drawingml/2006/main">
+            <a:pPr marL="457200" indent="-342900" algn="l">
+              <a:spcBef>
+                <a:spcPts val="0"/>
+              </a:spcBef>
+              <a:spcAft>
+                <a:spcPts val="0"/>
+              </a:spcAft>
+              <a:buChar char="●"/>
+            </a:pPr>
+            <a:r>
+              <a:t>Dirty-F1 gap is only 0.95 points</a:t>
+            </a:r>
+          </a:p>
+          <a:p xmlns:a="http://schemas.openxmlformats.org/drawingml/2006/main">
+            <a:pPr marL="457200" indent="-342900" algn="l">
+              <a:spcBef>
+                <a:spcPts val="0"/>
+              </a:spcBef>
+              <a:spcAft>
+                <a:spcPts val="0"/>
+              </a:spcAft>
+              <a:buChar char="●"/>
+            </a:pPr>
+            <a:r>
+              <a:t>Decision: freeze B2 and begin controlled B3 tuning</a:t>
+            </a:r>
+          </a:p>
+        </p:txBody>
+      </p:sp>
+    </p:spTree>
+    <p:extLst>
+      <p:ext uri="{BB962C8B-B14F-4D97-AF65-F5344CB8AC3E}">
+        <p14:creationId xmlns:p14="http://schemas.microsoft.com/office/powerpoint/2010/main" val="463416430"/>
+      </p:ext>
+    </p:extLst>
+  </p:cSld>
+</p:sld>
+</file>
+
 <file path=ppt/slides/slide3.xml><?xml version="1.0" encoding="utf-8"?>
 <p:sld xmlns:p="http://schemas.openxmlformats.org/presentationml/2006/main">
   <p:cSld>
@@ -18975,7 +21714,7 @@
           <p:nvPr/>
         </p:nvPicPr>
         <p:blipFill rotWithShape="1">
-          <a:blip xmlns:r="http://schemas.openxmlformats.org/officeDocument/2006/relationships" xmlns:a="http://schemas.openxmlformats.org/drawingml/2006/main" r:embed="Rf148cdf030744799">
+          <a:blip xmlns:r="http://schemas.openxmlformats.org/officeDocument/2006/relationships" xmlns:a="http://schemas.openxmlformats.org/drawingml/2006/main" r:embed="R6fd88953673e456e">
             <a:alphaModFix/>
           </a:blip>
           <a:srcRect xmlns:a="http://schemas.openxmlformats.org/drawingml/2006/main" l="0" t="0" r="0" b="0"/>
@@ -19003,7 +21742,7 @@
           <p:nvPr/>
         </p:nvPicPr>
         <p:blipFill rotWithShape="1">
-          <a:blip xmlns:r="http://schemas.openxmlformats.org/officeDocument/2006/relationships" xmlns:a="http://schemas.openxmlformats.org/drawingml/2006/main" r:embed="R5653eb48839a4447">
+          <a:blip xmlns:r="http://schemas.openxmlformats.org/officeDocument/2006/relationships" xmlns:a="http://schemas.openxmlformats.org/drawingml/2006/main" r:embed="Rc5b5ac3da56040d5">
             <a:alphaModFix/>
           </a:blip>
           <a:srcRect xmlns:a="http://schemas.openxmlformats.org/drawingml/2006/main" l="0" t="0" r="0" b="0"/>
@@ -19293,7 +22032,7 @@
           <p:nvPr/>
         </p:nvPicPr>
         <p:blipFill rotWithShape="1">
-          <a:blip xmlns:r="http://schemas.openxmlformats.org/officeDocument/2006/relationships" xmlns:a="http://schemas.openxmlformats.org/drawingml/2006/main" r:embed="R5eacde56980b4a34">
+          <a:blip xmlns:r="http://schemas.openxmlformats.org/officeDocument/2006/relationships" xmlns:a="http://schemas.openxmlformats.org/drawingml/2006/main" r:embed="R07f6d34e609644fe">
             <a:alphaModFix/>
           </a:blip>
           <a:srcRect xmlns:a="http://schemas.openxmlformats.org/drawingml/2006/main" l="0" t="0" r="0" b="0"/>
@@ -19606,7 +22345,7 @@
       </p:sp>
       <p:pic>
         <p:nvPicPr>
-          <p:cNvPr id="313" name="Google Shape;119;p17"/>
+          <p:cNvPr id="407" name="Google Shape;119;p17"/>
           <p:cNvPicPr>
             <a:picLocks xmlns:a="http://schemas.openxmlformats.org/drawingml/2006/main" noChangeAspect="1"/>
           </p:cNvPicPr>
@@ -19615,7 +22354,7 @@
           </p:nvPr>
         </p:nvPicPr>
         <p:blipFill rotWithShape="1">
-          <a:blip xmlns:r="http://schemas.openxmlformats.org/officeDocument/2006/relationships" xmlns:a="http://schemas.openxmlformats.org/drawingml/2006/main" r:embed="R0edd96bfe07846d9">
+          <a:blip xmlns:r="http://schemas.openxmlformats.org/officeDocument/2006/relationships" xmlns:a="http://schemas.openxmlformats.org/drawingml/2006/main" r:embed="Rd3e3cd2b376044be">
             <a:alphaModFix/>
           </a:blip>
           <a:srcRect xmlns:a="http://schemas.openxmlformats.org/drawingml/2006/main" l="0" t="0" r="0" b="0"/>
@@ -19640,14 +22379,14 @@
       </p:pic>
       <p:pic>
         <p:nvPicPr>
-          <p:cNvPr id="314" name="Google Shape;120;p17"/>
+          <p:cNvPr id="408" name="Google Shape;120;p17"/>
           <p:cNvPicPr>
             <a:picLocks xmlns:a="http://schemas.openxmlformats.org/drawingml/2006/main" noChangeAspect="1"/>
           </p:cNvPicPr>
           <p:nvPr/>
         </p:nvPicPr>
         <p:blipFill rotWithShape="1">
-          <a:blip xmlns:r="http://schemas.openxmlformats.org/officeDocument/2006/relationships" xmlns:a="http://schemas.openxmlformats.org/drawingml/2006/main" r:embed="R07f7ffd2240f46f5">
+          <a:blip xmlns:r="http://schemas.openxmlformats.org/officeDocument/2006/relationships" xmlns:a="http://schemas.openxmlformats.org/drawingml/2006/main" r:embed="Re40ad2f185da4e71">
             <a:alphaModFix/>
           </a:blip>
           <a:srcRect xmlns:a="http://schemas.openxmlformats.org/drawingml/2006/main" l="0" t="0" r="0" b="0"/>
@@ -19672,14 +22411,14 @@
       </p:pic>
       <p:pic>
         <p:nvPicPr>
-          <p:cNvPr id="315" name="Google Shape;122;p17"/>
+          <p:cNvPr id="409" name="Google Shape;122;p17"/>
           <p:cNvPicPr>
             <a:picLocks xmlns:a="http://schemas.openxmlformats.org/drawingml/2006/main" noChangeAspect="1"/>
           </p:cNvPicPr>
           <p:nvPr/>
         </p:nvPicPr>
         <p:blipFill rotWithShape="1">
-          <a:blip xmlns:r="http://schemas.openxmlformats.org/officeDocument/2006/relationships" xmlns:a="http://schemas.openxmlformats.org/drawingml/2006/main" r:embed="R0b0b6622fd7c458d">
+          <a:blip xmlns:r="http://schemas.openxmlformats.org/officeDocument/2006/relationships" xmlns:a="http://schemas.openxmlformats.org/drawingml/2006/main" r:embed="Rf5a8f9d7bd094516">
             <a:alphaModFix/>
           </a:blip>
           <a:srcRect xmlns:a="http://schemas.openxmlformats.org/drawingml/2006/main" l="0" t="0" r="0" b="0"/>
@@ -19969,14 +22708,14 @@
       </p:sp>
       <p:pic>
         <p:nvPicPr>
-          <p:cNvPr id="321" name="Google Shape;128;p17"/>
+          <p:cNvPr id="415" name="Google Shape;128;p17"/>
           <p:cNvPicPr>
             <a:picLocks xmlns:a="http://schemas.openxmlformats.org/drawingml/2006/main" noChangeAspect="1"/>
           </p:cNvPicPr>
           <p:nvPr/>
         </p:nvPicPr>
         <p:blipFill rotWithShape="1">
-          <a:blip xmlns:r="http://schemas.openxmlformats.org/officeDocument/2006/relationships" xmlns:a="http://schemas.openxmlformats.org/drawingml/2006/main" r:embed="R07f7ffd2240f46f5">
+          <a:blip xmlns:r="http://schemas.openxmlformats.org/officeDocument/2006/relationships" xmlns:a="http://schemas.openxmlformats.org/drawingml/2006/main" r:embed="Re40ad2f185da4e71">
             <a:alphaModFix/>
           </a:blip>
           <a:srcRect xmlns:a="http://schemas.openxmlformats.org/drawingml/2006/main" l="0" t="0" r="0" b="0"/>
@@ -20001,7 +22740,7 @@
       </p:pic>
       <p:cxnSp>
         <p:nvCxnSpPr>
-          <p:cNvPr id="322" name="Google Shape;129;p17"/>
+          <p:cNvPr id="416" name="Google Shape;129;p17"/>
           <p:cNvCxnSpPr/>
           <p:nvPr/>
         </p:nvCxnSpPr>
@@ -20026,7 +22765,7 @@
       </p:cxnSp>
       <p:cxnSp>
         <p:nvCxnSpPr>
-          <p:cNvPr id="323" name="Google Shape;130;p17"/>
+          <p:cNvPr id="417" name="Google Shape;130;p17"/>
           <p:cNvCxnSpPr/>
           <p:nvPr/>
         </p:nvCxnSpPr>
@@ -20051,14 +22790,14 @@
       </p:cxnSp>
       <p:pic>
         <p:nvPicPr>
-          <p:cNvPr id="324" name="Google Shape;131;p17"/>
+          <p:cNvPr id="418" name="Google Shape;131;p17"/>
           <p:cNvPicPr>
             <a:picLocks xmlns:a="http://schemas.openxmlformats.org/drawingml/2006/main" noChangeAspect="1"/>
           </p:cNvPicPr>
           <p:nvPr/>
         </p:nvPicPr>
         <p:blipFill rotWithShape="1">
-          <a:blip xmlns:r="http://schemas.openxmlformats.org/officeDocument/2006/relationships" xmlns:a="http://schemas.openxmlformats.org/drawingml/2006/main" r:embed="R316f7e3173bf42fd">
+          <a:blip xmlns:r="http://schemas.openxmlformats.org/officeDocument/2006/relationships" xmlns:a="http://schemas.openxmlformats.org/drawingml/2006/main" r:embed="R8d8ade8b438e4e4d">
             <a:alphaModFix/>
           </a:blip>
           <a:srcRect xmlns:a="http://schemas.openxmlformats.org/drawingml/2006/main" l="0" t="0" r="0" b="0"/>
@@ -20344,14 +23083,14 @@
       </p:sp>
       <p:pic>
         <p:nvPicPr>
-          <p:cNvPr id="329" name="Google Shape;136;p17"/>
+          <p:cNvPr id="423" name="Google Shape;136;p17"/>
           <p:cNvPicPr>
             <a:picLocks xmlns:a="http://schemas.openxmlformats.org/drawingml/2006/main" noChangeAspect="1"/>
           </p:cNvPicPr>
           <p:nvPr/>
         </p:nvPicPr>
         <p:blipFill rotWithShape="1">
-          <a:blip xmlns:r="http://schemas.openxmlformats.org/officeDocument/2006/relationships" xmlns:a="http://schemas.openxmlformats.org/drawingml/2006/main" r:embed="Re74da2768ac34dcd">
+          <a:blip xmlns:r="http://schemas.openxmlformats.org/officeDocument/2006/relationships" xmlns:a="http://schemas.openxmlformats.org/drawingml/2006/main" r:embed="R61a4e9b73c174027">
             <a:alphaModFix/>
           </a:blip>
           <a:srcRect xmlns:a="http://schemas.openxmlformats.org/drawingml/2006/main" l="0" t="0" r="0" b="0"/>
@@ -20372,14 +23111,14 @@
       </p:pic>
       <p:pic>
         <p:nvPicPr>
-          <p:cNvPr id="330" name="Google Shape;137;p17"/>
+          <p:cNvPr id="424" name="Google Shape;137;p17"/>
           <p:cNvPicPr>
             <a:picLocks xmlns:a="http://schemas.openxmlformats.org/drawingml/2006/main" noChangeAspect="1"/>
           </p:cNvPicPr>
           <p:nvPr/>
         </p:nvPicPr>
         <p:blipFill rotWithShape="1">
-          <a:blip xmlns:r="http://schemas.openxmlformats.org/officeDocument/2006/relationships" xmlns:a="http://schemas.openxmlformats.org/drawingml/2006/main" r:embed="Rf947ffb22f5b41cd">
+          <a:blip xmlns:r="http://schemas.openxmlformats.org/officeDocument/2006/relationships" xmlns:a="http://schemas.openxmlformats.org/drawingml/2006/main" r:embed="Redf10a94b75a4b1b">
             <a:alphaModFix/>
           </a:blip>
           <a:srcRect xmlns:a="http://schemas.openxmlformats.org/drawingml/2006/main" l="0" t="0" r="0" b="0"/>
@@ -20461,14 +23200,14 @@
       </p:sp>
       <p:pic>
         <p:nvPicPr>
-          <p:cNvPr id="332" name="Google Shape;139;p17"/>
+          <p:cNvPr id="426" name="Google Shape;139;p17"/>
           <p:cNvPicPr>
             <a:picLocks xmlns:a="http://schemas.openxmlformats.org/drawingml/2006/main" noChangeAspect="1"/>
           </p:cNvPicPr>
           <p:nvPr/>
         </p:nvPicPr>
         <p:blipFill rotWithShape="1">
-          <a:blip xmlns:r="http://schemas.openxmlformats.org/officeDocument/2006/relationships" xmlns:a="http://schemas.openxmlformats.org/drawingml/2006/main" r:embed="R6e24508958934c32">
+          <a:blip xmlns:r="http://schemas.openxmlformats.org/officeDocument/2006/relationships" xmlns:a="http://schemas.openxmlformats.org/drawingml/2006/main" r:embed="R74be8f7fff04495c">
             <a:alphaModFix/>
           </a:blip>
           <a:srcRect xmlns:a="http://schemas.openxmlformats.org/drawingml/2006/main" l="0" t="0" r="0" b="0"/>
@@ -20489,14 +23228,14 @@
       </p:pic>
       <p:pic>
         <p:nvPicPr>
-          <p:cNvPr id="333" name="Google Shape;140;p17"/>
+          <p:cNvPr id="427" name="Google Shape;140;p17"/>
           <p:cNvPicPr>
             <a:picLocks xmlns:a="http://schemas.openxmlformats.org/drawingml/2006/main" noChangeAspect="1"/>
           </p:cNvPicPr>
           <p:nvPr/>
         </p:nvPicPr>
         <p:blipFill rotWithShape="1">
-          <a:blip xmlns:r="http://schemas.openxmlformats.org/officeDocument/2006/relationships" xmlns:a="http://schemas.openxmlformats.org/drawingml/2006/main" r:embed="R078732a90a5f43eb">
+          <a:blip xmlns:r="http://schemas.openxmlformats.org/officeDocument/2006/relationships" xmlns:a="http://schemas.openxmlformats.org/drawingml/2006/main" r:embed="R52bd0f36f17e4f50">
             <a:alphaModFix/>
           </a:blip>
           <a:srcRect xmlns:a="http://schemas.openxmlformats.org/drawingml/2006/main" l="0" t="0" r="0" b="0"/>
@@ -20766,7 +23505,7 @@
       </p:sp>
       <p:cxnSp>
         <p:nvCxnSpPr>
-          <p:cNvPr id="336" name="Google Shape;143;p17"/>
+          <p:cNvPr id="430" name="Google Shape;143;p17"/>
           <p:cNvCxnSpPr>
             <a:stCxn xmlns:a="http://schemas.openxmlformats.org/drawingml/2006/main" id="119" idx="3"/>
             <a:endCxn xmlns:a="http://schemas.openxmlformats.org/drawingml/2006/main" id="120" idx="1"/>
@@ -20794,7 +23533,7 @@
       </p:cxnSp>
       <p:cxnSp>
         <p:nvCxnSpPr>
-          <p:cNvPr id="337" name="Google Shape;144;p17"/>
+          <p:cNvPr id="431" name="Google Shape;144;p17"/>
           <p:cNvCxnSpPr>
             <a:endCxn xmlns:a="http://schemas.openxmlformats.org/drawingml/2006/main" id="128" idx="1"/>
           </p:cNvCxnSpPr>
@@ -20821,7 +23560,7 @@
       </p:cxnSp>
       <p:cxnSp>
         <p:nvCxnSpPr>
-          <p:cNvPr id="338" name="Google Shape;145;p17"/>
+          <p:cNvPr id="432" name="Google Shape;145;p17"/>
           <p:cNvCxnSpPr>
             <a:endCxn xmlns:a="http://schemas.openxmlformats.org/drawingml/2006/main" id="132" idx="1"/>
           </p:cNvCxnSpPr>
@@ -20848,7 +23587,7 @@
       </p:cxnSp>
       <p:cxnSp>
         <p:nvCxnSpPr>
-          <p:cNvPr id="339" name="Google Shape;146;p17"/>
+          <p:cNvPr id="433" name="Google Shape;146;p17"/>
           <p:cNvCxnSpPr>
             <a:endCxn xmlns:a="http://schemas.openxmlformats.org/drawingml/2006/main" id="135" idx="3"/>
           </p:cNvCxnSpPr>
@@ -20875,7 +23614,7 @@
       </p:cxnSp>
       <p:cxnSp>
         <p:nvCxnSpPr>
-          <p:cNvPr id="340" name="Google Shape;147;p17"/>
+          <p:cNvPr id="434" name="Google Shape;147;p17"/>
           <p:cNvCxnSpPr>
             <a:endCxn xmlns:a="http://schemas.openxmlformats.org/drawingml/2006/main" id="135" idx="0"/>
           </p:cNvCxnSpPr>
@@ -20902,7 +23641,7 @@
       </p:cxnSp>
       <p:cxnSp>
         <p:nvCxnSpPr>
-          <p:cNvPr id="341" name="Google Shape;148;p17"/>
+          <p:cNvPr id="435" name="Google Shape;148;p17"/>
           <p:cNvCxnSpPr>
             <a:stCxn xmlns:a="http://schemas.openxmlformats.org/drawingml/2006/main" id="132" idx="3"/>
             <a:endCxn xmlns:a="http://schemas.openxmlformats.org/drawingml/2006/main" id="133" idx="0"/>
@@ -20930,7 +23669,7 @@
       </p:cxnSp>
       <p:cxnSp>
         <p:nvCxnSpPr>
-          <p:cNvPr id="342" name="Google Shape;149;p17"/>
+          <p:cNvPr id="436" name="Google Shape;149;p17"/>
           <p:cNvCxnSpPr>
             <a:stCxn xmlns:a="http://schemas.openxmlformats.org/drawingml/2006/main" id="133" idx="2"/>
             <a:endCxn xmlns:a="http://schemas.openxmlformats.org/drawingml/2006/main" id="131" idx="0"/>
@@ -20958,7 +23697,7 @@
       </p:cxnSp>
       <p:cxnSp>
         <p:nvCxnSpPr>
-          <p:cNvPr id="343" name="Google Shape;150;p17"/>
+          <p:cNvPr id="437" name="Google Shape;150;p17"/>
           <p:cNvCxnSpPr>
             <a:stCxn xmlns:a="http://schemas.openxmlformats.org/drawingml/2006/main" id="135" idx="1"/>
             <a:endCxn xmlns:a="http://schemas.openxmlformats.org/drawingml/2006/main" id="136" idx="3"/>
@@ -20986,7 +23725,7 @@
       </p:cxnSp>
       <p:cxnSp>
         <p:nvCxnSpPr>
-          <p:cNvPr id="344" name="Google Shape;151;p17"/>
+          <p:cNvPr id="438" name="Google Shape;151;p17"/>
           <p:cNvCxnSpPr>
             <a:stCxn xmlns:a="http://schemas.openxmlformats.org/drawingml/2006/main" id="135" idx="1"/>
             <a:endCxn xmlns:a="http://schemas.openxmlformats.org/drawingml/2006/main" id="137" idx="3"/>
@@ -21014,7 +23753,7 @@
       </p:cxnSp>
       <p:cxnSp>
         <p:nvCxnSpPr>
-          <p:cNvPr id="345" name="Google Shape;152;p17"/>
+          <p:cNvPr id="439" name="Google Shape;152;p17"/>
           <p:cNvCxnSpPr/>
           <p:nvPr/>
         </p:nvCxnSpPr>
@@ -21039,7 +23778,7 @@
       </p:cxnSp>
       <p:cxnSp>
         <p:nvCxnSpPr>
-          <p:cNvPr id="346" name="Google Shape;153;p17"/>
+          <p:cNvPr id="440" name="Google Shape;153;p17"/>
           <p:cNvCxnSpPr/>
           <p:nvPr/>
         </p:nvCxnSpPr>
@@ -21064,7 +23803,7 @@
       </p:cxnSp>
       <p:cxnSp>
         <p:nvCxnSpPr>
-          <p:cNvPr id="347" name="Google Shape;154;p17"/>
+          <p:cNvPr id="441" name="Google Shape;154;p17"/>
           <p:cNvCxnSpPr/>
           <p:nvPr/>
         </p:nvCxnSpPr>
@@ -21089,7 +23828,7 @@
       </p:cxnSp>
       <p:cxnSp>
         <p:nvCxnSpPr>
-          <p:cNvPr id="348" name="Google Shape;155;p17"/>
+          <p:cNvPr id="442" name="Google Shape;155;p17"/>
           <p:cNvCxnSpPr/>
           <p:nvPr/>
         </p:nvCxnSpPr>
@@ -21114,7 +23853,7 @@
       </p:cxnSp>
       <p:cxnSp>
         <p:nvCxnSpPr>
-          <p:cNvPr id="349" name="Google Shape;156;p17"/>
+          <p:cNvPr id="443" name="Google Shape;156;p17"/>
           <p:cNvCxnSpPr/>
           <p:nvPr/>
         </p:nvCxnSpPr>
@@ -21503,7 +24242,7 @@
           </p:nvPr>
         </p:nvPicPr>
         <p:blipFill rotWithShape="1">
-          <a:blip xmlns:r="http://schemas.openxmlformats.org/officeDocument/2006/relationships" xmlns:a="http://schemas.openxmlformats.org/drawingml/2006/main" r:embed="R10ed813f31c24fa6">
+          <a:blip xmlns:r="http://schemas.openxmlformats.org/officeDocument/2006/relationships" xmlns:a="http://schemas.openxmlformats.org/drawingml/2006/main" r:embed="Rad375e4d755a40f3">
             <a:alphaModFix/>
           </a:blip>
           <a:srcRect xmlns:a="http://schemas.openxmlformats.org/drawingml/2006/main" l="0" t="0" r="0" b="0"/>
@@ -21538,8 +24277,8 @@
         </p:nvSpPr>
         <p:spPr>
           <a:xfrm xmlns:a="http://schemas.openxmlformats.org/drawingml/2006/main">
-            <a:off x="1144825" y="3354585"/>
-            <a:ext cx="1131015" cy="1277273"/>
+            <a:off x="1143000" y="3714750"/>
+            <a:ext cx="1238250" cy="1333500"/>
           </a:xfrm>
           <a:prstGeom xmlns:a="http://schemas.openxmlformats.org/drawingml/2006/main" prst="rect">
             <a:avLst/>
@@ -21719,7 +24458,7 @@
           <p:nvPr/>
         </p:nvPicPr>
         <p:blipFill rotWithShape="1">
-          <a:blip xmlns:r="http://schemas.openxmlformats.org/officeDocument/2006/relationships" xmlns:a="http://schemas.openxmlformats.org/drawingml/2006/main" r:embed="R10fcc15540d34f1f">
+          <a:blip xmlns:r="http://schemas.openxmlformats.org/officeDocument/2006/relationships" xmlns:a="http://schemas.openxmlformats.org/drawingml/2006/main" r:embed="R4c8a6456876d4827">
             <a:alphaModFix/>
           </a:blip>
           <a:srcRect xmlns:a="http://schemas.openxmlformats.org/drawingml/2006/main" l="0" t="0" r="0" b="0"/>
@@ -21754,8 +24493,8 @@
         </p:nvSpPr>
         <p:spPr>
           <a:xfrm xmlns:a="http://schemas.openxmlformats.org/drawingml/2006/main">
-            <a:off x="2418080" y="3354585"/>
-            <a:ext cx="6096000" cy="1277273"/>
+            <a:off x="2476500" y="3714750"/>
+            <a:ext cx="1238250" cy="1333500"/>
           </a:xfrm>
           <a:prstGeom xmlns:a="http://schemas.openxmlformats.org/drawingml/2006/main" prst="rect">
             <a:avLst/>
@@ -21959,219 +24698,80 @@
           </a:bodyPr>
           <a:lstStyle xmlns:a="http://schemas.openxmlformats.org/drawingml/2006/main"/>
           <a:p xmlns:a="http://schemas.openxmlformats.org/drawingml/2006/main">
-            <a:pPr marL="285750" indent="-285750" algn="l">
-              <a:spcBef>
-                <a:spcPts val="0"/>
-              </a:spcBef>
-              <a:spcAft>
-                <a:spcPts val="0"/>
+            <a:pPr marL="24" indent="-14">
+              <a:spcAft>
+                <a:spcPts val="6"/>
               </a:spcAft>
               <a:buChar char="•"/>
             </a:pPr>
             <a:r>
               <a:rPr sz="2000">
-                <a:solidFill>
-                  <a:schemeClr val="dk1"/>
-                </a:solidFill>
                 <a:latin typeface="Arial"/>
                 <a:ea typeface="Arial"/>
                 <a:cs typeface="Arial"/>
               </a:rPr>
-              <a:t>Layout Size = 150u x 200u</a:t>
-            </a:r>
-          </a:p>
-          <a:p xmlns:a="http://schemas.openxmlformats.org/drawingml/2006/main">
-            <a:pPr marL="285750" indent="-285750" algn="l">
-              <a:spcBef>
-                <a:spcPts val="0"/>
-              </a:spcBef>
-              <a:spcAft>
-                <a:spcPts val="0"/>
+              <a:t>Layout size: 150 µm × 200 µm</a:t>
+            </a:r>
+          </a:p>
+          <a:p xmlns:a="http://schemas.openxmlformats.org/drawingml/2006/main">
+            <a:pPr marL="24" indent="-14">
+              <a:spcAft>
+                <a:spcPts val="6"/>
               </a:spcAft>
               <a:buChar char="•"/>
             </a:pPr>
             <a:r>
               <a:rPr sz="2000">
-                <a:solidFill>
-                  <a:schemeClr val="dk1"/>
-                </a:solidFill>
                 <a:latin typeface="Arial"/>
                 <a:ea typeface="Arial"/>
                 <a:cs typeface="Arial"/>
               </a:rPr>
-              <a:t>Window size = 2u x 2u</a:t>
-            </a:r>
-          </a:p>
-          <a:p xmlns:a="http://schemas.openxmlformats.org/drawingml/2006/main">
-            <a:pPr marL="285750" indent="-285750" algn="l">
-              <a:spcBef>
-                <a:spcPts val="0"/>
-              </a:spcBef>
-              <a:spcAft>
-                <a:spcPts val="0"/>
+              <a:t>Window size: 2 µm × 2 µm</a:t>
+            </a:r>
+          </a:p>
+          <a:p xmlns:a="http://schemas.openxmlformats.org/drawingml/2006/main">
+            <a:pPr marL="24" indent="-14">
+              <a:spcAft>
+                <a:spcPts val="6"/>
               </a:spcAft>
               <a:buChar char="•"/>
             </a:pPr>
             <a:r>
               <a:rPr sz="2000">
-                <a:solidFill>
-                  <a:schemeClr val="dk1"/>
-                </a:solidFill>
                 <a:latin typeface="Arial"/>
                 <a:ea typeface="Arial"/>
                 <a:cs typeface="Arial"/>
               </a:rPr>
-              <a:t>Window Stride = 1u</a:t>
-            </a:r>
-          </a:p>
-          <a:p xmlns:a="http://schemas.openxmlformats.org/drawingml/2006/main">
-            <a:pPr marL="285750" indent="-285750" algn="l">
-              <a:spcBef>
-                <a:spcPts val="0"/>
-              </a:spcBef>
-              <a:spcAft>
-                <a:spcPts val="0"/>
+              <a:t>Window stride: 1 µm</a:t>
+            </a:r>
+          </a:p>
+          <a:p xmlns:a="http://schemas.openxmlformats.org/drawingml/2006/main">
+            <a:pPr marL="24" indent="-14">
+              <a:spcAft>
+                <a:spcPts val="6"/>
               </a:spcAft>
               <a:buChar char="•"/>
             </a:pPr>
             <a:r>
               <a:rPr sz="2000">
-                <a:solidFill>
-                  <a:schemeClr val="dk1"/>
-                </a:solidFill>
                 <a:latin typeface="Arial"/>
                 <a:ea typeface="Arial"/>
                 <a:cs typeface="Arial"/>
               </a:rPr>
-              <a:t>200x200 matrices (scale factor of 0.1)</a:t>
-            </a:r>
-          </a:p>
-          <a:p xmlns:a="http://schemas.openxmlformats.org/drawingml/2006/main">
-            <a:pPr marL="0" indent="0" algn="l">
-              <a:spcBef>
-                <a:spcPts val="0"/>
-              </a:spcBef>
-              <a:spcAft>
-                <a:spcPts val="0"/>
-              </a:spcAft>
-              <a:buNone/>
-            </a:pPr>
-            <a:r>
-              <a:t/>
-            </a:r>
-          </a:p>
-          <a:p xmlns:a="http://schemas.openxmlformats.org/drawingml/2006/main">
-            <a:pPr marL="285750" indent="-171450" algn="l">
-              <a:spcBef>
-                <a:spcPts val="0"/>
-              </a:spcBef>
-              <a:spcAft>
-                <a:spcPts val="0"/>
-              </a:spcAft>
-              <a:buNone/>
-            </a:pPr>
-            <a:r>
-              <a:t/>
-            </a:r>
-          </a:p>
-          <a:p xmlns:a="http://schemas.openxmlformats.org/drawingml/2006/main">
-            <a:pPr marL="285750" indent="-171450" algn="l">
-              <a:spcBef>
-                <a:spcPts val="0"/>
-              </a:spcBef>
-              <a:spcAft>
-                <a:spcPts val="0"/>
-              </a:spcAft>
-              <a:buNone/>
-            </a:pPr>
-            <a:r>
-              <a:t/>
-            </a:r>
-          </a:p>
-          <a:p xmlns:a="http://schemas.openxmlformats.org/drawingml/2006/main">
-            <a:pPr marL="285750" indent="-171450" algn="l">
-              <a:spcBef>
-                <a:spcPts val="0"/>
-              </a:spcBef>
-              <a:spcAft>
-                <a:spcPts val="0"/>
-              </a:spcAft>
-              <a:buNone/>
-            </a:pPr>
-            <a:r>
-              <a:t/>
-            </a:r>
-          </a:p>
-          <a:p xmlns:a="http://schemas.openxmlformats.org/drawingml/2006/main">
-            <a:pPr marL="0" indent="0" algn="l">
-              <a:spcBef>
-                <a:spcPts val="0"/>
-              </a:spcBef>
-              <a:spcAft>
-                <a:spcPts val="0"/>
-              </a:spcAft>
-              <a:buNone/>
-            </a:pPr>
-            <a:r>
-              <a:rPr sz="1800">
-                <a:solidFill>
-                  <a:schemeClr val="dk1"/>
-                </a:solidFill>
+              <a:t>Each window becomes a 200 × 200 binary matrix</a:t>
+            </a:r>
+          </a:p>
+          <a:p xmlns:a="http://schemas.openxmlformats.org/drawingml/2006/main">
+            <a:pPr marL="24" indent="-14">
+              <a:buChar char="•"/>
+            </a:pPr>
+            <a:r>
+              <a:rPr sz="2000">
                 <a:latin typeface="Arial"/>
                 <a:ea typeface="Arial"/>
                 <a:cs typeface="Arial"/>
               </a:rPr>
-              <a:t>                             ,                          ,                          . . .</a:t>
-            </a:r>
-          </a:p>
-          <a:p xmlns:a="http://schemas.openxmlformats.org/drawingml/2006/main">
-            <a:pPr marL="0" indent="0" algn="l">
-              <a:spcBef>
-                <a:spcPts val="0"/>
-              </a:spcBef>
-              <a:spcAft>
-                <a:spcPts val="0"/>
-              </a:spcAft>
-              <a:buNone/>
-            </a:pPr>
-            <a:r>
-              <a:t/>
-            </a:r>
-          </a:p>
-          <a:p xmlns:a="http://schemas.openxmlformats.org/drawingml/2006/main">
-            <a:pPr marL="285750" indent="-285750" algn="l">
-              <a:spcBef>
-                <a:spcPts val="0"/>
-              </a:spcBef>
-              <a:spcAft>
-                <a:spcPts val="0"/>
-              </a:spcAft>
-              <a:buChar char="•"/>
-            </a:pPr>
-            <a:r>
-              <a:rPr sz="2000">
-                <a:solidFill>
-                  <a:schemeClr val="dk1"/>
-                </a:solidFill>
-                <a:latin typeface="Arial"/>
-                <a:ea typeface="Arial"/>
-                <a:cs typeface="Arial"/>
-              </a:rPr>
-              <a:t>Total of ~500 layout clips were generated.</a:t>
-            </a:r>
-          </a:p>
-          <a:p xmlns:a="http://schemas.openxmlformats.org/drawingml/2006/main">
-            <a:pPr marL="285750" indent="-171450" algn="l">
-              <a:spcBef>
-                <a:spcPts val="0"/>
-              </a:spcBef>
-              <a:spcAft>
-                <a:spcPts val="0"/>
-              </a:spcAft>
-              <a:buNone/>
-            </a:pPr>
-            <a:r>
-              <a:t/>
+              <a:t>About 500 layout clips were generated</a:t>
             </a:r>
           </a:p>
         </p:txBody>
@@ -22192,8 +24792,8 @@
         </p:nvSpPr>
         <p:spPr>
           <a:xfrm xmlns:a="http://schemas.openxmlformats.org/drawingml/2006/main">
-            <a:off x="3677920" y="3354584"/>
-            <a:ext cx="6096000" cy="1277273"/>
+            <a:off x="3810000" y="3714750"/>
+            <a:ext cx="1238250" cy="1333500"/>
           </a:xfrm>
           <a:prstGeom xmlns:a="http://schemas.openxmlformats.org/drawingml/2006/main" prst="rect">
             <a:avLst/>
@@ -22589,7 +25189,7 @@
           <p:nvPr/>
         </p:nvPicPr>
         <p:blipFill rotWithShape="1">
-          <a:blip xmlns:r="http://schemas.openxmlformats.org/officeDocument/2006/relationships" xmlns:a="http://schemas.openxmlformats.org/drawingml/2006/main" r:embed="R814bd08d4b914ead">
+          <a:blip xmlns:r="http://schemas.openxmlformats.org/officeDocument/2006/relationships" xmlns:a="http://schemas.openxmlformats.org/drawingml/2006/main" r:embed="R24252ac6bb334aac">
             <a:alphaModFix/>
           </a:blip>
           <a:srcRect xmlns:a="http://schemas.openxmlformats.org/drawingml/2006/main" l="0" t="0" r="0" b="0"/>
@@ -22617,7 +25217,7 @@
           <p:nvPr/>
         </p:nvPicPr>
         <p:blipFill rotWithShape="1">
-          <a:blip xmlns:r="http://schemas.openxmlformats.org/officeDocument/2006/relationships" xmlns:a="http://schemas.openxmlformats.org/drawingml/2006/main" r:embed="R707d075b14694c4a">
+          <a:blip xmlns:r="http://schemas.openxmlformats.org/officeDocument/2006/relationships" xmlns:a="http://schemas.openxmlformats.org/drawingml/2006/main" r:embed="Rc8b44b16d90046ec">
             <a:alphaModFix/>
           </a:blip>
           <a:srcRect xmlns:a="http://schemas.openxmlformats.org/drawingml/2006/main" l="0" t="0" r="0" b="0"/>
@@ -22645,7 +25245,7 @@
           <p:nvPr/>
         </p:nvPicPr>
         <p:blipFill rotWithShape="1">
-          <a:blip xmlns:r="http://schemas.openxmlformats.org/officeDocument/2006/relationships" xmlns:a="http://schemas.openxmlformats.org/drawingml/2006/main" r:embed="Ra164bc4142844541">
+          <a:blip xmlns:r="http://schemas.openxmlformats.org/officeDocument/2006/relationships" xmlns:a="http://schemas.openxmlformats.org/drawingml/2006/main" r:embed="R78927a0b258544a7">
             <a:alphaModFix/>
           </a:blip>
           <a:srcRect xmlns:a="http://schemas.openxmlformats.org/drawingml/2006/main" l="0" t="0" r="0" b="0"/>
@@ -23041,7 +25641,7 @@
               <a:buNone/>
             </a:pPr>
             <a:r>
-              <a:t>B0 + B1 complete · credible B2 baselines next</a:t>
+              <a:t>B0 + B1 + B2 complete · controlled B3 improvements next</a:t>
             </a:r>
           </a:p>
         </p:txBody>

</xml_diff>

<commit_message>
Document completed B4 architecture experiment
</commit_message>
<xml_diff>
--- a/presentation/ADVLSI2_DRC_CNN_Project_Progress.pptx
+++ b/presentation/ADVLSI2_DRC_CNN_Project_Progress.pptx
@@ -2,42 +2,44 @@
 <file path=ppt/presentation.xml><?xml version="1.0" encoding="utf-8"?>
 <p:presentation xmlns:p="http://schemas.openxmlformats.org/presentationml/2006/main" embedTrueTypeFonts="1" saveSubsetFonts="0">
   <p:sldMasterIdLst>
-    <p:sldMasterId xmlns:r="http://schemas.openxmlformats.org/officeDocument/2006/relationships" id="2147483648" r:id="R42757bf5996b4430"/>
+    <p:sldMasterId xmlns:r="http://schemas.openxmlformats.org/officeDocument/2006/relationships" id="2147483648" r:id="R4837fa08c5f246eb"/>
   </p:sldMasterIdLst>
   <p:notesMasterIdLst>
-    <p:notesMasterId xmlns:r="http://schemas.openxmlformats.org/officeDocument/2006/relationships" r:id="R675ca7f75dda4d0e"/>
+    <p:notesMasterId xmlns:r="http://schemas.openxmlformats.org/officeDocument/2006/relationships" r:id="R7b7ee4fb565d446f"/>
   </p:notesMasterIdLst>
   <p:sldIdLst>
-    <p:sldId xmlns:r="http://schemas.openxmlformats.org/officeDocument/2006/relationships" id="256" r:id="R17f5dad1ee394ac0"/>
-    <p:sldId xmlns:r="http://schemas.openxmlformats.org/officeDocument/2006/relationships" id="257" r:id="R94aa7c0422a84967"/>
-    <p:sldId xmlns:r="http://schemas.openxmlformats.org/officeDocument/2006/relationships" id="258" r:id="R8ed6c81632774817"/>
-    <p:sldId xmlns:r="http://schemas.openxmlformats.org/officeDocument/2006/relationships" id="259" r:id="R55ab8b9507924e25"/>
-    <p:sldId xmlns:r="http://schemas.openxmlformats.org/officeDocument/2006/relationships" id="260" r:id="Rf8f67285d7a14b7d"/>
-    <p:sldId xmlns:r="http://schemas.openxmlformats.org/officeDocument/2006/relationships" id="261" r:id="Rbe27d747e8524d2a"/>
-    <p:sldId xmlns:r="http://schemas.openxmlformats.org/officeDocument/2006/relationships" id="262" r:id="Rd9dcc84516234839"/>
-    <p:sldId xmlns:r="http://schemas.openxmlformats.org/officeDocument/2006/relationships" id="263" r:id="R1deeed7d83734d15"/>
-    <p:sldId xmlns:r="http://schemas.openxmlformats.org/officeDocument/2006/relationships" id="264" r:id="Raadb5b4e56b64032"/>
-    <p:sldId xmlns:r="http://schemas.openxmlformats.org/officeDocument/2006/relationships" id="265" r:id="R039fa4a1412b41ad"/>
-    <p:sldId xmlns:r="http://schemas.openxmlformats.org/officeDocument/2006/relationships" id="266" r:id="R4d18eba907d34d1d"/>
-    <p:sldId xmlns:r="http://schemas.openxmlformats.org/officeDocument/2006/relationships" id="267" r:id="R04da68f9b6684a8c"/>
-    <p:sldId xmlns:r="http://schemas.openxmlformats.org/officeDocument/2006/relationships" id="268" r:id="R905acd138b1d4b10"/>
-    <p:sldId xmlns:r="http://schemas.openxmlformats.org/officeDocument/2006/relationships" id="269" r:id="R934cf7046eb04cda"/>
-    <p:sldId xmlns:r="http://schemas.openxmlformats.org/officeDocument/2006/relationships" id="270" r:id="Rf24a79aa4d834c06"/>
-    <p:sldId xmlns:r="http://schemas.openxmlformats.org/officeDocument/2006/relationships" id="271" r:id="Rbf0c3a4497e84130"/>
-    <p:sldId xmlns:r="http://schemas.openxmlformats.org/officeDocument/2006/relationships" id="272" r:id="Rb275a10fcfea4b61"/>
-    <p:sldId xmlns:r="http://schemas.openxmlformats.org/officeDocument/2006/relationships" id="273" r:id="R34b7c397e2f940da"/>
-    <p:sldId xmlns:r="http://schemas.openxmlformats.org/officeDocument/2006/relationships" id="274" r:id="R1fc20979723b4ca4"/>
-    <p:sldId xmlns:r="http://schemas.openxmlformats.org/officeDocument/2006/relationships" id="275" r:id="R32b872f7d435458e"/>
-    <p:sldId xmlns:r="http://schemas.openxmlformats.org/officeDocument/2006/relationships" id="276" r:id="Re48b1acd92e140c0"/>
-    <p:sldId xmlns:r="http://schemas.openxmlformats.org/officeDocument/2006/relationships" id="277" r:id="R5f989a7dfbf04e6e"/>
+    <p:sldId xmlns:r="http://schemas.openxmlformats.org/officeDocument/2006/relationships" id="256" r:id="Rf8e315b12d23499e"/>
+    <p:sldId xmlns:r="http://schemas.openxmlformats.org/officeDocument/2006/relationships" id="257" r:id="Rbf5c625f185a4765"/>
+    <p:sldId xmlns:r="http://schemas.openxmlformats.org/officeDocument/2006/relationships" id="258" r:id="R9426baebe47243f0"/>
+    <p:sldId xmlns:r="http://schemas.openxmlformats.org/officeDocument/2006/relationships" id="259" r:id="R787fbfb4e40d4972"/>
+    <p:sldId xmlns:r="http://schemas.openxmlformats.org/officeDocument/2006/relationships" id="260" r:id="Rb1d16704ee534744"/>
+    <p:sldId xmlns:r="http://schemas.openxmlformats.org/officeDocument/2006/relationships" id="261" r:id="Rd5363935f36c41f1"/>
+    <p:sldId xmlns:r="http://schemas.openxmlformats.org/officeDocument/2006/relationships" id="262" r:id="Rfe0b9cefe1b14872"/>
+    <p:sldId xmlns:r="http://schemas.openxmlformats.org/officeDocument/2006/relationships" id="263" r:id="R77a8369de0d84e2e"/>
+    <p:sldId xmlns:r="http://schemas.openxmlformats.org/officeDocument/2006/relationships" id="264" r:id="Rb68da2c3b9fe468b"/>
+    <p:sldId xmlns:r="http://schemas.openxmlformats.org/officeDocument/2006/relationships" id="265" r:id="R5440d6729f004043"/>
+    <p:sldId xmlns:r="http://schemas.openxmlformats.org/officeDocument/2006/relationships" id="266" r:id="R75f6fe207fea4fa7"/>
+    <p:sldId xmlns:r="http://schemas.openxmlformats.org/officeDocument/2006/relationships" id="267" r:id="R57a621e437c7460e"/>
+    <p:sldId xmlns:r="http://schemas.openxmlformats.org/officeDocument/2006/relationships" id="268" r:id="Rd4262d37f72d41c5"/>
+    <p:sldId xmlns:r="http://schemas.openxmlformats.org/officeDocument/2006/relationships" id="269" r:id="Ra69e73558ef7479f"/>
+    <p:sldId xmlns:r="http://schemas.openxmlformats.org/officeDocument/2006/relationships" id="270" r:id="R5c85f0ad67584a8e"/>
+    <p:sldId xmlns:r="http://schemas.openxmlformats.org/officeDocument/2006/relationships" id="271" r:id="R24b85e49d0a84514"/>
+    <p:sldId xmlns:r="http://schemas.openxmlformats.org/officeDocument/2006/relationships" id="272" r:id="R94110022f71a40b7"/>
+    <p:sldId xmlns:r="http://schemas.openxmlformats.org/officeDocument/2006/relationships" id="273" r:id="R3d37c0e11d2747d5"/>
+    <p:sldId xmlns:r="http://schemas.openxmlformats.org/officeDocument/2006/relationships" id="274" r:id="Ra61e758306ee47f6"/>
+    <p:sldId xmlns:r="http://schemas.openxmlformats.org/officeDocument/2006/relationships" id="275" r:id="R863a8461e273411a"/>
+    <p:sldId xmlns:r="http://schemas.openxmlformats.org/officeDocument/2006/relationships" id="276" r:id="R53ff05ce9d00454d"/>
+    <p:sldId xmlns:r="http://schemas.openxmlformats.org/officeDocument/2006/relationships" id="277" r:id="Ra1e6cedb232040b9"/>
+    <p:sldId xmlns:r="http://schemas.openxmlformats.org/officeDocument/2006/relationships" id="278" r:id="R70533452dfc94ff2"/>
+    <p:sldId xmlns:r="http://schemas.openxmlformats.org/officeDocument/2006/relationships" id="279" r:id="R4ce7307e86794c40"/>
   </p:sldIdLst>
   <p:sldSz cx="12192000" cy="6858000"/>
   <p:notesSz cx="6858000" cy="9144000"/>
   <p:embeddedFontLst>
     <p:embeddedFont>
       <p:font typeface="Play"/>
-      <p:regular xmlns:r="http://schemas.openxmlformats.org/officeDocument/2006/relationships" r:id="Rfebce990e9364765"/>
-      <p:bold xmlns:r="http://schemas.openxmlformats.org/officeDocument/2006/relationships" r:id="Re5b694692d2c45ef"/>
+      <p:regular xmlns:r="http://schemas.openxmlformats.org/officeDocument/2006/relationships" r:id="R944a0518958d49d7"/>
+      <p:bold xmlns:r="http://schemas.openxmlformats.org/officeDocument/2006/relationships" r:id="R46ff4b152a054ef6"/>
     </p:embeddedFont>
   </p:embeddedFontLst>
   <p:defaultTextStyle>
@@ -1074,6 +1076,24 @@
               <a:t/>
             </a:r>
           </a:p>
+          <a:p xmlns:a="http://schemas.openxmlformats.org/drawingml/2006/main">
+            <a:r>
+              <a:t>
+[Sources]
+- MODEL_ROADMAP.md
+- results/b4_architecture/summary.json
+[/Sources]</a:t>
+            </a:r>
+          </a:p>
+          <a:p xmlns:a="http://schemas.openxmlformats.org/drawingml/2006/main">
+            <a:r>
+              <a:t>
+[Sources]
+- MODEL_ROADMAP.md
+- results/b4_architecture/summary.json
+[/Sources]</a:t>
+            </a:r>
+          </a:p>
         </p:txBody>
       </p:sp>
       <p:sp>
@@ -1209,6 +1229,24 @@
               <a:t>B3 accuracy/F1 are the frozen unseen-layout calibrated-threshold confirmation metrics; the candidate was rejected.</a:t>
             </a:r>
           </a:p>
+          <a:p xmlns:a="http://schemas.openxmlformats.org/drawingml/2006/main">
+            <a:r>
+              <a:t>
+[Sources]
+- MODEL_ROADMAP.md
+- results/b4_architecture/summary.json
+[/Sources]</a:t>
+            </a:r>
+          </a:p>
+          <a:p xmlns:a="http://schemas.openxmlformats.org/drawingml/2006/main">
+            <a:r>
+              <a:t>
+[Sources]
+- MODEL_ROADMAP.md
+- results/b4_architecture/summary.json
+[/Sources]</a:t>
+            </a:r>
+          </a:p>
         </p:txBody>
       </p:sp>
       <p:sp>
@@ -2152,6 +2190,248 @@
             </a:pPr>
             <a:r>
               <a:t>The candidate status is failed_confirmation; B2 remains the accepted baseline.</a:t>
+            </a:r>
+          </a:p>
+        </p:txBody>
+      </p:sp>
+      <p:sp>
+        <p:nvSpPr>
+          <p:cNvPr id="4" name="Slide Number Placeholder 3"/>
+          <p:cNvSpPr>
+            <a:spLocks xmlns:a="http://schemas.openxmlformats.org/drawingml/2006/main" noGrp="1"/>
+          </p:cNvSpPr>
+          <p:nvPr>
+            <p:ph type="sldNum" idx="5"/>
+          </p:nvPr>
+        </p:nvSpPr>
+        <p:spPr/>
+        <p:txBody>
+          <a:bodyPr xmlns:a="http://schemas.openxmlformats.org/drawingml/2006/main"/>
+          <a:lstStyle xmlns:a="http://schemas.openxmlformats.org/drawingml/2006/main"/>
+          <a:p xmlns:a="http://schemas.openxmlformats.org/drawingml/2006/main"/>
+        </p:txBody>
+      </p:sp>
+    </p:spTree>
+  </p:cSld>
+  <p:clrMapOvr>
+    <a:masterClrMapping xmlns:a="http://schemas.openxmlformats.org/drawingml/2006/main"/>
+  </p:clrMapOvr>
+</p:notes>
+</file>
+
+<file path=ppt/notesSlides/notesSlide23.xml><?xml version="1.0" encoding="utf-8"?>
+<p:notes xmlns:p="http://schemas.openxmlformats.org/presentationml/2006/main">
+  <p:cSld>
+    <p:spTree>
+      <p:nvGrpSpPr>
+        <p:cNvPr id="1" name=""/>
+        <p:cNvGrpSpPr/>
+        <p:nvPr/>
+      </p:nvGrpSpPr>
+      <p:grpSpPr>
+        <a:xfrm xmlns:a="http://schemas.openxmlformats.org/drawingml/2006/main"/>
+      </p:grpSpPr>
+      <p:sp>
+        <p:nvSpPr>
+          <p:cNvPr id="2" name="Slide Image Placeholder 1"/>
+          <p:cNvSpPr>
+            <a:spLocks xmlns:a="http://schemas.openxmlformats.org/drawingml/2006/main" noGrp="1"/>
+          </p:cNvSpPr>
+          <p:nvPr>
+            <p:ph type="sldImg" idx="0"/>
+          </p:nvPr>
+        </p:nvSpPr>
+        <p:spPr/>
+      </p:sp>
+      <p:sp>
+        <p:nvSpPr>
+          <p:cNvPr id="3" name="Notes Placeholder 2"/>
+          <p:cNvSpPr>
+            <a:spLocks xmlns:a="http://schemas.openxmlformats.org/drawingml/2006/main" noGrp="1"/>
+          </p:cNvSpPr>
+          <p:nvPr>
+            <p:ph type="body" idx="1"/>
+          </p:nvPr>
+        </p:nvSpPr>
+        <p:spPr/>
+        <p:txBody>
+          <a:bodyPr xmlns:a="http://schemas.openxmlformats.org/drawingml/2006/main"/>
+          <a:lstStyle xmlns:a="http://schemas.openxmlformats.org/drawingml/2006/main"/>
+          <a:p xmlns:a="http://schemas.openxmlformats.org/drawingml/2006/main">
+            <a:pPr marL="0" indent="0" algn="l">
+              <a:spcBef>
+                <a:spcPts val="0"/>
+              </a:spcBef>
+              <a:spcAft>
+                <a:spcPts val="0"/>
+              </a:spcAft>
+              <a:buNone/>
+            </a:pPr>
+            <a:r>
+              <a:t>[Sources]</a:t>
+            </a:r>
+          </a:p>
+          <a:p xmlns:a="http://schemas.openxmlformats.org/drawingml/2006/main">
+            <a:pPr marL="0" indent="0" algn="l">
+              <a:spcBef>
+                <a:spcPts val="0"/>
+              </a:spcBef>
+              <a:spcAft>
+                <a:spcPts val="0"/>
+              </a:spcAft>
+              <a:buNone/>
+            </a:pPr>
+            <a:r>
+              <a:t>- results/b4_architecture/summary.json</a:t>
+            </a:r>
+          </a:p>
+          <a:p xmlns:a="http://schemas.openxmlformats.org/drawingml/2006/main">
+            <a:pPr marL="0" indent="0" algn="l">
+              <a:spcBef>
+                <a:spcPts val="0"/>
+              </a:spcBef>
+              <a:spcAft>
+                <a:spcPts val="0"/>
+              </a:spcAft>
+              <a:buNone/>
+            </a:pPr>
+            <a:r>
+              <a:t>- results/b4_architecture/README.md</a:t>
+            </a:r>
+          </a:p>
+          <a:p xmlns:a="http://schemas.openxmlformats.org/drawingml/2006/main">
+            <a:pPr marL="0" indent="0" algn="l">
+              <a:spcBef>
+                <a:spcPts val="0"/>
+              </a:spcBef>
+              <a:spcAft>
+                <a:spcPts val="0"/>
+              </a:spcAft>
+              <a:buNone/>
+            </a:pPr>
+            <a:r>
+              <a:t>[/Sources]</a:t>
+            </a:r>
+          </a:p>
+        </p:txBody>
+      </p:sp>
+      <p:sp>
+        <p:nvSpPr>
+          <p:cNvPr id="4" name="Slide Number Placeholder 3"/>
+          <p:cNvSpPr>
+            <a:spLocks xmlns:a="http://schemas.openxmlformats.org/drawingml/2006/main" noGrp="1"/>
+          </p:cNvSpPr>
+          <p:nvPr>
+            <p:ph type="sldNum" idx="5"/>
+          </p:nvPr>
+        </p:nvSpPr>
+        <p:spPr/>
+        <p:txBody>
+          <a:bodyPr xmlns:a="http://schemas.openxmlformats.org/drawingml/2006/main"/>
+          <a:lstStyle xmlns:a="http://schemas.openxmlformats.org/drawingml/2006/main"/>
+          <a:p xmlns:a="http://schemas.openxmlformats.org/drawingml/2006/main"/>
+        </p:txBody>
+      </p:sp>
+    </p:spTree>
+  </p:cSld>
+  <p:clrMapOvr>
+    <a:masterClrMapping xmlns:a="http://schemas.openxmlformats.org/drawingml/2006/main"/>
+  </p:clrMapOvr>
+</p:notes>
+</file>
+
+<file path=ppt/notesSlides/notesSlide24.xml><?xml version="1.0" encoding="utf-8"?>
+<p:notes xmlns:p="http://schemas.openxmlformats.org/presentationml/2006/main">
+  <p:cSld>
+    <p:spTree>
+      <p:nvGrpSpPr>
+        <p:cNvPr id="1" name=""/>
+        <p:cNvGrpSpPr/>
+        <p:nvPr/>
+      </p:nvGrpSpPr>
+      <p:grpSpPr>
+        <a:xfrm xmlns:a="http://schemas.openxmlformats.org/drawingml/2006/main"/>
+      </p:grpSpPr>
+      <p:sp>
+        <p:nvSpPr>
+          <p:cNvPr id="2" name="Slide Image Placeholder 1"/>
+          <p:cNvSpPr>
+            <a:spLocks xmlns:a="http://schemas.openxmlformats.org/drawingml/2006/main" noGrp="1"/>
+          </p:cNvSpPr>
+          <p:nvPr>
+            <p:ph type="sldImg" idx="0"/>
+          </p:nvPr>
+        </p:nvSpPr>
+        <p:spPr/>
+      </p:sp>
+      <p:sp>
+        <p:nvSpPr>
+          <p:cNvPr id="3" name="Notes Placeholder 2"/>
+          <p:cNvSpPr>
+            <a:spLocks xmlns:a="http://schemas.openxmlformats.org/drawingml/2006/main" noGrp="1"/>
+          </p:cNvSpPr>
+          <p:nvPr>
+            <p:ph type="body" idx="1"/>
+          </p:nvPr>
+        </p:nvSpPr>
+        <p:spPr/>
+        <p:txBody>
+          <a:bodyPr xmlns:a="http://schemas.openxmlformats.org/drawingml/2006/main"/>
+          <a:lstStyle xmlns:a="http://schemas.openxmlformats.org/drawingml/2006/main"/>
+          <a:p xmlns:a="http://schemas.openxmlformats.org/drawingml/2006/main">
+            <a:pPr marL="0" indent="0" algn="l">
+              <a:spcBef>
+                <a:spcPts val="0"/>
+              </a:spcBef>
+              <a:spcAft>
+                <a:spcPts val="0"/>
+              </a:spcAft>
+              <a:buNone/>
+            </a:pPr>
+            <a:r>
+              <a:t>[Sources]</a:t>
+            </a:r>
+          </a:p>
+          <a:p xmlns:a="http://schemas.openxmlformats.org/drawingml/2006/main">
+            <a:pPr marL="0" indent="0" algn="l">
+              <a:spcBef>
+                <a:spcPts val="0"/>
+              </a:spcBef>
+              <a:spcAft>
+                <a:spcPts val="0"/>
+              </a:spcAft>
+              <a:buNone/>
+            </a:pPr>
+            <a:r>
+              <a:t>- results/b4_architecture/summary.json</a:t>
+            </a:r>
+          </a:p>
+          <a:p xmlns:a="http://schemas.openxmlformats.org/drawingml/2006/main">
+            <a:pPr marL="0" indent="0" algn="l">
+              <a:spcBef>
+                <a:spcPts val="0"/>
+              </a:spcBef>
+              <a:spcAft>
+                <a:spcPts val="0"/>
+              </a:spcAft>
+              <a:buNone/>
+            </a:pPr>
+            <a:r>
+              <a:t>- results/b4_architecture/README.md</a:t>
+            </a:r>
+          </a:p>
+          <a:p xmlns:a="http://schemas.openxmlformats.org/drawingml/2006/main">
+            <a:pPr marL="0" indent="0" algn="l">
+              <a:spcBef>
+                <a:spcPts val="0"/>
+              </a:spcBef>
+              <a:spcAft>
+                <a:spcPts val="0"/>
+              </a:spcAft>
+              <a:buNone/>
+            </a:pPr>
+            <a:r>
+              <a:t>[/Sources]</a:t>
             </a:r>
           </a:p>
         </p:txBody>
@@ -11573,17 +11853,17 @@
   </p:cSld>
   <p:clrMap bg1="lt1" tx1="dk1" bg2="dk2" tx2="lt2" accent1="accent1" accent2="accent2" accent3="accent3" accent4="accent4" accent5="accent5" accent6="accent6" hlink="hlink" folHlink="folHlink"/>
   <p:sldLayoutIdLst>
-    <p:sldLayoutId xmlns:r="http://schemas.openxmlformats.org/officeDocument/2006/relationships" id="2147483649" r:id="R4d6153bd9f074abe"/>
-    <p:sldLayoutId xmlns:r="http://schemas.openxmlformats.org/officeDocument/2006/relationships" id="2147483650" r:id="Rc8b378f395e0463f"/>
-    <p:sldLayoutId xmlns:r="http://schemas.openxmlformats.org/officeDocument/2006/relationships" id="2147483651" r:id="R169bc14220544859"/>
-    <p:sldLayoutId xmlns:r="http://schemas.openxmlformats.org/officeDocument/2006/relationships" id="2147483652" r:id="R5d7cc040c9a34c43"/>
-    <p:sldLayoutId xmlns:r="http://schemas.openxmlformats.org/officeDocument/2006/relationships" id="2147483653" r:id="R426f2a5b84e64c4a"/>
-    <p:sldLayoutId xmlns:r="http://schemas.openxmlformats.org/officeDocument/2006/relationships" id="2147483654" r:id="Rb0570727b7104115"/>
-    <p:sldLayoutId xmlns:r="http://schemas.openxmlformats.org/officeDocument/2006/relationships" id="2147483655" r:id="R9919d22da0eb4cda"/>
-    <p:sldLayoutId xmlns:r="http://schemas.openxmlformats.org/officeDocument/2006/relationships" id="2147483656" r:id="Rd287dd38f4494cc1"/>
-    <p:sldLayoutId xmlns:r="http://schemas.openxmlformats.org/officeDocument/2006/relationships" id="2147483657" r:id="R79c1d26f4ea74b5c"/>
-    <p:sldLayoutId xmlns:r="http://schemas.openxmlformats.org/officeDocument/2006/relationships" id="2147483658" r:id="R741d7db685464de3"/>
-    <p:sldLayoutId xmlns:r="http://schemas.openxmlformats.org/officeDocument/2006/relationships" id="2147483659" r:id="R9502d669b8334273"/>
+    <p:sldLayoutId xmlns:r="http://schemas.openxmlformats.org/officeDocument/2006/relationships" id="2147483649" r:id="R3b6280cc02e24f20"/>
+    <p:sldLayoutId xmlns:r="http://schemas.openxmlformats.org/officeDocument/2006/relationships" id="2147483650" r:id="R378080260697450e"/>
+    <p:sldLayoutId xmlns:r="http://schemas.openxmlformats.org/officeDocument/2006/relationships" id="2147483651" r:id="R900a4da617894d68"/>
+    <p:sldLayoutId xmlns:r="http://schemas.openxmlformats.org/officeDocument/2006/relationships" id="2147483652" r:id="Redd93e4f75014d0f"/>
+    <p:sldLayoutId xmlns:r="http://schemas.openxmlformats.org/officeDocument/2006/relationships" id="2147483653" r:id="Re0ca72a621d94dab"/>
+    <p:sldLayoutId xmlns:r="http://schemas.openxmlformats.org/officeDocument/2006/relationships" id="2147483654" r:id="R9c5a1f7b14a243f8"/>
+    <p:sldLayoutId xmlns:r="http://schemas.openxmlformats.org/officeDocument/2006/relationships" id="2147483655" r:id="Rc310956dc6c84a51"/>
+    <p:sldLayoutId xmlns:r="http://schemas.openxmlformats.org/officeDocument/2006/relationships" id="2147483656" r:id="R5e0672455ce047af"/>
+    <p:sldLayoutId xmlns:r="http://schemas.openxmlformats.org/officeDocument/2006/relationships" id="2147483657" r:id="Rdca783112af64d08"/>
+    <p:sldLayoutId xmlns:r="http://schemas.openxmlformats.org/officeDocument/2006/relationships" id="2147483658" r:id="R032597e46fda4610"/>
+    <p:sldLayoutId xmlns:r="http://schemas.openxmlformats.org/officeDocument/2006/relationships" id="2147483659" r:id="R972a6526be2d42eb"/>
   </p:sldLayoutIdLst>
   <p:hf sldNum="0" hdr="0" ftr="0" dt="0"/>
   <p:txStyles>
@@ -12535,7 +12815,7 @@
               <a:buNone/>
             </a:pPr>
             <a:r>
-              <a:t>CNN-based DRC | B0–B3 complete · B4 next</a:t>
+              <a:t>CNN-based DRC | B0–B4 complete · B5 experiments next</a:t>
             </a:r>
           </a:p>
         </p:txBody>
@@ -16464,7 +16744,7 @@
               <a:buChar char="●"/>
             </a:pPr>
             <a:r>
-              <a:t>B4  Architecture tests — next</a:t>
+              <a:t>B4  Architecture tests — complete</a:t>
             </a:r>
           </a:p>
         </p:txBody>
@@ -16510,7 +16790,7 @@
               <a:buChar char="●"/>
             </a:pPr>
             <a:r>
-              <a:t>B5  Error analysis + targeted data</a:t>
+              <a:t>B5  Ensemble + targeted improvements — next</a:t>
             </a:r>
           </a:p>
           <a:p xmlns:a="http://schemas.openxmlformats.org/drawingml/2006/main">
@@ -16623,7 +16903,7 @@
                   <a:srgbClr val="404040"/>
                 </a:solidFill>
               </a:rPr>
-              <a:t>Every phase records the delta vs. the previous phase while preserving frozen test sets.</a:t>
+              <a:t>Exhaust justified classifier gains, then deliver masks, coordinates, and verified repairs.</a:t>
             </a:r>
           </a:p>
         </p:txBody>
@@ -18516,7 +18796,7 @@
                   <a:srgbClr val="262626"/>
                 </a:solidFill>
               </a:rPr>
-              <a:t>Next</a:t>
+              <a:t>Done</a:t>
             </a:r>
           </a:p>
         </p:txBody>
@@ -18573,7 +18853,7 @@
                   <a:srgbClr val="262626"/>
                 </a:solidFill>
               </a:rPr>
-              <a:t>Compact architecture candidate</a:t>
+              <a:t>Compact model rejected</a:t>
             </a:r>
           </a:p>
         </p:txBody>
@@ -18630,7 +18910,7 @@
                   <a:srgbClr val="262626"/>
                 </a:solidFill>
               </a:rPr>
-              <a:t>—</a:t>
+              <a:t>89.36%</a:t>
             </a:r>
           </a:p>
         </p:txBody>
@@ -18687,7 +18967,7 @@
                   <a:srgbClr val="262626"/>
                 </a:solidFill>
               </a:rPr>
-              <a:t>—</a:t>
+              <a:t>0.904</a:t>
             </a:r>
           </a:p>
         </p:txBody>
@@ -18744,7 +19024,7 @@
                   <a:srgbClr val="262626"/>
                 </a:solidFill>
               </a:rPr>
-              <a:t>—</a:t>
+              <a:t>−0.006</a:t>
             </a:r>
           </a:p>
         </p:txBody>
@@ -18801,7 +19081,7 @@
                   <a:srgbClr val="73400D"/>
                 </a:solidFill>
               </a:rPr>
-              <a:t>B3 complete: recall reached 94.42%, but unseen accuracy regressed 0.67 points. B2 stays frozen; B4 is next.</a:t>
+              <a:t>B4: 14.3× smaller, but unseen F1 fell 0.58 points. B2 stays; B5 tests complementary B2+B4 errors.</a:t>
             </a:r>
           </a:p>
         </p:txBody>
@@ -19151,7 +19431,7 @@
           </p:nvPr>
         </p:nvPicPr>
         <p:blipFill rotWithShape="1">
-          <a:blip xmlns:r="http://schemas.openxmlformats.org/officeDocument/2006/relationships" xmlns:a="http://schemas.openxmlformats.org/drawingml/2006/main" r:embed="R9f764e9467b44ea4">
+          <a:blip xmlns:r="http://schemas.openxmlformats.org/officeDocument/2006/relationships" xmlns:a="http://schemas.openxmlformats.org/drawingml/2006/main" r:embed="R1e33ad49612b496e">
             <a:alphaModFix/>
           </a:blip>
           <a:srcRect xmlns:a="http://schemas.openxmlformats.org/drawingml/2006/main" l="0" t="0" r="0" b="0"/>
@@ -19179,7 +19459,7 @@
           <p:nvPr/>
         </p:nvPicPr>
         <p:blipFill rotWithShape="1">
-          <a:blip xmlns:r="http://schemas.openxmlformats.org/officeDocument/2006/relationships" xmlns:a="http://schemas.openxmlformats.org/drawingml/2006/main" r:embed="Rcd75fbefed1845f8">
+          <a:blip xmlns:r="http://schemas.openxmlformats.org/officeDocument/2006/relationships" xmlns:a="http://schemas.openxmlformats.org/drawingml/2006/main" r:embed="Rbb1e2d4736b94b1a">
             <a:alphaModFix/>
           </a:blip>
           <a:srcRect xmlns:a="http://schemas.openxmlformats.org/drawingml/2006/main" l="0" t="0" r="0" b="0"/>
@@ -24337,6 +24617,494 @@
 </p:sld>
 </file>
 
+<file path=ppt/slides/slide23.xml><?xml version="1.0" encoding="utf-8"?>
+<p:sld xmlns:p="http://schemas.openxmlformats.org/presentationml/2006/main">
+  <p:cSld>
+    <p:spTree>
+      <p:nvGrpSpPr>
+        <p:cNvPr id="1" name=""/>
+        <p:cNvGrpSpPr/>
+        <p:nvPr/>
+      </p:nvGrpSpPr>
+      <p:grpSpPr>
+        <a:xfrm xmlns:a="http://schemas.openxmlformats.org/drawingml/2006/main"/>
+      </p:grpSpPr>
+      <p:sp>
+        <p:nvSpPr>
+          <p:cNvPr id="212" name="Google Shape;212;p23">
+            <a:extLst xmlns:a="http://schemas.openxmlformats.org/drawingml/2006/main">
+              <a:ext uri="{FF2B5EF4-FFF2-40B4-BE49-F238E27FC236}">
+                <a16:creationId xmlns:a16="http://schemas.microsoft.com/office/drawing/2014/main" id="{CEA2EDDF-A2CD-44CF-98BB-801657D2DD0E}"/>
+              </a:ext>
+            </a:extLst>
+          </p:cNvPr>
+          <p:cNvSpPr>
+            <a:spLocks xmlns:a="http://schemas.openxmlformats.org/drawingml/2006/main" noGrp="1"/>
+          </p:cNvSpPr>
+          <p:nvPr>
+            <p:ph type="title" idx="0"/>
+          </p:nvPr>
+        </p:nvSpPr>
+        <p:spPr>
+          <a:xfrm xmlns:a="http://schemas.openxmlformats.org/drawingml/2006/main">
+            <a:off x="838200" y="365125"/>
+            <a:ext cx="10515600" cy="1325700"/>
+          </a:xfrm>
+          <a:prstGeom xmlns:a="http://schemas.openxmlformats.org/drawingml/2006/main" prst="rect">
+            <a:avLst/>
+          </a:prstGeom>
+        </p:spPr>
+        <p:txBody>
+          <a:bodyPr xmlns:a="http://schemas.openxmlformats.org/drawingml/2006/main" spcFirstLastPara="1" wrap="square" lIns="91425" tIns="45700" rIns="91425" bIns="45700" anchor="ctr">
+            <a:noAutofit/>
+          </a:bodyPr>
+          <a:lstStyle xmlns:a="http://schemas.openxmlformats.org/drawingml/2006/main"/>
+          <a:p xmlns:a="http://schemas.openxmlformats.org/drawingml/2006/main">
+            <a:pPr marL="0" indent="0" algn="l">
+              <a:spcBef>
+                <a:spcPts val="0"/>
+              </a:spcBef>
+              <a:spcAft>
+                <a:spcPts val="0"/>
+              </a:spcAft>
+              <a:buNone/>
+            </a:pPr>
+            <a:r>
+              <a:t>B4: validation and cost gates passed</a:t>
+            </a:r>
+          </a:p>
+        </p:txBody>
+      </p:sp>
+      <p:sp>
+        <p:nvSpPr>
+          <p:cNvPr id="213" name="Google Shape;213;p23">
+            <a:extLst xmlns:a="http://schemas.openxmlformats.org/drawingml/2006/main">
+              <a:ext uri="{FF2B5EF4-FFF2-40B4-BE49-F238E27FC236}">
+                <a16:creationId xmlns:a16="http://schemas.microsoft.com/office/drawing/2014/main" id="{DF709342-A5A8-450D-BE61-4B8EA771B374}"/>
+              </a:ext>
+            </a:extLst>
+          </p:cNvPr>
+          <p:cNvSpPr>
+            <a:spLocks xmlns:a="http://schemas.openxmlformats.org/drawingml/2006/main" noGrp="1"/>
+          </p:cNvSpPr>
+          <p:nvPr>
+            <p:ph type="body" idx="1"/>
+          </p:nvPr>
+        </p:nvSpPr>
+        <p:spPr>
+          <a:xfrm xmlns:a="http://schemas.openxmlformats.org/drawingml/2006/main">
+            <a:off x="838200" y="1825625"/>
+            <a:ext cx="5181600" cy="4351200"/>
+          </a:xfrm>
+          <a:prstGeom xmlns:a="http://schemas.openxmlformats.org/drawingml/2006/main" prst="rect">
+            <a:avLst/>
+          </a:prstGeom>
+        </p:spPr>
+        <p:txBody>
+          <a:bodyPr xmlns:a="http://schemas.openxmlformats.org/drawingml/2006/main" spcFirstLastPara="1" wrap="square" lIns="91425" tIns="45700" rIns="91425" bIns="45700" anchor="t">
+            <a:noAutofit/>
+          </a:bodyPr>
+          <a:lstStyle xmlns:a="http://schemas.openxmlformats.org/drawingml/2006/main"/>
+          <a:p xmlns:a="http://schemas.openxmlformats.org/drawingml/2006/main">
+            <a:pPr marL="457200" indent="-342900" algn="l">
+              <a:spcBef>
+                <a:spcPts val="1000"/>
+              </a:spcBef>
+              <a:spcAft>
+                <a:spcPts val="0"/>
+              </a:spcAft>
+              <a:buChar char="●"/>
+            </a:pPr>
+            <a:r>
+              <a:t>Validation F1: 91.36% → 93.61%</a:t>
+            </a:r>
+          </a:p>
+          <a:p xmlns:a="http://schemas.openxmlformats.org/drawingml/2006/main">
+            <a:pPr marL="457200" indent="-342900" algn="l">
+              <a:spcBef>
+                <a:spcPts val="0"/>
+              </a:spcBef>
+              <a:spcAft>
+                <a:spcPts val="0"/>
+              </a:spcAft>
+              <a:buChar char="●"/>
+            </a:pPr>
+            <a:r>
+              <a:t>Validation recall: 88.60% → 92.37%</a:t>
+            </a:r>
+          </a:p>
+          <a:p xmlns:a="http://schemas.openxmlformats.org/drawingml/2006/main">
+            <a:pPr marL="457200" indent="-342900" algn="l">
+              <a:spcBef>
+                <a:spcPts val="0"/>
+              </a:spcBef>
+              <a:spcAft>
+                <a:spcPts val="0"/>
+              </a:spcAft>
+              <a:buChar char="●"/>
+            </a:pPr>
+            <a:r>
+              <a:t>All three seeds improved F1</a:t>
+            </a:r>
+          </a:p>
+          <a:p xmlns:a="http://schemas.openxmlformats.org/drawingml/2006/main">
+            <a:pPr marL="457200" indent="-342900" algn="l">
+              <a:spcBef>
+                <a:spcPts val="0"/>
+              </a:spcBef>
+              <a:spcAft>
+                <a:spcPts val="0"/>
+              </a:spcAft>
+              <a:buChar char="●"/>
+            </a:pPr>
+            <a:r>
+              <a:t>Frozen tests unlocked</a:t>
+            </a:r>
+          </a:p>
+        </p:txBody>
+      </p:sp>
+      <p:sp>
+        <p:nvSpPr>
+          <p:cNvPr id="214" name="Google Shape;214;p23">
+            <a:extLst xmlns:a="http://schemas.openxmlformats.org/drawingml/2006/main">
+              <a:ext uri="{FF2B5EF4-FFF2-40B4-BE49-F238E27FC236}">
+                <a16:creationId xmlns:a16="http://schemas.microsoft.com/office/drawing/2014/main" id="{391DC8AD-B282-472F-BADA-EE209EE8D6C2}"/>
+              </a:ext>
+            </a:extLst>
+          </p:cNvPr>
+          <p:cNvSpPr>
+            <a:spLocks xmlns:a="http://schemas.openxmlformats.org/drawingml/2006/main" noGrp="1"/>
+          </p:cNvSpPr>
+          <p:nvPr>
+            <p:ph type="body" idx="2"/>
+          </p:nvPr>
+        </p:nvSpPr>
+        <p:spPr>
+          <a:xfrm xmlns:a="http://schemas.openxmlformats.org/drawingml/2006/main">
+            <a:off x="6172200" y="1825625"/>
+            <a:ext cx="5181600" cy="4351200"/>
+          </a:xfrm>
+          <a:prstGeom xmlns:a="http://schemas.openxmlformats.org/drawingml/2006/main" prst="rect">
+            <a:avLst/>
+          </a:prstGeom>
+        </p:spPr>
+        <p:txBody>
+          <a:bodyPr xmlns:a="http://schemas.openxmlformats.org/drawingml/2006/main" spcFirstLastPara="1" wrap="square" lIns="91425" tIns="45700" rIns="91425" bIns="45700" anchor="t">
+            <a:noAutofit/>
+          </a:bodyPr>
+          <a:lstStyle xmlns:a="http://schemas.openxmlformats.org/drawingml/2006/main"/>
+          <a:p xmlns:a="http://schemas.openxmlformats.org/drawingml/2006/main">
+            <a:pPr marL="457200" indent="-342900" algn="l">
+              <a:spcBef>
+                <a:spcPts val="1000"/>
+              </a:spcBef>
+              <a:spcAft>
+                <a:spcPts val="0"/>
+              </a:spcAft>
+              <a:buChar char="●"/>
+            </a:pPr>
+            <a:r>
+              <a:t>Parameters: 602k → 42k</a:t>
+            </a:r>
+          </a:p>
+          <a:p xmlns:a="http://schemas.openxmlformats.org/drawingml/2006/main">
+            <a:pPr marL="457200" indent="-342900" algn="l">
+              <a:spcBef>
+                <a:spcPts val="0"/>
+              </a:spcBef>
+              <a:spcAft>
+                <a:spcPts val="0"/>
+              </a:spcAft>
+              <a:buChar char="●"/>
+            </a:pPr>
+            <a:r>
+              <a:t>State dict: 2.41 MB → 179 KB</a:t>
+            </a:r>
+          </a:p>
+          <a:p xmlns:a="http://schemas.openxmlformats.org/drawingml/2006/main">
+            <a:pPr marL="457200" indent="-342900" algn="l">
+              <a:spcBef>
+                <a:spcPts val="0"/>
+              </a:spcBef>
+              <a:spcAft>
+                <a:spcPts val="0"/>
+              </a:spcAft>
+              <a:buChar char="●"/>
+            </a:pPr>
+            <a:r>
+              <a:t>PyTorch CPU: 14.06 → 8.63 ms</a:t>
+            </a:r>
+          </a:p>
+          <a:p xmlns:a="http://schemas.openxmlformats.org/drawingml/2006/main">
+            <a:pPr marL="457200" indent="-342900" algn="l">
+              <a:spcBef>
+                <a:spcPts val="0"/>
+              </a:spcBef>
+              <a:spcAft>
+                <a:spcPts val="0"/>
+              </a:spcAft>
+              <a:buChar char="●"/>
+            </a:pPr>
+            <a:r>
+              <a:t>ONNX CPU: 1.92 → 2.19 ms</a:t>
+            </a:r>
+          </a:p>
+        </p:txBody>
+      </p:sp>
+    </p:spTree>
+    <p:extLst>
+      <p:ext uri="{BB962C8B-B14F-4D97-AF65-F5344CB8AC3E}">
+        <p14:creationId xmlns:p14="http://schemas.microsoft.com/office/powerpoint/2010/main" val="463416430"/>
+      </p:ext>
+    </p:extLst>
+  </p:cSld>
+</p:sld>
+</file>
+
+<file path=ppt/slides/slide24.xml><?xml version="1.0" encoding="utf-8"?>
+<p:sld xmlns:p="http://schemas.openxmlformats.org/presentationml/2006/main">
+  <p:cSld>
+    <p:spTree>
+      <p:nvGrpSpPr>
+        <p:cNvPr id="1" name=""/>
+        <p:cNvGrpSpPr/>
+        <p:nvPr/>
+      </p:nvGrpSpPr>
+      <p:grpSpPr>
+        <a:xfrm xmlns:a="http://schemas.openxmlformats.org/drawingml/2006/main"/>
+      </p:grpSpPr>
+      <p:sp>
+        <p:nvSpPr>
+          <p:cNvPr id="212" name="Google Shape;212;p23">
+            <a:extLst xmlns:a="http://schemas.openxmlformats.org/drawingml/2006/main">
+              <a:ext uri="{FF2B5EF4-FFF2-40B4-BE49-F238E27FC236}">
+                <a16:creationId xmlns:a16="http://schemas.microsoft.com/office/drawing/2014/main" id="{CEA2EDDF-A2CD-44CF-98BB-801657D2DD0E}"/>
+              </a:ext>
+            </a:extLst>
+          </p:cNvPr>
+          <p:cNvSpPr>
+            <a:spLocks xmlns:a="http://schemas.openxmlformats.org/drawingml/2006/main" noGrp="1"/>
+          </p:cNvSpPr>
+          <p:nvPr>
+            <p:ph type="title" idx="0"/>
+          </p:nvPr>
+        </p:nvSpPr>
+        <p:spPr>
+          <a:xfrm xmlns:a="http://schemas.openxmlformats.org/drawingml/2006/main">
+            <a:off x="838200" y="365125"/>
+            <a:ext cx="10515600" cy="1325700"/>
+          </a:xfrm>
+          <a:prstGeom xmlns:a="http://schemas.openxmlformats.org/drawingml/2006/main" prst="rect">
+            <a:avLst/>
+          </a:prstGeom>
+        </p:spPr>
+        <p:txBody>
+          <a:bodyPr xmlns:a="http://schemas.openxmlformats.org/drawingml/2006/main" spcFirstLastPara="1" wrap="square" lIns="91425" tIns="45700" rIns="91425" bIns="45700" anchor="ctr">
+            <a:noAutofit/>
+          </a:bodyPr>
+          <a:lstStyle xmlns:a="http://schemas.openxmlformats.org/drawingml/2006/main"/>
+          <a:p xmlns:a="http://schemas.openxmlformats.org/drawingml/2006/main">
+            <a:pPr marL="0" indent="0" algn="l">
+              <a:spcBef>
+                <a:spcPts val="0"/>
+              </a:spcBef>
+              <a:spcAft>
+                <a:spcPts val="0"/>
+              </a:spcAft>
+              <a:buNone/>
+            </a:pPr>
+            <a:r>
+              <a:t>B4: compact model fails frozen tests</a:t>
+            </a:r>
+          </a:p>
+        </p:txBody>
+      </p:sp>
+      <p:sp>
+        <p:nvSpPr>
+          <p:cNvPr id="213" name="Google Shape;213;p23">
+            <a:extLst xmlns:a="http://schemas.openxmlformats.org/drawingml/2006/main">
+              <a:ext uri="{FF2B5EF4-FFF2-40B4-BE49-F238E27FC236}">
+                <a16:creationId xmlns:a16="http://schemas.microsoft.com/office/drawing/2014/main" id="{DF709342-A5A8-450D-BE61-4B8EA771B374}"/>
+              </a:ext>
+            </a:extLst>
+          </p:cNvPr>
+          <p:cNvSpPr>
+            <a:spLocks xmlns:a="http://schemas.openxmlformats.org/drawingml/2006/main" noGrp="1"/>
+          </p:cNvSpPr>
+          <p:nvPr>
+            <p:ph type="body" idx="1"/>
+          </p:nvPr>
+        </p:nvSpPr>
+        <p:spPr>
+          <a:xfrm xmlns:a="http://schemas.openxmlformats.org/drawingml/2006/main">
+            <a:off x="838200" y="1825625"/>
+            <a:ext cx="5181600" cy="4351200"/>
+          </a:xfrm>
+          <a:prstGeom xmlns:a="http://schemas.openxmlformats.org/drawingml/2006/main" prst="rect">
+            <a:avLst/>
+          </a:prstGeom>
+        </p:spPr>
+        <p:txBody>
+          <a:bodyPr xmlns:a="http://schemas.openxmlformats.org/drawingml/2006/main" spcFirstLastPara="1" wrap="square" lIns="91425" tIns="45700" rIns="91425" bIns="45700" anchor="t">
+            <a:noAutofit/>
+          </a:bodyPr>
+          <a:lstStyle xmlns:a="http://schemas.openxmlformats.org/drawingml/2006/main"/>
+          <a:p xmlns:a="http://schemas.openxmlformats.org/drawingml/2006/main">
+            <a:pPr marL="457200" indent="-342900" algn="l">
+              <a:spcBef>
+                <a:spcPts val="1000"/>
+              </a:spcBef>
+              <a:spcAft>
+                <a:spcPts val="0"/>
+              </a:spcAft>
+              <a:buChar char="●"/>
+            </a:pPr>
+            <a:r>
+              <a:t>Unseen accuracy: 90.38% → 89.36%</a:t>
+            </a:r>
+          </a:p>
+          <a:p xmlns:a="http://schemas.openxmlformats.org/drawingml/2006/main">
+            <a:pPr marL="457200" indent="-342900" algn="l">
+              <a:spcBef>
+                <a:spcPts val="0"/>
+              </a:spcBef>
+              <a:spcAft>
+                <a:spcPts val="0"/>
+              </a:spcAft>
+              <a:buChar char="●"/>
+            </a:pPr>
+            <a:r>
+              <a:t>Unseen F1: 90.94% → 90.36%</a:t>
+            </a:r>
+          </a:p>
+          <a:p xmlns:a="http://schemas.openxmlformats.org/drawingml/2006/main">
+            <a:pPr marL="457200" indent="-342900" algn="l">
+              <a:spcBef>
+                <a:spcPts val="0"/>
+              </a:spcBef>
+              <a:spcAft>
+                <a:spcPts val="0"/>
+              </a:spcAft>
+              <a:buChar char="●"/>
+            </a:pPr>
+            <a:r>
+              <a:t>Unseen recall: 90.73% → 93.72%</a:t>
+            </a:r>
+          </a:p>
+          <a:p xmlns:a="http://schemas.openxmlformats.org/drawingml/2006/main">
+            <a:pPr marL="457200" indent="-342900" algn="l">
+              <a:spcBef>
+                <a:spcPts val="0"/>
+              </a:spcBef>
+              <a:spcAft>
+                <a:spcPts val="0"/>
+              </a:spcAft>
+              <a:buChar char="●"/>
+            </a:pPr>
+            <a:r>
+              <a:t>No seed improved unseen F1</a:t>
+            </a:r>
+          </a:p>
+        </p:txBody>
+      </p:sp>
+      <p:sp>
+        <p:nvSpPr>
+          <p:cNvPr id="214" name="Google Shape;214;p23">
+            <a:extLst xmlns:a="http://schemas.openxmlformats.org/drawingml/2006/main">
+              <a:ext uri="{FF2B5EF4-FFF2-40B4-BE49-F238E27FC236}">
+                <a16:creationId xmlns:a16="http://schemas.microsoft.com/office/drawing/2014/main" id="{391DC8AD-B282-472F-BADA-EE209EE8D6C2}"/>
+              </a:ext>
+            </a:extLst>
+          </p:cNvPr>
+          <p:cNvSpPr>
+            <a:spLocks xmlns:a="http://schemas.openxmlformats.org/drawingml/2006/main" noGrp="1"/>
+          </p:cNvSpPr>
+          <p:nvPr>
+            <p:ph type="body" idx="2"/>
+          </p:nvPr>
+        </p:nvSpPr>
+        <p:spPr>
+          <a:xfrm xmlns:a="http://schemas.openxmlformats.org/drawingml/2006/main">
+            <a:off x="6172200" y="1825625"/>
+            <a:ext cx="5181600" cy="4351200"/>
+          </a:xfrm>
+          <a:prstGeom xmlns:a="http://schemas.openxmlformats.org/drawingml/2006/main" prst="rect">
+            <a:avLst/>
+          </a:prstGeom>
+        </p:spPr>
+        <p:txBody>
+          <a:bodyPr xmlns:a="http://schemas.openxmlformats.org/drawingml/2006/main" spcFirstLastPara="1" wrap="square" lIns="91425" tIns="45700" rIns="91425" bIns="45700" anchor="t">
+            <a:noAutofit/>
+          </a:bodyPr>
+          <a:lstStyle xmlns:a="http://schemas.openxmlformats.org/drawingml/2006/main"/>
+          <a:p xmlns:a="http://schemas.openxmlformats.org/drawingml/2006/main">
+            <a:pPr marL="457200" indent="-342900" algn="l">
+              <a:spcBef>
+                <a:spcPts val="1000"/>
+              </a:spcBef>
+              <a:spcAft>
+                <a:spcPts val="0"/>
+              </a:spcAft>
+              <a:buChar char="●"/>
+            </a:pPr>
+            <a:r>
+              <a:t>Tile accuracy: 92.47% → 94.42%</a:t>
+            </a:r>
+          </a:p>
+          <a:p xmlns:a="http://schemas.openxmlformats.org/drawingml/2006/main">
+            <a:pPr marL="457200" indent="-342900" algn="l">
+              <a:spcBef>
+                <a:spcPts val="0"/>
+              </a:spcBef>
+              <a:spcAft>
+                <a:spcPts val="0"/>
+              </a:spcAft>
+              <a:buChar char="●"/>
+            </a:pPr>
+            <a:r>
+              <a:t>Tile F1: 91.89% → 93.74%</a:t>
+            </a:r>
+          </a:p>
+          <a:p xmlns:a="http://schemas.openxmlformats.org/drawingml/2006/main">
+            <a:pPr marL="457200" indent="-342900" algn="l">
+              <a:spcBef>
+                <a:spcPts val="0"/>
+              </a:spcBef>
+              <a:spcAft>
+                <a:spcPts val="0"/>
+              </a:spcAft>
+              <a:buChar char="●"/>
+            </a:pPr>
+            <a:r>
+              <a:t>Tile recall: 93.39% → 91.36%</a:t>
+            </a:r>
+          </a:p>
+          <a:p xmlns:a="http://schemas.openxmlformats.org/drawingml/2006/main">
+            <a:pPr marL="457200" indent="-342900" algn="l">
+              <a:spcBef>
+                <a:spcPts val="0"/>
+              </a:spcBef>
+              <a:spcAft>
+                <a:spcPts val="0"/>
+              </a:spcAft>
+              <a:buChar char="●"/>
+            </a:pPr>
+            <a:r>
+              <a:t>Keep B2; test B2+B4 ensemble next</a:t>
+            </a:r>
+          </a:p>
+        </p:txBody>
+      </p:sp>
+    </p:spTree>
+    <p:extLst>
+      <p:ext uri="{BB962C8B-B14F-4D97-AF65-F5344CB8AC3E}">
+        <p14:creationId xmlns:p14="http://schemas.microsoft.com/office/powerpoint/2010/main" val="463416430"/>
+      </p:ext>
+    </p:extLst>
+  </p:cSld>
+</p:sld>
+</file>
+
 <file path=ppt/slides/slide3.xml><?xml version="1.0" encoding="utf-8"?>
 <p:sld xmlns:p="http://schemas.openxmlformats.org/presentationml/2006/main">
   <p:cSld>
@@ -24411,7 +25179,7 @@
           <p:nvPr/>
         </p:nvPicPr>
         <p:blipFill rotWithShape="1">
-          <a:blip xmlns:r="http://schemas.openxmlformats.org/officeDocument/2006/relationships" xmlns:a="http://schemas.openxmlformats.org/drawingml/2006/main" r:embed="R05624123856446b6">
+          <a:blip xmlns:r="http://schemas.openxmlformats.org/officeDocument/2006/relationships" xmlns:a="http://schemas.openxmlformats.org/drawingml/2006/main" r:embed="R9a4bd79626a24880">
             <a:alphaModFix/>
           </a:blip>
           <a:srcRect xmlns:a="http://schemas.openxmlformats.org/drawingml/2006/main" l="0" t="0" r="0" b="0"/>
@@ -24439,7 +25207,7 @@
           <p:nvPr/>
         </p:nvPicPr>
         <p:blipFill rotWithShape="1">
-          <a:blip xmlns:r="http://schemas.openxmlformats.org/officeDocument/2006/relationships" xmlns:a="http://schemas.openxmlformats.org/drawingml/2006/main" r:embed="Rd588cc2287e2422f">
+          <a:blip xmlns:r="http://schemas.openxmlformats.org/officeDocument/2006/relationships" xmlns:a="http://schemas.openxmlformats.org/drawingml/2006/main" r:embed="Re2fdc59fcbde47e8">
             <a:alphaModFix/>
           </a:blip>
           <a:srcRect xmlns:a="http://schemas.openxmlformats.org/drawingml/2006/main" l="0" t="0" r="0" b="0"/>
@@ -24729,7 +25497,7 @@
           <p:nvPr/>
         </p:nvPicPr>
         <p:blipFill rotWithShape="1">
-          <a:blip xmlns:r="http://schemas.openxmlformats.org/officeDocument/2006/relationships" xmlns:a="http://schemas.openxmlformats.org/drawingml/2006/main" r:embed="Rf1956eb7f2ac4b04">
+          <a:blip xmlns:r="http://schemas.openxmlformats.org/officeDocument/2006/relationships" xmlns:a="http://schemas.openxmlformats.org/drawingml/2006/main" r:embed="R1ec108b20f27464d">
             <a:alphaModFix/>
           </a:blip>
           <a:srcRect xmlns:a="http://schemas.openxmlformats.org/drawingml/2006/main" l="0" t="0" r="0" b="0"/>
@@ -25042,7 +25810,7 @@
       </p:sp>
       <p:pic>
         <p:nvPicPr>
-          <p:cNvPr id="501" name="Google Shape;119;p17"/>
+          <p:cNvPr id="689" name="Google Shape;119;p17"/>
           <p:cNvPicPr>
             <a:picLocks xmlns:a="http://schemas.openxmlformats.org/drawingml/2006/main" noChangeAspect="1"/>
           </p:cNvPicPr>
@@ -25051,7 +25819,7 @@
           </p:nvPr>
         </p:nvPicPr>
         <p:blipFill rotWithShape="1">
-          <a:blip xmlns:r="http://schemas.openxmlformats.org/officeDocument/2006/relationships" xmlns:a="http://schemas.openxmlformats.org/drawingml/2006/main" r:embed="Rcaa465c50f1943fd">
+          <a:blip xmlns:r="http://schemas.openxmlformats.org/officeDocument/2006/relationships" xmlns:a="http://schemas.openxmlformats.org/drawingml/2006/main" r:embed="R9801dadde359456b">
             <a:alphaModFix/>
           </a:blip>
           <a:srcRect xmlns:a="http://schemas.openxmlformats.org/drawingml/2006/main" l="0" t="0" r="0" b="0"/>
@@ -25076,14 +25844,14 @@
       </p:pic>
       <p:pic>
         <p:nvPicPr>
-          <p:cNvPr id="502" name="Google Shape;120;p17"/>
+          <p:cNvPr id="690" name="Google Shape;120;p17"/>
           <p:cNvPicPr>
             <a:picLocks xmlns:a="http://schemas.openxmlformats.org/drawingml/2006/main" noChangeAspect="1"/>
           </p:cNvPicPr>
           <p:nvPr/>
         </p:nvPicPr>
         <p:blipFill rotWithShape="1">
-          <a:blip xmlns:r="http://schemas.openxmlformats.org/officeDocument/2006/relationships" xmlns:a="http://schemas.openxmlformats.org/drawingml/2006/main" r:embed="R6ef0dab989044a34">
+          <a:blip xmlns:r="http://schemas.openxmlformats.org/officeDocument/2006/relationships" xmlns:a="http://schemas.openxmlformats.org/drawingml/2006/main" r:embed="R02fc553e8a604bc4">
             <a:alphaModFix/>
           </a:blip>
           <a:srcRect xmlns:a="http://schemas.openxmlformats.org/drawingml/2006/main" l="0" t="0" r="0" b="0"/>
@@ -25108,14 +25876,14 @@
       </p:pic>
       <p:pic>
         <p:nvPicPr>
-          <p:cNvPr id="503" name="Google Shape;122;p17"/>
+          <p:cNvPr id="691" name="Google Shape;122;p17"/>
           <p:cNvPicPr>
             <a:picLocks xmlns:a="http://schemas.openxmlformats.org/drawingml/2006/main" noChangeAspect="1"/>
           </p:cNvPicPr>
           <p:nvPr/>
         </p:nvPicPr>
         <p:blipFill rotWithShape="1">
-          <a:blip xmlns:r="http://schemas.openxmlformats.org/officeDocument/2006/relationships" xmlns:a="http://schemas.openxmlformats.org/drawingml/2006/main" r:embed="R8f2b287a4829403c">
+          <a:blip xmlns:r="http://schemas.openxmlformats.org/officeDocument/2006/relationships" xmlns:a="http://schemas.openxmlformats.org/drawingml/2006/main" r:embed="R08d219f57b144f50">
             <a:alphaModFix/>
           </a:blip>
           <a:srcRect xmlns:a="http://schemas.openxmlformats.org/drawingml/2006/main" l="0" t="0" r="0" b="0"/>
@@ -25405,14 +26173,14 @@
       </p:sp>
       <p:pic>
         <p:nvPicPr>
-          <p:cNvPr id="509" name="Google Shape;128;p17"/>
+          <p:cNvPr id="697" name="Google Shape;128;p17"/>
           <p:cNvPicPr>
             <a:picLocks xmlns:a="http://schemas.openxmlformats.org/drawingml/2006/main" noChangeAspect="1"/>
           </p:cNvPicPr>
           <p:nvPr/>
         </p:nvPicPr>
         <p:blipFill rotWithShape="1">
-          <a:blip xmlns:r="http://schemas.openxmlformats.org/officeDocument/2006/relationships" xmlns:a="http://schemas.openxmlformats.org/drawingml/2006/main" r:embed="R6ef0dab989044a34">
+          <a:blip xmlns:r="http://schemas.openxmlformats.org/officeDocument/2006/relationships" xmlns:a="http://schemas.openxmlformats.org/drawingml/2006/main" r:embed="R02fc553e8a604bc4">
             <a:alphaModFix/>
           </a:blip>
           <a:srcRect xmlns:a="http://schemas.openxmlformats.org/drawingml/2006/main" l="0" t="0" r="0" b="0"/>
@@ -25437,7 +26205,7 @@
       </p:pic>
       <p:cxnSp>
         <p:nvCxnSpPr>
-          <p:cNvPr id="510" name="Google Shape;129;p17"/>
+          <p:cNvPr id="698" name="Google Shape;129;p17"/>
           <p:cNvCxnSpPr/>
           <p:nvPr/>
         </p:nvCxnSpPr>
@@ -25462,7 +26230,7 @@
       </p:cxnSp>
       <p:cxnSp>
         <p:nvCxnSpPr>
-          <p:cNvPr id="511" name="Google Shape;130;p17"/>
+          <p:cNvPr id="699" name="Google Shape;130;p17"/>
           <p:cNvCxnSpPr/>
           <p:nvPr/>
         </p:nvCxnSpPr>
@@ -25487,14 +26255,14 @@
       </p:cxnSp>
       <p:pic>
         <p:nvPicPr>
-          <p:cNvPr id="512" name="Google Shape;131;p17"/>
+          <p:cNvPr id="700" name="Google Shape;131;p17"/>
           <p:cNvPicPr>
             <a:picLocks xmlns:a="http://schemas.openxmlformats.org/drawingml/2006/main" noChangeAspect="1"/>
           </p:cNvPicPr>
           <p:nvPr/>
         </p:nvPicPr>
         <p:blipFill rotWithShape="1">
-          <a:blip xmlns:r="http://schemas.openxmlformats.org/officeDocument/2006/relationships" xmlns:a="http://schemas.openxmlformats.org/drawingml/2006/main" r:embed="R983a6350130546ec">
+          <a:blip xmlns:r="http://schemas.openxmlformats.org/officeDocument/2006/relationships" xmlns:a="http://schemas.openxmlformats.org/drawingml/2006/main" r:embed="R9e1d0b0aa7614c1e">
             <a:alphaModFix/>
           </a:blip>
           <a:srcRect xmlns:a="http://schemas.openxmlformats.org/drawingml/2006/main" l="0" t="0" r="0" b="0"/>
@@ -25780,14 +26548,14 @@
       </p:sp>
       <p:pic>
         <p:nvPicPr>
-          <p:cNvPr id="517" name="Google Shape;136;p17"/>
+          <p:cNvPr id="705" name="Google Shape;136;p17"/>
           <p:cNvPicPr>
             <a:picLocks xmlns:a="http://schemas.openxmlformats.org/drawingml/2006/main" noChangeAspect="1"/>
           </p:cNvPicPr>
           <p:nvPr/>
         </p:nvPicPr>
         <p:blipFill rotWithShape="1">
-          <a:blip xmlns:r="http://schemas.openxmlformats.org/officeDocument/2006/relationships" xmlns:a="http://schemas.openxmlformats.org/drawingml/2006/main" r:embed="Rda7d3146761a4f0c">
+          <a:blip xmlns:r="http://schemas.openxmlformats.org/officeDocument/2006/relationships" xmlns:a="http://schemas.openxmlformats.org/drawingml/2006/main" r:embed="Rca5c609ed58b464f">
             <a:alphaModFix/>
           </a:blip>
           <a:srcRect xmlns:a="http://schemas.openxmlformats.org/drawingml/2006/main" l="0" t="0" r="0" b="0"/>
@@ -25808,14 +26576,14 @@
       </p:pic>
       <p:pic>
         <p:nvPicPr>
-          <p:cNvPr id="518" name="Google Shape;137;p17"/>
+          <p:cNvPr id="706" name="Google Shape;137;p17"/>
           <p:cNvPicPr>
             <a:picLocks xmlns:a="http://schemas.openxmlformats.org/drawingml/2006/main" noChangeAspect="1"/>
           </p:cNvPicPr>
           <p:nvPr/>
         </p:nvPicPr>
         <p:blipFill rotWithShape="1">
-          <a:blip xmlns:r="http://schemas.openxmlformats.org/officeDocument/2006/relationships" xmlns:a="http://schemas.openxmlformats.org/drawingml/2006/main" r:embed="Rae256137b6e24791">
+          <a:blip xmlns:r="http://schemas.openxmlformats.org/officeDocument/2006/relationships" xmlns:a="http://schemas.openxmlformats.org/drawingml/2006/main" r:embed="Rea27dd283390495e">
             <a:alphaModFix/>
           </a:blip>
           <a:srcRect xmlns:a="http://schemas.openxmlformats.org/drawingml/2006/main" l="0" t="0" r="0" b="0"/>
@@ -25897,14 +26665,14 @@
       </p:sp>
       <p:pic>
         <p:nvPicPr>
-          <p:cNvPr id="520" name="Google Shape;139;p17"/>
+          <p:cNvPr id="708" name="Google Shape;139;p17"/>
           <p:cNvPicPr>
             <a:picLocks xmlns:a="http://schemas.openxmlformats.org/drawingml/2006/main" noChangeAspect="1"/>
           </p:cNvPicPr>
           <p:nvPr/>
         </p:nvPicPr>
         <p:blipFill rotWithShape="1">
-          <a:blip xmlns:r="http://schemas.openxmlformats.org/officeDocument/2006/relationships" xmlns:a="http://schemas.openxmlformats.org/drawingml/2006/main" r:embed="R4b51d6b343154d4e">
+          <a:blip xmlns:r="http://schemas.openxmlformats.org/officeDocument/2006/relationships" xmlns:a="http://schemas.openxmlformats.org/drawingml/2006/main" r:embed="Rc2d84be1721b4d20">
             <a:alphaModFix/>
           </a:blip>
           <a:srcRect xmlns:a="http://schemas.openxmlformats.org/drawingml/2006/main" l="0" t="0" r="0" b="0"/>
@@ -25925,14 +26693,14 @@
       </p:pic>
       <p:pic>
         <p:nvPicPr>
-          <p:cNvPr id="521" name="Google Shape;140;p17"/>
+          <p:cNvPr id="709" name="Google Shape;140;p17"/>
           <p:cNvPicPr>
             <a:picLocks xmlns:a="http://schemas.openxmlformats.org/drawingml/2006/main" noChangeAspect="1"/>
           </p:cNvPicPr>
           <p:nvPr/>
         </p:nvPicPr>
         <p:blipFill rotWithShape="1">
-          <a:blip xmlns:r="http://schemas.openxmlformats.org/officeDocument/2006/relationships" xmlns:a="http://schemas.openxmlformats.org/drawingml/2006/main" r:embed="Rfff9e896a66d4b11">
+          <a:blip xmlns:r="http://schemas.openxmlformats.org/officeDocument/2006/relationships" xmlns:a="http://schemas.openxmlformats.org/drawingml/2006/main" r:embed="R45635abebd7c488c">
             <a:alphaModFix/>
           </a:blip>
           <a:srcRect xmlns:a="http://schemas.openxmlformats.org/drawingml/2006/main" l="0" t="0" r="0" b="0"/>
@@ -26202,7 +26970,7 @@
       </p:sp>
       <p:cxnSp>
         <p:nvCxnSpPr>
-          <p:cNvPr id="524" name="Google Shape;143;p17"/>
+          <p:cNvPr id="712" name="Google Shape;143;p17"/>
           <p:cNvCxnSpPr>
             <a:stCxn xmlns:a="http://schemas.openxmlformats.org/drawingml/2006/main" id="119" idx="3"/>
             <a:endCxn xmlns:a="http://schemas.openxmlformats.org/drawingml/2006/main" id="120" idx="1"/>
@@ -26230,7 +26998,7 @@
       </p:cxnSp>
       <p:cxnSp>
         <p:nvCxnSpPr>
-          <p:cNvPr id="525" name="Google Shape;144;p17"/>
+          <p:cNvPr id="713" name="Google Shape;144;p17"/>
           <p:cNvCxnSpPr>
             <a:endCxn xmlns:a="http://schemas.openxmlformats.org/drawingml/2006/main" id="128" idx="1"/>
           </p:cNvCxnSpPr>
@@ -26257,7 +27025,7 @@
       </p:cxnSp>
       <p:cxnSp>
         <p:nvCxnSpPr>
-          <p:cNvPr id="526" name="Google Shape;145;p17"/>
+          <p:cNvPr id="714" name="Google Shape;145;p17"/>
           <p:cNvCxnSpPr>
             <a:endCxn xmlns:a="http://schemas.openxmlformats.org/drawingml/2006/main" id="132" idx="1"/>
           </p:cNvCxnSpPr>
@@ -26284,7 +27052,7 @@
       </p:cxnSp>
       <p:cxnSp>
         <p:nvCxnSpPr>
-          <p:cNvPr id="527" name="Google Shape;146;p17"/>
+          <p:cNvPr id="715" name="Google Shape;146;p17"/>
           <p:cNvCxnSpPr>
             <a:endCxn xmlns:a="http://schemas.openxmlformats.org/drawingml/2006/main" id="135" idx="3"/>
           </p:cNvCxnSpPr>
@@ -26311,7 +27079,7 @@
       </p:cxnSp>
       <p:cxnSp>
         <p:nvCxnSpPr>
-          <p:cNvPr id="528" name="Google Shape;147;p17"/>
+          <p:cNvPr id="716" name="Google Shape;147;p17"/>
           <p:cNvCxnSpPr>
             <a:endCxn xmlns:a="http://schemas.openxmlformats.org/drawingml/2006/main" id="135" idx="0"/>
           </p:cNvCxnSpPr>
@@ -26338,7 +27106,7 @@
       </p:cxnSp>
       <p:cxnSp>
         <p:nvCxnSpPr>
-          <p:cNvPr id="529" name="Google Shape;148;p17"/>
+          <p:cNvPr id="717" name="Google Shape;148;p17"/>
           <p:cNvCxnSpPr>
             <a:stCxn xmlns:a="http://schemas.openxmlformats.org/drawingml/2006/main" id="132" idx="3"/>
             <a:endCxn xmlns:a="http://schemas.openxmlformats.org/drawingml/2006/main" id="133" idx="0"/>
@@ -26366,7 +27134,7 @@
       </p:cxnSp>
       <p:cxnSp>
         <p:nvCxnSpPr>
-          <p:cNvPr id="530" name="Google Shape;149;p17"/>
+          <p:cNvPr id="718" name="Google Shape;149;p17"/>
           <p:cNvCxnSpPr>
             <a:stCxn xmlns:a="http://schemas.openxmlformats.org/drawingml/2006/main" id="133" idx="2"/>
             <a:endCxn xmlns:a="http://schemas.openxmlformats.org/drawingml/2006/main" id="131" idx="0"/>
@@ -26394,7 +27162,7 @@
       </p:cxnSp>
       <p:cxnSp>
         <p:nvCxnSpPr>
-          <p:cNvPr id="531" name="Google Shape;150;p17"/>
+          <p:cNvPr id="719" name="Google Shape;150;p17"/>
           <p:cNvCxnSpPr>
             <a:stCxn xmlns:a="http://schemas.openxmlformats.org/drawingml/2006/main" id="135" idx="1"/>
             <a:endCxn xmlns:a="http://schemas.openxmlformats.org/drawingml/2006/main" id="136" idx="3"/>
@@ -26422,7 +27190,7 @@
       </p:cxnSp>
       <p:cxnSp>
         <p:nvCxnSpPr>
-          <p:cNvPr id="532" name="Google Shape;151;p17"/>
+          <p:cNvPr id="720" name="Google Shape;151;p17"/>
           <p:cNvCxnSpPr>
             <a:stCxn xmlns:a="http://schemas.openxmlformats.org/drawingml/2006/main" id="135" idx="1"/>
             <a:endCxn xmlns:a="http://schemas.openxmlformats.org/drawingml/2006/main" id="137" idx="3"/>
@@ -26450,7 +27218,7 @@
       </p:cxnSp>
       <p:cxnSp>
         <p:nvCxnSpPr>
-          <p:cNvPr id="533" name="Google Shape;152;p17"/>
+          <p:cNvPr id="721" name="Google Shape;152;p17"/>
           <p:cNvCxnSpPr/>
           <p:nvPr/>
         </p:nvCxnSpPr>
@@ -26475,7 +27243,7 @@
       </p:cxnSp>
       <p:cxnSp>
         <p:nvCxnSpPr>
-          <p:cNvPr id="534" name="Google Shape;153;p17"/>
+          <p:cNvPr id="722" name="Google Shape;153;p17"/>
           <p:cNvCxnSpPr/>
           <p:nvPr/>
         </p:nvCxnSpPr>
@@ -26500,7 +27268,7 @@
       </p:cxnSp>
       <p:cxnSp>
         <p:nvCxnSpPr>
-          <p:cNvPr id="535" name="Google Shape;154;p17"/>
+          <p:cNvPr id="723" name="Google Shape;154;p17"/>
           <p:cNvCxnSpPr/>
           <p:nvPr/>
         </p:nvCxnSpPr>
@@ -26525,7 +27293,7 @@
       </p:cxnSp>
       <p:cxnSp>
         <p:nvCxnSpPr>
-          <p:cNvPr id="536" name="Google Shape;155;p17"/>
+          <p:cNvPr id="724" name="Google Shape;155;p17"/>
           <p:cNvCxnSpPr/>
           <p:nvPr/>
         </p:nvCxnSpPr>
@@ -26550,7 +27318,7 @@
       </p:cxnSp>
       <p:cxnSp>
         <p:nvCxnSpPr>
-          <p:cNvPr id="537" name="Google Shape;156;p17"/>
+          <p:cNvPr id="725" name="Google Shape;156;p17"/>
           <p:cNvCxnSpPr/>
           <p:nvPr/>
         </p:nvCxnSpPr>
@@ -26939,7 +27707,7 @@
           </p:nvPr>
         </p:nvPicPr>
         <p:blipFill rotWithShape="1">
-          <a:blip xmlns:r="http://schemas.openxmlformats.org/officeDocument/2006/relationships" xmlns:a="http://schemas.openxmlformats.org/drawingml/2006/main" r:embed="Re98ae2e5070e4a07">
+          <a:blip xmlns:r="http://schemas.openxmlformats.org/officeDocument/2006/relationships" xmlns:a="http://schemas.openxmlformats.org/drawingml/2006/main" r:embed="Rd2601f346ef24bf1">
             <a:alphaModFix/>
           </a:blip>
           <a:srcRect xmlns:a="http://schemas.openxmlformats.org/drawingml/2006/main" l="0" t="0" r="0" b="0"/>
@@ -27155,7 +27923,7 @@
           <p:nvPr/>
         </p:nvPicPr>
         <p:blipFill rotWithShape="1">
-          <a:blip xmlns:r="http://schemas.openxmlformats.org/officeDocument/2006/relationships" xmlns:a="http://schemas.openxmlformats.org/drawingml/2006/main" r:embed="Rea4cc94a09c147be">
+          <a:blip xmlns:r="http://schemas.openxmlformats.org/officeDocument/2006/relationships" xmlns:a="http://schemas.openxmlformats.org/drawingml/2006/main" r:embed="R8d7dac13355649c0">
             <a:alphaModFix/>
           </a:blip>
           <a:srcRect xmlns:a="http://schemas.openxmlformats.org/drawingml/2006/main" l="0" t="0" r="0" b="0"/>
@@ -27886,7 +28654,7 @@
           <p:nvPr/>
         </p:nvPicPr>
         <p:blipFill rotWithShape="1">
-          <a:blip xmlns:r="http://schemas.openxmlformats.org/officeDocument/2006/relationships" xmlns:a="http://schemas.openxmlformats.org/drawingml/2006/main" r:embed="R51736ca1f5f341bb">
+          <a:blip xmlns:r="http://schemas.openxmlformats.org/officeDocument/2006/relationships" xmlns:a="http://schemas.openxmlformats.org/drawingml/2006/main" r:embed="Rf2573d078757455b">
             <a:alphaModFix/>
           </a:blip>
           <a:srcRect xmlns:a="http://schemas.openxmlformats.org/drawingml/2006/main" l="0" t="0" r="0" b="0"/>
@@ -27914,7 +28682,7 @@
           <p:nvPr/>
         </p:nvPicPr>
         <p:blipFill rotWithShape="1">
-          <a:blip xmlns:r="http://schemas.openxmlformats.org/officeDocument/2006/relationships" xmlns:a="http://schemas.openxmlformats.org/drawingml/2006/main" r:embed="Ree673e0337e54f75">
+          <a:blip xmlns:r="http://schemas.openxmlformats.org/officeDocument/2006/relationships" xmlns:a="http://schemas.openxmlformats.org/drawingml/2006/main" r:embed="Rac4c204a0bec443a">
             <a:alphaModFix/>
           </a:blip>
           <a:srcRect xmlns:a="http://schemas.openxmlformats.org/drawingml/2006/main" l="0" t="0" r="0" b="0"/>
@@ -27942,7 +28710,7 @@
           <p:nvPr/>
         </p:nvPicPr>
         <p:blipFill rotWithShape="1">
-          <a:blip xmlns:r="http://schemas.openxmlformats.org/officeDocument/2006/relationships" xmlns:a="http://schemas.openxmlformats.org/drawingml/2006/main" r:embed="R6af6b761480e4a32">
+          <a:blip xmlns:r="http://schemas.openxmlformats.org/officeDocument/2006/relationships" xmlns:a="http://schemas.openxmlformats.org/drawingml/2006/main" r:embed="Rc9ec6f565ba04c99">
             <a:alphaModFix/>
           </a:blip>
           <a:srcRect xmlns:a="http://schemas.openxmlformats.org/drawingml/2006/main" l="0" t="0" r="0" b="0"/>
@@ -28338,7 +29106,7 @@
               <a:buNone/>
             </a:pPr>
             <a:r>
-              <a:t>B0–B3 complete · controlled B4 architecture test next</a:t>
+              <a:t>B0–B4 complete · evidence-driven B5 improvement next</a:t>
             </a:r>
           </a:p>
         </p:txBody>

</xml_diff>

<commit_message>
Document completed B5 ensemble experiment
</commit_message>
<xml_diff>
--- a/presentation/ADVLSI2_DRC_CNN_Project_Progress.pptx
+++ b/presentation/ADVLSI2_DRC_CNN_Project_Progress.pptx
@@ -2,44 +2,44 @@
 <file path=ppt/presentation.xml><?xml version="1.0" encoding="utf-8"?>
 <p:presentation xmlns:p="http://schemas.openxmlformats.org/presentationml/2006/main" embedTrueTypeFonts="1" saveSubsetFonts="0">
   <p:sldMasterIdLst>
-    <p:sldMasterId xmlns:r="http://schemas.openxmlformats.org/officeDocument/2006/relationships" id="2147483648" r:id="R4837fa08c5f246eb"/>
+    <p:sldMasterId xmlns:r="http://schemas.openxmlformats.org/officeDocument/2006/relationships" id="2147483648" r:id="R83b6c6f81a9849ff"/>
   </p:sldMasterIdLst>
   <p:notesMasterIdLst>
-    <p:notesMasterId xmlns:r="http://schemas.openxmlformats.org/officeDocument/2006/relationships" r:id="R7b7ee4fb565d446f"/>
+    <p:notesMasterId xmlns:r="http://schemas.openxmlformats.org/officeDocument/2006/relationships" r:id="R2cd442149d654b5d"/>
   </p:notesMasterIdLst>
   <p:sldIdLst>
-    <p:sldId xmlns:r="http://schemas.openxmlformats.org/officeDocument/2006/relationships" id="256" r:id="Rf8e315b12d23499e"/>
-    <p:sldId xmlns:r="http://schemas.openxmlformats.org/officeDocument/2006/relationships" id="257" r:id="Rbf5c625f185a4765"/>
-    <p:sldId xmlns:r="http://schemas.openxmlformats.org/officeDocument/2006/relationships" id="258" r:id="R9426baebe47243f0"/>
-    <p:sldId xmlns:r="http://schemas.openxmlformats.org/officeDocument/2006/relationships" id="259" r:id="R787fbfb4e40d4972"/>
-    <p:sldId xmlns:r="http://schemas.openxmlformats.org/officeDocument/2006/relationships" id="260" r:id="Rb1d16704ee534744"/>
-    <p:sldId xmlns:r="http://schemas.openxmlformats.org/officeDocument/2006/relationships" id="261" r:id="Rd5363935f36c41f1"/>
-    <p:sldId xmlns:r="http://schemas.openxmlformats.org/officeDocument/2006/relationships" id="262" r:id="Rfe0b9cefe1b14872"/>
-    <p:sldId xmlns:r="http://schemas.openxmlformats.org/officeDocument/2006/relationships" id="263" r:id="R77a8369de0d84e2e"/>
-    <p:sldId xmlns:r="http://schemas.openxmlformats.org/officeDocument/2006/relationships" id="264" r:id="Rb68da2c3b9fe468b"/>
-    <p:sldId xmlns:r="http://schemas.openxmlformats.org/officeDocument/2006/relationships" id="265" r:id="R5440d6729f004043"/>
-    <p:sldId xmlns:r="http://schemas.openxmlformats.org/officeDocument/2006/relationships" id="266" r:id="R75f6fe207fea4fa7"/>
-    <p:sldId xmlns:r="http://schemas.openxmlformats.org/officeDocument/2006/relationships" id="267" r:id="R57a621e437c7460e"/>
-    <p:sldId xmlns:r="http://schemas.openxmlformats.org/officeDocument/2006/relationships" id="268" r:id="Rd4262d37f72d41c5"/>
-    <p:sldId xmlns:r="http://schemas.openxmlformats.org/officeDocument/2006/relationships" id="269" r:id="Ra69e73558ef7479f"/>
-    <p:sldId xmlns:r="http://schemas.openxmlformats.org/officeDocument/2006/relationships" id="270" r:id="R5c85f0ad67584a8e"/>
-    <p:sldId xmlns:r="http://schemas.openxmlformats.org/officeDocument/2006/relationships" id="271" r:id="R24b85e49d0a84514"/>
-    <p:sldId xmlns:r="http://schemas.openxmlformats.org/officeDocument/2006/relationships" id="272" r:id="R94110022f71a40b7"/>
-    <p:sldId xmlns:r="http://schemas.openxmlformats.org/officeDocument/2006/relationships" id="273" r:id="R3d37c0e11d2747d5"/>
-    <p:sldId xmlns:r="http://schemas.openxmlformats.org/officeDocument/2006/relationships" id="274" r:id="Ra61e758306ee47f6"/>
-    <p:sldId xmlns:r="http://schemas.openxmlformats.org/officeDocument/2006/relationships" id="275" r:id="R863a8461e273411a"/>
-    <p:sldId xmlns:r="http://schemas.openxmlformats.org/officeDocument/2006/relationships" id="276" r:id="R53ff05ce9d00454d"/>
-    <p:sldId xmlns:r="http://schemas.openxmlformats.org/officeDocument/2006/relationships" id="277" r:id="Ra1e6cedb232040b9"/>
-    <p:sldId xmlns:r="http://schemas.openxmlformats.org/officeDocument/2006/relationships" id="278" r:id="R70533452dfc94ff2"/>
-    <p:sldId xmlns:r="http://schemas.openxmlformats.org/officeDocument/2006/relationships" id="279" r:id="R4ce7307e86794c40"/>
+    <p:sldId xmlns:r="http://schemas.openxmlformats.org/officeDocument/2006/relationships" id="256" r:id="R2957f3ff9d954b11"/>
+    <p:sldId xmlns:r="http://schemas.openxmlformats.org/officeDocument/2006/relationships" id="257" r:id="Re5da6d9fa8274090"/>
+    <p:sldId xmlns:r="http://schemas.openxmlformats.org/officeDocument/2006/relationships" id="258" r:id="R4159b511771b42fc"/>
+    <p:sldId xmlns:r="http://schemas.openxmlformats.org/officeDocument/2006/relationships" id="259" r:id="Rf146408492644150"/>
+    <p:sldId xmlns:r="http://schemas.openxmlformats.org/officeDocument/2006/relationships" id="260" r:id="R34f5dfb7b8054f8d"/>
+    <p:sldId xmlns:r="http://schemas.openxmlformats.org/officeDocument/2006/relationships" id="261" r:id="R36e6fcda461b42bb"/>
+    <p:sldId xmlns:r="http://schemas.openxmlformats.org/officeDocument/2006/relationships" id="262" r:id="R4aebf4ced3d44aef"/>
+    <p:sldId xmlns:r="http://schemas.openxmlformats.org/officeDocument/2006/relationships" id="263" r:id="Re9c905759eaa4d5d"/>
+    <p:sldId xmlns:r="http://schemas.openxmlformats.org/officeDocument/2006/relationships" id="264" r:id="R8d950922e0454e0a"/>
+    <p:sldId xmlns:r="http://schemas.openxmlformats.org/officeDocument/2006/relationships" id="265" r:id="Rf349748e18284e28"/>
+    <p:sldId xmlns:r="http://schemas.openxmlformats.org/officeDocument/2006/relationships" id="266" r:id="R6a94b6ae26274a7a"/>
+    <p:sldId xmlns:r="http://schemas.openxmlformats.org/officeDocument/2006/relationships" id="267" r:id="R624a43d907db4e46"/>
+    <p:sldId xmlns:r="http://schemas.openxmlformats.org/officeDocument/2006/relationships" id="268" r:id="Rdb6ebf71b3db423c"/>
+    <p:sldId xmlns:r="http://schemas.openxmlformats.org/officeDocument/2006/relationships" id="269" r:id="Ra86d36d4e0c44225"/>
+    <p:sldId xmlns:r="http://schemas.openxmlformats.org/officeDocument/2006/relationships" id="270" r:id="R8cd244b7ddea4888"/>
+    <p:sldId xmlns:r="http://schemas.openxmlformats.org/officeDocument/2006/relationships" id="271" r:id="R4ce5b6cf9b434361"/>
+    <p:sldId xmlns:r="http://schemas.openxmlformats.org/officeDocument/2006/relationships" id="272" r:id="Re9923971b11448c1"/>
+    <p:sldId xmlns:r="http://schemas.openxmlformats.org/officeDocument/2006/relationships" id="273" r:id="R6687eb4f9a044614"/>
+    <p:sldId xmlns:r="http://schemas.openxmlformats.org/officeDocument/2006/relationships" id="274" r:id="R153e20b12299408d"/>
+    <p:sldId xmlns:r="http://schemas.openxmlformats.org/officeDocument/2006/relationships" id="275" r:id="R95bc3c3d30d6430f"/>
+    <p:sldId xmlns:r="http://schemas.openxmlformats.org/officeDocument/2006/relationships" id="276" r:id="R3ecee4703701424c"/>
+    <p:sldId xmlns:r="http://schemas.openxmlformats.org/officeDocument/2006/relationships" id="277" r:id="R14879c7977294655"/>
+    <p:sldId xmlns:r="http://schemas.openxmlformats.org/officeDocument/2006/relationships" id="278" r:id="R633a7b92f0be469b"/>
+    <p:sldId xmlns:r="http://schemas.openxmlformats.org/officeDocument/2006/relationships" id="279" r:id="Rb499af4a1aae4b4c"/>
   </p:sldIdLst>
   <p:sldSz cx="12192000" cy="6858000"/>
   <p:notesSz cx="6858000" cy="9144000"/>
   <p:embeddedFontLst>
     <p:embeddedFont>
       <p:font typeface="Play"/>
-      <p:regular xmlns:r="http://schemas.openxmlformats.org/officeDocument/2006/relationships" r:id="R944a0518958d49d7"/>
-      <p:bold xmlns:r="http://schemas.openxmlformats.org/officeDocument/2006/relationships" r:id="R46ff4b152a054ef6"/>
+      <p:regular xmlns:r="http://schemas.openxmlformats.org/officeDocument/2006/relationships" r:id="Rb231b68186784aef"/>
+      <p:bold xmlns:r="http://schemas.openxmlformats.org/officeDocument/2006/relationships" r:id="R67a3a7ee706f44aa"/>
     </p:embeddedFont>
   </p:embeddedFontLst>
   <p:defaultTextStyle>
@@ -599,7 +599,63 @@
               <a:buNone/>
             </a:pPr>
             <a:r>
-              <a:t/>
+              <a:t>[Sources]</a:t>
+            </a:r>
+          </a:p>
+          <a:p xmlns:a="http://schemas.openxmlformats.org/drawingml/2006/main">
+            <a:pPr marL="0" indent="0" algn="l">
+              <a:spcBef>
+                <a:spcPts val="0"/>
+              </a:spcBef>
+              <a:spcAft>
+                <a:spcPts val="0"/>
+              </a:spcAft>
+              <a:buNone/>
+            </a:pPr>
+            <a:r>
+              <a:t>- MODEL_ROADMAP.md</a:t>
+            </a:r>
+          </a:p>
+          <a:p xmlns:a="http://schemas.openxmlformats.org/drawingml/2006/main">
+            <a:pPr marL="0" indent="0" algn="l">
+              <a:spcBef>
+                <a:spcPts val="0"/>
+              </a:spcBef>
+              <a:spcAft>
+                <a:spcPts val="0"/>
+              </a:spcAft>
+              <a:buNone/>
+            </a:pPr>
+            <a:r>
+              <a:t>- results/b5_ensemble/summary.json</a:t>
+            </a:r>
+          </a:p>
+          <a:p xmlns:a="http://schemas.openxmlformats.org/drawingml/2006/main">
+            <a:pPr marL="0" indent="0" algn="l">
+              <a:spcBef>
+                <a:spcPts val="0"/>
+              </a:spcBef>
+              <a:spcAft>
+                <a:spcPts val="0"/>
+              </a:spcAft>
+              <a:buNone/>
+            </a:pPr>
+            <a:r>
+              <a:t>- results/b5_ensemble/README.md</a:t>
+            </a:r>
+          </a:p>
+          <a:p xmlns:a="http://schemas.openxmlformats.org/drawingml/2006/main">
+            <a:pPr marL="0" indent="0" algn="l">
+              <a:spcBef>
+                <a:spcPts val="0"/>
+              </a:spcBef>
+              <a:spcAft>
+                <a:spcPts val="0"/>
+              </a:spcAft>
+              <a:buNone/>
+            </a:pPr>
+            <a:r>
+              <a:t>[/Sources]</a:t>
             </a:r>
           </a:p>
         </p:txBody>
@@ -1073,25 +1129,27 @@
               <a:buNone/>
             </a:pPr>
             <a:r>
-              <a:t/>
-            </a:r>
-          </a:p>
-          <a:p xmlns:a="http://schemas.openxmlformats.org/drawingml/2006/main">
-            <a:r>
-              <a:t>
-[Sources]
-- MODEL_ROADMAP.md
-- results/b4_architecture/summary.json
-[/Sources]</a:t>
-            </a:r>
-          </a:p>
-          <a:p xmlns:a="http://schemas.openxmlformats.org/drawingml/2006/main">
-            <a:r>
-              <a:t>
-[Sources]
-- MODEL_ROADMAP.md
-- results/b4_architecture/summary.json
-[/Sources]</a:t>
+              <a:t>[Sources]</a:t>
+            </a:r>
+          </a:p>
+          <a:p xmlns:a="http://schemas.openxmlformats.org/drawingml/2006/main">
+            <a:r>
+              <a:t>- MODEL_ROADMAP.md</a:t>
+            </a:r>
+          </a:p>
+          <a:p xmlns:a="http://schemas.openxmlformats.org/drawingml/2006/main">
+            <a:r>
+              <a:t>- results/b5_ensemble/summary.json</a:t>
+            </a:r>
+          </a:p>
+          <a:p xmlns:a="http://schemas.openxmlformats.org/drawingml/2006/main">
+            <a:r>
+              <a:t>- results/b5_ensemble/README.md</a:t>
+            </a:r>
+          </a:p>
+          <a:p xmlns:a="http://schemas.openxmlformats.org/drawingml/2006/main">
+            <a:r>
+              <a:t>[/Sources]</a:t>
             </a:r>
           </a:p>
         </p:txBody>
@@ -1184,7 +1242,7 @@
               <a:buNone/>
             </a:pPr>
             <a:r>
-              <a:t>- results/b2_baselines/summary.json</a:t>
+              <a:t>- MODEL_ROADMAP.md</a:t>
             </a:r>
           </a:p>
           <a:p xmlns:a="http://schemas.openxmlformats.org/drawingml/2006/main">
@@ -1198,7 +1256,7 @@
               <a:buNone/>
             </a:pPr>
             <a:r>
-              <a:t>- results/b3_optimization/extension_summary.json</a:t>
+              <a:t>- results/b5_ensemble/summary.json</a:t>
             </a:r>
           </a:p>
           <a:p xmlns:a="http://schemas.openxmlformats.org/drawingml/2006/main">
@@ -1212,7 +1270,7 @@
               <a:buNone/>
             </a:pPr>
             <a:r>
-              <a:t/>
+              <a:t>- results/b5_ensemble/README.md</a:t>
             </a:r>
           </a:p>
           <a:p xmlns:a="http://schemas.openxmlformats.org/drawingml/2006/main">
@@ -1226,25 +1284,7 @@
               <a:buNone/>
             </a:pPr>
             <a:r>
-              <a:t>B3 accuracy/F1 are the frozen unseen-layout calibrated-threshold confirmation metrics; the candidate was rejected.</a:t>
-            </a:r>
-          </a:p>
-          <a:p xmlns:a="http://schemas.openxmlformats.org/drawingml/2006/main">
-            <a:r>
-              <a:t>
-[Sources]
-- MODEL_ROADMAP.md
-- results/b4_architecture/summary.json
-[/Sources]</a:t>
-            </a:r>
-          </a:p>
-          <a:p xmlns:a="http://schemas.openxmlformats.org/drawingml/2006/main">
-            <a:r>
-              <a:t>
-[Sources]
-- MODEL_ROADMAP.md
-- results/b4_architecture/summary.json
-[/Sources]</a:t>
+              <a:t>[/Sources]</a:t>
             </a:r>
           </a:p>
         </p:txBody>
@@ -2282,7 +2322,7 @@
               <a:buNone/>
             </a:pPr>
             <a:r>
-              <a:t>- results/b4_architecture/summary.json</a:t>
+              <a:t>- MODEL_ROADMAP.md</a:t>
             </a:r>
           </a:p>
           <a:p xmlns:a="http://schemas.openxmlformats.org/drawingml/2006/main">
@@ -2296,7 +2336,21 @@
               <a:buNone/>
             </a:pPr>
             <a:r>
-              <a:t>- results/b4_architecture/README.md</a:t>
+              <a:t>- results/b5_ensemble/summary.json</a:t>
+            </a:r>
+          </a:p>
+          <a:p xmlns:a="http://schemas.openxmlformats.org/drawingml/2006/main">
+            <a:pPr marL="0" indent="0" algn="l">
+              <a:spcBef>
+                <a:spcPts val="0"/>
+              </a:spcBef>
+              <a:spcAft>
+                <a:spcPts val="0"/>
+              </a:spcAft>
+              <a:buNone/>
+            </a:pPr>
+            <a:r>
+              <a:t>- results/b5_ensemble/README.md</a:t>
             </a:r>
           </a:p>
           <a:p xmlns:a="http://schemas.openxmlformats.org/drawingml/2006/main">
@@ -2403,7 +2457,7 @@
               <a:buNone/>
             </a:pPr>
             <a:r>
-              <a:t>- results/b4_architecture/summary.json</a:t>
+              <a:t>- MODEL_ROADMAP.md</a:t>
             </a:r>
           </a:p>
           <a:p xmlns:a="http://schemas.openxmlformats.org/drawingml/2006/main">
@@ -2417,7 +2471,21 @@
               <a:buNone/>
             </a:pPr>
             <a:r>
-              <a:t>- results/b4_architecture/README.md</a:t>
+              <a:t>- results/b5_ensemble/summary.json</a:t>
+            </a:r>
+          </a:p>
+          <a:p xmlns:a="http://schemas.openxmlformats.org/drawingml/2006/main">
+            <a:pPr marL="0" indent="0" algn="l">
+              <a:spcBef>
+                <a:spcPts val="0"/>
+              </a:spcBef>
+              <a:spcAft>
+                <a:spcPts val="0"/>
+              </a:spcAft>
+              <a:buNone/>
+            </a:pPr>
+            <a:r>
+              <a:t>- results/b5_ensemble/README.md</a:t>
             </a:r>
           </a:p>
           <a:p xmlns:a="http://schemas.openxmlformats.org/drawingml/2006/main">
@@ -3082,7 +3150,63 @@
               <a:buNone/>
             </a:pPr>
             <a:r>
-              <a:t/>
+              <a:t>[Sources]</a:t>
+            </a:r>
+          </a:p>
+          <a:p xmlns:a="http://schemas.openxmlformats.org/drawingml/2006/main">
+            <a:pPr marL="0" indent="0" algn="l">
+              <a:spcBef>
+                <a:spcPts val="0"/>
+              </a:spcBef>
+              <a:spcAft>
+                <a:spcPts val="0"/>
+              </a:spcAft>
+              <a:buNone/>
+            </a:pPr>
+            <a:r>
+              <a:t>- MODEL_ROADMAP.md</a:t>
+            </a:r>
+          </a:p>
+          <a:p xmlns:a="http://schemas.openxmlformats.org/drawingml/2006/main">
+            <a:pPr marL="0" indent="0" algn="l">
+              <a:spcBef>
+                <a:spcPts val="0"/>
+              </a:spcBef>
+              <a:spcAft>
+                <a:spcPts val="0"/>
+              </a:spcAft>
+              <a:buNone/>
+            </a:pPr>
+            <a:r>
+              <a:t>- results/b5_ensemble/summary.json</a:t>
+            </a:r>
+          </a:p>
+          <a:p xmlns:a="http://schemas.openxmlformats.org/drawingml/2006/main">
+            <a:pPr marL="0" indent="0" algn="l">
+              <a:spcBef>
+                <a:spcPts val="0"/>
+              </a:spcBef>
+              <a:spcAft>
+                <a:spcPts val="0"/>
+              </a:spcAft>
+              <a:buNone/>
+            </a:pPr>
+            <a:r>
+              <a:t>- results/b5_ensemble/README.md</a:t>
+            </a:r>
+          </a:p>
+          <a:p xmlns:a="http://schemas.openxmlformats.org/drawingml/2006/main">
+            <a:pPr marL="0" indent="0" algn="l">
+              <a:spcBef>
+                <a:spcPts val="0"/>
+              </a:spcBef>
+              <a:spcAft>
+                <a:spcPts val="0"/>
+              </a:spcAft>
+              <a:buNone/>
+            </a:pPr>
+            <a:r>
+              <a:t>[/Sources]</a:t>
             </a:r>
           </a:p>
         </p:txBody>
@@ -11853,17 +11977,17 @@
   </p:cSld>
   <p:clrMap bg1="lt1" tx1="dk1" bg2="dk2" tx2="lt2" accent1="accent1" accent2="accent2" accent3="accent3" accent4="accent4" accent5="accent5" accent6="accent6" hlink="hlink" folHlink="folHlink"/>
   <p:sldLayoutIdLst>
-    <p:sldLayoutId xmlns:r="http://schemas.openxmlformats.org/officeDocument/2006/relationships" id="2147483649" r:id="R3b6280cc02e24f20"/>
-    <p:sldLayoutId xmlns:r="http://schemas.openxmlformats.org/officeDocument/2006/relationships" id="2147483650" r:id="R378080260697450e"/>
-    <p:sldLayoutId xmlns:r="http://schemas.openxmlformats.org/officeDocument/2006/relationships" id="2147483651" r:id="R900a4da617894d68"/>
-    <p:sldLayoutId xmlns:r="http://schemas.openxmlformats.org/officeDocument/2006/relationships" id="2147483652" r:id="Redd93e4f75014d0f"/>
-    <p:sldLayoutId xmlns:r="http://schemas.openxmlformats.org/officeDocument/2006/relationships" id="2147483653" r:id="Re0ca72a621d94dab"/>
-    <p:sldLayoutId xmlns:r="http://schemas.openxmlformats.org/officeDocument/2006/relationships" id="2147483654" r:id="R9c5a1f7b14a243f8"/>
-    <p:sldLayoutId xmlns:r="http://schemas.openxmlformats.org/officeDocument/2006/relationships" id="2147483655" r:id="Rc310956dc6c84a51"/>
-    <p:sldLayoutId xmlns:r="http://schemas.openxmlformats.org/officeDocument/2006/relationships" id="2147483656" r:id="R5e0672455ce047af"/>
-    <p:sldLayoutId xmlns:r="http://schemas.openxmlformats.org/officeDocument/2006/relationships" id="2147483657" r:id="Rdca783112af64d08"/>
-    <p:sldLayoutId xmlns:r="http://schemas.openxmlformats.org/officeDocument/2006/relationships" id="2147483658" r:id="R032597e46fda4610"/>
-    <p:sldLayoutId xmlns:r="http://schemas.openxmlformats.org/officeDocument/2006/relationships" id="2147483659" r:id="R972a6526be2d42eb"/>
+    <p:sldLayoutId xmlns:r="http://schemas.openxmlformats.org/officeDocument/2006/relationships" id="2147483649" r:id="Ra2e7c6f67dd048ee"/>
+    <p:sldLayoutId xmlns:r="http://schemas.openxmlformats.org/officeDocument/2006/relationships" id="2147483650" r:id="R7f5ea866fde749cc"/>
+    <p:sldLayoutId xmlns:r="http://schemas.openxmlformats.org/officeDocument/2006/relationships" id="2147483651" r:id="R61c182885a434cda"/>
+    <p:sldLayoutId xmlns:r="http://schemas.openxmlformats.org/officeDocument/2006/relationships" id="2147483652" r:id="R5b22a1991dae4445"/>
+    <p:sldLayoutId xmlns:r="http://schemas.openxmlformats.org/officeDocument/2006/relationships" id="2147483653" r:id="Ra0270228fc6240b3"/>
+    <p:sldLayoutId xmlns:r="http://schemas.openxmlformats.org/officeDocument/2006/relationships" id="2147483654" r:id="R0e555d0f6c7e42c6"/>
+    <p:sldLayoutId xmlns:r="http://schemas.openxmlformats.org/officeDocument/2006/relationships" id="2147483655" r:id="R1bdc22da98b64d7b"/>
+    <p:sldLayoutId xmlns:r="http://schemas.openxmlformats.org/officeDocument/2006/relationships" id="2147483656" r:id="R17a33fc982754271"/>
+    <p:sldLayoutId xmlns:r="http://schemas.openxmlformats.org/officeDocument/2006/relationships" id="2147483657" r:id="Rd2e3d367db154577"/>
+    <p:sldLayoutId xmlns:r="http://schemas.openxmlformats.org/officeDocument/2006/relationships" id="2147483658" r:id="R4a14adb1ab184645"/>
+    <p:sldLayoutId xmlns:r="http://schemas.openxmlformats.org/officeDocument/2006/relationships" id="2147483659" r:id="R3dfe9c8d85934a31"/>
   </p:sldLayoutIdLst>
   <p:hf sldNum="0" hdr="0" ftr="0" dt="0"/>
   <p:txStyles>
@@ -12815,7 +12939,7 @@
               <a:buNone/>
             </a:pPr>
             <a:r>
-              <a:t>CNN-based DRC | B0–B4 complete · B5 experiments next</a:t>
+              <a:t>CNN-based DRC | B0–B5.1 complete · failure analysis next</a:t>
             </a:r>
           </a:p>
         </p:txBody>
@@ -16790,7 +16914,8 @@
               <a:buChar char="●"/>
             </a:pPr>
             <a:r>
-              <a:t>B5  Ensemble + targeted improvements — next</a:t>
+              <a:t>B5.1  Ensemble — rejected
+B5.2  Failure slices — next</a:t>
             </a:r>
           </a:p>
           <a:p xmlns:a="http://schemas.openxmlformats.org/drawingml/2006/main">
@@ -16903,7 +17028,7 @@
                   <a:srgbClr val="404040"/>
                 </a:solidFill>
               </a:rPr>
-              <a:t>Exhaust justified classifier gains, then deliver masks, coordinates, and verified repairs.</a:t>
+              <a:t>Use evidence-backed classifier gains, then deliver masks, coordinates, and verified repairs.</a:t>
             </a:r>
           </a:p>
         </p:txBody>
@@ -18739,7 +18864,7 @@
                   <a:srgbClr val="262626"/>
                 </a:solidFill>
               </a:rPr>
-              <a:t>B4</a:t>
+              <a:t>B5.1</a:t>
             </a:r>
           </a:p>
         </p:txBody>
@@ -18853,7 +18978,7 @@
                   <a:srgbClr val="262626"/>
                 </a:solidFill>
               </a:rPr>
-              <a:t>Compact model rejected</a:t>
+              <a:t>Ensemble rejected by recall gate</a:t>
             </a:r>
           </a:p>
         </p:txBody>
@@ -18910,7 +19035,7 @@
                   <a:srgbClr val="262626"/>
                 </a:solidFill>
               </a:rPr>
-              <a:t>89.36%</a:t>
+              <a:t>90.47%</a:t>
             </a:r>
           </a:p>
         </p:txBody>
@@ -18967,7 +19092,7 @@
                   <a:srgbClr val="262626"/>
                 </a:solidFill>
               </a:rPr>
-              <a:t>0.904</a:t>
+              <a:t>0.912</a:t>
             </a:r>
           </a:p>
         </p:txBody>
@@ -19024,7 +19149,7 @@
                   <a:srgbClr val="262626"/>
                 </a:solidFill>
               </a:rPr>
-              <a:t>−0.006</a:t>
+              <a:t>+0.003</a:t>
             </a:r>
           </a:p>
         </p:txBody>
@@ -19081,7 +19206,7 @@
                   <a:srgbClr val="73400D"/>
                 </a:solidFill>
               </a:rPr>
-              <a:t>B4: 14.3× smaller, but unseen F1 fell 0.58 points. B2 stays; B5 tests complementary B2+B4 errors.</a:t>
+              <a:t>B5.1 improved unseen F1, but tile recall fell 1.32 points. Keep B2; analyze failure slices before B6.</a:t>
             </a:r>
           </a:p>
         </p:txBody>
@@ -19431,7 +19556,7 @@
           </p:nvPr>
         </p:nvPicPr>
         <p:blipFill rotWithShape="1">
-          <a:blip xmlns:r="http://schemas.openxmlformats.org/officeDocument/2006/relationships" xmlns:a="http://schemas.openxmlformats.org/drawingml/2006/main" r:embed="R1e33ad49612b496e">
+          <a:blip xmlns:r="http://schemas.openxmlformats.org/officeDocument/2006/relationships" xmlns:a="http://schemas.openxmlformats.org/drawingml/2006/main" r:embed="R99c62eebfff44191">
             <a:alphaModFix/>
           </a:blip>
           <a:srcRect xmlns:a="http://schemas.openxmlformats.org/drawingml/2006/main" l="0" t="0" r="0" b="0"/>
@@ -19459,7 +19584,7 @@
           <p:nvPr/>
         </p:nvPicPr>
         <p:blipFill rotWithShape="1">
-          <a:blip xmlns:r="http://schemas.openxmlformats.org/officeDocument/2006/relationships" xmlns:a="http://schemas.openxmlformats.org/drawingml/2006/main" r:embed="Rbb1e2d4736b94b1a">
+          <a:blip xmlns:r="http://schemas.openxmlformats.org/officeDocument/2006/relationships" xmlns:a="http://schemas.openxmlformats.org/drawingml/2006/main" r:embed="R17164eb216fc4e76">
             <a:alphaModFix/>
           </a:blip>
           <a:srcRect xmlns:a="http://schemas.openxmlformats.org/drawingml/2006/main" l="0" t="0" r="0" b="0"/>
@@ -24670,7 +24795,7 @@
               <a:buNone/>
             </a:pPr>
             <a:r>
-              <a:t>B4: validation and cost gates passed</a:t>
+              <a:t>B5.1: ensemble passes validation gate</a:t>
             </a:r>
           </a:p>
         </p:txBody>
@@ -24716,7 +24841,7 @@
               <a:buChar char="●"/>
             </a:pPr>
             <a:r>
-              <a:t>Validation F1: 91.36% → 93.61%</a:t>
+              <a:t>Selected F1: 93.87%</a:t>
             </a:r>
           </a:p>
           <a:p xmlns:a="http://schemas.openxmlformats.org/drawingml/2006/main">
@@ -24730,7 +24855,7 @@
               <a:buChar char="●"/>
             </a:pPr>
             <a:r>
-              <a:t>Validation recall: 88.60% → 92.37%</a:t>
+              <a:t>Selected recall: 92.21%</a:t>
             </a:r>
           </a:p>
           <a:p xmlns:a="http://schemas.openxmlformats.org/drawingml/2006/main">
@@ -24744,7 +24869,7 @@
               <a:buChar char="●"/>
             </a:pPr>
             <a:r>
-              <a:t>All three seeds improved F1</a:t>
+              <a:t>All three seeds beat B4 F1</a:t>
             </a:r>
           </a:p>
           <a:p xmlns:a="http://schemas.openxmlformats.org/drawingml/2006/main">
@@ -24804,7 +24929,7 @@
               <a:buChar char="●"/>
             </a:pPr>
             <a:r>
-              <a:t>Parameters: 602k → 42k</a:t>
+              <a:t>Blend: 25% B2 / 75% B4</a:t>
             </a:r>
           </a:p>
           <a:p xmlns:a="http://schemas.openxmlformats.org/drawingml/2006/main">
@@ -24818,7 +24943,7 @@
               <a:buChar char="●"/>
             </a:pPr>
             <a:r>
-              <a:t>State dict: 2.41 MB → 179 KB</a:t>
+              <a:t>B4-only correct: 110</a:t>
             </a:r>
           </a:p>
           <a:p xmlns:a="http://schemas.openxmlformats.org/drawingml/2006/main">
@@ -24832,7 +24957,7 @@
               <a:buChar char="●"/>
             </a:pPr>
             <a:r>
-              <a:t>PyTorch CPU: 14.06 → 8.63 ms</a:t>
+              <a:t>B2-only correct: 68</a:t>
             </a:r>
           </a:p>
           <a:p xmlns:a="http://schemas.openxmlformats.org/drawingml/2006/main">
@@ -24846,7 +24971,7 @@
               <a:buChar char="●"/>
             </a:pPr>
             <a:r>
-              <a:t>ONNX CPU: 1.92 → 2.19 ms</a:t>
+              <a:t>Selection used validation only</a:t>
             </a:r>
           </a:p>
         </p:txBody>
@@ -24914,7 +25039,7 @@
               <a:buNone/>
             </a:pPr>
             <a:r>
-              <a:t>B4: compact model fails frozen tests</a:t>
+              <a:t>B5.1: gains, but recall gate fails</a:t>
             </a:r>
           </a:p>
         </p:txBody>
@@ -24960,7 +25085,7 @@
               <a:buChar char="●"/>
             </a:pPr>
             <a:r>
-              <a:t>Unseen accuracy: 90.38% → 89.36%</a:t>
+              <a:t>Unseen accuracy: 90.38% → 90.47%</a:t>
             </a:r>
           </a:p>
           <a:p xmlns:a="http://schemas.openxmlformats.org/drawingml/2006/main">
@@ -24974,7 +25099,7 @@
               <a:buChar char="●"/>
             </a:pPr>
             <a:r>
-              <a:t>Unseen F1: 90.94% → 90.36%</a:t>
+              <a:t>Unseen F1: 90.94% → 91.25%</a:t>
             </a:r>
           </a:p>
           <a:p xmlns:a="http://schemas.openxmlformats.org/drawingml/2006/main">
@@ -24988,7 +25113,7 @@
               <a:buChar char="●"/>
             </a:pPr>
             <a:r>
-              <a:t>Unseen recall: 90.73% → 93.72%</a:t>
+              <a:t>Unseen recall: 90.73% → 93.39%</a:t>
             </a:r>
           </a:p>
           <a:p xmlns:a="http://schemas.openxmlformats.org/drawingml/2006/main">
@@ -25002,7 +25127,7 @@
               <a:buChar char="●"/>
             </a:pPr>
             <a:r>
-              <a:t>No seed improved unseen F1</a:t>
+              <a:t>Unseen gate passed</a:t>
             </a:r>
           </a:p>
         </p:txBody>
@@ -25048,7 +25173,7 @@
               <a:buChar char="●"/>
             </a:pPr>
             <a:r>
-              <a:t>Tile accuracy: 92.47% → 94.42%</a:t>
+              <a:t>Tile accuracy: 92.47% → 94.70%</a:t>
             </a:r>
           </a:p>
           <a:p xmlns:a="http://schemas.openxmlformats.org/drawingml/2006/main">
@@ -25062,7 +25187,7 @@
               <a:buChar char="●"/>
             </a:pPr>
             <a:r>
-              <a:t>Tile F1: 91.89% → 93.74%</a:t>
+              <a:t>Tile F1: 91.89% → 94.08%</a:t>
             </a:r>
           </a:p>
           <a:p xmlns:a="http://schemas.openxmlformats.org/drawingml/2006/main">
@@ -25076,7 +25201,7 @@
               <a:buChar char="●"/>
             </a:pPr>
             <a:r>
-              <a:t>Tile recall: 93.39% → 91.36%</a:t>
+              <a:t>Tile recall: 93.39% → 92.07%</a:t>
             </a:r>
           </a:p>
           <a:p xmlns:a="http://schemas.openxmlformats.org/drawingml/2006/main">
@@ -25090,7 +25215,7 @@
               <a:buChar char="●"/>
             </a:pPr>
             <a:r>
-              <a:t>Keep B2; test B2+B4 ensemble next</a:t>
+              <a:t>Reject ensemble; keep B2</a:t>
             </a:r>
           </a:p>
         </p:txBody>
@@ -25179,7 +25304,7 @@
           <p:nvPr/>
         </p:nvPicPr>
         <p:blipFill rotWithShape="1">
-          <a:blip xmlns:r="http://schemas.openxmlformats.org/officeDocument/2006/relationships" xmlns:a="http://schemas.openxmlformats.org/drawingml/2006/main" r:embed="R9a4bd79626a24880">
+          <a:blip xmlns:r="http://schemas.openxmlformats.org/officeDocument/2006/relationships" xmlns:a="http://schemas.openxmlformats.org/drawingml/2006/main" r:embed="R047692fb06244200">
             <a:alphaModFix/>
           </a:blip>
           <a:srcRect xmlns:a="http://schemas.openxmlformats.org/drawingml/2006/main" l="0" t="0" r="0" b="0"/>
@@ -25207,7 +25332,7 @@
           <p:nvPr/>
         </p:nvPicPr>
         <p:blipFill rotWithShape="1">
-          <a:blip xmlns:r="http://schemas.openxmlformats.org/officeDocument/2006/relationships" xmlns:a="http://schemas.openxmlformats.org/drawingml/2006/main" r:embed="Re2fdc59fcbde47e8">
+          <a:blip xmlns:r="http://schemas.openxmlformats.org/officeDocument/2006/relationships" xmlns:a="http://schemas.openxmlformats.org/drawingml/2006/main" r:embed="Rc4d8036454954ed0">
             <a:alphaModFix/>
           </a:blip>
           <a:srcRect xmlns:a="http://schemas.openxmlformats.org/drawingml/2006/main" l="0" t="0" r="0" b="0"/>
@@ -25497,7 +25622,7 @@
           <p:nvPr/>
         </p:nvPicPr>
         <p:blipFill rotWithShape="1">
-          <a:blip xmlns:r="http://schemas.openxmlformats.org/officeDocument/2006/relationships" xmlns:a="http://schemas.openxmlformats.org/drawingml/2006/main" r:embed="R1ec108b20f27464d">
+          <a:blip xmlns:r="http://schemas.openxmlformats.org/officeDocument/2006/relationships" xmlns:a="http://schemas.openxmlformats.org/drawingml/2006/main" r:embed="Re842f921a67942ce">
             <a:alphaModFix/>
           </a:blip>
           <a:srcRect xmlns:a="http://schemas.openxmlformats.org/drawingml/2006/main" l="0" t="0" r="0" b="0"/>
@@ -25810,7 +25935,7 @@
       </p:sp>
       <p:pic>
         <p:nvPicPr>
-          <p:cNvPr id="689" name="Google Shape;119;p17"/>
+          <p:cNvPr id="783" name="Google Shape;119;p17"/>
           <p:cNvPicPr>
             <a:picLocks xmlns:a="http://schemas.openxmlformats.org/drawingml/2006/main" noChangeAspect="1"/>
           </p:cNvPicPr>
@@ -25819,7 +25944,7 @@
           </p:nvPr>
         </p:nvPicPr>
         <p:blipFill rotWithShape="1">
-          <a:blip xmlns:r="http://schemas.openxmlformats.org/officeDocument/2006/relationships" xmlns:a="http://schemas.openxmlformats.org/drawingml/2006/main" r:embed="R9801dadde359456b">
+          <a:blip xmlns:r="http://schemas.openxmlformats.org/officeDocument/2006/relationships" xmlns:a="http://schemas.openxmlformats.org/drawingml/2006/main" r:embed="R452ccbed58fa4457">
             <a:alphaModFix/>
           </a:blip>
           <a:srcRect xmlns:a="http://schemas.openxmlformats.org/drawingml/2006/main" l="0" t="0" r="0" b="0"/>
@@ -25844,14 +25969,14 @@
       </p:pic>
       <p:pic>
         <p:nvPicPr>
-          <p:cNvPr id="690" name="Google Shape;120;p17"/>
+          <p:cNvPr id="784" name="Google Shape;120;p17"/>
           <p:cNvPicPr>
             <a:picLocks xmlns:a="http://schemas.openxmlformats.org/drawingml/2006/main" noChangeAspect="1"/>
           </p:cNvPicPr>
           <p:nvPr/>
         </p:nvPicPr>
         <p:blipFill rotWithShape="1">
-          <a:blip xmlns:r="http://schemas.openxmlformats.org/officeDocument/2006/relationships" xmlns:a="http://schemas.openxmlformats.org/drawingml/2006/main" r:embed="R02fc553e8a604bc4">
+          <a:blip xmlns:r="http://schemas.openxmlformats.org/officeDocument/2006/relationships" xmlns:a="http://schemas.openxmlformats.org/drawingml/2006/main" r:embed="R0b68d27149a54cec">
             <a:alphaModFix/>
           </a:blip>
           <a:srcRect xmlns:a="http://schemas.openxmlformats.org/drawingml/2006/main" l="0" t="0" r="0" b="0"/>
@@ -25876,14 +26001,14 @@
       </p:pic>
       <p:pic>
         <p:nvPicPr>
-          <p:cNvPr id="691" name="Google Shape;122;p17"/>
+          <p:cNvPr id="785" name="Google Shape;122;p17"/>
           <p:cNvPicPr>
             <a:picLocks xmlns:a="http://schemas.openxmlformats.org/drawingml/2006/main" noChangeAspect="1"/>
           </p:cNvPicPr>
           <p:nvPr/>
         </p:nvPicPr>
         <p:blipFill rotWithShape="1">
-          <a:blip xmlns:r="http://schemas.openxmlformats.org/officeDocument/2006/relationships" xmlns:a="http://schemas.openxmlformats.org/drawingml/2006/main" r:embed="R08d219f57b144f50">
+          <a:blip xmlns:r="http://schemas.openxmlformats.org/officeDocument/2006/relationships" xmlns:a="http://schemas.openxmlformats.org/drawingml/2006/main" r:embed="R4206979cab7046a3">
             <a:alphaModFix/>
           </a:blip>
           <a:srcRect xmlns:a="http://schemas.openxmlformats.org/drawingml/2006/main" l="0" t="0" r="0" b="0"/>
@@ -26173,14 +26298,14 @@
       </p:sp>
       <p:pic>
         <p:nvPicPr>
-          <p:cNvPr id="697" name="Google Shape;128;p17"/>
+          <p:cNvPr id="791" name="Google Shape;128;p17"/>
           <p:cNvPicPr>
             <a:picLocks xmlns:a="http://schemas.openxmlformats.org/drawingml/2006/main" noChangeAspect="1"/>
           </p:cNvPicPr>
           <p:nvPr/>
         </p:nvPicPr>
         <p:blipFill rotWithShape="1">
-          <a:blip xmlns:r="http://schemas.openxmlformats.org/officeDocument/2006/relationships" xmlns:a="http://schemas.openxmlformats.org/drawingml/2006/main" r:embed="R02fc553e8a604bc4">
+          <a:blip xmlns:r="http://schemas.openxmlformats.org/officeDocument/2006/relationships" xmlns:a="http://schemas.openxmlformats.org/drawingml/2006/main" r:embed="R0b68d27149a54cec">
             <a:alphaModFix/>
           </a:blip>
           <a:srcRect xmlns:a="http://schemas.openxmlformats.org/drawingml/2006/main" l="0" t="0" r="0" b="0"/>
@@ -26205,7 +26330,7 @@
       </p:pic>
       <p:cxnSp>
         <p:nvCxnSpPr>
-          <p:cNvPr id="698" name="Google Shape;129;p17"/>
+          <p:cNvPr id="792" name="Google Shape;129;p17"/>
           <p:cNvCxnSpPr/>
           <p:nvPr/>
         </p:nvCxnSpPr>
@@ -26230,7 +26355,7 @@
       </p:cxnSp>
       <p:cxnSp>
         <p:nvCxnSpPr>
-          <p:cNvPr id="699" name="Google Shape;130;p17"/>
+          <p:cNvPr id="793" name="Google Shape;130;p17"/>
           <p:cNvCxnSpPr/>
           <p:nvPr/>
         </p:nvCxnSpPr>
@@ -26255,14 +26380,14 @@
       </p:cxnSp>
       <p:pic>
         <p:nvPicPr>
-          <p:cNvPr id="700" name="Google Shape;131;p17"/>
+          <p:cNvPr id="794" name="Google Shape;131;p17"/>
           <p:cNvPicPr>
             <a:picLocks xmlns:a="http://schemas.openxmlformats.org/drawingml/2006/main" noChangeAspect="1"/>
           </p:cNvPicPr>
           <p:nvPr/>
         </p:nvPicPr>
         <p:blipFill rotWithShape="1">
-          <a:blip xmlns:r="http://schemas.openxmlformats.org/officeDocument/2006/relationships" xmlns:a="http://schemas.openxmlformats.org/drawingml/2006/main" r:embed="R9e1d0b0aa7614c1e">
+          <a:blip xmlns:r="http://schemas.openxmlformats.org/officeDocument/2006/relationships" xmlns:a="http://schemas.openxmlformats.org/drawingml/2006/main" r:embed="R54597fef3a6545ec">
             <a:alphaModFix/>
           </a:blip>
           <a:srcRect xmlns:a="http://schemas.openxmlformats.org/drawingml/2006/main" l="0" t="0" r="0" b="0"/>
@@ -26548,14 +26673,14 @@
       </p:sp>
       <p:pic>
         <p:nvPicPr>
-          <p:cNvPr id="705" name="Google Shape;136;p17"/>
+          <p:cNvPr id="799" name="Google Shape;136;p17"/>
           <p:cNvPicPr>
             <a:picLocks xmlns:a="http://schemas.openxmlformats.org/drawingml/2006/main" noChangeAspect="1"/>
           </p:cNvPicPr>
           <p:nvPr/>
         </p:nvPicPr>
         <p:blipFill rotWithShape="1">
-          <a:blip xmlns:r="http://schemas.openxmlformats.org/officeDocument/2006/relationships" xmlns:a="http://schemas.openxmlformats.org/drawingml/2006/main" r:embed="Rca5c609ed58b464f">
+          <a:blip xmlns:r="http://schemas.openxmlformats.org/officeDocument/2006/relationships" xmlns:a="http://schemas.openxmlformats.org/drawingml/2006/main" r:embed="R2d51eb94f92f4540">
             <a:alphaModFix/>
           </a:blip>
           <a:srcRect xmlns:a="http://schemas.openxmlformats.org/drawingml/2006/main" l="0" t="0" r="0" b="0"/>
@@ -26576,14 +26701,14 @@
       </p:pic>
       <p:pic>
         <p:nvPicPr>
-          <p:cNvPr id="706" name="Google Shape;137;p17"/>
+          <p:cNvPr id="800" name="Google Shape;137;p17"/>
           <p:cNvPicPr>
             <a:picLocks xmlns:a="http://schemas.openxmlformats.org/drawingml/2006/main" noChangeAspect="1"/>
           </p:cNvPicPr>
           <p:nvPr/>
         </p:nvPicPr>
         <p:blipFill rotWithShape="1">
-          <a:blip xmlns:r="http://schemas.openxmlformats.org/officeDocument/2006/relationships" xmlns:a="http://schemas.openxmlformats.org/drawingml/2006/main" r:embed="Rea27dd283390495e">
+          <a:blip xmlns:r="http://schemas.openxmlformats.org/officeDocument/2006/relationships" xmlns:a="http://schemas.openxmlformats.org/drawingml/2006/main" r:embed="R0a88e25cedc14fbb">
             <a:alphaModFix/>
           </a:blip>
           <a:srcRect xmlns:a="http://schemas.openxmlformats.org/drawingml/2006/main" l="0" t="0" r="0" b="0"/>
@@ -26665,14 +26790,14 @@
       </p:sp>
       <p:pic>
         <p:nvPicPr>
-          <p:cNvPr id="708" name="Google Shape;139;p17"/>
+          <p:cNvPr id="802" name="Google Shape;139;p17"/>
           <p:cNvPicPr>
             <a:picLocks xmlns:a="http://schemas.openxmlformats.org/drawingml/2006/main" noChangeAspect="1"/>
           </p:cNvPicPr>
           <p:nvPr/>
         </p:nvPicPr>
         <p:blipFill rotWithShape="1">
-          <a:blip xmlns:r="http://schemas.openxmlformats.org/officeDocument/2006/relationships" xmlns:a="http://schemas.openxmlformats.org/drawingml/2006/main" r:embed="Rc2d84be1721b4d20">
+          <a:blip xmlns:r="http://schemas.openxmlformats.org/officeDocument/2006/relationships" xmlns:a="http://schemas.openxmlformats.org/drawingml/2006/main" r:embed="Rbb4fd0fad1124c2c">
             <a:alphaModFix/>
           </a:blip>
           <a:srcRect xmlns:a="http://schemas.openxmlformats.org/drawingml/2006/main" l="0" t="0" r="0" b="0"/>
@@ -26693,14 +26818,14 @@
       </p:pic>
       <p:pic>
         <p:nvPicPr>
-          <p:cNvPr id="709" name="Google Shape;140;p17"/>
+          <p:cNvPr id="803" name="Google Shape;140;p17"/>
           <p:cNvPicPr>
             <a:picLocks xmlns:a="http://schemas.openxmlformats.org/drawingml/2006/main" noChangeAspect="1"/>
           </p:cNvPicPr>
           <p:nvPr/>
         </p:nvPicPr>
         <p:blipFill rotWithShape="1">
-          <a:blip xmlns:r="http://schemas.openxmlformats.org/officeDocument/2006/relationships" xmlns:a="http://schemas.openxmlformats.org/drawingml/2006/main" r:embed="R45635abebd7c488c">
+          <a:blip xmlns:r="http://schemas.openxmlformats.org/officeDocument/2006/relationships" xmlns:a="http://schemas.openxmlformats.org/drawingml/2006/main" r:embed="R2335d23ae1e344c7">
             <a:alphaModFix/>
           </a:blip>
           <a:srcRect xmlns:a="http://schemas.openxmlformats.org/drawingml/2006/main" l="0" t="0" r="0" b="0"/>
@@ -26970,7 +27095,7 @@
       </p:sp>
       <p:cxnSp>
         <p:nvCxnSpPr>
-          <p:cNvPr id="712" name="Google Shape;143;p17"/>
+          <p:cNvPr id="806" name="Google Shape;143;p17"/>
           <p:cNvCxnSpPr>
             <a:stCxn xmlns:a="http://schemas.openxmlformats.org/drawingml/2006/main" id="119" idx="3"/>
             <a:endCxn xmlns:a="http://schemas.openxmlformats.org/drawingml/2006/main" id="120" idx="1"/>
@@ -26998,7 +27123,7 @@
       </p:cxnSp>
       <p:cxnSp>
         <p:nvCxnSpPr>
-          <p:cNvPr id="713" name="Google Shape;144;p17"/>
+          <p:cNvPr id="807" name="Google Shape;144;p17"/>
           <p:cNvCxnSpPr>
             <a:endCxn xmlns:a="http://schemas.openxmlformats.org/drawingml/2006/main" id="128" idx="1"/>
           </p:cNvCxnSpPr>
@@ -27025,7 +27150,7 @@
       </p:cxnSp>
       <p:cxnSp>
         <p:nvCxnSpPr>
-          <p:cNvPr id="714" name="Google Shape;145;p17"/>
+          <p:cNvPr id="808" name="Google Shape;145;p17"/>
           <p:cNvCxnSpPr>
             <a:endCxn xmlns:a="http://schemas.openxmlformats.org/drawingml/2006/main" id="132" idx="1"/>
           </p:cNvCxnSpPr>
@@ -27052,7 +27177,7 @@
       </p:cxnSp>
       <p:cxnSp>
         <p:nvCxnSpPr>
-          <p:cNvPr id="715" name="Google Shape;146;p17"/>
+          <p:cNvPr id="809" name="Google Shape;146;p17"/>
           <p:cNvCxnSpPr>
             <a:endCxn xmlns:a="http://schemas.openxmlformats.org/drawingml/2006/main" id="135" idx="3"/>
           </p:cNvCxnSpPr>
@@ -27079,7 +27204,7 @@
       </p:cxnSp>
       <p:cxnSp>
         <p:nvCxnSpPr>
-          <p:cNvPr id="716" name="Google Shape;147;p17"/>
+          <p:cNvPr id="810" name="Google Shape;147;p17"/>
           <p:cNvCxnSpPr>
             <a:endCxn xmlns:a="http://schemas.openxmlformats.org/drawingml/2006/main" id="135" idx="0"/>
           </p:cNvCxnSpPr>
@@ -27106,7 +27231,7 @@
       </p:cxnSp>
       <p:cxnSp>
         <p:nvCxnSpPr>
-          <p:cNvPr id="717" name="Google Shape;148;p17"/>
+          <p:cNvPr id="811" name="Google Shape;148;p17"/>
           <p:cNvCxnSpPr>
             <a:stCxn xmlns:a="http://schemas.openxmlformats.org/drawingml/2006/main" id="132" idx="3"/>
             <a:endCxn xmlns:a="http://schemas.openxmlformats.org/drawingml/2006/main" id="133" idx="0"/>
@@ -27134,7 +27259,7 @@
       </p:cxnSp>
       <p:cxnSp>
         <p:nvCxnSpPr>
-          <p:cNvPr id="718" name="Google Shape;149;p17"/>
+          <p:cNvPr id="812" name="Google Shape;149;p17"/>
           <p:cNvCxnSpPr>
             <a:stCxn xmlns:a="http://schemas.openxmlformats.org/drawingml/2006/main" id="133" idx="2"/>
             <a:endCxn xmlns:a="http://schemas.openxmlformats.org/drawingml/2006/main" id="131" idx="0"/>
@@ -27162,7 +27287,7 @@
       </p:cxnSp>
       <p:cxnSp>
         <p:nvCxnSpPr>
-          <p:cNvPr id="719" name="Google Shape;150;p17"/>
+          <p:cNvPr id="813" name="Google Shape;150;p17"/>
           <p:cNvCxnSpPr>
             <a:stCxn xmlns:a="http://schemas.openxmlformats.org/drawingml/2006/main" id="135" idx="1"/>
             <a:endCxn xmlns:a="http://schemas.openxmlformats.org/drawingml/2006/main" id="136" idx="3"/>
@@ -27190,7 +27315,7 @@
       </p:cxnSp>
       <p:cxnSp>
         <p:nvCxnSpPr>
-          <p:cNvPr id="720" name="Google Shape;151;p17"/>
+          <p:cNvPr id="814" name="Google Shape;151;p17"/>
           <p:cNvCxnSpPr>
             <a:stCxn xmlns:a="http://schemas.openxmlformats.org/drawingml/2006/main" id="135" idx="1"/>
             <a:endCxn xmlns:a="http://schemas.openxmlformats.org/drawingml/2006/main" id="137" idx="3"/>
@@ -27218,7 +27343,7 @@
       </p:cxnSp>
       <p:cxnSp>
         <p:nvCxnSpPr>
-          <p:cNvPr id="721" name="Google Shape;152;p17"/>
+          <p:cNvPr id="815" name="Google Shape;152;p17"/>
           <p:cNvCxnSpPr/>
           <p:nvPr/>
         </p:nvCxnSpPr>
@@ -27243,7 +27368,7 @@
       </p:cxnSp>
       <p:cxnSp>
         <p:nvCxnSpPr>
-          <p:cNvPr id="722" name="Google Shape;153;p17"/>
+          <p:cNvPr id="816" name="Google Shape;153;p17"/>
           <p:cNvCxnSpPr/>
           <p:nvPr/>
         </p:nvCxnSpPr>
@@ -27268,7 +27393,7 @@
       </p:cxnSp>
       <p:cxnSp>
         <p:nvCxnSpPr>
-          <p:cNvPr id="723" name="Google Shape;154;p17"/>
+          <p:cNvPr id="817" name="Google Shape;154;p17"/>
           <p:cNvCxnSpPr/>
           <p:nvPr/>
         </p:nvCxnSpPr>
@@ -27293,7 +27418,7 @@
       </p:cxnSp>
       <p:cxnSp>
         <p:nvCxnSpPr>
-          <p:cNvPr id="724" name="Google Shape;155;p17"/>
+          <p:cNvPr id="818" name="Google Shape;155;p17"/>
           <p:cNvCxnSpPr/>
           <p:nvPr/>
         </p:nvCxnSpPr>
@@ -27318,7 +27443,7 @@
       </p:cxnSp>
       <p:cxnSp>
         <p:nvCxnSpPr>
-          <p:cNvPr id="725" name="Google Shape;156;p17"/>
+          <p:cNvPr id="819" name="Google Shape;156;p17"/>
           <p:cNvCxnSpPr/>
           <p:nvPr/>
         </p:nvCxnSpPr>
@@ -27707,7 +27832,7 @@
           </p:nvPr>
         </p:nvPicPr>
         <p:blipFill rotWithShape="1">
-          <a:blip xmlns:r="http://schemas.openxmlformats.org/officeDocument/2006/relationships" xmlns:a="http://schemas.openxmlformats.org/drawingml/2006/main" r:embed="Rd2601f346ef24bf1">
+          <a:blip xmlns:r="http://schemas.openxmlformats.org/officeDocument/2006/relationships" xmlns:a="http://schemas.openxmlformats.org/drawingml/2006/main" r:embed="Rd401e9972b7546cf">
             <a:alphaModFix/>
           </a:blip>
           <a:srcRect xmlns:a="http://schemas.openxmlformats.org/drawingml/2006/main" l="0" t="0" r="0" b="0"/>
@@ -27923,7 +28048,7 @@
           <p:nvPr/>
         </p:nvPicPr>
         <p:blipFill rotWithShape="1">
-          <a:blip xmlns:r="http://schemas.openxmlformats.org/officeDocument/2006/relationships" xmlns:a="http://schemas.openxmlformats.org/drawingml/2006/main" r:embed="R8d7dac13355649c0">
+          <a:blip xmlns:r="http://schemas.openxmlformats.org/officeDocument/2006/relationships" xmlns:a="http://schemas.openxmlformats.org/drawingml/2006/main" r:embed="Reaedd04d4121403b">
             <a:alphaModFix/>
           </a:blip>
           <a:srcRect xmlns:a="http://schemas.openxmlformats.org/drawingml/2006/main" l="0" t="0" r="0" b="0"/>
@@ -28654,7 +28779,7 @@
           <p:nvPr/>
         </p:nvPicPr>
         <p:blipFill rotWithShape="1">
-          <a:blip xmlns:r="http://schemas.openxmlformats.org/officeDocument/2006/relationships" xmlns:a="http://schemas.openxmlformats.org/drawingml/2006/main" r:embed="Rf2573d078757455b">
+          <a:blip xmlns:r="http://schemas.openxmlformats.org/officeDocument/2006/relationships" xmlns:a="http://schemas.openxmlformats.org/drawingml/2006/main" r:embed="R0f8cbb3fa5bf4d4f">
             <a:alphaModFix/>
           </a:blip>
           <a:srcRect xmlns:a="http://schemas.openxmlformats.org/drawingml/2006/main" l="0" t="0" r="0" b="0"/>
@@ -28682,7 +28807,7 @@
           <p:nvPr/>
         </p:nvPicPr>
         <p:blipFill rotWithShape="1">
-          <a:blip xmlns:r="http://schemas.openxmlformats.org/officeDocument/2006/relationships" xmlns:a="http://schemas.openxmlformats.org/drawingml/2006/main" r:embed="Rac4c204a0bec443a">
+          <a:blip xmlns:r="http://schemas.openxmlformats.org/officeDocument/2006/relationships" xmlns:a="http://schemas.openxmlformats.org/drawingml/2006/main" r:embed="R738c245eb6544bab">
             <a:alphaModFix/>
           </a:blip>
           <a:srcRect xmlns:a="http://schemas.openxmlformats.org/drawingml/2006/main" l="0" t="0" r="0" b="0"/>
@@ -28710,7 +28835,7 @@
           <p:nvPr/>
         </p:nvPicPr>
         <p:blipFill rotWithShape="1">
-          <a:blip xmlns:r="http://schemas.openxmlformats.org/officeDocument/2006/relationships" xmlns:a="http://schemas.openxmlformats.org/drawingml/2006/main" r:embed="Rc9ec6f565ba04c99">
+          <a:blip xmlns:r="http://schemas.openxmlformats.org/officeDocument/2006/relationships" xmlns:a="http://schemas.openxmlformats.org/drawingml/2006/main" r:embed="R00afd8d8d83a4125">
             <a:alphaModFix/>
           </a:blip>
           <a:srcRect xmlns:a="http://schemas.openxmlformats.org/drawingml/2006/main" l="0" t="0" r="0" b="0"/>
@@ -29106,7 +29231,7 @@
               <a:buNone/>
             </a:pPr>
             <a:r>
-              <a:t>B0–B4 complete · evidence-driven B5 improvement next</a:t>
+              <a:t>B0–B5.1 complete · failure-slice analysis next</a:t>
             </a:r>
           </a:p>
         </p:txBody>

</xml_diff>

<commit_message>
Update presentation through B6.1
</commit_message>
<xml_diff>
--- a/presentation/ADVLSI2_DRC_CNN_Project_Progress.pptx
+++ b/presentation/ADVLSI2_DRC_CNN_Project_Progress.pptx
@@ -2,141 +2,50 @@
 <file path=ppt/presentation.xml><?xml version="1.0" encoding="utf-8"?>
 <p:presentation xmlns:p="http://schemas.openxmlformats.org/presentationml/2006/main" embedTrueTypeFonts="1" saveSubsetFonts="0">
   <p:sldMasterIdLst>
-    <p:sldMasterId xmlns:r="http://schemas.openxmlformats.org/officeDocument/2006/relationships" id="2147483648" r:id="R83b6c6f81a9849ff"/>
+    <p:sldMasterId xmlns:r="http://schemas.openxmlformats.org/officeDocument/2006/relationships" id="2147483648" r:id="R97f916a39f404c03"/>
   </p:sldMasterIdLst>
   <p:notesMasterIdLst>
-    <p:notesMasterId xmlns:r="http://schemas.openxmlformats.org/officeDocument/2006/relationships" r:id="R2cd442149d654b5d"/>
+    <p:notesMasterId xmlns:r="http://schemas.openxmlformats.org/officeDocument/2006/relationships" r:id="R3a1ba16c5f554403"/>
   </p:notesMasterIdLst>
   <p:sldIdLst>
-    <p:sldId xmlns:r="http://schemas.openxmlformats.org/officeDocument/2006/relationships" id="256" r:id="R2957f3ff9d954b11"/>
-    <p:sldId xmlns:r="http://schemas.openxmlformats.org/officeDocument/2006/relationships" id="257" r:id="Re5da6d9fa8274090"/>
-    <p:sldId xmlns:r="http://schemas.openxmlformats.org/officeDocument/2006/relationships" id="258" r:id="R4159b511771b42fc"/>
-    <p:sldId xmlns:r="http://schemas.openxmlformats.org/officeDocument/2006/relationships" id="259" r:id="Rf146408492644150"/>
-    <p:sldId xmlns:r="http://schemas.openxmlformats.org/officeDocument/2006/relationships" id="260" r:id="R34f5dfb7b8054f8d"/>
-    <p:sldId xmlns:r="http://schemas.openxmlformats.org/officeDocument/2006/relationships" id="261" r:id="R36e6fcda461b42bb"/>
-    <p:sldId xmlns:r="http://schemas.openxmlformats.org/officeDocument/2006/relationships" id="262" r:id="R4aebf4ced3d44aef"/>
-    <p:sldId xmlns:r="http://schemas.openxmlformats.org/officeDocument/2006/relationships" id="263" r:id="Re9c905759eaa4d5d"/>
-    <p:sldId xmlns:r="http://schemas.openxmlformats.org/officeDocument/2006/relationships" id="264" r:id="R8d950922e0454e0a"/>
-    <p:sldId xmlns:r="http://schemas.openxmlformats.org/officeDocument/2006/relationships" id="265" r:id="Rf349748e18284e28"/>
-    <p:sldId xmlns:r="http://schemas.openxmlformats.org/officeDocument/2006/relationships" id="266" r:id="R6a94b6ae26274a7a"/>
-    <p:sldId xmlns:r="http://schemas.openxmlformats.org/officeDocument/2006/relationships" id="267" r:id="R624a43d907db4e46"/>
-    <p:sldId xmlns:r="http://schemas.openxmlformats.org/officeDocument/2006/relationships" id="268" r:id="Rdb6ebf71b3db423c"/>
-    <p:sldId xmlns:r="http://schemas.openxmlformats.org/officeDocument/2006/relationships" id="269" r:id="Ra86d36d4e0c44225"/>
-    <p:sldId xmlns:r="http://schemas.openxmlformats.org/officeDocument/2006/relationships" id="270" r:id="R8cd244b7ddea4888"/>
-    <p:sldId xmlns:r="http://schemas.openxmlformats.org/officeDocument/2006/relationships" id="271" r:id="R4ce5b6cf9b434361"/>
-    <p:sldId xmlns:r="http://schemas.openxmlformats.org/officeDocument/2006/relationships" id="272" r:id="Re9923971b11448c1"/>
-    <p:sldId xmlns:r="http://schemas.openxmlformats.org/officeDocument/2006/relationships" id="273" r:id="R6687eb4f9a044614"/>
-    <p:sldId xmlns:r="http://schemas.openxmlformats.org/officeDocument/2006/relationships" id="274" r:id="R153e20b12299408d"/>
-    <p:sldId xmlns:r="http://schemas.openxmlformats.org/officeDocument/2006/relationships" id="275" r:id="R95bc3c3d30d6430f"/>
-    <p:sldId xmlns:r="http://schemas.openxmlformats.org/officeDocument/2006/relationships" id="276" r:id="R3ecee4703701424c"/>
-    <p:sldId xmlns:r="http://schemas.openxmlformats.org/officeDocument/2006/relationships" id="277" r:id="R14879c7977294655"/>
-    <p:sldId xmlns:r="http://schemas.openxmlformats.org/officeDocument/2006/relationships" id="278" r:id="R633a7b92f0be469b"/>
-    <p:sldId xmlns:r="http://schemas.openxmlformats.org/officeDocument/2006/relationships" id="279" r:id="Rb499af4a1aae4b4c"/>
+    <p:sldId xmlns:r="http://schemas.openxmlformats.org/officeDocument/2006/relationships" id="256" r:id="R72de3e47ea7a45af"/>
+    <p:sldId xmlns:r="http://schemas.openxmlformats.org/officeDocument/2006/relationships" id="257" r:id="R1ec4d2e03134449d"/>
+    <p:sldId xmlns:r="http://schemas.openxmlformats.org/officeDocument/2006/relationships" id="258" r:id="Rb84ad73590264f06"/>
+    <p:sldId xmlns:r="http://schemas.openxmlformats.org/officeDocument/2006/relationships" id="259" r:id="R2b9c5bbb38b9471b"/>
+    <p:sldId xmlns:r="http://schemas.openxmlformats.org/officeDocument/2006/relationships" id="260" r:id="R9236d55d04cf475a"/>
+    <p:sldId xmlns:r="http://schemas.openxmlformats.org/officeDocument/2006/relationships" id="261" r:id="R0bafc63a44a34801"/>
+    <p:sldId xmlns:r="http://schemas.openxmlformats.org/officeDocument/2006/relationships" id="262" r:id="R5e1a642a80d04560"/>
+    <p:sldId xmlns:r="http://schemas.openxmlformats.org/officeDocument/2006/relationships" id="263" r:id="R08828ee439c74c75"/>
+    <p:sldId xmlns:r="http://schemas.openxmlformats.org/officeDocument/2006/relationships" id="264" r:id="Rbc5781a2f34c4217"/>
+    <p:sldId xmlns:r="http://schemas.openxmlformats.org/officeDocument/2006/relationships" id="265" r:id="R78ce135f1c1644d3"/>
+    <p:sldId xmlns:r="http://schemas.openxmlformats.org/officeDocument/2006/relationships" id="266" r:id="Rc37c403a10284a82"/>
+    <p:sldId xmlns:r="http://schemas.openxmlformats.org/officeDocument/2006/relationships" id="267" r:id="R074eda3331b84adb"/>
+    <p:sldId xmlns:r="http://schemas.openxmlformats.org/officeDocument/2006/relationships" id="268" r:id="Rea5f73b96dd842ac"/>
+    <p:sldId xmlns:r="http://schemas.openxmlformats.org/officeDocument/2006/relationships" id="269" r:id="R4e35598118344f59"/>
+    <p:sldId xmlns:r="http://schemas.openxmlformats.org/officeDocument/2006/relationships" id="270" r:id="R170c1696a9084621"/>
+    <p:sldId xmlns:r="http://schemas.openxmlformats.org/officeDocument/2006/relationships" id="271" r:id="R7aa6c39fa7234dab"/>
+    <p:sldId xmlns:r="http://schemas.openxmlformats.org/officeDocument/2006/relationships" id="272" r:id="Reb568e75046440d3"/>
+    <p:sldId xmlns:r="http://schemas.openxmlformats.org/officeDocument/2006/relationships" id="273" r:id="Rd41b87bed9384664"/>
+    <p:sldId xmlns:r="http://schemas.openxmlformats.org/officeDocument/2006/relationships" id="274" r:id="R980f9f2f5d99415b"/>
+    <p:sldId xmlns:r="http://schemas.openxmlformats.org/officeDocument/2006/relationships" id="275" r:id="R096cfaeab20f4038"/>
+    <p:sldId xmlns:r="http://schemas.openxmlformats.org/officeDocument/2006/relationships" id="276" r:id="R4847ed7fb54a4a76"/>
+    <p:sldId xmlns:r="http://schemas.openxmlformats.org/officeDocument/2006/relationships" id="277" r:id="Rd9ea7c3454f4440d"/>
+    <p:sldId xmlns:r="http://schemas.openxmlformats.org/officeDocument/2006/relationships" id="278" r:id="Rccf6e85cf2374d46"/>
+    <p:sldId xmlns:r="http://schemas.openxmlformats.org/officeDocument/2006/relationships" id="279" r:id="R00b4d148062b464a"/>
+    <p:sldId xmlns:r="http://schemas.openxmlformats.org/officeDocument/2006/relationships" id="280" r:id="Rda5dbcbc0c374c46"/>
+    <p:sldId xmlns:r="http://schemas.openxmlformats.org/officeDocument/2006/relationships" id="281" r:id="R297220c29f744f33"/>
+    <p:sldId xmlns:r="http://schemas.openxmlformats.org/officeDocument/2006/relationships" id="282" r:id="Ra8e68c859ad24af3"/>
+    <p:sldId xmlns:r="http://schemas.openxmlformats.org/officeDocument/2006/relationships" id="283" r:id="Re8c9919ef4824d6a"/>
   </p:sldIdLst>
   <p:sldSz cx="12192000" cy="6858000"/>
   <p:notesSz cx="6858000" cy="9144000"/>
   <p:embeddedFontLst>
     <p:embeddedFont>
       <p:font typeface="Play"/>
-      <p:regular xmlns:r="http://schemas.openxmlformats.org/officeDocument/2006/relationships" r:id="Rb231b68186784aef"/>
-      <p:bold xmlns:r="http://schemas.openxmlformats.org/officeDocument/2006/relationships" r:id="R67a3a7ee706f44aa"/>
+      <p:regular xmlns:r="http://schemas.openxmlformats.org/officeDocument/2006/relationships" r:id="Rc2cb491e3a8f4cc8"/>
+      <p:bold xmlns:r="http://schemas.openxmlformats.org/officeDocument/2006/relationships" r:id="Rbf378c35f1f0408d"/>
     </p:embeddedFont>
   </p:embeddedFontLst>
-  <p:defaultTextStyle>
-    <a:defPPr xmlns:a="http://schemas.openxmlformats.org/drawingml/2006/main">
-      <a:defRPr lang="en-US"/>
-    </a:defPPr>
-    <a:lvl1pPr xmlns:a="http://schemas.openxmlformats.org/drawingml/2006/main" marL="0" indent="0" algn="l" defTabSz="914400">
-      <a:defRPr sz="1800" kern="1200">
-        <a:solidFill>
-          <a:schemeClr val="tx1"/>
-        </a:solidFill>
-        <a:latin typeface="+mn-lt"/>
-        <a:ea typeface="+mn-ea"/>
-        <a:cs typeface="+mn-cs"/>
-      </a:defRPr>
-    </a:lvl1pPr>
-    <a:lvl2pPr xmlns:a="http://schemas.openxmlformats.org/drawingml/2006/main" marL="457200" indent="0" algn="l" defTabSz="914400">
-      <a:defRPr sz="1800" kern="1200">
-        <a:solidFill>
-          <a:schemeClr val="tx1"/>
-        </a:solidFill>
-        <a:latin typeface="+mn-lt"/>
-        <a:ea typeface="+mn-ea"/>
-        <a:cs typeface="+mn-cs"/>
-      </a:defRPr>
-    </a:lvl2pPr>
-    <a:lvl3pPr xmlns:a="http://schemas.openxmlformats.org/drawingml/2006/main" marL="914400" indent="0" algn="l" defTabSz="914400">
-      <a:defRPr sz="1800" kern="1200">
-        <a:solidFill>
-          <a:schemeClr val="tx1"/>
-        </a:solidFill>
-        <a:latin typeface="+mn-lt"/>
-        <a:ea typeface="+mn-ea"/>
-        <a:cs typeface="+mn-cs"/>
-      </a:defRPr>
-    </a:lvl3pPr>
-    <a:lvl4pPr xmlns:a="http://schemas.openxmlformats.org/drawingml/2006/main" marL="1371600" indent="0" algn="l" defTabSz="914400">
-      <a:defRPr sz="1800" kern="1200">
-        <a:solidFill>
-          <a:schemeClr val="tx1"/>
-        </a:solidFill>
-        <a:latin typeface="+mn-lt"/>
-        <a:ea typeface="+mn-ea"/>
-        <a:cs typeface="+mn-cs"/>
-      </a:defRPr>
-    </a:lvl4pPr>
-    <a:lvl5pPr xmlns:a="http://schemas.openxmlformats.org/drawingml/2006/main" marL="1828800" indent="0" algn="l" defTabSz="914400">
-      <a:defRPr sz="1800" kern="1200">
-        <a:solidFill>
-          <a:schemeClr val="tx1"/>
-        </a:solidFill>
-        <a:latin typeface="+mn-lt"/>
-        <a:ea typeface="+mn-ea"/>
-        <a:cs typeface="+mn-cs"/>
-      </a:defRPr>
-    </a:lvl5pPr>
-    <a:lvl6pPr xmlns:a="http://schemas.openxmlformats.org/drawingml/2006/main" marL="2286000" indent="0" algn="l" defTabSz="914400">
-      <a:defRPr sz="1800" kern="1200">
-        <a:solidFill>
-          <a:schemeClr val="tx1"/>
-        </a:solidFill>
-        <a:latin typeface="+mn-lt"/>
-        <a:ea typeface="+mn-ea"/>
-        <a:cs typeface="+mn-cs"/>
-      </a:defRPr>
-    </a:lvl6pPr>
-    <a:lvl7pPr xmlns:a="http://schemas.openxmlformats.org/drawingml/2006/main" marL="2743200" indent="0" algn="l" defTabSz="914400">
-      <a:defRPr sz="1800" kern="1200">
-        <a:solidFill>
-          <a:schemeClr val="tx1"/>
-        </a:solidFill>
-        <a:latin typeface="+mn-lt"/>
-        <a:ea typeface="+mn-ea"/>
-        <a:cs typeface="+mn-cs"/>
-      </a:defRPr>
-    </a:lvl7pPr>
-    <a:lvl8pPr xmlns:a="http://schemas.openxmlformats.org/drawingml/2006/main" marL="3200400" indent="0" algn="l" defTabSz="914400">
-      <a:defRPr sz="1800" kern="1200">
-        <a:solidFill>
-          <a:schemeClr val="tx1"/>
-        </a:solidFill>
-        <a:latin typeface="+mn-lt"/>
-        <a:ea typeface="+mn-ea"/>
-        <a:cs typeface="+mn-cs"/>
-      </a:defRPr>
-    </a:lvl8pPr>
-    <a:lvl9pPr xmlns:a="http://schemas.openxmlformats.org/drawingml/2006/main" marL="3657600" indent="0" algn="l" defTabSz="914400">
-      <a:defRPr sz="1800" kern="1200">
-        <a:solidFill>
-          <a:schemeClr val="tx1"/>
-        </a:solidFill>
-        <a:latin typeface="+mn-lt"/>
-        <a:ea typeface="+mn-ea"/>
-        <a:cs typeface="+mn-cs"/>
-      </a:defRPr>
-    </a:lvl9pPr>
-  </p:defaultTextStyle>
 </p:presentation>
 </file>
 
@@ -627,7 +536,7 @@
               <a:buNone/>
             </a:pPr>
             <a:r>
-              <a:t>- results/b5_ensemble/summary.json</a:t>
+              <a:t>- results/b5_failure_audit/summary.json</a:t>
             </a:r>
           </a:p>
           <a:p xmlns:a="http://schemas.openxmlformats.org/drawingml/2006/main">
@@ -641,7 +550,7 @@
               <a:buNone/>
             </a:pPr>
             <a:r>
-              <a:t>- results/b5_ensemble/README.md</a:t>
+              <a:t>- results/b6_localization_dataset/summary.json</a:t>
             </a:r>
           </a:p>
           <a:p xmlns:a="http://schemas.openxmlformats.org/drawingml/2006/main">
@@ -1139,12 +1048,12 @@
           </a:p>
           <a:p xmlns:a="http://schemas.openxmlformats.org/drawingml/2006/main">
             <a:r>
-              <a:t>- results/b5_ensemble/summary.json</a:t>
-            </a:r>
-          </a:p>
-          <a:p xmlns:a="http://schemas.openxmlformats.org/drawingml/2006/main">
-            <a:r>
-              <a:t>- results/b5_ensemble/README.md</a:t>
+              <a:t>- results/b5_failure_audit/summary.json</a:t>
+            </a:r>
+          </a:p>
+          <a:p xmlns:a="http://schemas.openxmlformats.org/drawingml/2006/main">
+            <a:r>
+              <a:t>- results/b6_localization_dataset/summary.json</a:t>
             </a:r>
           </a:p>
           <a:p xmlns:a="http://schemas.openxmlformats.org/drawingml/2006/main">
@@ -1242,7 +1151,7 @@
               <a:buNone/>
             </a:pPr>
             <a:r>
-              <a:t>- MODEL_ROADMAP.md</a:t>
+              <a:t>- results/b2_baselines/summary.json</a:t>
             </a:r>
           </a:p>
           <a:p xmlns:a="http://schemas.openxmlformats.org/drawingml/2006/main">
@@ -1256,6 +1165,34 @@
               <a:buNone/>
             </a:pPr>
             <a:r>
+              <a:t>- results/b3_optimization/extension_summary.json</a:t>
+            </a:r>
+          </a:p>
+          <a:p xmlns:a="http://schemas.openxmlformats.org/drawingml/2006/main">
+            <a:pPr marL="0" indent="0" algn="l">
+              <a:spcBef>
+                <a:spcPts val="0"/>
+              </a:spcBef>
+              <a:spcAft>
+                <a:spcPts val="0"/>
+              </a:spcAft>
+              <a:buNone/>
+            </a:pPr>
+            <a:r>
+              <a:t>- results/b4_architecture/summary.json</a:t>
+            </a:r>
+          </a:p>
+          <a:p xmlns:a="http://schemas.openxmlformats.org/drawingml/2006/main">
+            <a:pPr marL="0" indent="0" algn="l">
+              <a:spcBef>
+                <a:spcPts val="0"/>
+              </a:spcBef>
+              <a:spcAft>
+                <a:spcPts val="0"/>
+              </a:spcAft>
+              <a:buNone/>
+            </a:pPr>
+            <a:r>
               <a:t>- results/b5_ensemble/summary.json</a:t>
             </a:r>
           </a:p>
@@ -1270,7 +1207,21 @@
               <a:buNone/>
             </a:pPr>
             <a:r>
-              <a:t>- results/b5_ensemble/README.md</a:t>
+              <a:t>- results/b5_failure_audit/summary.json</a:t>
+            </a:r>
+          </a:p>
+          <a:p xmlns:a="http://schemas.openxmlformats.org/drawingml/2006/main">
+            <a:pPr marL="0" indent="0" algn="l">
+              <a:spcBef>
+                <a:spcPts val="0"/>
+              </a:spcBef>
+              <a:spcAft>
+                <a:spcPts val="0"/>
+              </a:spcAft>
+              <a:buNone/>
+            </a:pPr>
+            <a:r>
+              <a:t>- results/b6_localization_dataset/summary.json</a:t>
             </a:r>
           </a:p>
           <a:p xmlns:a="http://schemas.openxmlformats.org/drawingml/2006/main">
@@ -2322,7 +2273,7 @@
               <a:buNone/>
             </a:pPr>
             <a:r>
-              <a:t>- MODEL_ROADMAP.md</a:t>
+              <a:t>- results/b4_architecture/summary.json</a:t>
             </a:r>
           </a:p>
           <a:p xmlns:a="http://schemas.openxmlformats.org/drawingml/2006/main">
@@ -2336,21 +2287,7 @@
               <a:buNone/>
             </a:pPr>
             <a:r>
-              <a:t>- results/b5_ensemble/summary.json</a:t>
-            </a:r>
-          </a:p>
-          <a:p xmlns:a="http://schemas.openxmlformats.org/drawingml/2006/main">
-            <a:pPr marL="0" indent="0" algn="l">
-              <a:spcBef>
-                <a:spcPts val="0"/>
-              </a:spcBef>
-              <a:spcAft>
-                <a:spcPts val="0"/>
-              </a:spcAft>
-              <a:buNone/>
-            </a:pPr>
-            <a:r>
-              <a:t>- results/b5_ensemble/README.md</a:t>
+              <a:t>- results/b4_architecture/README.md</a:t>
             </a:r>
           </a:p>
           <a:p xmlns:a="http://schemas.openxmlformats.org/drawingml/2006/main">
@@ -2529,6 +2466,532 @@
 </p:notes>
 </file>
 
+<file path=ppt/notesSlides/notesSlide25.xml><?xml version="1.0" encoding="utf-8"?>
+<p:notes xmlns:p="http://schemas.openxmlformats.org/presentationml/2006/main">
+  <p:cSld>
+    <p:spTree>
+      <p:nvGrpSpPr>
+        <p:cNvPr id="1" name=""/>
+        <p:cNvGrpSpPr/>
+        <p:nvPr/>
+      </p:nvGrpSpPr>
+      <p:grpSpPr>
+        <a:xfrm xmlns:a="http://schemas.openxmlformats.org/drawingml/2006/main"/>
+      </p:grpSpPr>
+      <p:sp>
+        <p:nvSpPr>
+          <p:cNvPr id="2" name="Slide Image Placeholder 1"/>
+          <p:cNvSpPr>
+            <a:spLocks xmlns:a="http://schemas.openxmlformats.org/drawingml/2006/main" noGrp="1"/>
+          </p:cNvSpPr>
+          <p:nvPr>
+            <p:ph type="sldImg" idx="0"/>
+          </p:nvPr>
+        </p:nvSpPr>
+        <p:spPr/>
+      </p:sp>
+      <p:sp>
+        <p:nvSpPr>
+          <p:cNvPr id="3" name="Notes Placeholder 2"/>
+          <p:cNvSpPr>
+            <a:spLocks xmlns:a="http://schemas.openxmlformats.org/drawingml/2006/main" noGrp="1"/>
+          </p:cNvSpPr>
+          <p:nvPr>
+            <p:ph type="body" idx="1"/>
+          </p:nvPr>
+        </p:nvSpPr>
+        <p:spPr/>
+        <p:txBody>
+          <a:bodyPr xmlns:a="http://schemas.openxmlformats.org/drawingml/2006/main"/>
+          <a:lstStyle xmlns:a="http://schemas.openxmlformats.org/drawingml/2006/main"/>
+          <a:p xmlns:a="http://schemas.openxmlformats.org/drawingml/2006/main">
+            <a:pPr marL="0" indent="0" algn="l">
+              <a:spcBef>
+                <a:spcPts val="0"/>
+              </a:spcBef>
+              <a:spcAft>
+                <a:spcPts val="0"/>
+              </a:spcAft>
+              <a:buNone/>
+            </a:pPr>
+            <a:r>
+              <a:t>[Sources]</a:t>
+            </a:r>
+          </a:p>
+          <a:p xmlns:a="http://schemas.openxmlformats.org/drawingml/2006/main">
+            <a:pPr marL="0" indent="0" algn="l">
+              <a:spcBef>
+                <a:spcPts val="0"/>
+              </a:spcBef>
+              <a:spcAft>
+                <a:spcPts val="0"/>
+              </a:spcAft>
+              <a:buNone/>
+            </a:pPr>
+            <a:r>
+              <a:t>- MODEL_ROADMAP.md</a:t>
+            </a:r>
+          </a:p>
+          <a:p xmlns:a="http://schemas.openxmlformats.org/drawingml/2006/main">
+            <a:pPr marL="0" indent="0" algn="l">
+              <a:spcBef>
+                <a:spcPts val="0"/>
+              </a:spcBef>
+              <a:spcAft>
+                <a:spcPts val="0"/>
+              </a:spcAft>
+              <a:buNone/>
+            </a:pPr>
+            <a:r>
+              <a:t>- results/b5_ensemble/summary.json</a:t>
+            </a:r>
+          </a:p>
+          <a:p xmlns:a="http://schemas.openxmlformats.org/drawingml/2006/main">
+            <a:pPr marL="0" indent="0" algn="l">
+              <a:spcBef>
+                <a:spcPts val="0"/>
+              </a:spcBef>
+              <a:spcAft>
+                <a:spcPts val="0"/>
+              </a:spcAft>
+              <a:buNone/>
+            </a:pPr>
+            <a:r>
+              <a:t>- results/b5_ensemble/README.md</a:t>
+            </a:r>
+          </a:p>
+          <a:p xmlns:a="http://schemas.openxmlformats.org/drawingml/2006/main">
+            <a:pPr marL="0" indent="0" algn="l">
+              <a:spcBef>
+                <a:spcPts val="0"/>
+              </a:spcBef>
+              <a:spcAft>
+                <a:spcPts val="0"/>
+              </a:spcAft>
+              <a:buNone/>
+            </a:pPr>
+            <a:r>
+              <a:t>[/Sources]</a:t>
+            </a:r>
+          </a:p>
+        </p:txBody>
+      </p:sp>
+      <p:sp>
+        <p:nvSpPr>
+          <p:cNvPr id="4" name="Slide Number Placeholder 3"/>
+          <p:cNvSpPr>
+            <a:spLocks xmlns:a="http://schemas.openxmlformats.org/drawingml/2006/main" noGrp="1"/>
+          </p:cNvSpPr>
+          <p:nvPr>
+            <p:ph type="sldNum" idx="5"/>
+          </p:nvPr>
+        </p:nvSpPr>
+        <p:spPr/>
+        <p:txBody>
+          <a:bodyPr xmlns:a="http://schemas.openxmlformats.org/drawingml/2006/main"/>
+          <a:lstStyle xmlns:a="http://schemas.openxmlformats.org/drawingml/2006/main"/>
+          <a:p xmlns:a="http://schemas.openxmlformats.org/drawingml/2006/main"/>
+        </p:txBody>
+      </p:sp>
+    </p:spTree>
+  </p:cSld>
+  <p:clrMapOvr>
+    <a:masterClrMapping xmlns:a="http://schemas.openxmlformats.org/drawingml/2006/main"/>
+  </p:clrMapOvr>
+</p:notes>
+</file>
+
+<file path=ppt/notesSlides/notesSlide26.xml><?xml version="1.0" encoding="utf-8"?>
+<p:notes xmlns:p="http://schemas.openxmlformats.org/presentationml/2006/main">
+  <p:cSld>
+    <p:spTree>
+      <p:nvGrpSpPr>
+        <p:cNvPr id="1" name=""/>
+        <p:cNvGrpSpPr/>
+        <p:nvPr/>
+      </p:nvGrpSpPr>
+      <p:grpSpPr>
+        <a:xfrm xmlns:a="http://schemas.openxmlformats.org/drawingml/2006/main"/>
+      </p:grpSpPr>
+      <p:sp>
+        <p:nvSpPr>
+          <p:cNvPr id="2" name="Slide Image Placeholder 1"/>
+          <p:cNvSpPr>
+            <a:spLocks xmlns:a="http://schemas.openxmlformats.org/drawingml/2006/main" noGrp="1"/>
+          </p:cNvSpPr>
+          <p:nvPr>
+            <p:ph type="sldImg" idx="0"/>
+          </p:nvPr>
+        </p:nvSpPr>
+        <p:spPr/>
+      </p:sp>
+      <p:sp>
+        <p:nvSpPr>
+          <p:cNvPr id="3" name="Notes Placeholder 2"/>
+          <p:cNvSpPr>
+            <a:spLocks xmlns:a="http://schemas.openxmlformats.org/drawingml/2006/main" noGrp="1"/>
+          </p:cNvSpPr>
+          <p:nvPr>
+            <p:ph type="body" idx="1"/>
+          </p:nvPr>
+        </p:nvSpPr>
+        <p:spPr/>
+        <p:txBody>
+          <a:bodyPr xmlns:a="http://schemas.openxmlformats.org/drawingml/2006/main"/>
+          <a:lstStyle xmlns:a="http://schemas.openxmlformats.org/drawingml/2006/main"/>
+          <a:p xmlns:a="http://schemas.openxmlformats.org/drawingml/2006/main">
+            <a:pPr marL="0" indent="0" algn="l">
+              <a:spcBef>
+                <a:spcPts val="0"/>
+              </a:spcBef>
+              <a:spcAft>
+                <a:spcPts val="0"/>
+              </a:spcAft>
+              <a:buNone/>
+            </a:pPr>
+            <a:r>
+              <a:t>[Sources]</a:t>
+            </a:r>
+          </a:p>
+          <a:p xmlns:a="http://schemas.openxmlformats.org/drawingml/2006/main">
+            <a:pPr marL="0" indent="0" algn="l">
+              <a:spcBef>
+                <a:spcPts val="0"/>
+              </a:spcBef>
+              <a:spcAft>
+                <a:spcPts val="0"/>
+              </a:spcAft>
+              <a:buNone/>
+            </a:pPr>
+            <a:r>
+              <a:t>- results/b5_failure_audit/summary.json</a:t>
+            </a:r>
+          </a:p>
+          <a:p xmlns:a="http://schemas.openxmlformats.org/drawingml/2006/main">
+            <a:pPr marL="0" indent="0" algn="l">
+              <a:spcBef>
+                <a:spcPts val="0"/>
+              </a:spcBef>
+              <a:spcAft>
+                <a:spcPts val="0"/>
+              </a:spcAft>
+              <a:buNone/>
+            </a:pPr>
+            <a:r>
+              <a:t>- results/b5_failure_audit/README.md</a:t>
+            </a:r>
+          </a:p>
+          <a:p xmlns:a="http://schemas.openxmlformats.org/drawingml/2006/main">
+            <a:pPr marL="0" indent="0" algn="l">
+              <a:spcBef>
+                <a:spcPts val="0"/>
+              </a:spcBef>
+              <a:spcAft>
+                <a:spcPts val="0"/>
+              </a:spcAft>
+              <a:buNone/>
+            </a:pPr>
+            <a:r>
+              <a:t>[/Sources]</a:t>
+            </a:r>
+          </a:p>
+        </p:txBody>
+      </p:sp>
+      <p:sp>
+        <p:nvSpPr>
+          <p:cNvPr id="4" name="Slide Number Placeholder 3"/>
+          <p:cNvSpPr>
+            <a:spLocks xmlns:a="http://schemas.openxmlformats.org/drawingml/2006/main" noGrp="1"/>
+          </p:cNvSpPr>
+          <p:nvPr>
+            <p:ph type="sldNum" idx="5"/>
+          </p:nvPr>
+        </p:nvSpPr>
+        <p:spPr/>
+        <p:txBody>
+          <a:bodyPr xmlns:a="http://schemas.openxmlformats.org/drawingml/2006/main"/>
+          <a:lstStyle xmlns:a="http://schemas.openxmlformats.org/drawingml/2006/main"/>
+          <a:p xmlns:a="http://schemas.openxmlformats.org/drawingml/2006/main"/>
+        </p:txBody>
+      </p:sp>
+    </p:spTree>
+  </p:cSld>
+  <p:clrMapOvr>
+    <a:masterClrMapping xmlns:a="http://schemas.openxmlformats.org/drawingml/2006/main"/>
+  </p:clrMapOvr>
+</p:notes>
+</file>
+
+<file path=ppt/notesSlides/notesSlide27.xml><?xml version="1.0" encoding="utf-8"?>
+<p:notes xmlns:p="http://schemas.openxmlformats.org/presentationml/2006/main">
+  <p:cSld>
+    <p:spTree>
+      <p:nvGrpSpPr>
+        <p:cNvPr id="1" name=""/>
+        <p:cNvGrpSpPr/>
+        <p:nvPr/>
+      </p:nvGrpSpPr>
+      <p:grpSpPr>
+        <a:xfrm xmlns:a="http://schemas.openxmlformats.org/drawingml/2006/main"/>
+      </p:grpSpPr>
+      <p:sp>
+        <p:nvSpPr>
+          <p:cNvPr id="2" name="Slide Image Placeholder 1"/>
+          <p:cNvSpPr>
+            <a:spLocks xmlns:a="http://schemas.openxmlformats.org/drawingml/2006/main" noGrp="1"/>
+          </p:cNvSpPr>
+          <p:nvPr>
+            <p:ph type="sldImg" idx="0"/>
+          </p:nvPr>
+        </p:nvSpPr>
+        <p:spPr/>
+      </p:sp>
+      <p:sp>
+        <p:nvSpPr>
+          <p:cNvPr id="3" name="Notes Placeholder 2"/>
+          <p:cNvSpPr>
+            <a:spLocks xmlns:a="http://schemas.openxmlformats.org/drawingml/2006/main" noGrp="1"/>
+          </p:cNvSpPr>
+          <p:nvPr>
+            <p:ph type="body" idx="1"/>
+          </p:nvPr>
+        </p:nvSpPr>
+        <p:spPr/>
+        <p:txBody>
+          <a:bodyPr xmlns:a="http://schemas.openxmlformats.org/drawingml/2006/main"/>
+          <a:lstStyle xmlns:a="http://schemas.openxmlformats.org/drawingml/2006/main"/>
+          <a:p xmlns:a="http://schemas.openxmlformats.org/drawingml/2006/main">
+            <a:pPr marL="0" indent="0" algn="l">
+              <a:spcBef>
+                <a:spcPts val="0"/>
+              </a:spcBef>
+              <a:spcAft>
+                <a:spcPts val="0"/>
+              </a:spcAft>
+              <a:buNone/>
+            </a:pPr>
+            <a:r>
+              <a:t>[Sources]</a:t>
+            </a:r>
+          </a:p>
+          <a:p xmlns:a="http://schemas.openxmlformats.org/drawingml/2006/main">
+            <a:pPr marL="0" indent="0" algn="l">
+              <a:spcBef>
+                <a:spcPts val="0"/>
+              </a:spcBef>
+              <a:spcAft>
+                <a:spcPts val="0"/>
+              </a:spcAft>
+              <a:buNone/>
+            </a:pPr>
+            <a:r>
+              <a:t>- MODEL_ROADMAP.md</a:t>
+            </a:r>
+          </a:p>
+          <a:p xmlns:a="http://schemas.openxmlformats.org/drawingml/2006/main">
+            <a:pPr marL="0" indent="0" algn="l">
+              <a:spcBef>
+                <a:spcPts val="0"/>
+              </a:spcBef>
+              <a:spcAft>
+                <a:spcPts val="0"/>
+              </a:spcAft>
+              <a:buNone/>
+            </a:pPr>
+            <a:r>
+              <a:t>- results/b6_localization_dataset/summary.json</a:t>
+            </a:r>
+          </a:p>
+          <a:p xmlns:a="http://schemas.openxmlformats.org/drawingml/2006/main">
+            <a:pPr marL="0" indent="0" algn="l">
+              <a:spcBef>
+                <a:spcPts val="0"/>
+              </a:spcBef>
+              <a:spcAft>
+                <a:spcPts val="0"/>
+              </a:spcAft>
+              <a:buNone/>
+            </a:pPr>
+            <a:r>
+              <a:t>- results/b6_localization_dataset/README.md</a:t>
+            </a:r>
+          </a:p>
+          <a:p xmlns:a="http://schemas.openxmlformats.org/drawingml/2006/main">
+            <a:pPr marL="0" indent="0" algn="l">
+              <a:spcBef>
+                <a:spcPts val="0"/>
+              </a:spcBef>
+              <a:spcAft>
+                <a:spcPts val="0"/>
+              </a:spcAft>
+              <a:buNone/>
+            </a:pPr>
+            <a:r>
+              <a:t>[/Sources]</a:t>
+            </a:r>
+          </a:p>
+        </p:txBody>
+      </p:sp>
+      <p:sp>
+        <p:nvSpPr>
+          <p:cNvPr id="4" name="Slide Number Placeholder 3"/>
+          <p:cNvSpPr>
+            <a:spLocks xmlns:a="http://schemas.openxmlformats.org/drawingml/2006/main" noGrp="1"/>
+          </p:cNvSpPr>
+          <p:nvPr>
+            <p:ph type="sldNum" idx="5"/>
+          </p:nvPr>
+        </p:nvSpPr>
+        <p:spPr/>
+        <p:txBody>
+          <a:bodyPr xmlns:a="http://schemas.openxmlformats.org/drawingml/2006/main"/>
+          <a:lstStyle xmlns:a="http://schemas.openxmlformats.org/drawingml/2006/main"/>
+          <a:p xmlns:a="http://schemas.openxmlformats.org/drawingml/2006/main"/>
+        </p:txBody>
+      </p:sp>
+    </p:spTree>
+  </p:cSld>
+  <p:clrMapOvr>
+    <a:masterClrMapping xmlns:a="http://schemas.openxmlformats.org/drawingml/2006/main"/>
+  </p:clrMapOvr>
+</p:notes>
+</file>
+
+<file path=ppt/notesSlides/notesSlide28.xml><?xml version="1.0" encoding="utf-8"?>
+<p:notes xmlns:p="http://schemas.openxmlformats.org/presentationml/2006/main">
+  <p:cSld>
+    <p:spTree>
+      <p:nvGrpSpPr>
+        <p:cNvPr id="1" name=""/>
+        <p:cNvGrpSpPr/>
+        <p:nvPr/>
+      </p:nvGrpSpPr>
+      <p:grpSpPr>
+        <a:xfrm xmlns:a="http://schemas.openxmlformats.org/drawingml/2006/main"/>
+      </p:grpSpPr>
+      <p:sp>
+        <p:nvSpPr>
+          <p:cNvPr id="2" name="Slide Image Placeholder 1"/>
+          <p:cNvSpPr>
+            <a:spLocks xmlns:a="http://schemas.openxmlformats.org/drawingml/2006/main" noGrp="1"/>
+          </p:cNvSpPr>
+          <p:nvPr>
+            <p:ph type="sldImg" idx="0"/>
+          </p:nvPr>
+        </p:nvSpPr>
+        <p:spPr/>
+      </p:sp>
+      <p:sp>
+        <p:nvSpPr>
+          <p:cNvPr id="3" name="Notes Placeholder 2"/>
+          <p:cNvSpPr>
+            <a:spLocks xmlns:a="http://schemas.openxmlformats.org/drawingml/2006/main" noGrp="1"/>
+          </p:cNvSpPr>
+          <p:nvPr>
+            <p:ph type="body" idx="1"/>
+          </p:nvPr>
+        </p:nvSpPr>
+        <p:spPr/>
+        <p:txBody>
+          <a:bodyPr xmlns:a="http://schemas.openxmlformats.org/drawingml/2006/main"/>
+          <a:lstStyle xmlns:a="http://schemas.openxmlformats.org/drawingml/2006/main"/>
+          <a:p xmlns:a="http://schemas.openxmlformats.org/drawingml/2006/main">
+            <a:pPr marL="0" indent="0" algn="l">
+              <a:spcBef>
+                <a:spcPts val="0"/>
+              </a:spcBef>
+              <a:spcAft>
+                <a:spcPts val="0"/>
+              </a:spcAft>
+              <a:buNone/>
+            </a:pPr>
+            <a:r>
+              <a:t>[Sources]</a:t>
+            </a:r>
+          </a:p>
+          <a:p xmlns:a="http://schemas.openxmlformats.org/drawingml/2006/main">
+            <a:pPr marL="0" indent="0" algn="l">
+              <a:spcBef>
+                <a:spcPts val="0"/>
+              </a:spcBef>
+              <a:spcAft>
+                <a:spcPts val="0"/>
+              </a:spcAft>
+              <a:buNone/>
+            </a:pPr>
+            <a:r>
+              <a:t>- MODEL_ROADMAP.md, B6.2</a:t>
+            </a:r>
+          </a:p>
+          <a:p xmlns:a="http://schemas.openxmlformats.org/drawingml/2006/main">
+            <a:pPr marL="0" indent="0" algn="l">
+              <a:spcBef>
+                <a:spcPts val="0"/>
+              </a:spcBef>
+              <a:spcAft>
+                <a:spcPts val="0"/>
+              </a:spcAft>
+              <a:buNone/>
+            </a:pPr>
+            <a:r>
+              <a:t>- results/b6_localization_dataset/summary.json</a:t>
+            </a:r>
+          </a:p>
+          <a:p xmlns:a="http://schemas.openxmlformats.org/drawingml/2006/main">
+            <a:pPr marL="0" indent="0" algn="l">
+              <a:spcBef>
+                <a:spcPts val="0"/>
+              </a:spcBef>
+              <a:spcAft>
+                <a:spcPts val="0"/>
+              </a:spcAft>
+              <a:buNone/>
+            </a:pPr>
+            <a:r>
+              <a:t>- Ronneberger et al., U-Net (arXiv:1505.04597)</a:t>
+            </a:r>
+          </a:p>
+          <a:p xmlns:a="http://schemas.openxmlformats.org/drawingml/2006/main">
+            <a:pPr marL="0" indent="0" algn="l">
+              <a:spcBef>
+                <a:spcPts val="0"/>
+              </a:spcBef>
+              <a:spcAft>
+                <a:spcPts val="0"/>
+              </a:spcAft>
+              <a:buNone/>
+            </a:pPr>
+            <a:r>
+              <a:t>[/Sources]</a:t>
+            </a:r>
+          </a:p>
+        </p:txBody>
+      </p:sp>
+      <p:sp>
+        <p:nvSpPr>
+          <p:cNvPr id="4" name="Slide Number Placeholder 3"/>
+          <p:cNvSpPr>
+            <a:spLocks xmlns:a="http://schemas.openxmlformats.org/drawingml/2006/main" noGrp="1"/>
+          </p:cNvSpPr>
+          <p:nvPr>
+            <p:ph type="sldNum" idx="5"/>
+          </p:nvPr>
+        </p:nvSpPr>
+        <p:spPr/>
+        <p:txBody>
+          <a:bodyPr xmlns:a="http://schemas.openxmlformats.org/drawingml/2006/main"/>
+          <a:lstStyle xmlns:a="http://schemas.openxmlformats.org/drawingml/2006/main"/>
+          <a:p xmlns:a="http://schemas.openxmlformats.org/drawingml/2006/main"/>
+        </p:txBody>
+      </p:sp>
+    </p:spTree>
+  </p:cSld>
+  <p:clrMapOvr>
+    <a:masterClrMapping xmlns:a="http://schemas.openxmlformats.org/drawingml/2006/main"/>
+  </p:clrMapOvr>
+</p:notes>
+</file>
+
 <file path=ppt/notesSlides/notesSlide3.xml><?xml version="1.0" encoding="utf-8"?>
 <p:notes xmlns:p="http://schemas.openxmlformats.org/presentationml/2006/main">
   <p:cSld>
@@ -3178,7 +3641,7 @@
               <a:buNone/>
             </a:pPr>
             <a:r>
-              <a:t>- results/b5_ensemble/summary.json</a:t>
+              <a:t>- results/b5_failure_audit/summary.json</a:t>
             </a:r>
           </a:p>
           <a:p xmlns:a="http://schemas.openxmlformats.org/drawingml/2006/main">
@@ -3192,7 +3655,7 @@
               <a:buNone/>
             </a:pPr>
             <a:r>
-              <a:t>- results/b5_ensemble/README.md</a:t>
+              <a:t>- results/b6_localization_dataset/summary.json</a:t>
             </a:r>
           </a:p>
           <a:p xmlns:a="http://schemas.openxmlformats.org/drawingml/2006/main">
@@ -11977,17 +12440,17 @@
   </p:cSld>
   <p:clrMap bg1="lt1" tx1="dk1" bg2="dk2" tx2="lt2" accent1="accent1" accent2="accent2" accent3="accent3" accent4="accent4" accent5="accent5" accent6="accent6" hlink="hlink" folHlink="folHlink"/>
   <p:sldLayoutIdLst>
-    <p:sldLayoutId xmlns:r="http://schemas.openxmlformats.org/officeDocument/2006/relationships" id="2147483649" r:id="Ra2e7c6f67dd048ee"/>
-    <p:sldLayoutId xmlns:r="http://schemas.openxmlformats.org/officeDocument/2006/relationships" id="2147483650" r:id="R7f5ea866fde749cc"/>
-    <p:sldLayoutId xmlns:r="http://schemas.openxmlformats.org/officeDocument/2006/relationships" id="2147483651" r:id="R61c182885a434cda"/>
-    <p:sldLayoutId xmlns:r="http://schemas.openxmlformats.org/officeDocument/2006/relationships" id="2147483652" r:id="R5b22a1991dae4445"/>
-    <p:sldLayoutId xmlns:r="http://schemas.openxmlformats.org/officeDocument/2006/relationships" id="2147483653" r:id="Ra0270228fc6240b3"/>
-    <p:sldLayoutId xmlns:r="http://schemas.openxmlformats.org/officeDocument/2006/relationships" id="2147483654" r:id="R0e555d0f6c7e42c6"/>
-    <p:sldLayoutId xmlns:r="http://schemas.openxmlformats.org/officeDocument/2006/relationships" id="2147483655" r:id="R1bdc22da98b64d7b"/>
-    <p:sldLayoutId xmlns:r="http://schemas.openxmlformats.org/officeDocument/2006/relationships" id="2147483656" r:id="R17a33fc982754271"/>
-    <p:sldLayoutId xmlns:r="http://schemas.openxmlformats.org/officeDocument/2006/relationships" id="2147483657" r:id="Rd2e3d367db154577"/>
-    <p:sldLayoutId xmlns:r="http://schemas.openxmlformats.org/officeDocument/2006/relationships" id="2147483658" r:id="R4a14adb1ab184645"/>
-    <p:sldLayoutId xmlns:r="http://schemas.openxmlformats.org/officeDocument/2006/relationships" id="2147483659" r:id="R3dfe9c8d85934a31"/>
+    <p:sldLayoutId xmlns:r="http://schemas.openxmlformats.org/officeDocument/2006/relationships" id="2147483649" r:id="R407a5c2aa2054a47"/>
+    <p:sldLayoutId xmlns:r="http://schemas.openxmlformats.org/officeDocument/2006/relationships" id="2147483650" r:id="Radef6650b8584ea0"/>
+    <p:sldLayoutId xmlns:r="http://schemas.openxmlformats.org/officeDocument/2006/relationships" id="2147483651" r:id="R8961f1aebd5e40e1"/>
+    <p:sldLayoutId xmlns:r="http://schemas.openxmlformats.org/officeDocument/2006/relationships" id="2147483652" r:id="R6371f0bdefd74638"/>
+    <p:sldLayoutId xmlns:r="http://schemas.openxmlformats.org/officeDocument/2006/relationships" id="2147483653" r:id="R0d9dbbaa1caa404a"/>
+    <p:sldLayoutId xmlns:r="http://schemas.openxmlformats.org/officeDocument/2006/relationships" id="2147483654" r:id="R08e798c0e6ea4f60"/>
+    <p:sldLayoutId xmlns:r="http://schemas.openxmlformats.org/officeDocument/2006/relationships" id="2147483655" r:id="Re591310537d040c5"/>
+    <p:sldLayoutId xmlns:r="http://schemas.openxmlformats.org/officeDocument/2006/relationships" id="2147483656" r:id="Rbf7be9b1edcb4e36"/>
+    <p:sldLayoutId xmlns:r="http://schemas.openxmlformats.org/officeDocument/2006/relationships" id="2147483657" r:id="R54bb288944c246d7"/>
+    <p:sldLayoutId xmlns:r="http://schemas.openxmlformats.org/officeDocument/2006/relationships" id="2147483658" r:id="Rec441082f68b4849"/>
+    <p:sldLayoutId xmlns:r="http://schemas.openxmlformats.org/officeDocument/2006/relationships" id="2147483659" r:id="R9859e5c93171418d"/>
   </p:sldLayoutIdLst>
   <p:hf sldNum="0" hdr="0" ftr="0" dt="0"/>
   <p:txStyles>
@@ -12939,7 +13402,7 @@
               <a:buNone/>
             </a:pPr>
             <a:r>
-              <a:t>CNN-based DRC | B0–B5.1 complete · failure analysis next</a:t>
+              <a:t>CNN-based DRC | B0–B6.1 complete · multi-task U-Net next</a:t>
             </a:r>
           </a:p>
         </p:txBody>
@@ -16914,8 +17377,7 @@
               <a:buChar char="●"/>
             </a:pPr>
             <a:r>
-              <a:t>B5.1  Ensemble — rejected
-B5.2  Failure slices — next</a:t>
+              <a:t>B5  Classifier tuning — closed</a:t>
             </a:r>
           </a:p>
           <a:p xmlns:a="http://schemas.openxmlformats.org/drawingml/2006/main">
@@ -16929,7 +17391,7 @@
               <a:buChar char="●"/>
             </a:pPr>
             <a:r>
-              <a:t>B6  Pixel-level localization</a:t>
+              <a:t>B6.1  Localization data — complete</a:t>
             </a:r>
           </a:p>
           <a:p xmlns:a="http://schemas.openxmlformats.org/drawingml/2006/main">
@@ -16943,6 +17405,20 @@
               <a:buChar char="●"/>
             </a:pPr>
             <a:r>
+              <a:t>B6.2  Multi-task U-Net — next</a:t>
+            </a:r>
+          </a:p>
+          <a:p xmlns:a="http://schemas.openxmlformats.org/drawingml/2006/main">
+            <a:pPr marL="457200" indent="-342900" algn="l">
+              <a:spcBef>
+                <a:spcPts val="0"/>
+              </a:spcBef>
+              <a:spcAft>
+                <a:spcPts val="0"/>
+              </a:spcAft>
+              <a:buChar char="●"/>
+            </a:pPr>
+            <a:r>
               <a:t>B7  Exact GDS coordinates</a:t>
             </a:r>
           </a:p>
@@ -16957,7 +17433,7 @@
               <a:buChar char="●"/>
             </a:pPr>
             <a:r>
-              <a:t>B8  DRC/LVS-verified auto-fix</a:t>
+              <a:t>B8  Verified repair</a:t>
             </a:r>
           </a:p>
           <a:p xmlns:a="http://schemas.openxmlformats.org/drawingml/2006/main">
@@ -16971,7 +17447,7 @@
               <a:buChar char="●"/>
             </a:pPr>
             <a:r>
-              <a:t>B9  Reproducible release candidate</a:t>
+              <a:t>B9  Release candidate</a:t>
             </a:r>
           </a:p>
         </p:txBody>
@@ -17028,7 +17504,7 @@
                   <a:srgbClr val="404040"/>
                 </a:solidFill>
               </a:rPr>
-              <a:t>Use evidence-backed classifier gains, then deliver masks, coordinates, and verified repairs.</a:t>
+              <a:t>B2 remains the classifier baseline; B6.1 enables U-Net localization training.</a:t>
             </a:r>
           </a:p>
         </p:txBody>
@@ -17496,7 +17972,7 @@
                   <a:srgbClr val="262626"/>
                 </a:solidFill>
               </a:rPr>
-              <a:t>B0</a:t>
+              <a:t>B2</a:t>
             </a:r>
           </a:p>
         </p:txBody>
@@ -17553,7 +18029,7 @@
                   <a:srgbClr val="262626"/>
                 </a:solidFill>
               </a:rPr>
-              <a:t>Done</a:t>
+              <a:t>Accepted</a:t>
             </a:r>
           </a:p>
         </p:txBody>
@@ -17610,7 +18086,7 @@
                   <a:srgbClr val="262626"/>
                 </a:solidFill>
               </a:rPr>
-              <a:t>Functional random-tile sanity run</a:t>
+              <a:t>Frozen classifier baseline</a:t>
             </a:r>
           </a:p>
         </p:txBody>
@@ -17667,7 +18143,7 @@
                   <a:srgbClr val="262626"/>
                 </a:solidFill>
               </a:rPr>
-              <a:t>79.2%</a:t>
+              <a:t>90.38%</a:t>
             </a:r>
           </a:p>
         </p:txBody>
@@ -17724,7 +18200,7 @@
                   <a:srgbClr val="262626"/>
                 </a:solidFill>
               </a:rPr>
-              <a:t>0.786</a:t>
+              <a:t>0.909</a:t>
             </a:r>
           </a:p>
         </p:txBody>
@@ -17838,7 +18314,7 @@
                   <a:srgbClr val="262626"/>
                 </a:solidFill>
               </a:rPr>
-              <a:t>B1</a:t>
+              <a:t>B3</a:t>
             </a:r>
           </a:p>
         </p:txBody>
@@ -17895,7 +18371,7 @@
                   <a:srgbClr val="262626"/>
                 </a:solidFill>
               </a:rPr>
-              <a:t>Done</a:t>
+              <a:t>Rejected</a:t>
             </a:r>
           </a:p>
         </p:txBody>
@@ -17952,7 +18428,7 @@
                   <a:srgbClr val="262626"/>
                 </a:solidFill>
               </a:rPr>
-              <a:t>14,348 tiles · 14 frozen families</a:t>
+              <a:t>Recall gain failed confirmation</a:t>
             </a:r>
           </a:p>
         </p:txBody>
@@ -18009,7 +18485,7 @@
                   <a:srgbClr val="262626"/>
                 </a:solidFill>
               </a:rPr>
-              <a:t>—</a:t>
+              <a:t>89.71%</a:t>
             </a:r>
           </a:p>
         </p:txBody>
@@ -18066,7 +18542,7 @@
                   <a:srgbClr val="262626"/>
                 </a:solidFill>
               </a:rPr>
-              <a:t>—</a:t>
+              <a:t>0.907</a:t>
             </a:r>
           </a:p>
         </p:txBody>
@@ -18123,7 +18599,7 @@
                   <a:srgbClr val="262626"/>
                 </a:solidFill>
               </a:rPr>
-              <a:t>—</a:t>
+              <a:t>−0.002</a:t>
             </a:r>
           </a:p>
         </p:txBody>
@@ -18180,7 +18656,7 @@
                   <a:srgbClr val="262626"/>
                 </a:solidFill>
               </a:rPr>
-              <a:t>B2</a:t>
+              <a:t>B4</a:t>
             </a:r>
           </a:p>
         </p:txBody>
@@ -18237,7 +18713,7 @@
                   <a:srgbClr val="262626"/>
                 </a:solidFill>
               </a:rPr>
-              <a:t>Done</a:t>
+              <a:t>Rejected</a:t>
             </a:r>
           </a:p>
         </p:txBody>
@@ -18294,7 +18770,7 @@
                   <a:srgbClr val="262626"/>
                 </a:solidFill>
               </a:rPr>
-              <a:t>Three-seed unseen-layout baseline</a:t>
+              <a:t>Compact model failed frozen test</a:t>
             </a:r>
           </a:p>
         </p:txBody>
@@ -18351,7 +18827,7 @@
                   <a:srgbClr val="262626"/>
                 </a:solidFill>
               </a:rPr>
-              <a:t>90.38%</a:t>
+              <a:t>89.36%</a:t>
             </a:r>
           </a:p>
         </p:txBody>
@@ -18408,7 +18884,7 @@
                   <a:srgbClr val="262626"/>
                 </a:solidFill>
               </a:rPr>
-              <a:t>0.909</a:t>
+              <a:t>0.904</a:t>
             </a:r>
           </a:p>
         </p:txBody>
@@ -18465,7 +18941,7 @@
                   <a:srgbClr val="262626"/>
                 </a:solidFill>
               </a:rPr>
-              <a:t>n/a*</a:t>
+              <a:t>−0.005</a:t>
             </a:r>
           </a:p>
         </p:txBody>
@@ -18522,7 +18998,7 @@
                   <a:srgbClr val="262626"/>
                 </a:solidFill>
               </a:rPr>
-              <a:t>B3</a:t>
+              <a:t>B5</a:t>
             </a:r>
           </a:p>
         </p:txBody>
@@ -18579,7 +19055,7 @@
                   <a:srgbClr val="262626"/>
                 </a:solidFill>
               </a:rPr>
-              <a:t>Done</a:t>
+              <a:t>Closed</a:t>
             </a:r>
           </a:p>
         </p:txBody>
@@ -18636,7 +19112,7 @@
                   <a:srgbClr val="262626"/>
                 </a:solidFill>
               </a:rPr>
-              <a:t>Recall trade-off rejected</a:t>
+              <a:t>Ensemble + failure audit</a:t>
             </a:r>
           </a:p>
         </p:txBody>
@@ -18693,7 +19169,7 @@
                   <a:srgbClr val="262626"/>
                 </a:solidFill>
               </a:rPr>
-              <a:t>89.71%</a:t>
+              <a:t>90.47%</a:t>
             </a:r>
           </a:p>
         </p:txBody>
@@ -18750,7 +19226,7 @@
                   <a:srgbClr val="262626"/>
                 </a:solidFill>
               </a:rPr>
-              <a:t>0.907</a:t>
+              <a:t>0.912</a:t>
             </a:r>
           </a:p>
         </p:txBody>
@@ -18807,7 +19283,7 @@
                   <a:srgbClr val="262626"/>
                 </a:solidFill>
               </a:rPr>
-              <a:t>−0.002</a:t>
+              <a:t>+0.003</a:t>
             </a:r>
           </a:p>
         </p:txBody>
@@ -18864,7 +19340,7 @@
                   <a:srgbClr val="262626"/>
                 </a:solidFill>
               </a:rPr>
-              <a:t>B5.1</a:t>
+              <a:t>B6.1</a:t>
             </a:r>
           </a:p>
         </p:txBody>
@@ -18978,7 +19454,7 @@
                   <a:srgbClr val="262626"/>
                 </a:solidFill>
               </a:rPr>
-              <a:t>Ensemble rejected by recall gate</a:t>
+              <a:t>Exact localization dataset</a:t>
             </a:r>
           </a:p>
         </p:txBody>
@@ -19035,7 +19511,7 @@
                   <a:srgbClr val="262626"/>
                 </a:solidFill>
               </a:rPr>
-              <a:t>90.47%</a:t>
+              <a:t>—</a:t>
             </a:r>
           </a:p>
         </p:txBody>
@@ -19092,7 +19568,7 @@
                   <a:srgbClr val="262626"/>
                 </a:solidFill>
               </a:rPr>
-              <a:t>0.912</a:t>
+              <a:t>—</a:t>
             </a:r>
           </a:p>
         </p:txBody>
@@ -19149,7 +19625,7 @@
                   <a:srgbClr val="262626"/>
                 </a:solidFill>
               </a:rPr>
-              <a:t>+0.003</a:t>
+              <a:t>—</a:t>
             </a:r>
           </a:p>
         </p:txBody>
@@ -19206,7 +19682,7 @@
                   <a:srgbClr val="73400D"/>
                 </a:solidFill>
               </a:rPr>
-              <a:t>B5.1 improved unseen F1, but tile recall fell 1.32 points. Keep B2; analyze failure slices before B6.</a:t>
+              <a:t>B2 remains accepted; B5.2 closed classifier-only tuning. B6.1 is complete, so U-Net training is next.</a:t>
             </a:r>
           </a:p>
         </p:txBody>
@@ -19556,7 +20032,7 @@
           </p:nvPr>
         </p:nvPicPr>
         <p:blipFill rotWithShape="1">
-          <a:blip xmlns:r="http://schemas.openxmlformats.org/officeDocument/2006/relationships" xmlns:a="http://schemas.openxmlformats.org/drawingml/2006/main" r:embed="R99c62eebfff44191">
+          <a:blip xmlns:r="http://schemas.openxmlformats.org/officeDocument/2006/relationships" xmlns:a="http://schemas.openxmlformats.org/drawingml/2006/main" r:embed="Ra6949aee5ace43c1">
             <a:alphaModFix/>
           </a:blip>
           <a:srcRect xmlns:a="http://schemas.openxmlformats.org/drawingml/2006/main" l="0" t="0" r="0" b="0"/>
@@ -19584,7 +20060,7 @@
           <p:nvPr/>
         </p:nvPicPr>
         <p:blipFill rotWithShape="1">
-          <a:blip xmlns:r="http://schemas.openxmlformats.org/officeDocument/2006/relationships" xmlns:a="http://schemas.openxmlformats.org/drawingml/2006/main" r:embed="R17164eb216fc4e76">
+          <a:blip xmlns:r="http://schemas.openxmlformats.org/officeDocument/2006/relationships" xmlns:a="http://schemas.openxmlformats.org/drawingml/2006/main" r:embed="R2e5ed662fe4d468e">
             <a:alphaModFix/>
           </a:blip>
           <a:srcRect xmlns:a="http://schemas.openxmlformats.org/drawingml/2006/main" l="0" t="0" r="0" b="0"/>
@@ -24795,7 +25271,7 @@
               <a:buNone/>
             </a:pPr>
             <a:r>
-              <a:t>B5.1: ensemble passes validation gate</a:t>
+              <a:t>B4: compact model failed confirmation</a:t>
             </a:r>
           </a:p>
         </p:txBody>
@@ -24841,7 +25317,7 @@
               <a:buChar char="●"/>
             </a:pPr>
             <a:r>
-              <a:t>Selected F1: 93.87%</a:t>
+              <a:t>Validation F1: 93.61%</a:t>
             </a:r>
           </a:p>
           <a:p xmlns:a="http://schemas.openxmlformats.org/drawingml/2006/main">
@@ -24855,7 +25331,7 @@
               <a:buChar char="●"/>
             </a:pPr>
             <a:r>
-              <a:t>Selected recall: 92.21%</a:t>
+              <a:t>14.3× fewer parameters</a:t>
             </a:r>
           </a:p>
           <a:p xmlns:a="http://schemas.openxmlformats.org/drawingml/2006/main">
@@ -24869,7 +25345,7 @@
               <a:buChar char="●"/>
             </a:pPr>
             <a:r>
-              <a:t>All three seeds beat B4 F1</a:t>
+              <a:t>ONNX: 172 KB vs. 2.41 MB</a:t>
             </a:r>
           </a:p>
           <a:p xmlns:a="http://schemas.openxmlformats.org/drawingml/2006/main">
@@ -24883,7 +25359,7 @@
               <a:buChar char="●"/>
             </a:pPr>
             <a:r>
-              <a:t>Frozen tests unlocked</a:t>
+              <a:t>Validation gate passed</a:t>
             </a:r>
           </a:p>
         </p:txBody>
@@ -24929,7 +25405,7 @@
               <a:buChar char="●"/>
             </a:pPr>
             <a:r>
-              <a:t>Blend: 25% B2 / 75% B4</a:t>
+              <a:t>Unseen accuracy: 89.36%</a:t>
             </a:r>
           </a:p>
           <a:p xmlns:a="http://schemas.openxmlformats.org/drawingml/2006/main">
@@ -24943,7 +25419,7 @@
               <a:buChar char="●"/>
             </a:pPr>
             <a:r>
-              <a:t>B4-only correct: 110</a:t>
+              <a:t>Unseen F1: 90.36%</a:t>
             </a:r>
           </a:p>
           <a:p xmlns:a="http://schemas.openxmlformats.org/drawingml/2006/main">
@@ -24957,7 +25433,7 @@
               <a:buChar char="●"/>
             </a:pPr>
             <a:r>
-              <a:t>B2-only correct: 68</a:t>
+              <a:t>Tile recall: 91.36%</a:t>
             </a:r>
           </a:p>
           <a:p xmlns:a="http://schemas.openxmlformats.org/drawingml/2006/main">
@@ -24971,7 +25447,7 @@
               <a:buChar char="●"/>
             </a:pPr>
             <a:r>
-              <a:t>Selection used validation only</a:t>
+              <a:t>Reject B4; retain B2</a:t>
             </a:r>
           </a:p>
         </p:txBody>
@@ -25039,7 +25515,7 @@
               <a:buNone/>
             </a:pPr>
             <a:r>
-              <a:t>B5.1: gains, but recall gate fails</a:t>
+              <a:t>B5.1: ensemble passes validation gate</a:t>
             </a:r>
           </a:p>
         </p:txBody>
@@ -25085,7 +25561,7 @@
               <a:buChar char="●"/>
             </a:pPr>
             <a:r>
-              <a:t>Unseen accuracy: 90.38% → 90.47%</a:t>
+              <a:t>Selected F1: 93.87%</a:t>
             </a:r>
           </a:p>
           <a:p xmlns:a="http://schemas.openxmlformats.org/drawingml/2006/main">
@@ -25099,7 +25575,7 @@
               <a:buChar char="●"/>
             </a:pPr>
             <a:r>
-              <a:t>Unseen F1: 90.94% → 91.25%</a:t>
+              <a:t>Selected recall: 92.21%</a:t>
             </a:r>
           </a:p>
           <a:p xmlns:a="http://schemas.openxmlformats.org/drawingml/2006/main">
@@ -25113,7 +25589,7 @@
               <a:buChar char="●"/>
             </a:pPr>
             <a:r>
-              <a:t>Unseen recall: 90.73% → 93.39%</a:t>
+              <a:t>All three seeds beat B4 F1</a:t>
             </a:r>
           </a:p>
           <a:p xmlns:a="http://schemas.openxmlformats.org/drawingml/2006/main">
@@ -25127,7 +25603,7 @@
               <a:buChar char="●"/>
             </a:pPr>
             <a:r>
-              <a:t>Unseen gate passed</a:t>
+              <a:t>Frozen tests unlocked</a:t>
             </a:r>
           </a:p>
         </p:txBody>
@@ -25173,7 +25649,7 @@
               <a:buChar char="●"/>
             </a:pPr>
             <a:r>
-              <a:t>Tile accuracy: 92.47% → 94.70%</a:t>
+              <a:t>Blend: 25% B2 / 75% B4</a:t>
             </a:r>
           </a:p>
           <a:p xmlns:a="http://schemas.openxmlformats.org/drawingml/2006/main">
@@ -25187,7 +25663,7 @@
               <a:buChar char="●"/>
             </a:pPr>
             <a:r>
-              <a:t>Tile F1: 91.89% → 94.08%</a:t>
+              <a:t>B4-only correct: 110</a:t>
             </a:r>
           </a:p>
           <a:p xmlns:a="http://schemas.openxmlformats.org/drawingml/2006/main">
@@ -25201,7 +25677,7 @@
               <a:buChar char="●"/>
             </a:pPr>
             <a:r>
-              <a:t>Tile recall: 93.39% → 92.07%</a:t>
+              <a:t>B2-only correct: 68</a:t>
             </a:r>
           </a:p>
           <a:p xmlns:a="http://schemas.openxmlformats.org/drawingml/2006/main">
@@ -25215,7 +25691,7 @@
               <a:buChar char="●"/>
             </a:pPr>
             <a:r>
-              <a:t>Reject ensemble; keep B2</a:t>
+              <a:t>Selection used validation only</a:t>
             </a:r>
           </a:p>
         </p:txBody>
@@ -25224,6 +25700,1074 @@
     <p:extLst>
       <p:ext uri="{BB962C8B-B14F-4D97-AF65-F5344CB8AC3E}">
         <p14:creationId xmlns:p14="http://schemas.microsoft.com/office/powerpoint/2010/main" val="463416430"/>
+      </p:ext>
+    </p:extLst>
+  </p:cSld>
+</p:sld>
+</file>
+
+<file path=ppt/slides/slide25.xml><?xml version="1.0" encoding="utf-8"?>
+<p:sld xmlns:p="http://schemas.openxmlformats.org/presentationml/2006/main">
+  <p:cSld>
+    <p:spTree>
+      <p:nvGrpSpPr>
+        <p:cNvPr id="1" name=""/>
+        <p:cNvGrpSpPr/>
+        <p:nvPr/>
+      </p:nvGrpSpPr>
+      <p:grpSpPr>
+        <a:xfrm xmlns:a="http://schemas.openxmlformats.org/drawingml/2006/main"/>
+      </p:grpSpPr>
+      <p:sp>
+        <p:nvSpPr>
+          <p:cNvPr id="212" name="Google Shape;212;p23">
+            <a:extLst xmlns:a="http://schemas.openxmlformats.org/drawingml/2006/main">
+              <a:ext uri="{FF2B5EF4-FFF2-40B4-BE49-F238E27FC236}">
+                <a16:creationId xmlns:a16="http://schemas.microsoft.com/office/drawing/2014/main" id="{CEA2EDDF-A2CD-44CF-98BB-801657D2DD0E}"/>
+              </a:ext>
+            </a:extLst>
+          </p:cNvPr>
+          <p:cNvSpPr>
+            <a:spLocks xmlns:a="http://schemas.openxmlformats.org/drawingml/2006/main" noGrp="1"/>
+          </p:cNvSpPr>
+          <p:nvPr>
+            <p:ph type="title" idx="0"/>
+          </p:nvPr>
+        </p:nvSpPr>
+        <p:spPr>
+          <a:xfrm xmlns:a="http://schemas.openxmlformats.org/drawingml/2006/main">
+            <a:off x="838200" y="365125"/>
+            <a:ext cx="10515600" cy="1325700"/>
+          </a:xfrm>
+          <a:prstGeom xmlns:a="http://schemas.openxmlformats.org/drawingml/2006/main" prst="rect">
+            <a:avLst/>
+          </a:prstGeom>
+        </p:spPr>
+        <p:txBody>
+          <a:bodyPr xmlns:a="http://schemas.openxmlformats.org/drawingml/2006/main" spcFirstLastPara="1" wrap="square" lIns="91425" tIns="45700" rIns="91425" bIns="45700" anchor="ctr">
+            <a:noAutofit/>
+          </a:bodyPr>
+          <a:lstStyle xmlns:a="http://schemas.openxmlformats.org/drawingml/2006/main"/>
+          <a:p xmlns:a="http://schemas.openxmlformats.org/drawingml/2006/main">
+            <a:pPr marL="0" indent="0" algn="l">
+              <a:spcBef>
+                <a:spcPts val="0"/>
+              </a:spcBef>
+              <a:spcAft>
+                <a:spcPts val="0"/>
+              </a:spcAft>
+              <a:buNone/>
+            </a:pPr>
+            <a:r>
+              <a:t>B5.1: gains, but recall gate fails</a:t>
+            </a:r>
+          </a:p>
+        </p:txBody>
+      </p:sp>
+      <p:sp>
+        <p:nvSpPr>
+          <p:cNvPr id="213" name="Google Shape;213;p23">
+            <a:extLst xmlns:a="http://schemas.openxmlformats.org/drawingml/2006/main">
+              <a:ext uri="{FF2B5EF4-FFF2-40B4-BE49-F238E27FC236}">
+                <a16:creationId xmlns:a16="http://schemas.microsoft.com/office/drawing/2014/main" id="{DF709342-A5A8-450D-BE61-4B8EA771B374}"/>
+              </a:ext>
+            </a:extLst>
+          </p:cNvPr>
+          <p:cNvSpPr>
+            <a:spLocks xmlns:a="http://schemas.openxmlformats.org/drawingml/2006/main" noGrp="1"/>
+          </p:cNvSpPr>
+          <p:nvPr>
+            <p:ph type="body" idx="1"/>
+          </p:nvPr>
+        </p:nvSpPr>
+        <p:spPr>
+          <a:xfrm xmlns:a="http://schemas.openxmlformats.org/drawingml/2006/main">
+            <a:off x="838200" y="1825625"/>
+            <a:ext cx="5181600" cy="4351200"/>
+          </a:xfrm>
+          <a:prstGeom xmlns:a="http://schemas.openxmlformats.org/drawingml/2006/main" prst="rect">
+            <a:avLst/>
+          </a:prstGeom>
+        </p:spPr>
+        <p:txBody>
+          <a:bodyPr xmlns:a="http://schemas.openxmlformats.org/drawingml/2006/main" spcFirstLastPara="1" wrap="square" lIns="91425" tIns="45700" rIns="91425" bIns="45700" anchor="t">
+            <a:noAutofit/>
+          </a:bodyPr>
+          <a:lstStyle xmlns:a="http://schemas.openxmlformats.org/drawingml/2006/main"/>
+          <a:p xmlns:a="http://schemas.openxmlformats.org/drawingml/2006/main">
+            <a:pPr marL="457200" indent="-342900" algn="l">
+              <a:spcBef>
+                <a:spcPts val="1000"/>
+              </a:spcBef>
+              <a:spcAft>
+                <a:spcPts val="0"/>
+              </a:spcAft>
+              <a:buChar char="●"/>
+            </a:pPr>
+            <a:r>
+              <a:t>Unseen accuracy: 90.38% → 90.47%</a:t>
+            </a:r>
+          </a:p>
+          <a:p xmlns:a="http://schemas.openxmlformats.org/drawingml/2006/main">
+            <a:pPr marL="457200" indent="-342900" algn="l">
+              <a:spcBef>
+                <a:spcPts val="0"/>
+              </a:spcBef>
+              <a:spcAft>
+                <a:spcPts val="0"/>
+              </a:spcAft>
+              <a:buChar char="●"/>
+            </a:pPr>
+            <a:r>
+              <a:t>Unseen F1: 90.94% → 91.25%</a:t>
+            </a:r>
+          </a:p>
+          <a:p xmlns:a="http://schemas.openxmlformats.org/drawingml/2006/main">
+            <a:pPr marL="457200" indent="-342900" algn="l">
+              <a:spcBef>
+                <a:spcPts val="0"/>
+              </a:spcBef>
+              <a:spcAft>
+                <a:spcPts val="0"/>
+              </a:spcAft>
+              <a:buChar char="●"/>
+            </a:pPr>
+            <a:r>
+              <a:t>Unseen recall: 90.73% → 93.39%</a:t>
+            </a:r>
+          </a:p>
+          <a:p xmlns:a="http://schemas.openxmlformats.org/drawingml/2006/main">
+            <a:pPr marL="457200" indent="-342900" algn="l">
+              <a:spcBef>
+                <a:spcPts val="0"/>
+              </a:spcBef>
+              <a:spcAft>
+                <a:spcPts val="0"/>
+              </a:spcAft>
+              <a:buChar char="●"/>
+            </a:pPr>
+            <a:r>
+              <a:t>Unseen gate passed</a:t>
+            </a:r>
+          </a:p>
+        </p:txBody>
+      </p:sp>
+      <p:sp>
+        <p:nvSpPr>
+          <p:cNvPr id="214" name="Google Shape;214;p23">
+            <a:extLst xmlns:a="http://schemas.openxmlformats.org/drawingml/2006/main">
+              <a:ext uri="{FF2B5EF4-FFF2-40B4-BE49-F238E27FC236}">
+                <a16:creationId xmlns:a16="http://schemas.microsoft.com/office/drawing/2014/main" id="{391DC8AD-B282-472F-BADA-EE209EE8D6C2}"/>
+              </a:ext>
+            </a:extLst>
+          </p:cNvPr>
+          <p:cNvSpPr>
+            <a:spLocks xmlns:a="http://schemas.openxmlformats.org/drawingml/2006/main" noGrp="1"/>
+          </p:cNvSpPr>
+          <p:nvPr>
+            <p:ph type="body" idx="2"/>
+          </p:nvPr>
+        </p:nvSpPr>
+        <p:spPr>
+          <a:xfrm xmlns:a="http://schemas.openxmlformats.org/drawingml/2006/main">
+            <a:off x="6172200" y="1825625"/>
+            <a:ext cx="5181600" cy="4351200"/>
+          </a:xfrm>
+          <a:prstGeom xmlns:a="http://schemas.openxmlformats.org/drawingml/2006/main" prst="rect">
+            <a:avLst/>
+          </a:prstGeom>
+        </p:spPr>
+        <p:txBody>
+          <a:bodyPr xmlns:a="http://schemas.openxmlformats.org/drawingml/2006/main" spcFirstLastPara="1" wrap="square" lIns="91425" tIns="45700" rIns="91425" bIns="45700" anchor="t">
+            <a:noAutofit/>
+          </a:bodyPr>
+          <a:lstStyle xmlns:a="http://schemas.openxmlformats.org/drawingml/2006/main"/>
+          <a:p xmlns:a="http://schemas.openxmlformats.org/drawingml/2006/main">
+            <a:pPr marL="457200" indent="-342900" algn="l">
+              <a:spcBef>
+                <a:spcPts val="1000"/>
+              </a:spcBef>
+              <a:spcAft>
+                <a:spcPts val="0"/>
+              </a:spcAft>
+              <a:buChar char="●"/>
+            </a:pPr>
+            <a:r>
+              <a:t>Tile accuracy: 92.47% → 94.70%</a:t>
+            </a:r>
+          </a:p>
+          <a:p xmlns:a="http://schemas.openxmlformats.org/drawingml/2006/main">
+            <a:pPr marL="457200" indent="-342900" algn="l">
+              <a:spcBef>
+                <a:spcPts val="0"/>
+              </a:spcBef>
+              <a:spcAft>
+                <a:spcPts val="0"/>
+              </a:spcAft>
+              <a:buChar char="●"/>
+            </a:pPr>
+            <a:r>
+              <a:t>Tile F1: 91.89% → 94.08%</a:t>
+            </a:r>
+          </a:p>
+          <a:p xmlns:a="http://schemas.openxmlformats.org/drawingml/2006/main">
+            <a:pPr marL="457200" indent="-342900" algn="l">
+              <a:spcBef>
+                <a:spcPts val="0"/>
+              </a:spcBef>
+              <a:spcAft>
+                <a:spcPts val="0"/>
+              </a:spcAft>
+              <a:buChar char="●"/>
+            </a:pPr>
+            <a:r>
+              <a:t>Tile recall: 93.39% → 92.07%</a:t>
+            </a:r>
+          </a:p>
+          <a:p xmlns:a="http://schemas.openxmlformats.org/drawingml/2006/main">
+            <a:pPr marL="457200" indent="-342900" algn="l">
+              <a:spcBef>
+                <a:spcPts val="0"/>
+              </a:spcBef>
+              <a:spcAft>
+                <a:spcPts val="0"/>
+              </a:spcAft>
+              <a:buChar char="●"/>
+            </a:pPr>
+            <a:r>
+              <a:t>Reject ensemble; keep B2</a:t>
+            </a:r>
+          </a:p>
+        </p:txBody>
+      </p:sp>
+    </p:spTree>
+    <p:extLst>
+      <p:ext uri="{BB962C8B-B14F-4D97-AF65-F5344CB8AC3E}">
+        <p14:creationId xmlns:p14="http://schemas.microsoft.com/office/powerpoint/2010/main" val="463416430"/>
+      </p:ext>
+    </p:extLst>
+  </p:cSld>
+</p:sld>
+</file>
+
+<file path=ppt/slides/slide26.xml><?xml version="1.0" encoding="utf-8"?>
+<p:sld xmlns:p="http://schemas.openxmlformats.org/presentationml/2006/main">
+  <p:cSld>
+    <p:spTree>
+      <p:nvGrpSpPr>
+        <p:cNvPr id="1" name=""/>
+        <p:cNvGrpSpPr/>
+        <p:nvPr/>
+      </p:nvGrpSpPr>
+      <p:grpSpPr>
+        <a:xfrm xmlns:a="http://schemas.openxmlformats.org/drawingml/2006/main"/>
+      </p:grpSpPr>
+      <p:sp>
+        <p:nvSpPr>
+          <p:cNvPr id="212" name="Google Shape;212;p23">
+            <a:extLst xmlns:a="http://schemas.openxmlformats.org/drawingml/2006/main">
+              <a:ext uri="{FF2B5EF4-FFF2-40B4-BE49-F238E27FC236}">
+                <a16:creationId xmlns:a16="http://schemas.microsoft.com/office/drawing/2014/main" id="{CEA2EDDF-A2CD-44CF-98BB-801657D2DD0E}"/>
+              </a:ext>
+            </a:extLst>
+          </p:cNvPr>
+          <p:cNvSpPr>
+            <a:spLocks xmlns:a="http://schemas.openxmlformats.org/drawingml/2006/main" noGrp="1"/>
+          </p:cNvSpPr>
+          <p:nvPr>
+            <p:ph type="title" idx="0"/>
+          </p:nvPr>
+        </p:nvSpPr>
+        <p:spPr>
+          <a:xfrm xmlns:a="http://schemas.openxmlformats.org/drawingml/2006/main">
+            <a:off x="838200" y="365125"/>
+            <a:ext cx="10515600" cy="1325700"/>
+          </a:xfrm>
+          <a:prstGeom xmlns:a="http://schemas.openxmlformats.org/drawingml/2006/main" prst="rect">
+            <a:avLst/>
+          </a:prstGeom>
+        </p:spPr>
+        <p:txBody>
+          <a:bodyPr xmlns:a="http://schemas.openxmlformats.org/drawingml/2006/main" spcFirstLastPara="1" wrap="square" lIns="91425" tIns="45700" rIns="91425" bIns="45700" anchor="ctr">
+            <a:noAutofit/>
+          </a:bodyPr>
+          <a:lstStyle xmlns:a="http://schemas.openxmlformats.org/drawingml/2006/main"/>
+          <a:p xmlns:a="http://schemas.openxmlformats.org/drawingml/2006/main">
+            <a:pPr marL="0" indent="0" algn="l">
+              <a:spcBef>
+                <a:spcPts val="0"/>
+              </a:spcBef>
+              <a:spcAft>
+                <a:spcPts val="0"/>
+              </a:spcAft>
+              <a:buNone/>
+            </a:pPr>
+            <a:r>
+              <a:t>B5.2: audit closes classifier-only tuning</a:t>
+            </a:r>
+          </a:p>
+        </p:txBody>
+      </p:sp>
+      <p:sp>
+        <p:nvSpPr>
+          <p:cNvPr id="213" name="Google Shape;213;p23">
+            <a:extLst xmlns:a="http://schemas.openxmlformats.org/drawingml/2006/main">
+              <a:ext uri="{FF2B5EF4-FFF2-40B4-BE49-F238E27FC236}">
+                <a16:creationId xmlns:a16="http://schemas.microsoft.com/office/drawing/2014/main" id="{DF709342-A5A8-450D-BE61-4B8EA771B374}"/>
+              </a:ext>
+            </a:extLst>
+          </p:cNvPr>
+          <p:cNvSpPr>
+            <a:spLocks xmlns:a="http://schemas.openxmlformats.org/drawingml/2006/main" noGrp="1"/>
+          </p:cNvSpPr>
+          <p:nvPr>
+            <p:ph type="body" idx="1"/>
+          </p:nvPr>
+        </p:nvSpPr>
+        <p:spPr>
+          <a:xfrm xmlns:a="http://schemas.openxmlformats.org/drawingml/2006/main">
+            <a:off x="838200" y="1825625"/>
+            <a:ext cx="5181600" cy="4351200"/>
+          </a:xfrm>
+          <a:prstGeom xmlns:a="http://schemas.openxmlformats.org/drawingml/2006/main" prst="rect">
+            <a:avLst/>
+          </a:prstGeom>
+        </p:spPr>
+        <p:txBody>
+          <a:bodyPr xmlns:a="http://schemas.openxmlformats.org/drawingml/2006/main" spcFirstLastPara="1" wrap="square" lIns="91425" tIns="45700" rIns="91425" bIns="45700" anchor="t">
+            <a:noAutofit/>
+          </a:bodyPr>
+          <a:lstStyle xmlns:a="http://schemas.openxmlformats.org/drawingml/2006/main"/>
+          <a:p xmlns:a="http://schemas.openxmlformats.org/drawingml/2006/main">
+            <a:pPr marL="457200" indent="-342900" algn="l">
+              <a:spcBef>
+                <a:spcPts val="1000"/>
+              </a:spcBef>
+              <a:spcAft>
+                <a:spcPts val="0"/>
+              </a:spcAft>
+              <a:buChar char="●"/>
+            </a:pPr>
+            <a:r>
+              <a:t>B4 led unseen validation in every seed</a:t>
+            </a:r>
+          </a:p>
+          <a:p xmlns:a="http://schemas.openxmlformats.org/drawingml/2006/main">
+            <a:pPr marL="457200" indent="-342900" algn="l">
+              <a:spcBef>
+                <a:spcPts val="0"/>
+              </a:spcBef>
+              <a:spcAft>
+                <a:spcPts val="0"/>
+              </a:spcAft>
+              <a:buChar char="●"/>
+            </a:pPr>
+            <a:r>
+              <a:t>B2 dirty advantage: tile-random only</a:t>
+            </a:r>
+          </a:p>
+          <a:p xmlns:a="http://schemas.openxmlformats.org/drawingml/2006/main">
+            <a:pPr marL="457200" indent="-342900" algn="l">
+              <a:spcBef>
+                <a:spcPts val="0"/>
+              </a:spcBef>
+              <a:spcAft>
+                <a:spcPts val="0"/>
+              </a:spcAft>
+              <a:buChar char="●"/>
+            </a:pPr>
+            <a:r>
+              <a:t>Joint disagreement gate failed</a:t>
+            </a:r>
+          </a:p>
+          <a:p xmlns:a="http://schemas.openxmlformats.org/drawingml/2006/main">
+            <a:pPr marL="457200" indent="-342900" algn="l">
+              <a:spcBef>
+                <a:spcPts val="0"/>
+              </a:spcBef>
+              <a:spcAft>
+                <a:spcPts val="0"/>
+              </a:spcAft>
+              <a:buChar char="●"/>
+            </a:pPr>
+            <a:r>
+              <a:t>No stable ensemble mechanism</a:t>
+            </a:r>
+          </a:p>
+        </p:txBody>
+      </p:sp>
+      <p:sp>
+        <p:nvSpPr>
+          <p:cNvPr id="214" name="Google Shape;214;p23">
+            <a:extLst xmlns:a="http://schemas.openxmlformats.org/drawingml/2006/main">
+              <a:ext uri="{FF2B5EF4-FFF2-40B4-BE49-F238E27FC236}">
+                <a16:creationId xmlns:a16="http://schemas.microsoft.com/office/drawing/2014/main" id="{391DC8AD-B282-472F-BADA-EE209EE8D6C2}"/>
+              </a:ext>
+            </a:extLst>
+          </p:cNvPr>
+          <p:cNvSpPr>
+            <a:spLocks xmlns:a="http://schemas.openxmlformats.org/drawingml/2006/main" noGrp="1"/>
+          </p:cNvSpPr>
+          <p:nvPr>
+            <p:ph type="body" idx="2"/>
+          </p:nvPr>
+        </p:nvSpPr>
+        <p:spPr>
+          <a:xfrm xmlns:a="http://schemas.openxmlformats.org/drawingml/2006/main">
+            <a:off x="6172200" y="1825625"/>
+            <a:ext cx="5181600" cy="4351200"/>
+          </a:xfrm>
+          <a:prstGeom xmlns:a="http://schemas.openxmlformats.org/drawingml/2006/main" prst="rect">
+            <a:avLst/>
+          </a:prstGeom>
+        </p:spPr>
+        <p:txBody>
+          <a:bodyPr xmlns:a="http://schemas.openxmlformats.org/drawingml/2006/main" spcFirstLastPara="1" wrap="square" lIns="91425" tIns="45700" rIns="91425" bIns="45700" anchor="t">
+            <a:noAutofit/>
+          </a:bodyPr>
+          <a:lstStyle xmlns:a="http://schemas.openxmlformats.org/drawingml/2006/main"/>
+          <a:p xmlns:a="http://schemas.openxmlformats.org/drawingml/2006/main">
+            <a:pPr marL="457200" indent="-342900" algn="l">
+              <a:spcBef>
+                <a:spcPts val="1000"/>
+              </a:spcBef>
+              <a:spcAft>
+                <a:spcPts val="0"/>
+              </a:spcAft>
+              <a:buChar char="●"/>
+            </a:pPr>
+            <a:r>
+              <a:t>10 replicated density slices</a:t>
+            </a:r>
+          </a:p>
+          <a:p xmlns:a="http://schemas.openxmlformats.org/drawingml/2006/main">
+            <a:pPr marL="457200" indent="-342900" algn="l">
+              <a:spcBef>
+                <a:spcPts val="0"/>
+              </a:spcBef>
+              <a:spcAft>
+                <a:spcPts val="0"/>
+              </a:spcAft>
+              <a:buChar char="●"/>
+            </a:pPr>
+            <a:r>
+              <a:t>All were clean-sample effects</a:t>
+            </a:r>
+          </a:p>
+          <a:p xmlns:a="http://schemas.openxmlformats.org/drawingml/2006/main">
+            <a:pPr marL="457200" indent="-342900" algn="l">
+              <a:spcBef>
+                <a:spcPts val="0"/>
+              </a:spcBef>
+              <a:spcAft>
+                <a:spcPts val="0"/>
+              </a:spcAft>
+              <a:buChar char="●"/>
+            </a:pPr>
+            <a:r>
+              <a:t>Density bin changed by protocol</a:t>
+            </a:r>
+          </a:p>
+          <a:p xmlns:a="http://schemas.openxmlformats.org/drawingml/2006/main">
+            <a:pPr marL="457200" indent="-342900" algn="l">
+              <a:spcBef>
+                <a:spcPts val="0"/>
+              </a:spcBef>
+              <a:spcAft>
+                <a:spcPts val="0"/>
+              </a:spcAft>
+              <a:buChar char="●"/>
+            </a:pPr>
+            <a:r>
+              <a:t>No B5.3; retain B2</a:t>
+            </a:r>
+          </a:p>
+        </p:txBody>
+      </p:sp>
+    </p:spTree>
+    <p:extLst>
+      <p:ext uri="{BB962C8B-B14F-4D97-AF65-F5344CB8AC3E}">
+        <p14:creationId xmlns:p14="http://schemas.microsoft.com/office/powerpoint/2010/main" val="463416430"/>
+      </p:ext>
+    </p:extLst>
+  </p:cSld>
+</p:sld>
+</file>
+
+<file path=ppt/slides/slide27.xml><?xml version="1.0" encoding="utf-8"?>
+<p:sld xmlns:p="http://schemas.openxmlformats.org/presentationml/2006/main">
+  <p:cSld>
+    <p:spTree>
+      <p:nvGrpSpPr>
+        <p:cNvPr id="1" name=""/>
+        <p:cNvGrpSpPr/>
+        <p:nvPr/>
+      </p:nvGrpSpPr>
+      <p:grpSpPr>
+        <a:xfrm xmlns:a="http://schemas.openxmlformats.org/drawingml/2006/main"/>
+      </p:grpSpPr>
+      <p:sp>
+        <p:nvSpPr>
+          <p:cNvPr id="212" name="Google Shape;212;p23">
+            <a:extLst xmlns:a="http://schemas.openxmlformats.org/drawingml/2006/main">
+              <a:ext uri="{FF2B5EF4-FFF2-40B4-BE49-F238E27FC236}">
+                <a16:creationId xmlns:a16="http://schemas.microsoft.com/office/drawing/2014/main" id="{CEA2EDDF-A2CD-44CF-98BB-801657D2DD0E}"/>
+              </a:ext>
+            </a:extLst>
+          </p:cNvPr>
+          <p:cNvSpPr>
+            <a:spLocks xmlns:a="http://schemas.openxmlformats.org/drawingml/2006/main" noGrp="1"/>
+          </p:cNvSpPr>
+          <p:nvPr>
+            <p:ph type="title" idx="0"/>
+          </p:nvPr>
+        </p:nvSpPr>
+        <p:spPr>
+          <a:xfrm xmlns:a="http://schemas.openxmlformats.org/drawingml/2006/main">
+            <a:off x="838200" y="365125"/>
+            <a:ext cx="10515600" cy="1325700"/>
+          </a:xfrm>
+          <a:prstGeom xmlns:a="http://schemas.openxmlformats.org/drawingml/2006/main" prst="rect">
+            <a:avLst/>
+          </a:prstGeom>
+        </p:spPr>
+        <p:txBody>
+          <a:bodyPr xmlns:a="http://schemas.openxmlformats.org/drawingml/2006/main" spcFirstLastPara="1" wrap="square" lIns="91425" tIns="45700" rIns="91425" bIns="45700" anchor="ctr">
+            <a:noAutofit/>
+          </a:bodyPr>
+          <a:lstStyle xmlns:a="http://schemas.openxmlformats.org/drawingml/2006/main"/>
+          <a:p xmlns:a="http://schemas.openxmlformats.org/drawingml/2006/main">
+            <a:pPr marL="0" indent="0" algn="l">
+              <a:spcBef>
+                <a:spcPts val="0"/>
+              </a:spcBef>
+              <a:spcAft>
+                <a:spcPts val="0"/>
+              </a:spcAft>
+              <a:buNone/>
+            </a:pPr>
+            <a:r>
+              <a:t>B6.1: exact localization data is ready</a:t>
+            </a:r>
+          </a:p>
+        </p:txBody>
+      </p:sp>
+      <p:sp>
+        <p:nvSpPr>
+          <p:cNvPr id="213" name="Google Shape;213;p23">
+            <a:extLst xmlns:a="http://schemas.openxmlformats.org/drawingml/2006/main">
+              <a:ext uri="{FF2B5EF4-FFF2-40B4-BE49-F238E27FC236}">
+                <a16:creationId xmlns:a16="http://schemas.microsoft.com/office/drawing/2014/main" id="{DF709342-A5A8-450D-BE61-4B8EA771B374}"/>
+              </a:ext>
+            </a:extLst>
+          </p:cNvPr>
+          <p:cNvSpPr>
+            <a:spLocks xmlns:a="http://schemas.openxmlformats.org/drawingml/2006/main" noGrp="1"/>
+          </p:cNvSpPr>
+          <p:nvPr>
+            <p:ph type="body" idx="1"/>
+          </p:nvPr>
+        </p:nvSpPr>
+        <p:spPr>
+          <a:xfrm xmlns:a="http://schemas.openxmlformats.org/drawingml/2006/main">
+            <a:off x="838200" y="1825625"/>
+            <a:ext cx="5181600" cy="4351200"/>
+          </a:xfrm>
+          <a:prstGeom xmlns:a="http://schemas.openxmlformats.org/drawingml/2006/main" prst="rect">
+            <a:avLst/>
+          </a:prstGeom>
+        </p:spPr>
+        <p:txBody>
+          <a:bodyPr xmlns:a="http://schemas.openxmlformats.org/drawingml/2006/main" spcFirstLastPara="1" wrap="square" lIns="91425" tIns="45700" rIns="91425" bIns="45700" anchor="t">
+            <a:noAutofit/>
+          </a:bodyPr>
+          <a:lstStyle xmlns:a="http://schemas.openxmlformats.org/drawingml/2006/main"/>
+          <a:p xmlns:a="http://schemas.openxmlformats.org/drawingml/2006/main">
+            <a:pPr marL="457200" indent="-342900" algn="l">
+              <a:spcBef>
+                <a:spcPts val="1000"/>
+              </a:spcBef>
+              <a:spcAft>
+                <a:spcPts val="0"/>
+              </a:spcAft>
+              <a:buChar char="●"/>
+            </a:pPr>
+            <a:r>
+              <a:t>14 layout families</a:t>
+            </a:r>
+          </a:p>
+          <a:p xmlns:a="http://schemas.openxmlformats.org/drawingml/2006/main">
+            <a:pPr marL="457200" indent="-342900" algn="l">
+              <a:spcBef>
+                <a:spcPts val="0"/>
+              </a:spcBef>
+              <a:spcAft>
+                <a:spcPts val="0"/>
+              </a:spcAft>
+              <a:buChar char="●"/>
+            </a:pPr>
+            <a:r>
+              <a:t>6,924 exact KLayout violations</a:t>
+            </a:r>
+          </a:p>
+          <a:p xmlns:a="http://schemas.openxmlformats.org/drawingml/2006/main">
+            <a:pPr marL="457200" indent="-342900" algn="l">
+              <a:spcBef>
+                <a:spcPts val="0"/>
+              </a:spcBef>
+              <a:spcAft>
+                <a:spcPts val="0"/>
+              </a:spcAft>
+              <a:buChar char="●"/>
+            </a:pPr>
+            <a:r>
+              <a:t>6,924 unique owners</a:t>
+            </a:r>
+          </a:p>
+          <a:p xmlns:a="http://schemas.openxmlformats.org/drawingml/2006/main">
+            <a:pPr marL="457200" indent="-342900" algn="l">
+              <a:spcBef>
+                <a:spcPts val="0"/>
+              </a:spcBef>
+              <a:spcAft>
+                <a:spcPts val="0"/>
+              </a:spcAft>
+              <a:buChar char="●"/>
+            </a:pPr>
+            <a:r>
+              <a:t>8,021 dirty + 8,021 clean tiles</a:t>
+            </a:r>
+          </a:p>
+        </p:txBody>
+      </p:sp>
+      <p:sp>
+        <p:nvSpPr>
+          <p:cNvPr id="214" name="Google Shape;214;p23">
+            <a:extLst xmlns:a="http://schemas.openxmlformats.org/drawingml/2006/main">
+              <a:ext uri="{FF2B5EF4-FFF2-40B4-BE49-F238E27FC236}">
+                <a16:creationId xmlns:a16="http://schemas.microsoft.com/office/drawing/2014/main" id="{391DC8AD-B282-472F-BADA-EE209EE8D6C2}"/>
+              </a:ext>
+            </a:extLst>
+          </p:cNvPr>
+          <p:cNvSpPr>
+            <a:spLocks xmlns:a="http://schemas.openxmlformats.org/drawingml/2006/main" noGrp="1"/>
+          </p:cNvSpPr>
+          <p:nvPr>
+            <p:ph type="body" idx="2"/>
+          </p:nvPr>
+        </p:nvSpPr>
+        <p:spPr>
+          <a:xfrm xmlns:a="http://schemas.openxmlformats.org/drawingml/2006/main">
+            <a:off x="6172200" y="1825625"/>
+            <a:ext cx="5181600" cy="4351200"/>
+          </a:xfrm>
+          <a:prstGeom xmlns:a="http://schemas.openxmlformats.org/drawingml/2006/main" prst="rect">
+            <a:avLst/>
+          </a:prstGeom>
+        </p:spPr>
+        <p:txBody>
+          <a:bodyPr xmlns:a="http://schemas.openxmlformats.org/drawingml/2006/main" spcFirstLastPara="1" wrap="square" lIns="91425" tIns="45700" rIns="91425" bIns="45700" anchor="t">
+            <a:noAutofit/>
+          </a:bodyPr>
+          <a:lstStyle xmlns:a="http://schemas.openxmlformats.org/drawingml/2006/main"/>
+          <a:p xmlns:a="http://schemas.openxmlformats.org/drawingml/2006/main">
+            <a:pPr marL="457200" indent="-342900" algn="l">
+              <a:spcBef>
+                <a:spcPts val="1000"/>
+              </a:spcBef>
+              <a:spcAft>
+                <a:spcPts val="0"/>
+              </a:spcAft>
+              <a:buChar char="●"/>
+            </a:pPr>
+            <a:r>
+              <a:t>1600 nm input + 160 nm halo</a:t>
+            </a:r>
+          </a:p>
+          <a:p xmlns:a="http://schemas.openxmlformats.org/drawingml/2006/main">
+            <a:pPr marL="457200" indent="-342900" algn="l">
+              <a:spcBef>
+                <a:spcPts val="0"/>
+              </a:spcBef>
+              <a:spcAft>
+                <a:spcPts val="0"/>
+              </a:spcAft>
+              <a:buChar char="●"/>
+            </a:pPr>
+            <a:r>
+              <a:t>1280 nm gap-free owned output</a:t>
+            </a:r>
+          </a:p>
+          <a:p xmlns:a="http://schemas.openxmlformats.org/drawingml/2006/main">
+            <a:pPr marL="457200" indent="-342900" algn="l">
+              <a:spcBef>
+                <a:spcPts val="0"/>
+              </a:spcBef>
+              <a:spcAft>
+                <a:spcPts val="0"/>
+              </a:spcAft>
+              <a:buChar char="●"/>
+            </a:pPr>
+            <a:r>
+              <a:t>200×200 image + 160×160 mask</a:t>
+            </a:r>
+          </a:p>
+          <a:p xmlns:a="http://schemas.openxmlformats.org/drawingml/2006/main">
+            <a:pPr marL="457200" indent="-342900" algn="l">
+              <a:spcBef>
+                <a:spcPts val="0"/>
+              </a:spcBef>
+              <a:spcAft>
+                <a:spcPts val="0"/>
+              </a:spcAft>
+              <a:buChar char="●"/>
+            </a:pPr>
+            <a:r>
+              <a:t>All 7 visual-audit categories passed</a:t>
+            </a:r>
+          </a:p>
+        </p:txBody>
+      </p:sp>
+    </p:spTree>
+    <p:extLst>
+      <p:ext uri="{BB962C8B-B14F-4D97-AF65-F5344CB8AC3E}">
+        <p14:creationId xmlns:p14="http://schemas.microsoft.com/office/powerpoint/2010/main" val="463416430"/>
+      </p:ext>
+    </p:extLst>
+  </p:cSld>
+</p:sld>
+</file>
+
+<file path=ppt/slides/slide28.xml><?xml version="1.0" encoding="utf-8"?>
+<p:sld xmlns:p="http://schemas.openxmlformats.org/presentationml/2006/main">
+  <p:cSld>
+    <p:spTree>
+      <p:nvGrpSpPr>
+        <p:cNvPr id="1" name=""/>
+        <p:cNvGrpSpPr/>
+        <p:nvPr/>
+      </p:nvGrpSpPr>
+      <p:grpSpPr>
+        <a:xfrm xmlns:a="http://schemas.openxmlformats.org/drawingml/2006/main"/>
+      </p:grpSpPr>
+      <p:sp>
+        <p:nvSpPr>
+          <p:cNvPr id="202" name="Google Shape;202;p22">
+            <a:extLst xmlns:a="http://schemas.openxmlformats.org/drawingml/2006/main">
+              <a:ext uri="{FF2B5EF4-FFF2-40B4-BE49-F238E27FC236}">
+                <a16:creationId xmlns:a16="http://schemas.microsoft.com/office/drawing/2014/main" id="{C8118EBF-173B-493F-B181-80ED61AEAA88}"/>
+              </a:ext>
+            </a:extLst>
+          </p:cNvPr>
+          <p:cNvSpPr>
+            <a:spLocks xmlns:a="http://schemas.openxmlformats.org/drawingml/2006/main" noGrp="1"/>
+          </p:cNvSpPr>
+          <p:nvPr>
+            <p:ph type="title" idx="0"/>
+          </p:nvPr>
+        </p:nvSpPr>
+        <p:spPr>
+          <a:xfrm xmlns:a="http://schemas.openxmlformats.org/drawingml/2006/main">
+            <a:off x="839788" y="365125"/>
+            <a:ext cx="10515600" cy="1325700"/>
+          </a:xfrm>
+          <a:prstGeom xmlns:a="http://schemas.openxmlformats.org/drawingml/2006/main" prst="rect">
+            <a:avLst/>
+          </a:prstGeom>
+        </p:spPr>
+        <p:txBody>
+          <a:bodyPr xmlns:a="http://schemas.openxmlformats.org/drawingml/2006/main" spcFirstLastPara="1" wrap="square" lIns="91425" tIns="45700" rIns="91425" bIns="45700" anchor="ctr">
+            <a:noAutofit/>
+          </a:bodyPr>
+          <a:lstStyle xmlns:a="http://schemas.openxmlformats.org/drawingml/2006/main"/>
+          <a:p xmlns:a="http://schemas.openxmlformats.org/drawingml/2006/main">
+            <a:pPr marL="0" indent="0" algn="l">
+              <a:spcBef>
+                <a:spcPts val="0"/>
+              </a:spcBef>
+              <a:spcAft>
+                <a:spcPts val="0"/>
+              </a:spcAft>
+              <a:buNone/>
+            </a:pPr>
+            <a:r>
+              <a:t>B6.2: one U-Net, two supervised tasks</a:t>
+            </a:r>
+          </a:p>
+        </p:txBody>
+      </p:sp>
+      <p:sp>
+        <p:nvSpPr>
+          <p:cNvPr id="203" name="Google Shape;203;p22">
+            <a:extLst xmlns:a="http://schemas.openxmlformats.org/drawingml/2006/main">
+              <a:ext uri="{FF2B5EF4-FFF2-40B4-BE49-F238E27FC236}">
+                <a16:creationId xmlns:a16="http://schemas.microsoft.com/office/drawing/2014/main" id="{8C8967A8-AFDD-4A36-BD2A-6A37DA6F4631}"/>
+              </a:ext>
+            </a:extLst>
+          </p:cNvPr>
+          <p:cNvSpPr>
+            <a:spLocks xmlns:a="http://schemas.openxmlformats.org/drawingml/2006/main" noGrp="1"/>
+          </p:cNvSpPr>
+          <p:nvPr>
+            <p:ph type="body" idx="1"/>
+          </p:nvPr>
+        </p:nvSpPr>
+        <p:spPr>
+          <a:xfrm xmlns:a="http://schemas.openxmlformats.org/drawingml/2006/main">
+            <a:off x="839788" y="1681163"/>
+            <a:ext cx="5157900" cy="823800"/>
+          </a:xfrm>
+          <a:prstGeom xmlns:a="http://schemas.openxmlformats.org/drawingml/2006/main" prst="rect">
+            <a:avLst/>
+          </a:prstGeom>
+        </p:spPr>
+        <p:txBody>
+          <a:bodyPr xmlns:a="http://schemas.openxmlformats.org/drawingml/2006/main" spcFirstLastPara="1" wrap="square" lIns="91425" tIns="45700" rIns="91425" bIns="45700" anchor="b">
+            <a:noAutofit/>
+          </a:bodyPr>
+          <a:lstStyle xmlns:a="http://schemas.openxmlformats.org/drawingml/2006/main"/>
+          <a:p xmlns:a="http://schemas.openxmlformats.org/drawingml/2006/main">
+            <a:pPr marL="0" indent="0" algn="l">
+              <a:spcBef>
+                <a:spcPts val="1000"/>
+              </a:spcBef>
+              <a:spcAft>
+                <a:spcPts val="0"/>
+              </a:spcAft>
+              <a:buNone/>
+            </a:pPr>
+            <a:r>
+              <a:t>Encoder + classification head</a:t>
+            </a:r>
+          </a:p>
+        </p:txBody>
+      </p:sp>
+      <p:sp>
+        <p:nvSpPr>
+          <p:cNvPr id="204" name="Google Shape;204;p22">
+            <a:extLst xmlns:a="http://schemas.openxmlformats.org/drawingml/2006/main">
+              <a:ext uri="{FF2B5EF4-FFF2-40B4-BE49-F238E27FC236}">
+                <a16:creationId xmlns:a16="http://schemas.microsoft.com/office/drawing/2014/main" id="{19A9097E-C301-4B04-A28D-C7CF5D1666DA}"/>
+              </a:ext>
+            </a:extLst>
+          </p:cNvPr>
+          <p:cNvSpPr>
+            <a:spLocks xmlns:a="http://schemas.openxmlformats.org/drawingml/2006/main" noGrp="1"/>
+          </p:cNvSpPr>
+          <p:nvPr>
+            <p:ph type="body" idx="2"/>
+          </p:nvPr>
+        </p:nvSpPr>
+        <p:spPr>
+          <a:xfrm xmlns:a="http://schemas.openxmlformats.org/drawingml/2006/main">
+            <a:off x="839788" y="2505075"/>
+            <a:ext cx="5157900" cy="3684600"/>
+          </a:xfrm>
+          <a:prstGeom xmlns:a="http://schemas.openxmlformats.org/drawingml/2006/main" prst="rect">
+            <a:avLst/>
+          </a:prstGeom>
+        </p:spPr>
+        <p:txBody>
+          <a:bodyPr xmlns:a="http://schemas.openxmlformats.org/drawingml/2006/main" spcFirstLastPara="1" wrap="square" lIns="91425" tIns="45700" rIns="91425" bIns="45700" anchor="t">
+            <a:noAutofit/>
+          </a:bodyPr>
+          <a:lstStyle xmlns:a="http://schemas.openxmlformats.org/drawingml/2006/main"/>
+          <a:p xmlns:a="http://schemas.openxmlformats.org/drawingml/2006/main">
+            <a:pPr marL="457200" indent="-342900" algn="l">
+              <a:spcBef>
+                <a:spcPts val="1000"/>
+              </a:spcBef>
+              <a:spcAft>
+                <a:spcPts val="0"/>
+              </a:spcAft>
+              <a:buChar char="●"/>
+            </a:pPr>
+            <a:r>
+              <a:t>Shared encoder learns geometry</a:t>
+            </a:r>
+          </a:p>
+          <a:p xmlns:a="http://schemas.openxmlformats.org/drawingml/2006/main">
+            <a:pPr marL="457200" indent="-342900" algn="l">
+              <a:spcBef>
+                <a:spcPts val="0"/>
+              </a:spcBef>
+              <a:spcAft>
+                <a:spcPts val="0"/>
+              </a:spcAft>
+              <a:buChar char="●"/>
+            </a:pPr>
+            <a:r>
+              <a:t>Global head predicts clean / dirty</a:t>
+            </a:r>
+          </a:p>
+          <a:p xmlns:a="http://schemas.openxmlformats.org/drawingml/2006/main">
+            <a:pPr marL="457200" indent="-342900" algn="l">
+              <a:spcBef>
+                <a:spcPts val="0"/>
+              </a:spcBef>
+              <a:spcAft>
+                <a:spcPts val="0"/>
+              </a:spcAft>
+              <a:buChar char="●"/>
+            </a:pPr>
+            <a:r>
+              <a:t>Compare with accepted B2</a:t>
+            </a:r>
+          </a:p>
+          <a:p xmlns:a="http://schemas.openxmlformats.org/drawingml/2006/main">
+            <a:pPr marL="457200" indent="-342900" algn="l">
+              <a:spcBef>
+                <a:spcPts val="0"/>
+              </a:spcBef>
+              <a:spcAft>
+                <a:spcPts val="0"/>
+              </a:spcAft>
+              <a:buChar char="●"/>
+            </a:pPr>
+            <a:r>
+              <a:t>Reject if dirty recall regresses</a:t>
+            </a:r>
+          </a:p>
+        </p:txBody>
+      </p:sp>
+      <p:sp>
+        <p:nvSpPr>
+          <p:cNvPr id="205" name="Google Shape;205;p22">
+            <a:extLst xmlns:a="http://schemas.openxmlformats.org/drawingml/2006/main">
+              <a:ext uri="{FF2B5EF4-FFF2-40B4-BE49-F238E27FC236}">
+                <a16:creationId xmlns:a16="http://schemas.microsoft.com/office/drawing/2014/main" id="{1E0BEAE3-F26D-4391-B700-136E11ECA92F}"/>
+              </a:ext>
+            </a:extLst>
+          </p:cNvPr>
+          <p:cNvSpPr>
+            <a:spLocks xmlns:a="http://schemas.openxmlformats.org/drawingml/2006/main" noGrp="1"/>
+          </p:cNvSpPr>
+          <p:nvPr>
+            <p:ph type="body" idx="3"/>
+          </p:nvPr>
+        </p:nvSpPr>
+        <p:spPr>
+          <a:xfrm xmlns:a="http://schemas.openxmlformats.org/drawingml/2006/main">
+            <a:off x="6172200" y="1681163"/>
+            <a:ext cx="5183100" cy="823800"/>
+          </a:xfrm>
+          <a:prstGeom xmlns:a="http://schemas.openxmlformats.org/drawingml/2006/main" prst="rect">
+            <a:avLst/>
+          </a:prstGeom>
+        </p:spPr>
+        <p:txBody>
+          <a:bodyPr xmlns:a="http://schemas.openxmlformats.org/drawingml/2006/main" spcFirstLastPara="1" wrap="square" lIns="91425" tIns="45700" rIns="91425" bIns="45700" anchor="b">
+            <a:noAutofit/>
+          </a:bodyPr>
+          <a:lstStyle xmlns:a="http://schemas.openxmlformats.org/drawingml/2006/main"/>
+          <a:p xmlns:a="http://schemas.openxmlformats.org/drawingml/2006/main">
+            <a:pPr marL="0" indent="0" algn="l">
+              <a:spcBef>
+                <a:spcPts val="1000"/>
+              </a:spcBef>
+              <a:spcAft>
+                <a:spcPts val="0"/>
+              </a:spcAft>
+              <a:buNone/>
+            </a:pPr>
+            <a:r>
+              <a:t>Decoder + segmentation head</a:t>
+            </a:r>
+          </a:p>
+        </p:txBody>
+      </p:sp>
+      <p:sp>
+        <p:nvSpPr>
+          <p:cNvPr id="206" name="Google Shape;206;p22">
+            <a:extLst xmlns:a="http://schemas.openxmlformats.org/drawingml/2006/main">
+              <a:ext uri="{FF2B5EF4-FFF2-40B4-BE49-F238E27FC236}">
+                <a16:creationId xmlns:a16="http://schemas.microsoft.com/office/drawing/2014/main" id="{76F59418-2FDB-4369-B235-930A4716F3F6}"/>
+              </a:ext>
+            </a:extLst>
+          </p:cNvPr>
+          <p:cNvSpPr>
+            <a:spLocks xmlns:a="http://schemas.openxmlformats.org/drawingml/2006/main" noGrp="1"/>
+          </p:cNvSpPr>
+          <p:nvPr>
+            <p:ph type="body" idx="4"/>
+          </p:nvPr>
+        </p:nvSpPr>
+        <p:spPr>
+          <a:xfrm xmlns:a="http://schemas.openxmlformats.org/drawingml/2006/main">
+            <a:off x="6172200" y="2505075"/>
+            <a:ext cx="5183100" cy="3684600"/>
+          </a:xfrm>
+          <a:prstGeom xmlns:a="http://schemas.openxmlformats.org/drawingml/2006/main" prst="rect">
+            <a:avLst/>
+          </a:prstGeom>
+        </p:spPr>
+        <p:txBody>
+          <a:bodyPr xmlns:a="http://schemas.openxmlformats.org/drawingml/2006/main" spcFirstLastPara="1" wrap="square" lIns="91425" tIns="45700" rIns="91425" bIns="45700" anchor="t">
+            <a:noAutofit/>
+          </a:bodyPr>
+          <a:lstStyle xmlns:a="http://schemas.openxmlformats.org/drawingml/2006/main"/>
+          <a:p xmlns:a="http://schemas.openxmlformats.org/drawingml/2006/main">
+            <a:pPr marL="457200" indent="-342900" algn="l">
+              <a:spcBef>
+                <a:spcPts val="1000"/>
+              </a:spcBef>
+              <a:spcAft>
+                <a:spcPts val="0"/>
+              </a:spcAft>
+              <a:buChar char="●"/>
+            </a:pPr>
+            <a:r>
+              <a:t>Skip connections recover edge detail</a:t>
+            </a:r>
+          </a:p>
+          <a:p xmlns:a="http://schemas.openxmlformats.org/drawingml/2006/main">
+            <a:pPr marL="457200" indent="-342900" algn="l">
+              <a:spcBef>
+                <a:spcPts val="0"/>
+              </a:spcBef>
+              <a:spcAft>
+                <a:spcPts val="0"/>
+              </a:spcAft>
+              <a:buChar char="●"/>
+            </a:pPr>
+            <a:r>
+              <a:t>Predict a 160×160 central mask</a:t>
+            </a:r>
+          </a:p>
+          <a:p xmlns:a="http://schemas.openxmlformats.org/drawingml/2006/main">
+            <a:pPr marL="457200" indent="-342900" algn="l">
+              <a:spcBef>
+                <a:spcPts val="0"/>
+              </a:spcBef>
+              <a:spcAft>
+                <a:spcPts val="0"/>
+              </a:spcAft>
+              <a:buChar char="●"/>
+            </a:pPr>
+            <a:r>
+              <a:t>Dice + weighted BCE/focal loss</a:t>
+            </a:r>
+          </a:p>
+          <a:p xmlns:a="http://schemas.openxmlformats.org/drawingml/2006/main">
+            <a:pPr marL="457200" indent="-342900" algn="l">
+              <a:spcBef>
+                <a:spcPts val="0"/>
+              </a:spcBef>
+              <a:spcAft>
+                <a:spcPts val="0"/>
+              </a:spcAft>
+              <a:buChar char="●"/>
+            </a:pPr>
+            <a:r>
+              <a:t>KLayout vectors remain coordinate truth</a:t>
+            </a:r>
+          </a:p>
+        </p:txBody>
+      </p:sp>
+    </p:spTree>
+    <p:extLst>
+      <p:ext uri="{BB962C8B-B14F-4D97-AF65-F5344CB8AC3E}">
+        <p14:creationId xmlns:p14="http://schemas.microsoft.com/office/powerpoint/2010/main" val="1161288531"/>
       </p:ext>
     </p:extLst>
   </p:cSld>
@@ -25304,7 +26848,7 @@
           <p:nvPr/>
         </p:nvPicPr>
         <p:blipFill rotWithShape="1">
-          <a:blip xmlns:r="http://schemas.openxmlformats.org/officeDocument/2006/relationships" xmlns:a="http://schemas.openxmlformats.org/drawingml/2006/main" r:embed="R047692fb06244200">
+          <a:blip xmlns:r="http://schemas.openxmlformats.org/officeDocument/2006/relationships" xmlns:a="http://schemas.openxmlformats.org/drawingml/2006/main" r:embed="R2b25a7550cf442ea">
             <a:alphaModFix/>
           </a:blip>
           <a:srcRect xmlns:a="http://schemas.openxmlformats.org/drawingml/2006/main" l="0" t="0" r="0" b="0"/>
@@ -25332,7 +26876,7 @@
           <p:nvPr/>
         </p:nvPicPr>
         <p:blipFill rotWithShape="1">
-          <a:blip xmlns:r="http://schemas.openxmlformats.org/officeDocument/2006/relationships" xmlns:a="http://schemas.openxmlformats.org/drawingml/2006/main" r:embed="Rc4d8036454954ed0">
+          <a:blip xmlns:r="http://schemas.openxmlformats.org/officeDocument/2006/relationships" xmlns:a="http://schemas.openxmlformats.org/drawingml/2006/main" r:embed="R767990aba61f46c2">
             <a:alphaModFix/>
           </a:blip>
           <a:srcRect xmlns:a="http://schemas.openxmlformats.org/drawingml/2006/main" l="0" t="0" r="0" b="0"/>
@@ -25622,7 +27166,7 @@
           <p:nvPr/>
         </p:nvPicPr>
         <p:blipFill rotWithShape="1">
-          <a:blip xmlns:r="http://schemas.openxmlformats.org/officeDocument/2006/relationships" xmlns:a="http://schemas.openxmlformats.org/drawingml/2006/main" r:embed="Re842f921a67942ce">
+          <a:blip xmlns:r="http://schemas.openxmlformats.org/officeDocument/2006/relationships" xmlns:a="http://schemas.openxmlformats.org/drawingml/2006/main" r:embed="R5aa819e5d43e48d3">
             <a:alphaModFix/>
           </a:blip>
           <a:srcRect xmlns:a="http://schemas.openxmlformats.org/drawingml/2006/main" l="0" t="0" r="0" b="0"/>
@@ -25935,7 +27479,7 @@
       </p:sp>
       <p:pic>
         <p:nvPicPr>
-          <p:cNvPr id="783" name="Google Shape;119;p17"/>
+          <p:cNvPr id="877" name="Google Shape;119;p17"/>
           <p:cNvPicPr>
             <a:picLocks xmlns:a="http://schemas.openxmlformats.org/drawingml/2006/main" noChangeAspect="1"/>
           </p:cNvPicPr>
@@ -25944,7 +27488,7 @@
           </p:nvPr>
         </p:nvPicPr>
         <p:blipFill rotWithShape="1">
-          <a:blip xmlns:r="http://schemas.openxmlformats.org/officeDocument/2006/relationships" xmlns:a="http://schemas.openxmlformats.org/drawingml/2006/main" r:embed="R452ccbed58fa4457">
+          <a:blip xmlns:r="http://schemas.openxmlformats.org/officeDocument/2006/relationships" xmlns:a="http://schemas.openxmlformats.org/drawingml/2006/main" r:embed="R24adc5675cd14c57">
             <a:alphaModFix/>
           </a:blip>
           <a:srcRect xmlns:a="http://schemas.openxmlformats.org/drawingml/2006/main" l="0" t="0" r="0" b="0"/>
@@ -25969,14 +27513,14 @@
       </p:pic>
       <p:pic>
         <p:nvPicPr>
-          <p:cNvPr id="784" name="Google Shape;120;p17"/>
+          <p:cNvPr id="878" name="Google Shape;120;p17"/>
           <p:cNvPicPr>
             <a:picLocks xmlns:a="http://schemas.openxmlformats.org/drawingml/2006/main" noChangeAspect="1"/>
           </p:cNvPicPr>
           <p:nvPr/>
         </p:nvPicPr>
         <p:blipFill rotWithShape="1">
-          <a:blip xmlns:r="http://schemas.openxmlformats.org/officeDocument/2006/relationships" xmlns:a="http://schemas.openxmlformats.org/drawingml/2006/main" r:embed="R0b68d27149a54cec">
+          <a:blip xmlns:r="http://schemas.openxmlformats.org/officeDocument/2006/relationships" xmlns:a="http://schemas.openxmlformats.org/drawingml/2006/main" r:embed="Re87a584e26ed4c0b">
             <a:alphaModFix/>
           </a:blip>
           <a:srcRect xmlns:a="http://schemas.openxmlformats.org/drawingml/2006/main" l="0" t="0" r="0" b="0"/>
@@ -26001,14 +27545,14 @@
       </p:pic>
       <p:pic>
         <p:nvPicPr>
-          <p:cNvPr id="785" name="Google Shape;122;p17"/>
+          <p:cNvPr id="879" name="Google Shape;122;p17"/>
           <p:cNvPicPr>
             <a:picLocks xmlns:a="http://schemas.openxmlformats.org/drawingml/2006/main" noChangeAspect="1"/>
           </p:cNvPicPr>
           <p:nvPr/>
         </p:nvPicPr>
         <p:blipFill rotWithShape="1">
-          <a:blip xmlns:r="http://schemas.openxmlformats.org/officeDocument/2006/relationships" xmlns:a="http://schemas.openxmlformats.org/drawingml/2006/main" r:embed="R4206979cab7046a3">
+          <a:blip xmlns:r="http://schemas.openxmlformats.org/officeDocument/2006/relationships" xmlns:a="http://schemas.openxmlformats.org/drawingml/2006/main" r:embed="R44101218bc024b36">
             <a:alphaModFix/>
           </a:blip>
           <a:srcRect xmlns:a="http://schemas.openxmlformats.org/drawingml/2006/main" l="0" t="0" r="0" b="0"/>
@@ -26298,14 +27842,14 @@
       </p:sp>
       <p:pic>
         <p:nvPicPr>
-          <p:cNvPr id="791" name="Google Shape;128;p17"/>
+          <p:cNvPr id="885" name="Google Shape;128;p17"/>
           <p:cNvPicPr>
             <a:picLocks xmlns:a="http://schemas.openxmlformats.org/drawingml/2006/main" noChangeAspect="1"/>
           </p:cNvPicPr>
           <p:nvPr/>
         </p:nvPicPr>
         <p:blipFill rotWithShape="1">
-          <a:blip xmlns:r="http://schemas.openxmlformats.org/officeDocument/2006/relationships" xmlns:a="http://schemas.openxmlformats.org/drawingml/2006/main" r:embed="R0b68d27149a54cec">
+          <a:blip xmlns:r="http://schemas.openxmlformats.org/officeDocument/2006/relationships" xmlns:a="http://schemas.openxmlformats.org/drawingml/2006/main" r:embed="Re87a584e26ed4c0b">
             <a:alphaModFix/>
           </a:blip>
           <a:srcRect xmlns:a="http://schemas.openxmlformats.org/drawingml/2006/main" l="0" t="0" r="0" b="0"/>
@@ -26330,7 +27874,7 @@
       </p:pic>
       <p:cxnSp>
         <p:nvCxnSpPr>
-          <p:cNvPr id="792" name="Google Shape;129;p17"/>
+          <p:cNvPr id="886" name="Google Shape;129;p17"/>
           <p:cNvCxnSpPr/>
           <p:nvPr/>
         </p:nvCxnSpPr>
@@ -26355,7 +27899,7 @@
       </p:cxnSp>
       <p:cxnSp>
         <p:nvCxnSpPr>
-          <p:cNvPr id="793" name="Google Shape;130;p17"/>
+          <p:cNvPr id="887" name="Google Shape;130;p17"/>
           <p:cNvCxnSpPr/>
           <p:nvPr/>
         </p:nvCxnSpPr>
@@ -26380,14 +27924,14 @@
       </p:cxnSp>
       <p:pic>
         <p:nvPicPr>
-          <p:cNvPr id="794" name="Google Shape;131;p17"/>
+          <p:cNvPr id="888" name="Google Shape;131;p17"/>
           <p:cNvPicPr>
             <a:picLocks xmlns:a="http://schemas.openxmlformats.org/drawingml/2006/main" noChangeAspect="1"/>
           </p:cNvPicPr>
           <p:nvPr/>
         </p:nvPicPr>
         <p:blipFill rotWithShape="1">
-          <a:blip xmlns:r="http://schemas.openxmlformats.org/officeDocument/2006/relationships" xmlns:a="http://schemas.openxmlformats.org/drawingml/2006/main" r:embed="R54597fef3a6545ec">
+          <a:blip xmlns:r="http://schemas.openxmlformats.org/officeDocument/2006/relationships" xmlns:a="http://schemas.openxmlformats.org/drawingml/2006/main" r:embed="Ra6d547f839894c1f">
             <a:alphaModFix/>
           </a:blip>
           <a:srcRect xmlns:a="http://schemas.openxmlformats.org/drawingml/2006/main" l="0" t="0" r="0" b="0"/>
@@ -26673,14 +28217,14 @@
       </p:sp>
       <p:pic>
         <p:nvPicPr>
-          <p:cNvPr id="799" name="Google Shape;136;p17"/>
+          <p:cNvPr id="893" name="Google Shape;136;p17"/>
           <p:cNvPicPr>
             <a:picLocks xmlns:a="http://schemas.openxmlformats.org/drawingml/2006/main" noChangeAspect="1"/>
           </p:cNvPicPr>
           <p:nvPr/>
         </p:nvPicPr>
         <p:blipFill rotWithShape="1">
-          <a:blip xmlns:r="http://schemas.openxmlformats.org/officeDocument/2006/relationships" xmlns:a="http://schemas.openxmlformats.org/drawingml/2006/main" r:embed="R2d51eb94f92f4540">
+          <a:blip xmlns:r="http://schemas.openxmlformats.org/officeDocument/2006/relationships" xmlns:a="http://schemas.openxmlformats.org/drawingml/2006/main" r:embed="R001161a28c854cb0">
             <a:alphaModFix/>
           </a:blip>
           <a:srcRect xmlns:a="http://schemas.openxmlformats.org/drawingml/2006/main" l="0" t="0" r="0" b="0"/>
@@ -26701,14 +28245,14 @@
       </p:pic>
       <p:pic>
         <p:nvPicPr>
-          <p:cNvPr id="800" name="Google Shape;137;p17"/>
+          <p:cNvPr id="894" name="Google Shape;137;p17"/>
           <p:cNvPicPr>
             <a:picLocks xmlns:a="http://schemas.openxmlformats.org/drawingml/2006/main" noChangeAspect="1"/>
           </p:cNvPicPr>
           <p:nvPr/>
         </p:nvPicPr>
         <p:blipFill rotWithShape="1">
-          <a:blip xmlns:r="http://schemas.openxmlformats.org/officeDocument/2006/relationships" xmlns:a="http://schemas.openxmlformats.org/drawingml/2006/main" r:embed="R0a88e25cedc14fbb">
+          <a:blip xmlns:r="http://schemas.openxmlformats.org/officeDocument/2006/relationships" xmlns:a="http://schemas.openxmlformats.org/drawingml/2006/main" r:embed="R1f9465d56645473c">
             <a:alphaModFix/>
           </a:blip>
           <a:srcRect xmlns:a="http://schemas.openxmlformats.org/drawingml/2006/main" l="0" t="0" r="0" b="0"/>
@@ -26790,14 +28334,14 @@
       </p:sp>
       <p:pic>
         <p:nvPicPr>
-          <p:cNvPr id="802" name="Google Shape;139;p17"/>
+          <p:cNvPr id="896" name="Google Shape;139;p17"/>
           <p:cNvPicPr>
             <a:picLocks xmlns:a="http://schemas.openxmlformats.org/drawingml/2006/main" noChangeAspect="1"/>
           </p:cNvPicPr>
           <p:nvPr/>
         </p:nvPicPr>
         <p:blipFill rotWithShape="1">
-          <a:blip xmlns:r="http://schemas.openxmlformats.org/officeDocument/2006/relationships" xmlns:a="http://schemas.openxmlformats.org/drawingml/2006/main" r:embed="Rbb4fd0fad1124c2c">
+          <a:blip xmlns:r="http://schemas.openxmlformats.org/officeDocument/2006/relationships" xmlns:a="http://schemas.openxmlformats.org/drawingml/2006/main" r:embed="Rea6d0a952eed47cd">
             <a:alphaModFix/>
           </a:blip>
           <a:srcRect xmlns:a="http://schemas.openxmlformats.org/drawingml/2006/main" l="0" t="0" r="0" b="0"/>
@@ -26818,14 +28362,14 @@
       </p:pic>
       <p:pic>
         <p:nvPicPr>
-          <p:cNvPr id="803" name="Google Shape;140;p17"/>
+          <p:cNvPr id="897" name="Google Shape;140;p17"/>
           <p:cNvPicPr>
             <a:picLocks xmlns:a="http://schemas.openxmlformats.org/drawingml/2006/main" noChangeAspect="1"/>
           </p:cNvPicPr>
           <p:nvPr/>
         </p:nvPicPr>
         <p:blipFill rotWithShape="1">
-          <a:blip xmlns:r="http://schemas.openxmlformats.org/officeDocument/2006/relationships" xmlns:a="http://schemas.openxmlformats.org/drawingml/2006/main" r:embed="R2335d23ae1e344c7">
+          <a:blip xmlns:r="http://schemas.openxmlformats.org/officeDocument/2006/relationships" xmlns:a="http://schemas.openxmlformats.org/drawingml/2006/main" r:embed="Reb63b93b6dae47f2">
             <a:alphaModFix/>
           </a:blip>
           <a:srcRect xmlns:a="http://schemas.openxmlformats.org/drawingml/2006/main" l="0" t="0" r="0" b="0"/>
@@ -27095,7 +28639,7 @@
       </p:sp>
       <p:cxnSp>
         <p:nvCxnSpPr>
-          <p:cNvPr id="806" name="Google Shape;143;p17"/>
+          <p:cNvPr id="900" name="Google Shape;143;p17"/>
           <p:cNvCxnSpPr>
             <a:stCxn xmlns:a="http://schemas.openxmlformats.org/drawingml/2006/main" id="119" idx="3"/>
             <a:endCxn xmlns:a="http://schemas.openxmlformats.org/drawingml/2006/main" id="120" idx="1"/>
@@ -27123,7 +28667,7 @@
       </p:cxnSp>
       <p:cxnSp>
         <p:nvCxnSpPr>
-          <p:cNvPr id="807" name="Google Shape;144;p17"/>
+          <p:cNvPr id="901" name="Google Shape;144;p17"/>
           <p:cNvCxnSpPr>
             <a:endCxn xmlns:a="http://schemas.openxmlformats.org/drawingml/2006/main" id="128" idx="1"/>
           </p:cNvCxnSpPr>
@@ -27150,7 +28694,7 @@
       </p:cxnSp>
       <p:cxnSp>
         <p:nvCxnSpPr>
-          <p:cNvPr id="808" name="Google Shape;145;p17"/>
+          <p:cNvPr id="902" name="Google Shape;145;p17"/>
           <p:cNvCxnSpPr>
             <a:endCxn xmlns:a="http://schemas.openxmlformats.org/drawingml/2006/main" id="132" idx="1"/>
           </p:cNvCxnSpPr>
@@ -27177,7 +28721,7 @@
       </p:cxnSp>
       <p:cxnSp>
         <p:nvCxnSpPr>
-          <p:cNvPr id="809" name="Google Shape;146;p17"/>
+          <p:cNvPr id="903" name="Google Shape;146;p17"/>
           <p:cNvCxnSpPr>
             <a:endCxn xmlns:a="http://schemas.openxmlformats.org/drawingml/2006/main" id="135" idx="3"/>
           </p:cNvCxnSpPr>
@@ -27204,7 +28748,7 @@
       </p:cxnSp>
       <p:cxnSp>
         <p:nvCxnSpPr>
-          <p:cNvPr id="810" name="Google Shape;147;p17"/>
+          <p:cNvPr id="904" name="Google Shape;147;p17"/>
           <p:cNvCxnSpPr>
             <a:endCxn xmlns:a="http://schemas.openxmlformats.org/drawingml/2006/main" id="135" idx="0"/>
           </p:cNvCxnSpPr>
@@ -27231,7 +28775,7 @@
       </p:cxnSp>
       <p:cxnSp>
         <p:nvCxnSpPr>
-          <p:cNvPr id="811" name="Google Shape;148;p17"/>
+          <p:cNvPr id="905" name="Google Shape;148;p17"/>
           <p:cNvCxnSpPr>
             <a:stCxn xmlns:a="http://schemas.openxmlformats.org/drawingml/2006/main" id="132" idx="3"/>
             <a:endCxn xmlns:a="http://schemas.openxmlformats.org/drawingml/2006/main" id="133" idx="0"/>
@@ -27259,7 +28803,7 @@
       </p:cxnSp>
       <p:cxnSp>
         <p:nvCxnSpPr>
-          <p:cNvPr id="812" name="Google Shape;149;p17"/>
+          <p:cNvPr id="906" name="Google Shape;149;p17"/>
           <p:cNvCxnSpPr>
             <a:stCxn xmlns:a="http://schemas.openxmlformats.org/drawingml/2006/main" id="133" idx="2"/>
             <a:endCxn xmlns:a="http://schemas.openxmlformats.org/drawingml/2006/main" id="131" idx="0"/>
@@ -27287,7 +28831,7 @@
       </p:cxnSp>
       <p:cxnSp>
         <p:nvCxnSpPr>
-          <p:cNvPr id="813" name="Google Shape;150;p17"/>
+          <p:cNvPr id="907" name="Google Shape;150;p17"/>
           <p:cNvCxnSpPr>
             <a:stCxn xmlns:a="http://schemas.openxmlformats.org/drawingml/2006/main" id="135" idx="1"/>
             <a:endCxn xmlns:a="http://schemas.openxmlformats.org/drawingml/2006/main" id="136" idx="3"/>
@@ -27315,7 +28859,7 @@
       </p:cxnSp>
       <p:cxnSp>
         <p:nvCxnSpPr>
-          <p:cNvPr id="814" name="Google Shape;151;p17"/>
+          <p:cNvPr id="908" name="Google Shape;151;p17"/>
           <p:cNvCxnSpPr>
             <a:stCxn xmlns:a="http://schemas.openxmlformats.org/drawingml/2006/main" id="135" idx="1"/>
             <a:endCxn xmlns:a="http://schemas.openxmlformats.org/drawingml/2006/main" id="137" idx="3"/>
@@ -27343,7 +28887,7 @@
       </p:cxnSp>
       <p:cxnSp>
         <p:nvCxnSpPr>
-          <p:cNvPr id="815" name="Google Shape;152;p17"/>
+          <p:cNvPr id="909" name="Google Shape;152;p17"/>
           <p:cNvCxnSpPr/>
           <p:nvPr/>
         </p:nvCxnSpPr>
@@ -27368,7 +28912,7 @@
       </p:cxnSp>
       <p:cxnSp>
         <p:nvCxnSpPr>
-          <p:cNvPr id="816" name="Google Shape;153;p17"/>
+          <p:cNvPr id="910" name="Google Shape;153;p17"/>
           <p:cNvCxnSpPr/>
           <p:nvPr/>
         </p:nvCxnSpPr>
@@ -27393,7 +28937,7 @@
       </p:cxnSp>
       <p:cxnSp>
         <p:nvCxnSpPr>
-          <p:cNvPr id="817" name="Google Shape;154;p17"/>
+          <p:cNvPr id="911" name="Google Shape;154;p17"/>
           <p:cNvCxnSpPr/>
           <p:nvPr/>
         </p:nvCxnSpPr>
@@ -27418,7 +28962,7 @@
       </p:cxnSp>
       <p:cxnSp>
         <p:nvCxnSpPr>
-          <p:cNvPr id="818" name="Google Shape;155;p17"/>
+          <p:cNvPr id="912" name="Google Shape;155;p17"/>
           <p:cNvCxnSpPr/>
           <p:nvPr/>
         </p:nvCxnSpPr>
@@ -27443,7 +28987,7 @@
       </p:cxnSp>
       <p:cxnSp>
         <p:nvCxnSpPr>
-          <p:cNvPr id="819" name="Google Shape;156;p17"/>
+          <p:cNvPr id="913" name="Google Shape;156;p17"/>
           <p:cNvCxnSpPr/>
           <p:nvPr/>
         </p:nvCxnSpPr>
@@ -27832,7 +29376,7 @@
           </p:nvPr>
         </p:nvPicPr>
         <p:blipFill rotWithShape="1">
-          <a:blip xmlns:r="http://schemas.openxmlformats.org/officeDocument/2006/relationships" xmlns:a="http://schemas.openxmlformats.org/drawingml/2006/main" r:embed="Rd401e9972b7546cf">
+          <a:blip xmlns:r="http://schemas.openxmlformats.org/officeDocument/2006/relationships" xmlns:a="http://schemas.openxmlformats.org/drawingml/2006/main" r:embed="Re9ac3dde755a413e">
             <a:alphaModFix/>
           </a:blip>
           <a:srcRect xmlns:a="http://schemas.openxmlformats.org/drawingml/2006/main" l="0" t="0" r="0" b="0"/>
@@ -28048,7 +29592,7 @@
           <p:nvPr/>
         </p:nvPicPr>
         <p:blipFill rotWithShape="1">
-          <a:blip xmlns:r="http://schemas.openxmlformats.org/officeDocument/2006/relationships" xmlns:a="http://schemas.openxmlformats.org/drawingml/2006/main" r:embed="Reaedd04d4121403b">
+          <a:blip xmlns:r="http://schemas.openxmlformats.org/officeDocument/2006/relationships" xmlns:a="http://schemas.openxmlformats.org/drawingml/2006/main" r:embed="R11affe4a9e744248">
             <a:alphaModFix/>
           </a:blip>
           <a:srcRect xmlns:a="http://schemas.openxmlformats.org/drawingml/2006/main" l="0" t="0" r="0" b="0"/>
@@ -28779,7 +30323,7 @@
           <p:nvPr/>
         </p:nvPicPr>
         <p:blipFill rotWithShape="1">
-          <a:blip xmlns:r="http://schemas.openxmlformats.org/officeDocument/2006/relationships" xmlns:a="http://schemas.openxmlformats.org/drawingml/2006/main" r:embed="R0f8cbb3fa5bf4d4f">
+          <a:blip xmlns:r="http://schemas.openxmlformats.org/officeDocument/2006/relationships" xmlns:a="http://schemas.openxmlformats.org/drawingml/2006/main" r:embed="R5fd9c6984a064490">
             <a:alphaModFix/>
           </a:blip>
           <a:srcRect xmlns:a="http://schemas.openxmlformats.org/drawingml/2006/main" l="0" t="0" r="0" b="0"/>
@@ -28807,7 +30351,7 @@
           <p:nvPr/>
         </p:nvPicPr>
         <p:blipFill rotWithShape="1">
-          <a:blip xmlns:r="http://schemas.openxmlformats.org/officeDocument/2006/relationships" xmlns:a="http://schemas.openxmlformats.org/drawingml/2006/main" r:embed="R738c245eb6544bab">
+          <a:blip xmlns:r="http://schemas.openxmlformats.org/officeDocument/2006/relationships" xmlns:a="http://schemas.openxmlformats.org/drawingml/2006/main" r:embed="Ra2481d8c899f4b6d">
             <a:alphaModFix/>
           </a:blip>
           <a:srcRect xmlns:a="http://schemas.openxmlformats.org/drawingml/2006/main" l="0" t="0" r="0" b="0"/>
@@ -28835,7 +30379,7 @@
           <p:nvPr/>
         </p:nvPicPr>
         <p:blipFill rotWithShape="1">
-          <a:blip xmlns:r="http://schemas.openxmlformats.org/officeDocument/2006/relationships" xmlns:a="http://schemas.openxmlformats.org/drawingml/2006/main" r:embed="R00afd8d8d83a4125">
+          <a:blip xmlns:r="http://schemas.openxmlformats.org/officeDocument/2006/relationships" xmlns:a="http://schemas.openxmlformats.org/drawingml/2006/main" r:embed="Ree5f9c4284494c18">
             <a:alphaModFix/>
           </a:blip>
           <a:srcRect xmlns:a="http://schemas.openxmlformats.org/drawingml/2006/main" l="0" t="0" r="0" b="0"/>
@@ -29231,7 +30775,7 @@
               <a:buNone/>
             </a:pPr>
             <a:r>
-              <a:t>B0–B5.1 complete · failure-slice analysis next</a:t>
+              <a:t>B0–B6.1 complete · multi-task U-Net training next</a:t>
             </a:r>
           </a:p>
         </p:txBody>

</xml_diff>

<commit_message>
Record accepted B6.2 results
</commit_message>
<xml_diff>
--- a/presentation/ADVLSI2_DRC_CNN_Project_Progress.pptx
+++ b/presentation/ADVLSI2_DRC_CNN_Project_Progress.pptx
@@ -2,48 +2,48 @@
 <file path=ppt/presentation.xml><?xml version="1.0" encoding="utf-8"?>
 <p:presentation xmlns:p="http://schemas.openxmlformats.org/presentationml/2006/main" embedTrueTypeFonts="1" saveSubsetFonts="0">
   <p:sldMasterIdLst>
-    <p:sldMasterId xmlns:r="http://schemas.openxmlformats.org/officeDocument/2006/relationships" id="2147483648" r:id="R97f916a39f404c03"/>
+    <p:sldMasterId xmlns:r="http://schemas.openxmlformats.org/officeDocument/2006/relationships" id="2147483648" r:id="Rd270b55a86964462"/>
   </p:sldMasterIdLst>
   <p:notesMasterIdLst>
-    <p:notesMasterId xmlns:r="http://schemas.openxmlformats.org/officeDocument/2006/relationships" r:id="R3a1ba16c5f554403"/>
+    <p:notesMasterId xmlns:r="http://schemas.openxmlformats.org/officeDocument/2006/relationships" r:id="R26bb4a37c7e2481d"/>
   </p:notesMasterIdLst>
   <p:sldIdLst>
-    <p:sldId xmlns:r="http://schemas.openxmlformats.org/officeDocument/2006/relationships" id="256" r:id="R72de3e47ea7a45af"/>
-    <p:sldId xmlns:r="http://schemas.openxmlformats.org/officeDocument/2006/relationships" id="257" r:id="R1ec4d2e03134449d"/>
-    <p:sldId xmlns:r="http://schemas.openxmlformats.org/officeDocument/2006/relationships" id="258" r:id="Rb84ad73590264f06"/>
-    <p:sldId xmlns:r="http://schemas.openxmlformats.org/officeDocument/2006/relationships" id="259" r:id="R2b9c5bbb38b9471b"/>
-    <p:sldId xmlns:r="http://schemas.openxmlformats.org/officeDocument/2006/relationships" id="260" r:id="R9236d55d04cf475a"/>
-    <p:sldId xmlns:r="http://schemas.openxmlformats.org/officeDocument/2006/relationships" id="261" r:id="R0bafc63a44a34801"/>
-    <p:sldId xmlns:r="http://schemas.openxmlformats.org/officeDocument/2006/relationships" id="262" r:id="R5e1a642a80d04560"/>
-    <p:sldId xmlns:r="http://schemas.openxmlformats.org/officeDocument/2006/relationships" id="263" r:id="R08828ee439c74c75"/>
-    <p:sldId xmlns:r="http://schemas.openxmlformats.org/officeDocument/2006/relationships" id="264" r:id="Rbc5781a2f34c4217"/>
-    <p:sldId xmlns:r="http://schemas.openxmlformats.org/officeDocument/2006/relationships" id="265" r:id="R78ce135f1c1644d3"/>
-    <p:sldId xmlns:r="http://schemas.openxmlformats.org/officeDocument/2006/relationships" id="266" r:id="Rc37c403a10284a82"/>
-    <p:sldId xmlns:r="http://schemas.openxmlformats.org/officeDocument/2006/relationships" id="267" r:id="R074eda3331b84adb"/>
-    <p:sldId xmlns:r="http://schemas.openxmlformats.org/officeDocument/2006/relationships" id="268" r:id="Rea5f73b96dd842ac"/>
-    <p:sldId xmlns:r="http://schemas.openxmlformats.org/officeDocument/2006/relationships" id="269" r:id="R4e35598118344f59"/>
-    <p:sldId xmlns:r="http://schemas.openxmlformats.org/officeDocument/2006/relationships" id="270" r:id="R170c1696a9084621"/>
-    <p:sldId xmlns:r="http://schemas.openxmlformats.org/officeDocument/2006/relationships" id="271" r:id="R7aa6c39fa7234dab"/>
-    <p:sldId xmlns:r="http://schemas.openxmlformats.org/officeDocument/2006/relationships" id="272" r:id="Reb568e75046440d3"/>
-    <p:sldId xmlns:r="http://schemas.openxmlformats.org/officeDocument/2006/relationships" id="273" r:id="Rd41b87bed9384664"/>
-    <p:sldId xmlns:r="http://schemas.openxmlformats.org/officeDocument/2006/relationships" id="274" r:id="R980f9f2f5d99415b"/>
-    <p:sldId xmlns:r="http://schemas.openxmlformats.org/officeDocument/2006/relationships" id="275" r:id="R096cfaeab20f4038"/>
-    <p:sldId xmlns:r="http://schemas.openxmlformats.org/officeDocument/2006/relationships" id="276" r:id="R4847ed7fb54a4a76"/>
-    <p:sldId xmlns:r="http://schemas.openxmlformats.org/officeDocument/2006/relationships" id="277" r:id="Rd9ea7c3454f4440d"/>
-    <p:sldId xmlns:r="http://schemas.openxmlformats.org/officeDocument/2006/relationships" id="278" r:id="Rccf6e85cf2374d46"/>
-    <p:sldId xmlns:r="http://schemas.openxmlformats.org/officeDocument/2006/relationships" id="279" r:id="R00b4d148062b464a"/>
-    <p:sldId xmlns:r="http://schemas.openxmlformats.org/officeDocument/2006/relationships" id="280" r:id="Rda5dbcbc0c374c46"/>
-    <p:sldId xmlns:r="http://schemas.openxmlformats.org/officeDocument/2006/relationships" id="281" r:id="R297220c29f744f33"/>
-    <p:sldId xmlns:r="http://schemas.openxmlformats.org/officeDocument/2006/relationships" id="282" r:id="Ra8e68c859ad24af3"/>
-    <p:sldId xmlns:r="http://schemas.openxmlformats.org/officeDocument/2006/relationships" id="283" r:id="Re8c9919ef4824d6a"/>
+    <p:sldId xmlns:r="http://schemas.openxmlformats.org/officeDocument/2006/relationships" id="256" r:id="R784367d400bf44b8"/>
+    <p:sldId xmlns:r="http://schemas.openxmlformats.org/officeDocument/2006/relationships" id="257" r:id="Rf6f7618a027d4008"/>
+    <p:sldId xmlns:r="http://schemas.openxmlformats.org/officeDocument/2006/relationships" id="258" r:id="Re18f0d80924d4b28"/>
+    <p:sldId xmlns:r="http://schemas.openxmlformats.org/officeDocument/2006/relationships" id="259" r:id="Rd3252ee39b034fe0"/>
+    <p:sldId xmlns:r="http://schemas.openxmlformats.org/officeDocument/2006/relationships" id="260" r:id="Rb17057fab46b45a1"/>
+    <p:sldId xmlns:r="http://schemas.openxmlformats.org/officeDocument/2006/relationships" id="261" r:id="R7b729287e1ec429e"/>
+    <p:sldId xmlns:r="http://schemas.openxmlformats.org/officeDocument/2006/relationships" id="262" r:id="R789e758bccf04217"/>
+    <p:sldId xmlns:r="http://schemas.openxmlformats.org/officeDocument/2006/relationships" id="263" r:id="R2ed7910aa0974222"/>
+    <p:sldId xmlns:r="http://schemas.openxmlformats.org/officeDocument/2006/relationships" id="264" r:id="Rb6f6ac85c7c34cd2"/>
+    <p:sldId xmlns:r="http://schemas.openxmlformats.org/officeDocument/2006/relationships" id="265" r:id="R1fad68ac81dd4db7"/>
+    <p:sldId xmlns:r="http://schemas.openxmlformats.org/officeDocument/2006/relationships" id="266" r:id="R8b7169f71ee34ba6"/>
+    <p:sldId xmlns:r="http://schemas.openxmlformats.org/officeDocument/2006/relationships" id="267" r:id="R33bd69254c154c5d"/>
+    <p:sldId xmlns:r="http://schemas.openxmlformats.org/officeDocument/2006/relationships" id="268" r:id="R44dee50c22384e81"/>
+    <p:sldId xmlns:r="http://schemas.openxmlformats.org/officeDocument/2006/relationships" id="269" r:id="Raa0e42ffdada4e13"/>
+    <p:sldId xmlns:r="http://schemas.openxmlformats.org/officeDocument/2006/relationships" id="270" r:id="R55f01844028d4aa3"/>
+    <p:sldId xmlns:r="http://schemas.openxmlformats.org/officeDocument/2006/relationships" id="271" r:id="Rb5ecf20664294619"/>
+    <p:sldId xmlns:r="http://schemas.openxmlformats.org/officeDocument/2006/relationships" id="272" r:id="R6c04e864544d4a50"/>
+    <p:sldId xmlns:r="http://schemas.openxmlformats.org/officeDocument/2006/relationships" id="273" r:id="Ra8c6882a28ca4212"/>
+    <p:sldId xmlns:r="http://schemas.openxmlformats.org/officeDocument/2006/relationships" id="274" r:id="R4cd251490db54d1d"/>
+    <p:sldId xmlns:r="http://schemas.openxmlformats.org/officeDocument/2006/relationships" id="275" r:id="R65ca00a827e1434f"/>
+    <p:sldId xmlns:r="http://schemas.openxmlformats.org/officeDocument/2006/relationships" id="276" r:id="R1f2265feb795470e"/>
+    <p:sldId xmlns:r="http://schemas.openxmlformats.org/officeDocument/2006/relationships" id="277" r:id="R2bba9b86f04a47f7"/>
+    <p:sldId xmlns:r="http://schemas.openxmlformats.org/officeDocument/2006/relationships" id="278" r:id="Rbd0a6ac5f4314ef2"/>
+    <p:sldId xmlns:r="http://schemas.openxmlformats.org/officeDocument/2006/relationships" id="279" r:id="Rc383af52e12543b8"/>
+    <p:sldId xmlns:r="http://schemas.openxmlformats.org/officeDocument/2006/relationships" id="280" r:id="R96015069773d4773"/>
+    <p:sldId xmlns:r="http://schemas.openxmlformats.org/officeDocument/2006/relationships" id="281" r:id="R94dbf8bc649e4264"/>
+    <p:sldId xmlns:r="http://schemas.openxmlformats.org/officeDocument/2006/relationships" id="282" r:id="R00ba191be8614c96"/>
+    <p:sldId xmlns:r="http://schemas.openxmlformats.org/officeDocument/2006/relationships" id="283" r:id="R2a92c752dd7648a1"/>
   </p:sldIdLst>
   <p:sldSz cx="12192000" cy="6858000"/>
   <p:notesSz cx="6858000" cy="9144000"/>
   <p:embeddedFontLst>
     <p:embeddedFont>
       <p:font typeface="Play"/>
-      <p:regular xmlns:r="http://schemas.openxmlformats.org/officeDocument/2006/relationships" r:id="Rc2cb491e3a8f4cc8"/>
-      <p:bold xmlns:r="http://schemas.openxmlformats.org/officeDocument/2006/relationships" r:id="Rbf378c35f1f0408d"/>
+      <p:regular xmlns:r="http://schemas.openxmlformats.org/officeDocument/2006/relationships" r:id="R57c67886a7e04682"/>
+      <p:bold xmlns:r="http://schemas.openxmlformats.org/officeDocument/2006/relationships" r:id="R67126723a388413f"/>
     </p:embeddedFont>
   </p:embeddedFontLst>
 </p:presentation>
@@ -536,21 +536,7 @@
               <a:buNone/>
             </a:pPr>
             <a:r>
-              <a:t>- results/b5_failure_audit/summary.json</a:t>
-            </a:r>
-          </a:p>
-          <a:p xmlns:a="http://schemas.openxmlformats.org/drawingml/2006/main">
-            <a:pPr marL="0" indent="0" algn="l">
-              <a:spcBef>
-                <a:spcPts val="0"/>
-              </a:spcBef>
-              <a:spcAft>
-                <a:spcPts val="0"/>
-              </a:spcAft>
-              <a:buNone/>
-            </a:pPr>
-            <a:r>
-              <a:t>- results/b6_localization_dataset/summary.json</a:t>
+              <a:t>- results/b6_multitask_unet/summary.json</a:t>
             </a:r>
           </a:p>
           <a:p xmlns:a="http://schemas.openxmlformats.org/drawingml/2006/main">
@@ -1048,12 +1034,7 @@
           </a:p>
           <a:p xmlns:a="http://schemas.openxmlformats.org/drawingml/2006/main">
             <a:r>
-              <a:t>- results/b5_failure_audit/summary.json</a:t>
-            </a:r>
-          </a:p>
-          <a:p xmlns:a="http://schemas.openxmlformats.org/drawingml/2006/main">
-            <a:r>
-              <a:t>- results/b6_localization_dataset/summary.json</a:t>
+              <a:t>- results/b6_multitask_unet/summary.json</a:t>
             </a:r>
           </a:p>
           <a:p xmlns:a="http://schemas.openxmlformats.org/drawingml/2006/main">
@@ -1221,7 +1202,7 @@
               <a:buNone/>
             </a:pPr>
             <a:r>
-              <a:t>- results/b6_localization_dataset/summary.json</a:t>
+              <a:t>- results/b6_multitask_unet/summary.json</a:t>
             </a:r>
           </a:p>
           <a:p xmlns:a="http://schemas.openxmlformats.org/drawingml/2006/main">
@@ -2920,7 +2901,7 @@
               <a:buNone/>
             </a:pPr>
             <a:r>
-              <a:t>- MODEL_ROADMAP.md, B6.2</a:t>
+              <a:t>- results/b6_multitask_unet/summary.json</a:t>
             </a:r>
           </a:p>
           <a:p xmlns:a="http://schemas.openxmlformats.org/drawingml/2006/main">
@@ -2934,7 +2915,7 @@
               <a:buNone/>
             </a:pPr>
             <a:r>
-              <a:t>- results/b6_localization_dataset/summary.json</a:t>
+              <a:t>- results/b6_multitask_unet/runs/seed_42.json</a:t>
             </a:r>
           </a:p>
           <a:p xmlns:a="http://schemas.openxmlformats.org/drawingml/2006/main">
@@ -2948,7 +2929,21 @@
               <a:buNone/>
             </a:pPr>
             <a:r>
-              <a:t>- Ronneberger et al., U-Net (arXiv:1505.04597)</a:t>
+              <a:t>- results/b6_multitask_unet/runs/seed_43.json</a:t>
+            </a:r>
+          </a:p>
+          <a:p xmlns:a="http://schemas.openxmlformats.org/drawingml/2006/main">
+            <a:pPr marL="0" indent="0" algn="l">
+              <a:spcBef>
+                <a:spcPts val="0"/>
+              </a:spcBef>
+              <a:spcAft>
+                <a:spcPts val="0"/>
+              </a:spcAft>
+              <a:buNone/>
+            </a:pPr>
+            <a:r>
+              <a:t>- results/b6_multitask_unet/runs/seed_44.json</a:t>
             </a:r>
           </a:p>
           <a:p xmlns:a="http://schemas.openxmlformats.org/drawingml/2006/main">
@@ -3641,21 +3636,7 @@
               <a:buNone/>
             </a:pPr>
             <a:r>
-              <a:t>- results/b5_failure_audit/summary.json</a:t>
-            </a:r>
-          </a:p>
-          <a:p xmlns:a="http://schemas.openxmlformats.org/drawingml/2006/main">
-            <a:pPr marL="0" indent="0" algn="l">
-              <a:spcBef>
-                <a:spcPts val="0"/>
-              </a:spcBef>
-              <a:spcAft>
-                <a:spcPts val="0"/>
-              </a:spcAft>
-              <a:buNone/>
-            </a:pPr>
-            <a:r>
-              <a:t>- results/b6_localization_dataset/summary.json</a:t>
+              <a:t>- results/b6_multitask_unet/summary.json</a:t>
             </a:r>
           </a:p>
           <a:p xmlns:a="http://schemas.openxmlformats.org/drawingml/2006/main">
@@ -12440,17 +12421,17 @@
   </p:cSld>
   <p:clrMap bg1="lt1" tx1="dk1" bg2="dk2" tx2="lt2" accent1="accent1" accent2="accent2" accent3="accent3" accent4="accent4" accent5="accent5" accent6="accent6" hlink="hlink" folHlink="folHlink"/>
   <p:sldLayoutIdLst>
-    <p:sldLayoutId xmlns:r="http://schemas.openxmlformats.org/officeDocument/2006/relationships" id="2147483649" r:id="R407a5c2aa2054a47"/>
-    <p:sldLayoutId xmlns:r="http://schemas.openxmlformats.org/officeDocument/2006/relationships" id="2147483650" r:id="Radef6650b8584ea0"/>
-    <p:sldLayoutId xmlns:r="http://schemas.openxmlformats.org/officeDocument/2006/relationships" id="2147483651" r:id="R8961f1aebd5e40e1"/>
-    <p:sldLayoutId xmlns:r="http://schemas.openxmlformats.org/officeDocument/2006/relationships" id="2147483652" r:id="R6371f0bdefd74638"/>
-    <p:sldLayoutId xmlns:r="http://schemas.openxmlformats.org/officeDocument/2006/relationships" id="2147483653" r:id="R0d9dbbaa1caa404a"/>
-    <p:sldLayoutId xmlns:r="http://schemas.openxmlformats.org/officeDocument/2006/relationships" id="2147483654" r:id="R08e798c0e6ea4f60"/>
-    <p:sldLayoutId xmlns:r="http://schemas.openxmlformats.org/officeDocument/2006/relationships" id="2147483655" r:id="Re591310537d040c5"/>
-    <p:sldLayoutId xmlns:r="http://schemas.openxmlformats.org/officeDocument/2006/relationships" id="2147483656" r:id="Rbf7be9b1edcb4e36"/>
-    <p:sldLayoutId xmlns:r="http://schemas.openxmlformats.org/officeDocument/2006/relationships" id="2147483657" r:id="R54bb288944c246d7"/>
-    <p:sldLayoutId xmlns:r="http://schemas.openxmlformats.org/officeDocument/2006/relationships" id="2147483658" r:id="Rec441082f68b4849"/>
-    <p:sldLayoutId xmlns:r="http://schemas.openxmlformats.org/officeDocument/2006/relationships" id="2147483659" r:id="R9859e5c93171418d"/>
+    <p:sldLayoutId xmlns:r="http://schemas.openxmlformats.org/officeDocument/2006/relationships" id="2147483649" r:id="R1be4db58d4614cc9"/>
+    <p:sldLayoutId xmlns:r="http://schemas.openxmlformats.org/officeDocument/2006/relationships" id="2147483650" r:id="R154439db0c4f4d4d"/>
+    <p:sldLayoutId xmlns:r="http://schemas.openxmlformats.org/officeDocument/2006/relationships" id="2147483651" r:id="Rae1181e3b6b14569"/>
+    <p:sldLayoutId xmlns:r="http://schemas.openxmlformats.org/officeDocument/2006/relationships" id="2147483652" r:id="R1f956cd0440743d5"/>
+    <p:sldLayoutId xmlns:r="http://schemas.openxmlformats.org/officeDocument/2006/relationships" id="2147483653" r:id="R07137ea51dc7464d"/>
+    <p:sldLayoutId xmlns:r="http://schemas.openxmlformats.org/officeDocument/2006/relationships" id="2147483654" r:id="R2c3886ab91504234"/>
+    <p:sldLayoutId xmlns:r="http://schemas.openxmlformats.org/officeDocument/2006/relationships" id="2147483655" r:id="R709c60d01f774304"/>
+    <p:sldLayoutId xmlns:r="http://schemas.openxmlformats.org/officeDocument/2006/relationships" id="2147483656" r:id="R61d5eac25a814186"/>
+    <p:sldLayoutId xmlns:r="http://schemas.openxmlformats.org/officeDocument/2006/relationships" id="2147483657" r:id="Rb37627820fed4f99"/>
+    <p:sldLayoutId xmlns:r="http://schemas.openxmlformats.org/officeDocument/2006/relationships" id="2147483658" r:id="Rca43e02437604d1d"/>
+    <p:sldLayoutId xmlns:r="http://schemas.openxmlformats.org/officeDocument/2006/relationships" id="2147483659" r:id="R4f39db1c868a44e5"/>
   </p:sldLayoutIdLst>
   <p:hf sldNum="0" hdr="0" ftr="0" dt="0"/>
   <p:txStyles>
@@ -13402,7 +13383,7 @@
               <a:buNone/>
             </a:pPr>
             <a:r>
-              <a:t>CNN-based DRC | B0–B6.1 complete · multi-task U-Net next</a:t>
+              <a:t>CNN-based DRC | B0–B6.2 complete · exact edge recovery next</a:t>
             </a:r>
           </a:p>
         </p:txBody>
@@ -17391,7 +17372,7 @@
               <a:buChar char="●"/>
             </a:pPr>
             <a:r>
-              <a:t>B6.1  Localization data — complete</a:t>
+              <a:t>B6.1  Localization data — done</a:t>
             </a:r>
           </a:p>
           <a:p xmlns:a="http://schemas.openxmlformats.org/drawingml/2006/main">
@@ -17405,7 +17386,7 @@
               <a:buChar char="●"/>
             </a:pPr>
             <a:r>
-              <a:t>B6.2  Multi-task U-Net — next</a:t>
+              <a:t>B6.2  U-Net — accepted</a:t>
             </a:r>
           </a:p>
           <a:p xmlns:a="http://schemas.openxmlformats.org/drawingml/2006/main">
@@ -17419,7 +17400,7 @@
               <a:buChar char="●"/>
             </a:pPr>
             <a:r>
-              <a:t>B7  Exact GDS coordinates</a:t>
+              <a:t>B7  Exact coordinates — next</a:t>
             </a:r>
           </a:p>
           <a:p xmlns:a="http://schemas.openxmlformats.org/drawingml/2006/main">
@@ -17504,7 +17485,7 @@
                   <a:srgbClr val="404040"/>
                 </a:solidFill>
               </a:rPr>
-              <a:t>B2 remains the classifier baseline; B6.1 enables U-Net localization training.</a:t>
+              <a:t>B6.2 passed all development gates; B7 turns high-recall masks into unique exact violations.</a:t>
             </a:r>
           </a:p>
         </p:txBody>
@@ -19340,7 +19321,7 @@
                   <a:srgbClr val="262626"/>
                 </a:solidFill>
               </a:rPr>
-              <a:t>B6.1</a:t>
+              <a:t>B6.2</a:t>
             </a:r>
           </a:p>
         </p:txBody>
@@ -19397,7 +19378,7 @@
                   <a:srgbClr val="262626"/>
                 </a:solidFill>
               </a:rPr>
-              <a:t>Done</a:t>
+              <a:t>Accepted</a:t>
             </a:r>
           </a:p>
         </p:txBody>
@@ -19454,7 +19435,7 @@
                   <a:srgbClr val="262626"/>
                 </a:solidFill>
               </a:rPr>
-              <a:t>Exact localization dataset</a:t>
+              <a:t>Multi-task localization</a:t>
             </a:r>
           </a:p>
         </p:txBody>
@@ -19511,7 +19492,7 @@
                   <a:srgbClr val="262626"/>
                 </a:solidFill>
               </a:rPr>
-              <a:t>—</a:t>
+              <a:t>95.51%</a:t>
             </a:r>
           </a:p>
         </p:txBody>
@@ -19568,7 +19549,7 @@
                   <a:srgbClr val="262626"/>
                 </a:solidFill>
               </a:rPr>
-              <a:t>—</a:t>
+              <a:t>0.957</a:t>
             </a:r>
           </a:p>
         </p:txBody>
@@ -19625,7 +19606,7 @@
                   <a:srgbClr val="262626"/>
                 </a:solidFill>
               </a:rPr>
-              <a:t>—</a:t>
+              <a:t>+0.015</a:t>
             </a:r>
           </a:p>
         </p:txBody>
@@ -19682,7 +19663,7 @@
                   <a:srgbClr val="73400D"/>
                 </a:solidFill>
               </a:rPr>
-              <a:t>B2 remains accepted; B5.2 closed classifier-only tuning. B6.1 is complete, so U-Net training is next.</a:t>
+              <a:t>B6.2 passes all gates; B7 now stitches masks, recovers exact edges, and measures full-layout false alarms.</a:t>
             </a:r>
           </a:p>
         </p:txBody>
@@ -20032,7 +20013,7 @@
           </p:nvPr>
         </p:nvPicPr>
         <p:blipFill rotWithShape="1">
-          <a:blip xmlns:r="http://schemas.openxmlformats.org/officeDocument/2006/relationships" xmlns:a="http://schemas.openxmlformats.org/drawingml/2006/main" r:embed="Ra6949aee5ace43c1">
+          <a:blip xmlns:r="http://schemas.openxmlformats.org/officeDocument/2006/relationships" xmlns:a="http://schemas.openxmlformats.org/drawingml/2006/main" r:embed="Rfc36a133a9414af6">
             <a:alphaModFix/>
           </a:blip>
           <a:srcRect xmlns:a="http://schemas.openxmlformats.org/drawingml/2006/main" l="0" t="0" r="0" b="0"/>
@@ -20060,7 +20041,7 @@
           <p:nvPr/>
         </p:nvPicPr>
         <p:blipFill rotWithShape="1">
-          <a:blip xmlns:r="http://schemas.openxmlformats.org/officeDocument/2006/relationships" xmlns:a="http://schemas.openxmlformats.org/drawingml/2006/main" r:embed="R2e5ed662fe4d468e">
+          <a:blip xmlns:r="http://schemas.openxmlformats.org/officeDocument/2006/relationships" xmlns:a="http://schemas.openxmlformats.org/drawingml/2006/main" r:embed="R88d429f09ca04f03">
             <a:alphaModFix/>
           </a:blip>
           <a:srcRect xmlns:a="http://schemas.openxmlformats.org/drawingml/2006/main" l="0" t="0" r="0" b="0"/>
@@ -26491,7 +26472,7 @@
               <a:buNone/>
             </a:pPr>
             <a:r>
-              <a:t>B6.2: one U-Net, two supervised tasks</a:t>
+              <a:t>B6.2 passes every development gate</a:t>
             </a:r>
           </a:p>
         </p:txBody>
@@ -26537,7 +26518,7 @@
               <a:buNone/>
             </a:pPr>
             <a:r>
-              <a:t>Encoder + classification head</a:t>
+              <a:t>Classification improves vs. B2</a:t>
             </a:r>
           </a:p>
         </p:txBody>
@@ -26583,7 +26564,7 @@
               <a:buChar char="●"/>
             </a:pPr>
             <a:r>
-              <a:t>Shared encoder learns geometry</a:t>
+              <a:t>Accuracy: 95.51% (+1.50)</a:t>
             </a:r>
           </a:p>
           <a:p xmlns:a="http://schemas.openxmlformats.org/drawingml/2006/main">
@@ -26597,7 +26578,7 @@
               <a:buChar char="●"/>
             </a:pPr>
             <a:r>
-              <a:t>Global head predicts clean / dirty</a:t>
+              <a:t>Dirty recall: 98.86% (+2.67)</a:t>
             </a:r>
           </a:p>
           <a:p xmlns:a="http://schemas.openxmlformats.org/drawingml/2006/main">
@@ -26611,7 +26592,7 @@
               <a:buChar char="●"/>
             </a:pPr>
             <a:r>
-              <a:t>Compare with accepted B2</a:t>
+              <a:t>Dirty F1: 95.66% (+1.51)</a:t>
             </a:r>
           </a:p>
           <a:p xmlns:a="http://schemas.openxmlformats.org/drawingml/2006/main">
@@ -26625,7 +26606,7 @@
               <a:buChar char="●"/>
             </a:pPr>
             <a:r>
-              <a:t>Reject if dirty recall regresses</a:t>
+              <a:t>Same B6 tiles · 3 seeds</a:t>
             </a:r>
           </a:p>
         </p:txBody>
@@ -26671,7 +26652,7 @@
               <a:buNone/>
             </a:pPr>
             <a:r>
-              <a:t>Decoder + segmentation head</a:t>
+              <a:t>Localization passes; precision next</a:t>
             </a:r>
           </a:p>
         </p:txBody>
@@ -26717,7 +26698,7 @@
               <a:buChar char="●"/>
             </a:pPr>
             <a:r>
-              <a:t>Skip connections recover edge detail</a:t>
+              <a:t>Mask Dice: 86.32%</a:t>
             </a:r>
           </a:p>
           <a:p xmlns:a="http://schemas.openxmlformats.org/drawingml/2006/main">
@@ -26731,7 +26712,7 @@
               <a:buChar char="●"/>
             </a:pPr>
             <a:r>
-              <a:t>Predict a 160×160 central mask</a:t>
+              <a:t>Object F1: 84.23%</a:t>
             </a:r>
           </a:p>
           <a:p xmlns:a="http://schemas.openxmlformats.org/drawingml/2006/main">
@@ -26745,7 +26726,7 @@
               <a:buChar char="●"/>
             </a:pPr>
             <a:r>
-              <a:t>Dice + weighted BCE/focal loss</a:t>
+              <a:t>Vector-owner recall: 87.19%</a:t>
             </a:r>
           </a:p>
           <a:p xmlns:a="http://schemas.openxmlformats.org/drawingml/2006/main">
@@ -26759,7 +26740,7 @@
               <a:buChar char="●"/>
             </a:pPr>
             <a:r>
-              <a:t>KLayout vectors remain coordinate truth</a:t>
+              <a:t>Object recall 99.36%; precision 73.12%</a:t>
             </a:r>
           </a:p>
         </p:txBody>
@@ -26848,7 +26829,7 @@
           <p:nvPr/>
         </p:nvPicPr>
         <p:blipFill rotWithShape="1">
-          <a:blip xmlns:r="http://schemas.openxmlformats.org/officeDocument/2006/relationships" xmlns:a="http://schemas.openxmlformats.org/drawingml/2006/main" r:embed="R2b25a7550cf442ea">
+          <a:blip xmlns:r="http://schemas.openxmlformats.org/officeDocument/2006/relationships" xmlns:a="http://schemas.openxmlformats.org/drawingml/2006/main" r:embed="R60a6c73b9c1b4b6d">
             <a:alphaModFix/>
           </a:blip>
           <a:srcRect xmlns:a="http://schemas.openxmlformats.org/drawingml/2006/main" l="0" t="0" r="0" b="0"/>
@@ -26876,7 +26857,7 @@
           <p:nvPr/>
         </p:nvPicPr>
         <p:blipFill rotWithShape="1">
-          <a:blip xmlns:r="http://schemas.openxmlformats.org/officeDocument/2006/relationships" xmlns:a="http://schemas.openxmlformats.org/drawingml/2006/main" r:embed="R767990aba61f46c2">
+          <a:blip xmlns:r="http://schemas.openxmlformats.org/officeDocument/2006/relationships" xmlns:a="http://schemas.openxmlformats.org/drawingml/2006/main" r:embed="R0b5653c24c954ba9">
             <a:alphaModFix/>
           </a:blip>
           <a:srcRect xmlns:a="http://schemas.openxmlformats.org/drawingml/2006/main" l="0" t="0" r="0" b="0"/>
@@ -27166,7 +27147,7 @@
           <p:nvPr/>
         </p:nvPicPr>
         <p:blipFill rotWithShape="1">
-          <a:blip xmlns:r="http://schemas.openxmlformats.org/officeDocument/2006/relationships" xmlns:a="http://schemas.openxmlformats.org/drawingml/2006/main" r:embed="R5aa819e5d43e48d3">
+          <a:blip xmlns:r="http://schemas.openxmlformats.org/officeDocument/2006/relationships" xmlns:a="http://schemas.openxmlformats.org/drawingml/2006/main" r:embed="R2d2c0d295a7e4259">
             <a:alphaModFix/>
           </a:blip>
           <a:srcRect xmlns:a="http://schemas.openxmlformats.org/drawingml/2006/main" l="0" t="0" r="0" b="0"/>
@@ -27479,7 +27460,7 @@
       </p:sp>
       <p:pic>
         <p:nvPicPr>
-          <p:cNvPr id="877" name="Google Shape;119;p17"/>
+          <p:cNvPr id="971" name="Google Shape;119;p17"/>
           <p:cNvPicPr>
             <a:picLocks xmlns:a="http://schemas.openxmlformats.org/drawingml/2006/main" noChangeAspect="1"/>
           </p:cNvPicPr>
@@ -27488,7 +27469,7 @@
           </p:nvPr>
         </p:nvPicPr>
         <p:blipFill rotWithShape="1">
-          <a:blip xmlns:r="http://schemas.openxmlformats.org/officeDocument/2006/relationships" xmlns:a="http://schemas.openxmlformats.org/drawingml/2006/main" r:embed="R24adc5675cd14c57">
+          <a:blip xmlns:r="http://schemas.openxmlformats.org/officeDocument/2006/relationships" xmlns:a="http://schemas.openxmlformats.org/drawingml/2006/main" r:embed="R9365620fc5674751">
             <a:alphaModFix/>
           </a:blip>
           <a:srcRect xmlns:a="http://schemas.openxmlformats.org/drawingml/2006/main" l="0" t="0" r="0" b="0"/>
@@ -27513,14 +27494,14 @@
       </p:pic>
       <p:pic>
         <p:nvPicPr>
-          <p:cNvPr id="878" name="Google Shape;120;p17"/>
+          <p:cNvPr id="972" name="Google Shape;120;p17"/>
           <p:cNvPicPr>
             <a:picLocks xmlns:a="http://schemas.openxmlformats.org/drawingml/2006/main" noChangeAspect="1"/>
           </p:cNvPicPr>
           <p:nvPr/>
         </p:nvPicPr>
         <p:blipFill rotWithShape="1">
-          <a:blip xmlns:r="http://schemas.openxmlformats.org/officeDocument/2006/relationships" xmlns:a="http://schemas.openxmlformats.org/drawingml/2006/main" r:embed="Re87a584e26ed4c0b">
+          <a:blip xmlns:r="http://schemas.openxmlformats.org/officeDocument/2006/relationships" xmlns:a="http://schemas.openxmlformats.org/drawingml/2006/main" r:embed="Rcee337d8800044c7">
             <a:alphaModFix/>
           </a:blip>
           <a:srcRect xmlns:a="http://schemas.openxmlformats.org/drawingml/2006/main" l="0" t="0" r="0" b="0"/>
@@ -27545,14 +27526,14 @@
       </p:pic>
       <p:pic>
         <p:nvPicPr>
-          <p:cNvPr id="879" name="Google Shape;122;p17"/>
+          <p:cNvPr id="973" name="Google Shape;122;p17"/>
           <p:cNvPicPr>
             <a:picLocks xmlns:a="http://schemas.openxmlformats.org/drawingml/2006/main" noChangeAspect="1"/>
           </p:cNvPicPr>
           <p:nvPr/>
         </p:nvPicPr>
         <p:blipFill rotWithShape="1">
-          <a:blip xmlns:r="http://schemas.openxmlformats.org/officeDocument/2006/relationships" xmlns:a="http://schemas.openxmlformats.org/drawingml/2006/main" r:embed="R44101218bc024b36">
+          <a:blip xmlns:r="http://schemas.openxmlformats.org/officeDocument/2006/relationships" xmlns:a="http://schemas.openxmlformats.org/drawingml/2006/main" r:embed="R0a6122d4f61343d1">
             <a:alphaModFix/>
           </a:blip>
           <a:srcRect xmlns:a="http://schemas.openxmlformats.org/drawingml/2006/main" l="0" t="0" r="0" b="0"/>
@@ -27842,14 +27823,14 @@
       </p:sp>
       <p:pic>
         <p:nvPicPr>
-          <p:cNvPr id="885" name="Google Shape;128;p17"/>
+          <p:cNvPr id="979" name="Google Shape;128;p17"/>
           <p:cNvPicPr>
             <a:picLocks xmlns:a="http://schemas.openxmlformats.org/drawingml/2006/main" noChangeAspect="1"/>
           </p:cNvPicPr>
           <p:nvPr/>
         </p:nvPicPr>
         <p:blipFill rotWithShape="1">
-          <a:blip xmlns:r="http://schemas.openxmlformats.org/officeDocument/2006/relationships" xmlns:a="http://schemas.openxmlformats.org/drawingml/2006/main" r:embed="Re87a584e26ed4c0b">
+          <a:blip xmlns:r="http://schemas.openxmlformats.org/officeDocument/2006/relationships" xmlns:a="http://schemas.openxmlformats.org/drawingml/2006/main" r:embed="Rcee337d8800044c7">
             <a:alphaModFix/>
           </a:blip>
           <a:srcRect xmlns:a="http://schemas.openxmlformats.org/drawingml/2006/main" l="0" t="0" r="0" b="0"/>
@@ -27874,7 +27855,7 @@
       </p:pic>
       <p:cxnSp>
         <p:nvCxnSpPr>
-          <p:cNvPr id="886" name="Google Shape;129;p17"/>
+          <p:cNvPr id="980" name="Google Shape;129;p17"/>
           <p:cNvCxnSpPr/>
           <p:nvPr/>
         </p:nvCxnSpPr>
@@ -27899,7 +27880,7 @@
       </p:cxnSp>
       <p:cxnSp>
         <p:nvCxnSpPr>
-          <p:cNvPr id="887" name="Google Shape;130;p17"/>
+          <p:cNvPr id="981" name="Google Shape;130;p17"/>
           <p:cNvCxnSpPr/>
           <p:nvPr/>
         </p:nvCxnSpPr>
@@ -27924,14 +27905,14 @@
       </p:cxnSp>
       <p:pic>
         <p:nvPicPr>
-          <p:cNvPr id="888" name="Google Shape;131;p17"/>
+          <p:cNvPr id="982" name="Google Shape;131;p17"/>
           <p:cNvPicPr>
             <a:picLocks xmlns:a="http://schemas.openxmlformats.org/drawingml/2006/main" noChangeAspect="1"/>
           </p:cNvPicPr>
           <p:nvPr/>
         </p:nvPicPr>
         <p:blipFill rotWithShape="1">
-          <a:blip xmlns:r="http://schemas.openxmlformats.org/officeDocument/2006/relationships" xmlns:a="http://schemas.openxmlformats.org/drawingml/2006/main" r:embed="Ra6d547f839894c1f">
+          <a:blip xmlns:r="http://schemas.openxmlformats.org/officeDocument/2006/relationships" xmlns:a="http://schemas.openxmlformats.org/drawingml/2006/main" r:embed="Re968c4817cf64e52">
             <a:alphaModFix/>
           </a:blip>
           <a:srcRect xmlns:a="http://schemas.openxmlformats.org/drawingml/2006/main" l="0" t="0" r="0" b="0"/>
@@ -28217,14 +28198,14 @@
       </p:sp>
       <p:pic>
         <p:nvPicPr>
-          <p:cNvPr id="893" name="Google Shape;136;p17"/>
+          <p:cNvPr id="987" name="Google Shape;136;p17"/>
           <p:cNvPicPr>
             <a:picLocks xmlns:a="http://schemas.openxmlformats.org/drawingml/2006/main" noChangeAspect="1"/>
           </p:cNvPicPr>
           <p:nvPr/>
         </p:nvPicPr>
         <p:blipFill rotWithShape="1">
-          <a:blip xmlns:r="http://schemas.openxmlformats.org/officeDocument/2006/relationships" xmlns:a="http://schemas.openxmlformats.org/drawingml/2006/main" r:embed="R001161a28c854cb0">
+          <a:blip xmlns:r="http://schemas.openxmlformats.org/officeDocument/2006/relationships" xmlns:a="http://schemas.openxmlformats.org/drawingml/2006/main" r:embed="R00f487b7bfe54172">
             <a:alphaModFix/>
           </a:blip>
           <a:srcRect xmlns:a="http://schemas.openxmlformats.org/drawingml/2006/main" l="0" t="0" r="0" b="0"/>
@@ -28245,14 +28226,14 @@
       </p:pic>
       <p:pic>
         <p:nvPicPr>
-          <p:cNvPr id="894" name="Google Shape;137;p17"/>
+          <p:cNvPr id="988" name="Google Shape;137;p17"/>
           <p:cNvPicPr>
             <a:picLocks xmlns:a="http://schemas.openxmlformats.org/drawingml/2006/main" noChangeAspect="1"/>
           </p:cNvPicPr>
           <p:nvPr/>
         </p:nvPicPr>
         <p:blipFill rotWithShape="1">
-          <a:blip xmlns:r="http://schemas.openxmlformats.org/officeDocument/2006/relationships" xmlns:a="http://schemas.openxmlformats.org/drawingml/2006/main" r:embed="R1f9465d56645473c">
+          <a:blip xmlns:r="http://schemas.openxmlformats.org/officeDocument/2006/relationships" xmlns:a="http://schemas.openxmlformats.org/drawingml/2006/main" r:embed="Ra0071a1f193c4210">
             <a:alphaModFix/>
           </a:blip>
           <a:srcRect xmlns:a="http://schemas.openxmlformats.org/drawingml/2006/main" l="0" t="0" r="0" b="0"/>
@@ -28334,14 +28315,14 @@
       </p:sp>
       <p:pic>
         <p:nvPicPr>
-          <p:cNvPr id="896" name="Google Shape;139;p17"/>
+          <p:cNvPr id="990" name="Google Shape;139;p17"/>
           <p:cNvPicPr>
             <a:picLocks xmlns:a="http://schemas.openxmlformats.org/drawingml/2006/main" noChangeAspect="1"/>
           </p:cNvPicPr>
           <p:nvPr/>
         </p:nvPicPr>
         <p:blipFill rotWithShape="1">
-          <a:blip xmlns:r="http://schemas.openxmlformats.org/officeDocument/2006/relationships" xmlns:a="http://schemas.openxmlformats.org/drawingml/2006/main" r:embed="Rea6d0a952eed47cd">
+          <a:blip xmlns:r="http://schemas.openxmlformats.org/officeDocument/2006/relationships" xmlns:a="http://schemas.openxmlformats.org/drawingml/2006/main" r:embed="R2ceabc8b31014ecb">
             <a:alphaModFix/>
           </a:blip>
           <a:srcRect xmlns:a="http://schemas.openxmlformats.org/drawingml/2006/main" l="0" t="0" r="0" b="0"/>
@@ -28362,14 +28343,14 @@
       </p:pic>
       <p:pic>
         <p:nvPicPr>
-          <p:cNvPr id="897" name="Google Shape;140;p17"/>
+          <p:cNvPr id="991" name="Google Shape;140;p17"/>
           <p:cNvPicPr>
             <a:picLocks xmlns:a="http://schemas.openxmlformats.org/drawingml/2006/main" noChangeAspect="1"/>
           </p:cNvPicPr>
           <p:nvPr/>
         </p:nvPicPr>
         <p:blipFill rotWithShape="1">
-          <a:blip xmlns:r="http://schemas.openxmlformats.org/officeDocument/2006/relationships" xmlns:a="http://schemas.openxmlformats.org/drawingml/2006/main" r:embed="Reb63b93b6dae47f2">
+          <a:blip xmlns:r="http://schemas.openxmlformats.org/officeDocument/2006/relationships" xmlns:a="http://schemas.openxmlformats.org/drawingml/2006/main" r:embed="R1578337995eb44e3">
             <a:alphaModFix/>
           </a:blip>
           <a:srcRect xmlns:a="http://schemas.openxmlformats.org/drawingml/2006/main" l="0" t="0" r="0" b="0"/>
@@ -28639,7 +28620,7 @@
       </p:sp>
       <p:cxnSp>
         <p:nvCxnSpPr>
-          <p:cNvPr id="900" name="Google Shape;143;p17"/>
+          <p:cNvPr id="994" name="Google Shape;143;p17"/>
           <p:cNvCxnSpPr>
             <a:stCxn xmlns:a="http://schemas.openxmlformats.org/drawingml/2006/main" id="119" idx="3"/>
             <a:endCxn xmlns:a="http://schemas.openxmlformats.org/drawingml/2006/main" id="120" idx="1"/>
@@ -28667,7 +28648,7 @@
       </p:cxnSp>
       <p:cxnSp>
         <p:nvCxnSpPr>
-          <p:cNvPr id="901" name="Google Shape;144;p17"/>
+          <p:cNvPr id="995" name="Google Shape;144;p17"/>
           <p:cNvCxnSpPr>
             <a:endCxn xmlns:a="http://schemas.openxmlformats.org/drawingml/2006/main" id="128" idx="1"/>
           </p:cNvCxnSpPr>
@@ -28694,7 +28675,7 @@
       </p:cxnSp>
       <p:cxnSp>
         <p:nvCxnSpPr>
-          <p:cNvPr id="902" name="Google Shape;145;p17"/>
+          <p:cNvPr id="996" name="Google Shape;145;p17"/>
           <p:cNvCxnSpPr>
             <a:endCxn xmlns:a="http://schemas.openxmlformats.org/drawingml/2006/main" id="132" idx="1"/>
           </p:cNvCxnSpPr>
@@ -28721,7 +28702,7 @@
       </p:cxnSp>
       <p:cxnSp>
         <p:nvCxnSpPr>
-          <p:cNvPr id="903" name="Google Shape;146;p17"/>
+          <p:cNvPr id="997" name="Google Shape;146;p17"/>
           <p:cNvCxnSpPr>
             <a:endCxn xmlns:a="http://schemas.openxmlformats.org/drawingml/2006/main" id="135" idx="3"/>
           </p:cNvCxnSpPr>
@@ -28748,7 +28729,7 @@
       </p:cxnSp>
       <p:cxnSp>
         <p:nvCxnSpPr>
-          <p:cNvPr id="904" name="Google Shape;147;p17"/>
+          <p:cNvPr id="998" name="Google Shape;147;p17"/>
           <p:cNvCxnSpPr>
             <a:endCxn xmlns:a="http://schemas.openxmlformats.org/drawingml/2006/main" id="135" idx="0"/>
           </p:cNvCxnSpPr>
@@ -28775,7 +28756,7 @@
       </p:cxnSp>
       <p:cxnSp>
         <p:nvCxnSpPr>
-          <p:cNvPr id="905" name="Google Shape;148;p17"/>
+          <p:cNvPr id="999" name="Google Shape;148;p17"/>
           <p:cNvCxnSpPr>
             <a:stCxn xmlns:a="http://schemas.openxmlformats.org/drawingml/2006/main" id="132" idx="3"/>
             <a:endCxn xmlns:a="http://schemas.openxmlformats.org/drawingml/2006/main" id="133" idx="0"/>
@@ -28803,7 +28784,7 @@
       </p:cxnSp>
       <p:cxnSp>
         <p:nvCxnSpPr>
-          <p:cNvPr id="906" name="Google Shape;149;p17"/>
+          <p:cNvPr id="1000" name="Google Shape;149;p17"/>
           <p:cNvCxnSpPr>
             <a:stCxn xmlns:a="http://schemas.openxmlformats.org/drawingml/2006/main" id="133" idx="2"/>
             <a:endCxn xmlns:a="http://schemas.openxmlformats.org/drawingml/2006/main" id="131" idx="0"/>
@@ -28831,7 +28812,7 @@
       </p:cxnSp>
       <p:cxnSp>
         <p:nvCxnSpPr>
-          <p:cNvPr id="907" name="Google Shape;150;p17"/>
+          <p:cNvPr id="1001" name="Google Shape;150;p17"/>
           <p:cNvCxnSpPr>
             <a:stCxn xmlns:a="http://schemas.openxmlformats.org/drawingml/2006/main" id="135" idx="1"/>
             <a:endCxn xmlns:a="http://schemas.openxmlformats.org/drawingml/2006/main" id="136" idx="3"/>
@@ -28859,7 +28840,7 @@
       </p:cxnSp>
       <p:cxnSp>
         <p:nvCxnSpPr>
-          <p:cNvPr id="908" name="Google Shape;151;p17"/>
+          <p:cNvPr id="1002" name="Google Shape;151;p17"/>
           <p:cNvCxnSpPr>
             <a:stCxn xmlns:a="http://schemas.openxmlformats.org/drawingml/2006/main" id="135" idx="1"/>
             <a:endCxn xmlns:a="http://schemas.openxmlformats.org/drawingml/2006/main" id="137" idx="3"/>
@@ -28887,7 +28868,7 @@
       </p:cxnSp>
       <p:cxnSp>
         <p:nvCxnSpPr>
-          <p:cNvPr id="909" name="Google Shape;152;p17"/>
+          <p:cNvPr id="1003" name="Google Shape;152;p17"/>
           <p:cNvCxnSpPr/>
           <p:nvPr/>
         </p:nvCxnSpPr>
@@ -28912,7 +28893,7 @@
       </p:cxnSp>
       <p:cxnSp>
         <p:nvCxnSpPr>
-          <p:cNvPr id="910" name="Google Shape;153;p17"/>
+          <p:cNvPr id="1004" name="Google Shape;153;p17"/>
           <p:cNvCxnSpPr/>
           <p:nvPr/>
         </p:nvCxnSpPr>
@@ -28937,7 +28918,7 @@
       </p:cxnSp>
       <p:cxnSp>
         <p:nvCxnSpPr>
-          <p:cNvPr id="911" name="Google Shape;154;p17"/>
+          <p:cNvPr id="1005" name="Google Shape;154;p17"/>
           <p:cNvCxnSpPr/>
           <p:nvPr/>
         </p:nvCxnSpPr>
@@ -28962,7 +28943,7 @@
       </p:cxnSp>
       <p:cxnSp>
         <p:nvCxnSpPr>
-          <p:cNvPr id="912" name="Google Shape;155;p17"/>
+          <p:cNvPr id="1006" name="Google Shape;155;p17"/>
           <p:cNvCxnSpPr/>
           <p:nvPr/>
         </p:nvCxnSpPr>
@@ -28987,7 +28968,7 @@
       </p:cxnSp>
       <p:cxnSp>
         <p:nvCxnSpPr>
-          <p:cNvPr id="913" name="Google Shape;156;p17"/>
+          <p:cNvPr id="1007" name="Google Shape;156;p17"/>
           <p:cNvCxnSpPr/>
           <p:nvPr/>
         </p:nvCxnSpPr>
@@ -29376,7 +29357,7 @@
           </p:nvPr>
         </p:nvPicPr>
         <p:blipFill rotWithShape="1">
-          <a:blip xmlns:r="http://schemas.openxmlformats.org/officeDocument/2006/relationships" xmlns:a="http://schemas.openxmlformats.org/drawingml/2006/main" r:embed="Re9ac3dde755a413e">
+          <a:blip xmlns:r="http://schemas.openxmlformats.org/officeDocument/2006/relationships" xmlns:a="http://schemas.openxmlformats.org/drawingml/2006/main" r:embed="Rc8f421fc21264d7e">
             <a:alphaModFix/>
           </a:blip>
           <a:srcRect xmlns:a="http://schemas.openxmlformats.org/drawingml/2006/main" l="0" t="0" r="0" b="0"/>
@@ -29592,7 +29573,7 @@
           <p:nvPr/>
         </p:nvPicPr>
         <p:blipFill rotWithShape="1">
-          <a:blip xmlns:r="http://schemas.openxmlformats.org/officeDocument/2006/relationships" xmlns:a="http://schemas.openxmlformats.org/drawingml/2006/main" r:embed="R11affe4a9e744248">
+          <a:blip xmlns:r="http://schemas.openxmlformats.org/officeDocument/2006/relationships" xmlns:a="http://schemas.openxmlformats.org/drawingml/2006/main" r:embed="R3db648d735a048b5">
             <a:alphaModFix/>
           </a:blip>
           <a:srcRect xmlns:a="http://schemas.openxmlformats.org/drawingml/2006/main" l="0" t="0" r="0" b="0"/>
@@ -30323,7 +30304,7 @@
           <p:nvPr/>
         </p:nvPicPr>
         <p:blipFill rotWithShape="1">
-          <a:blip xmlns:r="http://schemas.openxmlformats.org/officeDocument/2006/relationships" xmlns:a="http://schemas.openxmlformats.org/drawingml/2006/main" r:embed="R5fd9c6984a064490">
+          <a:blip xmlns:r="http://schemas.openxmlformats.org/officeDocument/2006/relationships" xmlns:a="http://schemas.openxmlformats.org/drawingml/2006/main" r:embed="R0199a5bb3aba4670">
             <a:alphaModFix/>
           </a:blip>
           <a:srcRect xmlns:a="http://schemas.openxmlformats.org/drawingml/2006/main" l="0" t="0" r="0" b="0"/>
@@ -30351,7 +30332,7 @@
           <p:nvPr/>
         </p:nvPicPr>
         <p:blipFill rotWithShape="1">
-          <a:blip xmlns:r="http://schemas.openxmlformats.org/officeDocument/2006/relationships" xmlns:a="http://schemas.openxmlformats.org/drawingml/2006/main" r:embed="Ra2481d8c899f4b6d">
+          <a:blip xmlns:r="http://schemas.openxmlformats.org/officeDocument/2006/relationships" xmlns:a="http://schemas.openxmlformats.org/drawingml/2006/main" r:embed="Re284ea0790424350">
             <a:alphaModFix/>
           </a:blip>
           <a:srcRect xmlns:a="http://schemas.openxmlformats.org/drawingml/2006/main" l="0" t="0" r="0" b="0"/>
@@ -30379,7 +30360,7 @@
           <p:nvPr/>
         </p:nvPicPr>
         <p:blipFill rotWithShape="1">
-          <a:blip xmlns:r="http://schemas.openxmlformats.org/officeDocument/2006/relationships" xmlns:a="http://schemas.openxmlformats.org/drawingml/2006/main" r:embed="Ree5f9c4284494c18">
+          <a:blip xmlns:r="http://schemas.openxmlformats.org/officeDocument/2006/relationships" xmlns:a="http://schemas.openxmlformats.org/drawingml/2006/main" r:embed="Rcb4f5922b13b4f13">
             <a:alphaModFix/>
           </a:blip>
           <a:srcRect xmlns:a="http://schemas.openxmlformats.org/drawingml/2006/main" l="0" t="0" r="0" b="0"/>
@@ -30775,7 +30756,7 @@
               <a:buNone/>
             </a:pPr>
             <a:r>
-              <a:t>B0–B6.1 complete · multi-task U-Net training next</a:t>
+              <a:t>B0–B6.2 complete · exact-coordinate recovery next</a:t>
             </a:r>
           </a:p>
         </p:txBody>

</xml_diff>

<commit_message>
Record accepted B7.1 full-layout result
</commit_message>
<xml_diff>
--- a/presentation/ADVLSI2_DRC_CNN_Project_Progress.pptx
+++ b/presentation/ADVLSI2_DRC_CNN_Project_Progress.pptx
@@ -2,48 +2,49 @@
 <file path=ppt/presentation.xml><?xml version="1.0" encoding="utf-8"?>
 <p:presentation xmlns:p="http://schemas.openxmlformats.org/presentationml/2006/main" embedTrueTypeFonts="1" saveSubsetFonts="0">
   <p:sldMasterIdLst>
-    <p:sldMasterId xmlns:r="http://schemas.openxmlformats.org/officeDocument/2006/relationships" id="2147483648" r:id="Rd270b55a86964462"/>
+    <p:sldMasterId xmlns:r="http://schemas.openxmlformats.org/officeDocument/2006/relationships" id="2147483648" r:id="Rf6646fc1a5044a1a"/>
   </p:sldMasterIdLst>
   <p:notesMasterIdLst>
-    <p:notesMasterId xmlns:r="http://schemas.openxmlformats.org/officeDocument/2006/relationships" r:id="R26bb4a37c7e2481d"/>
+    <p:notesMasterId xmlns:r="http://schemas.openxmlformats.org/officeDocument/2006/relationships" r:id="Rb0171bdc05864930"/>
   </p:notesMasterIdLst>
   <p:sldIdLst>
-    <p:sldId xmlns:r="http://schemas.openxmlformats.org/officeDocument/2006/relationships" id="256" r:id="R784367d400bf44b8"/>
-    <p:sldId xmlns:r="http://schemas.openxmlformats.org/officeDocument/2006/relationships" id="257" r:id="Rf6f7618a027d4008"/>
-    <p:sldId xmlns:r="http://schemas.openxmlformats.org/officeDocument/2006/relationships" id="258" r:id="Re18f0d80924d4b28"/>
-    <p:sldId xmlns:r="http://schemas.openxmlformats.org/officeDocument/2006/relationships" id="259" r:id="Rd3252ee39b034fe0"/>
-    <p:sldId xmlns:r="http://schemas.openxmlformats.org/officeDocument/2006/relationships" id="260" r:id="Rb17057fab46b45a1"/>
-    <p:sldId xmlns:r="http://schemas.openxmlformats.org/officeDocument/2006/relationships" id="261" r:id="R7b729287e1ec429e"/>
-    <p:sldId xmlns:r="http://schemas.openxmlformats.org/officeDocument/2006/relationships" id="262" r:id="R789e758bccf04217"/>
-    <p:sldId xmlns:r="http://schemas.openxmlformats.org/officeDocument/2006/relationships" id="263" r:id="R2ed7910aa0974222"/>
-    <p:sldId xmlns:r="http://schemas.openxmlformats.org/officeDocument/2006/relationships" id="264" r:id="Rb6f6ac85c7c34cd2"/>
-    <p:sldId xmlns:r="http://schemas.openxmlformats.org/officeDocument/2006/relationships" id="265" r:id="R1fad68ac81dd4db7"/>
-    <p:sldId xmlns:r="http://schemas.openxmlformats.org/officeDocument/2006/relationships" id="266" r:id="R8b7169f71ee34ba6"/>
-    <p:sldId xmlns:r="http://schemas.openxmlformats.org/officeDocument/2006/relationships" id="267" r:id="R33bd69254c154c5d"/>
-    <p:sldId xmlns:r="http://schemas.openxmlformats.org/officeDocument/2006/relationships" id="268" r:id="R44dee50c22384e81"/>
-    <p:sldId xmlns:r="http://schemas.openxmlformats.org/officeDocument/2006/relationships" id="269" r:id="Raa0e42ffdada4e13"/>
-    <p:sldId xmlns:r="http://schemas.openxmlformats.org/officeDocument/2006/relationships" id="270" r:id="R55f01844028d4aa3"/>
-    <p:sldId xmlns:r="http://schemas.openxmlformats.org/officeDocument/2006/relationships" id="271" r:id="Rb5ecf20664294619"/>
-    <p:sldId xmlns:r="http://schemas.openxmlformats.org/officeDocument/2006/relationships" id="272" r:id="R6c04e864544d4a50"/>
-    <p:sldId xmlns:r="http://schemas.openxmlformats.org/officeDocument/2006/relationships" id="273" r:id="Ra8c6882a28ca4212"/>
-    <p:sldId xmlns:r="http://schemas.openxmlformats.org/officeDocument/2006/relationships" id="274" r:id="R4cd251490db54d1d"/>
-    <p:sldId xmlns:r="http://schemas.openxmlformats.org/officeDocument/2006/relationships" id="275" r:id="R65ca00a827e1434f"/>
-    <p:sldId xmlns:r="http://schemas.openxmlformats.org/officeDocument/2006/relationships" id="276" r:id="R1f2265feb795470e"/>
-    <p:sldId xmlns:r="http://schemas.openxmlformats.org/officeDocument/2006/relationships" id="277" r:id="R2bba9b86f04a47f7"/>
-    <p:sldId xmlns:r="http://schemas.openxmlformats.org/officeDocument/2006/relationships" id="278" r:id="Rbd0a6ac5f4314ef2"/>
-    <p:sldId xmlns:r="http://schemas.openxmlformats.org/officeDocument/2006/relationships" id="279" r:id="Rc383af52e12543b8"/>
-    <p:sldId xmlns:r="http://schemas.openxmlformats.org/officeDocument/2006/relationships" id="280" r:id="R96015069773d4773"/>
-    <p:sldId xmlns:r="http://schemas.openxmlformats.org/officeDocument/2006/relationships" id="281" r:id="R94dbf8bc649e4264"/>
-    <p:sldId xmlns:r="http://schemas.openxmlformats.org/officeDocument/2006/relationships" id="282" r:id="R00ba191be8614c96"/>
-    <p:sldId xmlns:r="http://schemas.openxmlformats.org/officeDocument/2006/relationships" id="283" r:id="R2a92c752dd7648a1"/>
+    <p:sldId xmlns:r="http://schemas.openxmlformats.org/officeDocument/2006/relationships" id="256" r:id="R473d248b85e3432e"/>
+    <p:sldId xmlns:r="http://schemas.openxmlformats.org/officeDocument/2006/relationships" id="257" r:id="R493242bc866d4bc3"/>
+    <p:sldId xmlns:r="http://schemas.openxmlformats.org/officeDocument/2006/relationships" id="258" r:id="R700f233335824651"/>
+    <p:sldId xmlns:r="http://schemas.openxmlformats.org/officeDocument/2006/relationships" id="259" r:id="Rfd43c99577654f5e"/>
+    <p:sldId xmlns:r="http://schemas.openxmlformats.org/officeDocument/2006/relationships" id="260" r:id="Rfa13f559a9b6430d"/>
+    <p:sldId xmlns:r="http://schemas.openxmlformats.org/officeDocument/2006/relationships" id="261" r:id="Rf7f1a52b45ef4aac"/>
+    <p:sldId xmlns:r="http://schemas.openxmlformats.org/officeDocument/2006/relationships" id="262" r:id="Rc172e0c9def1440f"/>
+    <p:sldId xmlns:r="http://schemas.openxmlformats.org/officeDocument/2006/relationships" id="263" r:id="Rbcae3d58b5a4410c"/>
+    <p:sldId xmlns:r="http://schemas.openxmlformats.org/officeDocument/2006/relationships" id="264" r:id="Re2985ee495c3441e"/>
+    <p:sldId xmlns:r="http://schemas.openxmlformats.org/officeDocument/2006/relationships" id="265" r:id="R503dda376cc24660"/>
+    <p:sldId xmlns:r="http://schemas.openxmlformats.org/officeDocument/2006/relationships" id="266" r:id="R2aac68d777d7490e"/>
+    <p:sldId xmlns:r="http://schemas.openxmlformats.org/officeDocument/2006/relationships" id="267" r:id="Rfa67ed9bfe204425"/>
+    <p:sldId xmlns:r="http://schemas.openxmlformats.org/officeDocument/2006/relationships" id="268" r:id="R52cb85386a4a4ddf"/>
+    <p:sldId xmlns:r="http://schemas.openxmlformats.org/officeDocument/2006/relationships" id="269" r:id="Ra4a603b927a042b6"/>
+    <p:sldId xmlns:r="http://schemas.openxmlformats.org/officeDocument/2006/relationships" id="270" r:id="Re6976dfbc96c46f1"/>
+    <p:sldId xmlns:r="http://schemas.openxmlformats.org/officeDocument/2006/relationships" id="271" r:id="R61fc1015ddb14c74"/>
+    <p:sldId xmlns:r="http://schemas.openxmlformats.org/officeDocument/2006/relationships" id="272" r:id="R78f458a191084229"/>
+    <p:sldId xmlns:r="http://schemas.openxmlformats.org/officeDocument/2006/relationships" id="273" r:id="R50ed91069f57414b"/>
+    <p:sldId xmlns:r="http://schemas.openxmlformats.org/officeDocument/2006/relationships" id="274" r:id="Rcb73719f3d70494f"/>
+    <p:sldId xmlns:r="http://schemas.openxmlformats.org/officeDocument/2006/relationships" id="275" r:id="Rfa08e12c9ae44eb5"/>
+    <p:sldId xmlns:r="http://schemas.openxmlformats.org/officeDocument/2006/relationships" id="276" r:id="R4595022a0d22432a"/>
+    <p:sldId xmlns:r="http://schemas.openxmlformats.org/officeDocument/2006/relationships" id="277" r:id="R15ddde53e61b436a"/>
+    <p:sldId xmlns:r="http://schemas.openxmlformats.org/officeDocument/2006/relationships" id="278" r:id="R8fea7f05cc724ab6"/>
+    <p:sldId xmlns:r="http://schemas.openxmlformats.org/officeDocument/2006/relationships" id="279" r:id="R6bdd30de3fa54412"/>
+    <p:sldId xmlns:r="http://schemas.openxmlformats.org/officeDocument/2006/relationships" id="280" r:id="R50845b6994544489"/>
+    <p:sldId xmlns:r="http://schemas.openxmlformats.org/officeDocument/2006/relationships" id="281" r:id="Re254872c49c143a2"/>
+    <p:sldId xmlns:r="http://schemas.openxmlformats.org/officeDocument/2006/relationships" id="282" r:id="R1ff107fa12db4c5f"/>
+    <p:sldId xmlns:r="http://schemas.openxmlformats.org/officeDocument/2006/relationships" id="283" r:id="Re29547a3707b46b1"/>
+    <p:sldId xmlns:r="http://schemas.openxmlformats.org/officeDocument/2006/relationships" id="284" r:id="R1e5ba12c1a99438c"/>
   </p:sldIdLst>
   <p:sldSz cx="12192000" cy="6858000"/>
   <p:notesSz cx="6858000" cy="9144000"/>
   <p:embeddedFontLst>
     <p:embeddedFont>
       <p:font typeface="Play"/>
-      <p:regular xmlns:r="http://schemas.openxmlformats.org/officeDocument/2006/relationships" r:id="R57c67886a7e04682"/>
-      <p:bold xmlns:r="http://schemas.openxmlformats.org/officeDocument/2006/relationships" r:id="R67126723a388413f"/>
+      <p:regular xmlns:r="http://schemas.openxmlformats.org/officeDocument/2006/relationships" r:id="R32f3b50f7fc740c9"/>
+      <p:bold xmlns:r="http://schemas.openxmlformats.org/officeDocument/2006/relationships" r:id="R1024a9de4a3547c8"/>
     </p:embeddedFont>
   </p:embeddedFontLst>
 </p:presentation>
@@ -553,6 +554,13 @@
               <a:t>[/Sources]</a:t>
             </a:r>
           </a:p>
+          <a:p xmlns:a="http://schemas.openxmlformats.org/drawingml/2006/main">
+            <a:r>
+              <a:t>
+[Sources]
+- results/b7_full_layout/b7_1_summary.json and results/b7_full_layout/README.md; measured 2026-08-15; validation-only policy selection; B9 unopened.</a:t>
+            </a:r>
+          </a:p>
         </p:txBody>
       </p:sp>
       <p:sp>
@@ -1042,6 +1050,13 @@
               <a:t>[/Sources]</a:t>
             </a:r>
           </a:p>
+          <a:p xmlns:a="http://schemas.openxmlformats.org/drawingml/2006/main">
+            <a:r>
+              <a:t>
+[Sources]
+- results/b7_full_layout/b7_1_summary.json and results/b7_full_layout/README.md; measured 2026-08-15; validation-only policy selection; B9 unopened.</a:t>
+            </a:r>
+          </a:p>
         </p:txBody>
       </p:sp>
       <p:sp>
@@ -1219,6 +1234,13 @@
               <a:t>[/Sources]</a:t>
             </a:r>
           </a:p>
+          <a:p xmlns:a="http://schemas.openxmlformats.org/drawingml/2006/main">
+            <a:r>
+              <a:t>
+[Sources]
+- results/b7_full_layout/b7_1_summary.json and results/b7_full_layout/README.md; measured 2026-08-15; validation-only policy selection; B9 unopened.</a:t>
+            </a:r>
+          </a:p>
         </p:txBody>
       </p:sp>
       <p:sp>
@@ -2987,6 +3009,162 @@
 </p:notes>
 </file>
 
+<file path=ppt/notesSlides/notesSlide29.xml><?xml version="1.0" encoding="utf-8"?>
+<p:notes xmlns:p="http://schemas.openxmlformats.org/presentationml/2006/main">
+  <p:cSld>
+    <p:spTree>
+      <p:nvGrpSpPr>
+        <p:cNvPr id="1" name=""/>
+        <p:cNvGrpSpPr/>
+        <p:nvPr/>
+      </p:nvGrpSpPr>
+      <p:grpSpPr>
+        <a:xfrm xmlns:a="http://schemas.openxmlformats.org/drawingml/2006/main"/>
+      </p:grpSpPr>
+      <p:sp>
+        <p:nvSpPr>
+          <p:cNvPr id="2" name="Slide Image Placeholder 1"/>
+          <p:cNvSpPr>
+            <a:spLocks xmlns:a="http://schemas.openxmlformats.org/drawingml/2006/main" noGrp="1"/>
+          </p:cNvSpPr>
+          <p:nvPr>
+            <p:ph type="sldImg" idx="0"/>
+          </p:nvPr>
+        </p:nvSpPr>
+        <p:spPr/>
+      </p:sp>
+      <p:sp>
+        <p:nvSpPr>
+          <p:cNvPr id="3" name="Notes Placeholder 2"/>
+          <p:cNvSpPr>
+            <a:spLocks xmlns:a="http://schemas.openxmlformats.org/drawingml/2006/main" noGrp="1"/>
+          </p:cNvSpPr>
+          <p:nvPr>
+            <p:ph type="body" idx="1"/>
+          </p:nvPr>
+        </p:nvSpPr>
+        <p:spPr/>
+        <p:txBody>
+          <a:bodyPr xmlns:a="http://schemas.openxmlformats.org/drawingml/2006/main"/>
+          <a:lstStyle xmlns:a="http://schemas.openxmlformats.org/drawingml/2006/main"/>
+          <a:p xmlns:a="http://schemas.openxmlformats.org/drawingml/2006/main">
+            <a:pPr marL="0" indent="0" algn="l">
+              <a:spcBef>
+                <a:spcPts val="0"/>
+              </a:spcBef>
+              <a:spcAft>
+                <a:spcPts val="0"/>
+              </a:spcAft>
+              <a:buNone/>
+            </a:pPr>
+            <a:r>
+              <a:t>[Sources]</a:t>
+            </a:r>
+          </a:p>
+          <a:p xmlns:a="http://schemas.openxmlformats.org/drawingml/2006/main">
+            <a:pPr marL="0" indent="0" algn="l">
+              <a:spcBef>
+                <a:spcPts val="0"/>
+              </a:spcBef>
+              <a:spcAft>
+                <a:spcPts val="0"/>
+              </a:spcAft>
+              <a:buNone/>
+            </a:pPr>
+            <a:r>
+              <a:t>- results/b6_multitask_unet/summary.json</a:t>
+            </a:r>
+          </a:p>
+          <a:p xmlns:a="http://schemas.openxmlformats.org/drawingml/2006/main">
+            <a:pPr marL="0" indent="0" algn="l">
+              <a:spcBef>
+                <a:spcPts val="0"/>
+              </a:spcBef>
+              <a:spcAft>
+                <a:spcPts val="0"/>
+              </a:spcAft>
+              <a:buNone/>
+            </a:pPr>
+            <a:r>
+              <a:t>- results/b6_multitask_unet/runs/seed_42.json</a:t>
+            </a:r>
+          </a:p>
+          <a:p xmlns:a="http://schemas.openxmlformats.org/drawingml/2006/main">
+            <a:pPr marL="0" indent="0" algn="l">
+              <a:spcBef>
+                <a:spcPts val="0"/>
+              </a:spcBef>
+              <a:spcAft>
+                <a:spcPts val="0"/>
+              </a:spcAft>
+              <a:buNone/>
+            </a:pPr>
+            <a:r>
+              <a:t>- results/b6_multitask_unet/runs/seed_43.json</a:t>
+            </a:r>
+          </a:p>
+          <a:p xmlns:a="http://schemas.openxmlformats.org/drawingml/2006/main">
+            <a:pPr marL="0" indent="0" algn="l">
+              <a:spcBef>
+                <a:spcPts val="0"/>
+              </a:spcBef>
+              <a:spcAft>
+                <a:spcPts val="0"/>
+              </a:spcAft>
+              <a:buNone/>
+            </a:pPr>
+            <a:r>
+              <a:t>- results/b6_multitask_unet/runs/seed_44.json</a:t>
+            </a:r>
+          </a:p>
+          <a:p xmlns:a="http://schemas.openxmlformats.org/drawingml/2006/main">
+            <a:pPr marL="0" indent="0" algn="l">
+              <a:spcBef>
+                <a:spcPts val="0"/>
+              </a:spcBef>
+              <a:spcAft>
+                <a:spcPts val="0"/>
+              </a:spcAft>
+              <a:buNone/>
+            </a:pPr>
+            <a:r>
+              <a:t>[/Sources]</a:t>
+            </a:r>
+          </a:p>
+          <a:p xmlns:a="http://schemas.openxmlformats.org/drawingml/2006/main">
+            <a:r>
+              <a:t>
+[Sources]
+- results/b7_full_layout/b7_1_summary.json and results/b7_full_layout/README.md; measured 2026-08-15; validation-only policy selection; B9 unopened.</a:t>
+            </a:r>
+          </a:p>
+        </p:txBody>
+      </p:sp>
+      <p:sp>
+        <p:nvSpPr>
+          <p:cNvPr id="4" name="Slide Number Placeholder 3"/>
+          <p:cNvSpPr>
+            <a:spLocks xmlns:a="http://schemas.openxmlformats.org/drawingml/2006/main" noGrp="1"/>
+          </p:cNvSpPr>
+          <p:nvPr>
+            <p:ph type="sldNum" idx="5"/>
+          </p:nvPr>
+        </p:nvSpPr>
+        <p:spPr/>
+        <p:txBody>
+          <a:bodyPr xmlns:a="http://schemas.openxmlformats.org/drawingml/2006/main"/>
+          <a:lstStyle xmlns:a="http://schemas.openxmlformats.org/drawingml/2006/main"/>
+          <a:p xmlns:a="http://schemas.openxmlformats.org/drawingml/2006/main"/>
+        </p:txBody>
+      </p:sp>
+    </p:spTree>
+  </p:cSld>
+  <p:clrMapOvr>
+    <a:masterClrMapping xmlns:a="http://schemas.openxmlformats.org/drawingml/2006/main"/>
+  </p:clrMapOvr>
+</p:notes>
+</file>
+
 <file path=ppt/notesSlides/notesSlide3.xml><?xml version="1.0" encoding="utf-8"?>
 <p:notes xmlns:p="http://schemas.openxmlformats.org/presentationml/2006/main">
   <p:cSld>
@@ -3651,6 +3829,13 @@
             </a:pPr>
             <a:r>
               <a:t>[/Sources]</a:t>
+            </a:r>
+          </a:p>
+          <a:p xmlns:a="http://schemas.openxmlformats.org/drawingml/2006/main">
+            <a:r>
+              <a:t>
+[Sources]
+- results/b7_full_layout/b7_1_summary.json and results/b7_full_layout/README.md; measured 2026-08-15; validation-only policy selection; B9 unopened.</a:t>
             </a:r>
           </a:p>
         </p:txBody>
@@ -12421,17 +12606,17 @@
   </p:cSld>
   <p:clrMap bg1="lt1" tx1="dk1" bg2="dk2" tx2="lt2" accent1="accent1" accent2="accent2" accent3="accent3" accent4="accent4" accent5="accent5" accent6="accent6" hlink="hlink" folHlink="folHlink"/>
   <p:sldLayoutIdLst>
-    <p:sldLayoutId xmlns:r="http://schemas.openxmlformats.org/officeDocument/2006/relationships" id="2147483649" r:id="R1be4db58d4614cc9"/>
-    <p:sldLayoutId xmlns:r="http://schemas.openxmlformats.org/officeDocument/2006/relationships" id="2147483650" r:id="R154439db0c4f4d4d"/>
-    <p:sldLayoutId xmlns:r="http://schemas.openxmlformats.org/officeDocument/2006/relationships" id="2147483651" r:id="Rae1181e3b6b14569"/>
-    <p:sldLayoutId xmlns:r="http://schemas.openxmlformats.org/officeDocument/2006/relationships" id="2147483652" r:id="R1f956cd0440743d5"/>
-    <p:sldLayoutId xmlns:r="http://schemas.openxmlformats.org/officeDocument/2006/relationships" id="2147483653" r:id="R07137ea51dc7464d"/>
-    <p:sldLayoutId xmlns:r="http://schemas.openxmlformats.org/officeDocument/2006/relationships" id="2147483654" r:id="R2c3886ab91504234"/>
-    <p:sldLayoutId xmlns:r="http://schemas.openxmlformats.org/officeDocument/2006/relationships" id="2147483655" r:id="R709c60d01f774304"/>
-    <p:sldLayoutId xmlns:r="http://schemas.openxmlformats.org/officeDocument/2006/relationships" id="2147483656" r:id="R61d5eac25a814186"/>
-    <p:sldLayoutId xmlns:r="http://schemas.openxmlformats.org/officeDocument/2006/relationships" id="2147483657" r:id="Rb37627820fed4f99"/>
-    <p:sldLayoutId xmlns:r="http://schemas.openxmlformats.org/officeDocument/2006/relationships" id="2147483658" r:id="Rca43e02437604d1d"/>
-    <p:sldLayoutId xmlns:r="http://schemas.openxmlformats.org/officeDocument/2006/relationships" id="2147483659" r:id="R4f39db1c868a44e5"/>
+    <p:sldLayoutId xmlns:r="http://schemas.openxmlformats.org/officeDocument/2006/relationships" id="2147483649" r:id="R0c127dc816104192"/>
+    <p:sldLayoutId xmlns:r="http://schemas.openxmlformats.org/officeDocument/2006/relationships" id="2147483650" r:id="R31a69b014d9e49a2"/>
+    <p:sldLayoutId xmlns:r="http://schemas.openxmlformats.org/officeDocument/2006/relationships" id="2147483651" r:id="R7efeb80b2fec4f78"/>
+    <p:sldLayoutId xmlns:r="http://schemas.openxmlformats.org/officeDocument/2006/relationships" id="2147483652" r:id="R757b0c29a6594129"/>
+    <p:sldLayoutId xmlns:r="http://schemas.openxmlformats.org/officeDocument/2006/relationships" id="2147483653" r:id="Ra0b9ca24321e48c4"/>
+    <p:sldLayoutId xmlns:r="http://schemas.openxmlformats.org/officeDocument/2006/relationships" id="2147483654" r:id="Re689639930af49d6"/>
+    <p:sldLayoutId xmlns:r="http://schemas.openxmlformats.org/officeDocument/2006/relationships" id="2147483655" r:id="R179d712a9c34429a"/>
+    <p:sldLayoutId xmlns:r="http://schemas.openxmlformats.org/officeDocument/2006/relationships" id="2147483656" r:id="R5fd02340475c42df"/>
+    <p:sldLayoutId xmlns:r="http://schemas.openxmlformats.org/officeDocument/2006/relationships" id="2147483657" r:id="R7dd1bc142fe2425b"/>
+    <p:sldLayoutId xmlns:r="http://schemas.openxmlformats.org/officeDocument/2006/relationships" id="2147483658" r:id="R834370dc79ab4a55"/>
+    <p:sldLayoutId xmlns:r="http://schemas.openxmlformats.org/officeDocument/2006/relationships" id="2147483659" r:id="R43c2039de99545c9"/>
   </p:sldLayoutIdLst>
   <p:hf sldNum="0" hdr="0" ftr="0" dt="0"/>
   <p:txStyles>
@@ -13383,7 +13568,7 @@
               <a:buNone/>
             </a:pPr>
             <a:r>
-              <a:t>CNN-based DRC | B0–B6.2 complete · exact edge recovery next</a:t>
+              <a:t>CNN-based DRC | B0–B7.1 complete · verified repair next</a:t>
             </a:r>
           </a:p>
         </p:txBody>
@@ -17400,7 +17585,7 @@
               <a:buChar char="●"/>
             </a:pPr>
             <a:r>
-              <a:t>B7  Exact coordinates — next</a:t>
+              <a:t>B7.1  Exact recovery — accepted</a:t>
             </a:r>
           </a:p>
           <a:p xmlns:a="http://schemas.openxmlformats.org/drawingml/2006/main">
@@ -17414,7 +17599,7 @@
               <a:buChar char="●"/>
             </a:pPr>
             <a:r>
-              <a:t>B8  Verified repair</a:t>
+              <a:t>B8  Verified repair — next</a:t>
             </a:r>
           </a:p>
           <a:p xmlns:a="http://schemas.openxmlformats.org/drawingml/2006/main">
@@ -17428,7 +17613,7 @@
               <a:buChar char="●"/>
             </a:pPr>
             <a:r>
-              <a:t>B9  Release candidate</a:t>
+              <a:t>B9  Sealed</a:t>
             </a:r>
           </a:p>
         </p:txBody>
@@ -17485,7 +17670,7 @@
                   <a:srgbClr val="404040"/>
                 </a:solidFill>
               </a:rPr>
-              <a:t>B6.2 passed all development gates; B7 turns high-recall masks into unique exact violations.</a:t>
+              <a:t>B7.1 passed full-layout gates: 95.51% recall, 81.44% precision, and 100% exact-pair precision.</a:t>
             </a:r>
           </a:p>
         </p:txBody>
@@ -19663,7 +19848,7 @@
                   <a:srgbClr val="73400D"/>
                 </a:solidFill>
               </a:rPr>
-              <a:t>B6.2 passes all gates; B7 now stitches masks, recovers exact edges, and measures full-layout false alarms.</a:t>
+              <a:t>B7.1 passes full-layout gates; B8 now converts exact edge pairs into verified repair proposals.</a:t>
             </a:r>
           </a:p>
         </p:txBody>
@@ -20013,7 +20198,7 @@
           </p:nvPr>
         </p:nvPicPr>
         <p:blipFill rotWithShape="1">
-          <a:blip xmlns:r="http://schemas.openxmlformats.org/officeDocument/2006/relationships" xmlns:a="http://schemas.openxmlformats.org/drawingml/2006/main" r:embed="Rfc36a133a9414af6">
+          <a:blip xmlns:r="http://schemas.openxmlformats.org/officeDocument/2006/relationships" xmlns:a="http://schemas.openxmlformats.org/drawingml/2006/main" r:embed="R738da81614c0421d">
             <a:alphaModFix/>
           </a:blip>
           <a:srcRect xmlns:a="http://schemas.openxmlformats.org/drawingml/2006/main" l="0" t="0" r="0" b="0"/>
@@ -20041,7 +20226,7 @@
           <p:nvPr/>
         </p:nvPicPr>
         <p:blipFill rotWithShape="1">
-          <a:blip xmlns:r="http://schemas.openxmlformats.org/officeDocument/2006/relationships" xmlns:a="http://schemas.openxmlformats.org/drawingml/2006/main" r:embed="R88d429f09ca04f03">
+          <a:blip xmlns:r="http://schemas.openxmlformats.org/officeDocument/2006/relationships" xmlns:a="http://schemas.openxmlformats.org/drawingml/2006/main" r:embed="Rd84827508b7b48fc">
             <a:alphaModFix/>
           </a:blip>
           <a:srcRect xmlns:a="http://schemas.openxmlformats.org/drawingml/2006/main" l="0" t="0" r="0" b="0"/>
@@ -26755,6 +26940,342 @@
 </p:sld>
 </file>
 
+<file path=ppt/slides/slide29.xml><?xml version="1.0" encoding="utf-8"?>
+<p:sld xmlns:p="http://schemas.openxmlformats.org/presentationml/2006/main">
+  <p:cSld>
+    <p:spTree>
+      <p:nvGrpSpPr>
+        <p:cNvPr id="1" name=""/>
+        <p:cNvGrpSpPr/>
+        <p:nvPr/>
+      </p:nvGrpSpPr>
+      <p:grpSpPr>
+        <a:xfrm xmlns:a="http://schemas.openxmlformats.org/drawingml/2006/main"/>
+      </p:grpSpPr>
+      <p:sp>
+        <p:nvSpPr>
+          <p:cNvPr id="202" name="Google Shape;202;p22">
+            <a:extLst xmlns:a="http://schemas.openxmlformats.org/drawingml/2006/main">
+              <a:ext uri="{FF2B5EF4-FFF2-40B4-BE49-F238E27FC236}">
+                <a16:creationId xmlns:a16="http://schemas.microsoft.com/office/drawing/2014/main" id="{C8118EBF-173B-493F-B181-80ED61AEAA88}"/>
+              </a:ext>
+            </a:extLst>
+          </p:cNvPr>
+          <p:cNvSpPr>
+            <a:spLocks xmlns:a="http://schemas.openxmlformats.org/drawingml/2006/main" noGrp="1"/>
+          </p:cNvSpPr>
+          <p:nvPr>
+            <p:ph type="title" idx="0"/>
+          </p:nvPr>
+        </p:nvSpPr>
+        <p:spPr>
+          <a:xfrm xmlns:a="http://schemas.openxmlformats.org/drawingml/2006/main">
+            <a:off x="839788" y="365125"/>
+            <a:ext cx="10515600" cy="1325700"/>
+          </a:xfrm>
+          <a:prstGeom xmlns:a="http://schemas.openxmlformats.org/drawingml/2006/main" prst="rect">
+            <a:avLst/>
+          </a:prstGeom>
+        </p:spPr>
+        <p:txBody>
+          <a:bodyPr xmlns:a="http://schemas.openxmlformats.org/drawingml/2006/main" spcFirstLastPara="1" wrap="square" lIns="91425" tIns="45700" rIns="91425" bIns="45700" anchor="ctr">
+            <a:noAutofit/>
+          </a:bodyPr>
+          <a:lstStyle xmlns:a="http://schemas.openxmlformats.org/drawingml/2006/main"/>
+          <a:p xmlns:a="http://schemas.openxmlformats.org/drawingml/2006/main">
+            <a:pPr marL="0" indent="0" algn="l">
+              <a:spcBef>
+                <a:spcPts val="0"/>
+              </a:spcBef>
+              <a:spcAft>
+                <a:spcPts val="0"/>
+              </a:spcAft>
+              <a:buNone/>
+            </a:pPr>
+            <a:r>
+              <a:t>B7.1 passes all full-layout gates</a:t>
+            </a:r>
+          </a:p>
+        </p:txBody>
+      </p:sp>
+      <p:sp>
+        <p:nvSpPr>
+          <p:cNvPr id="203" name="Google Shape;203;p22">
+            <a:extLst xmlns:a="http://schemas.openxmlformats.org/drawingml/2006/main">
+              <a:ext uri="{FF2B5EF4-FFF2-40B4-BE49-F238E27FC236}">
+                <a16:creationId xmlns:a16="http://schemas.microsoft.com/office/drawing/2014/main" id="{8C8967A8-AFDD-4A36-BD2A-6A37DA6F4631}"/>
+              </a:ext>
+            </a:extLst>
+          </p:cNvPr>
+          <p:cNvSpPr>
+            <a:spLocks xmlns:a="http://schemas.openxmlformats.org/drawingml/2006/main" noGrp="1"/>
+          </p:cNvSpPr>
+          <p:nvPr>
+            <p:ph type="body" idx="1"/>
+          </p:nvPr>
+        </p:nvSpPr>
+        <p:spPr>
+          <a:xfrm xmlns:a="http://schemas.openxmlformats.org/drawingml/2006/main">
+            <a:off x="839788" y="1681163"/>
+            <a:ext cx="5157900" cy="823800"/>
+          </a:xfrm>
+          <a:prstGeom xmlns:a="http://schemas.openxmlformats.org/drawingml/2006/main" prst="rect">
+            <a:avLst/>
+          </a:prstGeom>
+        </p:spPr>
+        <p:txBody>
+          <a:bodyPr xmlns:a="http://schemas.openxmlformats.org/drawingml/2006/main" spcFirstLastPara="1" wrap="square" lIns="91425" tIns="45700" rIns="91425" bIns="45700" anchor="b">
+            <a:noAutofit/>
+          </a:bodyPr>
+          <a:lstStyle xmlns:a="http://schemas.openxmlformats.org/drawingml/2006/main"/>
+          <a:p xmlns:a="http://schemas.openxmlformats.org/drawingml/2006/main">
+            <a:pPr marL="0" indent="0" algn="l">
+              <a:spcBef>
+                <a:spcPts val="1000"/>
+              </a:spcBef>
+              <a:spcAft>
+                <a:spcPts val="0"/>
+              </a:spcAft>
+              <a:buNone/>
+            </a:pPr>
+            <a:r>
+              <a:t>Validation-only policy</a:t>
+            </a:r>
+          </a:p>
+        </p:txBody>
+      </p:sp>
+      <p:sp>
+        <p:nvSpPr>
+          <p:cNvPr id="204" name="Google Shape;204;p22">
+            <a:extLst xmlns:a="http://schemas.openxmlformats.org/drawingml/2006/main">
+              <a:ext uri="{FF2B5EF4-FFF2-40B4-BE49-F238E27FC236}">
+                <a16:creationId xmlns:a16="http://schemas.microsoft.com/office/drawing/2014/main" id="{19A9097E-C301-4B04-A28D-C7CF5D1666DA}"/>
+              </a:ext>
+            </a:extLst>
+          </p:cNvPr>
+          <p:cNvSpPr>
+            <a:spLocks xmlns:a="http://schemas.openxmlformats.org/drawingml/2006/main" noGrp="1"/>
+          </p:cNvSpPr>
+          <p:nvPr>
+            <p:ph type="body" idx="2"/>
+          </p:nvPr>
+        </p:nvSpPr>
+        <p:spPr>
+          <a:xfrm xmlns:a="http://schemas.openxmlformats.org/drawingml/2006/main">
+            <a:off x="839788" y="2505075"/>
+            <a:ext cx="5157900" cy="3684600"/>
+          </a:xfrm>
+          <a:prstGeom xmlns:a="http://schemas.openxmlformats.org/drawingml/2006/main" prst="rect">
+            <a:avLst/>
+          </a:prstGeom>
+        </p:spPr>
+        <p:txBody>
+          <a:bodyPr xmlns:a="http://schemas.openxmlformats.org/drawingml/2006/main" spcFirstLastPara="1" wrap="square" lIns="91425" tIns="45700" rIns="91425" bIns="45700" anchor="t">
+            <a:noAutofit/>
+          </a:bodyPr>
+          <a:lstStyle xmlns:a="http://schemas.openxmlformats.org/drawingml/2006/main"/>
+          <a:p xmlns:a="http://schemas.openxmlformats.org/drawingml/2006/main">
+            <a:pPr marL="457200" indent="-342900" algn="l">
+              <a:spcBef>
+                <a:spcPts val="1000"/>
+              </a:spcBef>
+              <a:spcAft>
+                <a:spcPts val="0"/>
+              </a:spcAft>
+              <a:buChar char="●"/>
+            </a:pPr>
+            <a:r>
+              <a:t>Classification threshold: 0.92</a:t>
+            </a:r>
+          </a:p>
+          <a:p xmlns:a="http://schemas.openxmlformats.org/drawingml/2006/main">
+            <a:pPr marL="457200" indent="-342900" algn="l">
+              <a:spcBef>
+                <a:spcPts val="0"/>
+              </a:spcBef>
+              <a:spcAft>
+                <a:spcPts val="0"/>
+              </a:spcAft>
+              <a:buChar char="●"/>
+            </a:pPr>
+            <a:r>
+              <a:t>Segmentation threshold: 0.40</a:t>
+            </a:r>
+          </a:p>
+          <a:p xmlns:a="http://schemas.openxmlformats.org/drawingml/2006/main">
+            <a:pPr marL="457200" indent="-342900" algn="l">
+              <a:spcBef>
+                <a:spcPts val="0"/>
+              </a:spcBef>
+              <a:spcAft>
+                <a:spcPts val="0"/>
+              </a:spcAft>
+              <a:buChar char="●"/>
+            </a:pPr>
+            <a:r>
+              <a:t>Minimum area: 16 px</a:t>
+            </a:r>
+          </a:p>
+          <a:p xmlns:a="http://schemas.openxmlformats.org/drawingml/2006/main">
+            <a:pPr marL="457200" indent="-342900" algn="l">
+              <a:spcBef>
+                <a:spcPts val="0"/>
+              </a:spcBef>
+              <a:spcAft>
+                <a:spcPts val="0"/>
+              </a:spcAft>
+              <a:buChar char="●"/>
+            </a:pPr>
+            <a:r>
+              <a:t>Merge gap: 2 px</a:t>
+            </a:r>
+          </a:p>
+        </p:txBody>
+      </p:sp>
+      <p:sp>
+        <p:nvSpPr>
+          <p:cNvPr id="205" name="Google Shape;205;p22">
+            <a:extLst xmlns:a="http://schemas.openxmlformats.org/drawingml/2006/main">
+              <a:ext uri="{FF2B5EF4-FFF2-40B4-BE49-F238E27FC236}">
+                <a16:creationId xmlns:a16="http://schemas.microsoft.com/office/drawing/2014/main" id="{1E0BEAE3-F26D-4391-B700-136E11ECA92F}"/>
+              </a:ext>
+            </a:extLst>
+          </p:cNvPr>
+          <p:cNvSpPr>
+            <a:spLocks xmlns:a="http://schemas.openxmlformats.org/drawingml/2006/main" noGrp="1"/>
+          </p:cNvSpPr>
+          <p:nvPr>
+            <p:ph type="body" idx="3"/>
+          </p:nvPr>
+        </p:nvSpPr>
+        <p:spPr>
+          <a:xfrm xmlns:a="http://schemas.openxmlformats.org/drawingml/2006/main">
+            <a:off x="6172200" y="1681163"/>
+            <a:ext cx="5183100" cy="823800"/>
+          </a:xfrm>
+          <a:prstGeom xmlns:a="http://schemas.openxmlformats.org/drawingml/2006/main" prst="rect">
+            <a:avLst/>
+          </a:prstGeom>
+        </p:spPr>
+        <p:txBody>
+          <a:bodyPr xmlns:a="http://schemas.openxmlformats.org/drawingml/2006/main" spcFirstLastPara="1" wrap="square" lIns="91425" tIns="45700" rIns="91425" bIns="45700" anchor="b">
+            <a:noAutofit/>
+          </a:bodyPr>
+          <a:lstStyle xmlns:a="http://schemas.openxmlformats.org/drawingml/2006/main"/>
+          <a:p xmlns:a="http://schemas.openxmlformats.org/drawingml/2006/main">
+            <a:pPr marL="0" indent="0" algn="l">
+              <a:spcBef>
+                <a:spcPts val="1000"/>
+              </a:spcBef>
+              <a:spcAft>
+                <a:spcPts val="0"/>
+              </a:spcAft>
+              <a:buNone/>
+            </a:pPr>
+            <a:r>
+              <a:t>Development confirmation</a:t>
+            </a:r>
+          </a:p>
+        </p:txBody>
+      </p:sp>
+      <p:sp>
+        <p:nvSpPr>
+          <p:cNvPr id="206" name="Google Shape;206;p22">
+            <a:extLst xmlns:a="http://schemas.openxmlformats.org/drawingml/2006/main">
+              <a:ext uri="{FF2B5EF4-FFF2-40B4-BE49-F238E27FC236}">
+                <a16:creationId xmlns:a16="http://schemas.microsoft.com/office/drawing/2014/main" id="{76F59418-2FDB-4369-B235-930A4716F3F6}"/>
+              </a:ext>
+            </a:extLst>
+          </p:cNvPr>
+          <p:cNvSpPr>
+            <a:spLocks xmlns:a="http://schemas.openxmlformats.org/drawingml/2006/main" noGrp="1"/>
+          </p:cNvSpPr>
+          <p:nvPr>
+            <p:ph type="body" idx="4"/>
+          </p:nvPr>
+        </p:nvSpPr>
+        <p:spPr>
+          <a:xfrm xmlns:a="http://schemas.openxmlformats.org/drawingml/2006/main">
+            <a:off x="6172200" y="2505075"/>
+            <a:ext cx="5183100" cy="3684600"/>
+          </a:xfrm>
+          <a:prstGeom xmlns:a="http://schemas.openxmlformats.org/drawingml/2006/main" prst="rect">
+            <a:avLst/>
+          </a:prstGeom>
+        </p:spPr>
+        <p:txBody>
+          <a:bodyPr xmlns:a="http://schemas.openxmlformats.org/drawingml/2006/main" spcFirstLastPara="1" wrap="square" lIns="91425" tIns="45700" rIns="91425" bIns="45700" anchor="t">
+            <a:noAutofit/>
+          </a:bodyPr>
+          <a:lstStyle xmlns:a="http://schemas.openxmlformats.org/drawingml/2006/main"/>
+          <a:p xmlns:a="http://schemas.openxmlformats.org/drawingml/2006/main">
+            <a:pPr marL="457200" indent="-342900" algn="l">
+              <a:spcBef>
+                <a:spcPts val="1000"/>
+              </a:spcBef>
+              <a:spcAft>
+                <a:spcPts val="0"/>
+              </a:spcAft>
+              <a:buChar char="●"/>
+            </a:pPr>
+            <a:r>
+              <a:t>Violation recall: 95.51%</a:t>
+            </a:r>
+          </a:p>
+          <a:p xmlns:a="http://schemas.openxmlformats.org/drawingml/2006/main">
+            <a:pPr marL="457200" indent="-342900" algn="l">
+              <a:spcBef>
+                <a:spcPts val="0"/>
+              </a:spcBef>
+              <a:spcAft>
+                <a:spcPts val="0"/>
+              </a:spcAft>
+              <a:buChar char="●"/>
+            </a:pPr>
+            <a:r>
+              <a:t>Candidate precision: 81.44%</a:t>
+            </a:r>
+          </a:p>
+          <a:p xmlns:a="http://schemas.openxmlformats.org/drawingml/2006/main">
+            <a:pPr marL="457200" indent="-342900" algn="l">
+              <a:spcBef>
+                <a:spcPts val="0"/>
+              </a:spcBef>
+              <a:spcAft>
+                <a:spcPts val="0"/>
+              </a:spcAft>
+              <a:buChar char="●"/>
+            </a:pPr>
+            <a:r>
+              <a:t>Component F1: 87.92%</a:t>
+            </a:r>
+          </a:p>
+          <a:p xmlns:a="http://schemas.openxmlformats.org/drawingml/2006/main">
+            <a:pPr marL="457200" indent="-342900" algn="l">
+              <a:spcBef>
+                <a:spcPts val="0"/>
+              </a:spcBef>
+              <a:spcAft>
+                <a:spcPts val="0"/>
+              </a:spcAft>
+              <a:buChar char="●"/>
+            </a:pPr>
+            <a:r>
+              <a:t>Exact-pair precision: 100%</a:t>
+            </a:r>
+          </a:p>
+        </p:txBody>
+      </p:sp>
+    </p:spTree>
+    <p:extLst>
+      <p:ext uri="{BB962C8B-B14F-4D97-AF65-F5344CB8AC3E}">
+        <p14:creationId xmlns:p14="http://schemas.microsoft.com/office/powerpoint/2010/main" val="1161288531"/>
+      </p:ext>
+    </p:extLst>
+  </p:cSld>
+</p:sld>
+</file>
+
 <file path=ppt/slides/slide3.xml><?xml version="1.0" encoding="utf-8"?>
 <p:sld xmlns:p="http://schemas.openxmlformats.org/presentationml/2006/main">
   <p:cSld>
@@ -26829,7 +27350,7 @@
           <p:nvPr/>
         </p:nvPicPr>
         <p:blipFill rotWithShape="1">
-          <a:blip xmlns:r="http://schemas.openxmlformats.org/officeDocument/2006/relationships" xmlns:a="http://schemas.openxmlformats.org/drawingml/2006/main" r:embed="R60a6c73b9c1b4b6d">
+          <a:blip xmlns:r="http://schemas.openxmlformats.org/officeDocument/2006/relationships" xmlns:a="http://schemas.openxmlformats.org/drawingml/2006/main" r:embed="R4800f316b93b4a2e">
             <a:alphaModFix/>
           </a:blip>
           <a:srcRect xmlns:a="http://schemas.openxmlformats.org/drawingml/2006/main" l="0" t="0" r="0" b="0"/>
@@ -26857,7 +27378,7 @@
           <p:nvPr/>
         </p:nvPicPr>
         <p:blipFill rotWithShape="1">
-          <a:blip xmlns:r="http://schemas.openxmlformats.org/officeDocument/2006/relationships" xmlns:a="http://schemas.openxmlformats.org/drawingml/2006/main" r:embed="R0b5653c24c954ba9">
+          <a:blip xmlns:r="http://schemas.openxmlformats.org/officeDocument/2006/relationships" xmlns:a="http://schemas.openxmlformats.org/drawingml/2006/main" r:embed="R7fc4999744f747fe">
             <a:alphaModFix/>
           </a:blip>
           <a:srcRect xmlns:a="http://schemas.openxmlformats.org/drawingml/2006/main" l="0" t="0" r="0" b="0"/>
@@ -27147,7 +27668,7 @@
           <p:nvPr/>
         </p:nvPicPr>
         <p:blipFill rotWithShape="1">
-          <a:blip xmlns:r="http://schemas.openxmlformats.org/officeDocument/2006/relationships" xmlns:a="http://schemas.openxmlformats.org/drawingml/2006/main" r:embed="R2d2c0d295a7e4259">
+          <a:blip xmlns:r="http://schemas.openxmlformats.org/officeDocument/2006/relationships" xmlns:a="http://schemas.openxmlformats.org/drawingml/2006/main" r:embed="R6e508f4f9e404594">
             <a:alphaModFix/>
           </a:blip>
           <a:srcRect xmlns:a="http://schemas.openxmlformats.org/drawingml/2006/main" l="0" t="0" r="0" b="0"/>
@@ -27460,7 +27981,7 @@
       </p:sp>
       <p:pic>
         <p:nvPicPr>
-          <p:cNvPr id="971" name="Google Shape;119;p17"/>
+          <p:cNvPr id="1065" name="Google Shape;119;p17"/>
           <p:cNvPicPr>
             <a:picLocks xmlns:a="http://schemas.openxmlformats.org/drawingml/2006/main" noChangeAspect="1"/>
           </p:cNvPicPr>
@@ -27469,7 +27990,7 @@
           </p:nvPr>
         </p:nvPicPr>
         <p:blipFill rotWithShape="1">
-          <a:blip xmlns:r="http://schemas.openxmlformats.org/officeDocument/2006/relationships" xmlns:a="http://schemas.openxmlformats.org/drawingml/2006/main" r:embed="R9365620fc5674751">
+          <a:blip xmlns:r="http://schemas.openxmlformats.org/officeDocument/2006/relationships" xmlns:a="http://schemas.openxmlformats.org/drawingml/2006/main" r:embed="Rf7227624e8184563">
             <a:alphaModFix/>
           </a:blip>
           <a:srcRect xmlns:a="http://schemas.openxmlformats.org/drawingml/2006/main" l="0" t="0" r="0" b="0"/>
@@ -27494,14 +28015,14 @@
       </p:pic>
       <p:pic>
         <p:nvPicPr>
-          <p:cNvPr id="972" name="Google Shape;120;p17"/>
+          <p:cNvPr id="1066" name="Google Shape;120;p17"/>
           <p:cNvPicPr>
             <a:picLocks xmlns:a="http://schemas.openxmlformats.org/drawingml/2006/main" noChangeAspect="1"/>
           </p:cNvPicPr>
           <p:nvPr/>
         </p:nvPicPr>
         <p:blipFill rotWithShape="1">
-          <a:blip xmlns:r="http://schemas.openxmlformats.org/officeDocument/2006/relationships" xmlns:a="http://schemas.openxmlformats.org/drawingml/2006/main" r:embed="Rcee337d8800044c7">
+          <a:blip xmlns:r="http://schemas.openxmlformats.org/officeDocument/2006/relationships" xmlns:a="http://schemas.openxmlformats.org/drawingml/2006/main" r:embed="R11e36e435f8b4468">
             <a:alphaModFix/>
           </a:blip>
           <a:srcRect xmlns:a="http://schemas.openxmlformats.org/drawingml/2006/main" l="0" t="0" r="0" b="0"/>
@@ -27526,14 +28047,14 @@
       </p:pic>
       <p:pic>
         <p:nvPicPr>
-          <p:cNvPr id="973" name="Google Shape;122;p17"/>
+          <p:cNvPr id="1067" name="Google Shape;122;p17"/>
           <p:cNvPicPr>
             <a:picLocks xmlns:a="http://schemas.openxmlformats.org/drawingml/2006/main" noChangeAspect="1"/>
           </p:cNvPicPr>
           <p:nvPr/>
         </p:nvPicPr>
         <p:blipFill rotWithShape="1">
-          <a:blip xmlns:r="http://schemas.openxmlformats.org/officeDocument/2006/relationships" xmlns:a="http://schemas.openxmlformats.org/drawingml/2006/main" r:embed="R0a6122d4f61343d1">
+          <a:blip xmlns:r="http://schemas.openxmlformats.org/officeDocument/2006/relationships" xmlns:a="http://schemas.openxmlformats.org/drawingml/2006/main" r:embed="R1be146bc5d2a40c8">
             <a:alphaModFix/>
           </a:blip>
           <a:srcRect xmlns:a="http://schemas.openxmlformats.org/drawingml/2006/main" l="0" t="0" r="0" b="0"/>
@@ -27823,14 +28344,14 @@
       </p:sp>
       <p:pic>
         <p:nvPicPr>
-          <p:cNvPr id="979" name="Google Shape;128;p17"/>
+          <p:cNvPr id="1073" name="Google Shape;128;p17"/>
           <p:cNvPicPr>
             <a:picLocks xmlns:a="http://schemas.openxmlformats.org/drawingml/2006/main" noChangeAspect="1"/>
           </p:cNvPicPr>
           <p:nvPr/>
         </p:nvPicPr>
         <p:blipFill rotWithShape="1">
-          <a:blip xmlns:r="http://schemas.openxmlformats.org/officeDocument/2006/relationships" xmlns:a="http://schemas.openxmlformats.org/drawingml/2006/main" r:embed="Rcee337d8800044c7">
+          <a:blip xmlns:r="http://schemas.openxmlformats.org/officeDocument/2006/relationships" xmlns:a="http://schemas.openxmlformats.org/drawingml/2006/main" r:embed="R11e36e435f8b4468">
             <a:alphaModFix/>
           </a:blip>
           <a:srcRect xmlns:a="http://schemas.openxmlformats.org/drawingml/2006/main" l="0" t="0" r="0" b="0"/>
@@ -27855,7 +28376,7 @@
       </p:pic>
       <p:cxnSp>
         <p:nvCxnSpPr>
-          <p:cNvPr id="980" name="Google Shape;129;p17"/>
+          <p:cNvPr id="1074" name="Google Shape;129;p17"/>
           <p:cNvCxnSpPr/>
           <p:nvPr/>
         </p:nvCxnSpPr>
@@ -27880,7 +28401,7 @@
       </p:cxnSp>
       <p:cxnSp>
         <p:nvCxnSpPr>
-          <p:cNvPr id="981" name="Google Shape;130;p17"/>
+          <p:cNvPr id="1075" name="Google Shape;130;p17"/>
           <p:cNvCxnSpPr/>
           <p:nvPr/>
         </p:nvCxnSpPr>
@@ -27905,14 +28426,14 @@
       </p:cxnSp>
       <p:pic>
         <p:nvPicPr>
-          <p:cNvPr id="982" name="Google Shape;131;p17"/>
+          <p:cNvPr id="1076" name="Google Shape;131;p17"/>
           <p:cNvPicPr>
             <a:picLocks xmlns:a="http://schemas.openxmlformats.org/drawingml/2006/main" noChangeAspect="1"/>
           </p:cNvPicPr>
           <p:nvPr/>
         </p:nvPicPr>
         <p:blipFill rotWithShape="1">
-          <a:blip xmlns:r="http://schemas.openxmlformats.org/officeDocument/2006/relationships" xmlns:a="http://schemas.openxmlformats.org/drawingml/2006/main" r:embed="Re968c4817cf64e52">
+          <a:blip xmlns:r="http://schemas.openxmlformats.org/officeDocument/2006/relationships" xmlns:a="http://schemas.openxmlformats.org/drawingml/2006/main" r:embed="Rb5dc3840d1354e31">
             <a:alphaModFix/>
           </a:blip>
           <a:srcRect xmlns:a="http://schemas.openxmlformats.org/drawingml/2006/main" l="0" t="0" r="0" b="0"/>
@@ -28198,14 +28719,14 @@
       </p:sp>
       <p:pic>
         <p:nvPicPr>
-          <p:cNvPr id="987" name="Google Shape;136;p17"/>
+          <p:cNvPr id="1081" name="Google Shape;136;p17"/>
           <p:cNvPicPr>
             <a:picLocks xmlns:a="http://schemas.openxmlformats.org/drawingml/2006/main" noChangeAspect="1"/>
           </p:cNvPicPr>
           <p:nvPr/>
         </p:nvPicPr>
         <p:blipFill rotWithShape="1">
-          <a:blip xmlns:r="http://schemas.openxmlformats.org/officeDocument/2006/relationships" xmlns:a="http://schemas.openxmlformats.org/drawingml/2006/main" r:embed="R00f487b7bfe54172">
+          <a:blip xmlns:r="http://schemas.openxmlformats.org/officeDocument/2006/relationships" xmlns:a="http://schemas.openxmlformats.org/drawingml/2006/main" r:embed="Rbce8fa76fe8a4605">
             <a:alphaModFix/>
           </a:blip>
           <a:srcRect xmlns:a="http://schemas.openxmlformats.org/drawingml/2006/main" l="0" t="0" r="0" b="0"/>
@@ -28226,14 +28747,14 @@
       </p:pic>
       <p:pic>
         <p:nvPicPr>
-          <p:cNvPr id="988" name="Google Shape;137;p17"/>
+          <p:cNvPr id="1082" name="Google Shape;137;p17"/>
           <p:cNvPicPr>
             <a:picLocks xmlns:a="http://schemas.openxmlformats.org/drawingml/2006/main" noChangeAspect="1"/>
           </p:cNvPicPr>
           <p:nvPr/>
         </p:nvPicPr>
         <p:blipFill rotWithShape="1">
-          <a:blip xmlns:r="http://schemas.openxmlformats.org/officeDocument/2006/relationships" xmlns:a="http://schemas.openxmlformats.org/drawingml/2006/main" r:embed="Ra0071a1f193c4210">
+          <a:blip xmlns:r="http://schemas.openxmlformats.org/officeDocument/2006/relationships" xmlns:a="http://schemas.openxmlformats.org/drawingml/2006/main" r:embed="R3ebab1fa521744bd">
             <a:alphaModFix/>
           </a:blip>
           <a:srcRect xmlns:a="http://schemas.openxmlformats.org/drawingml/2006/main" l="0" t="0" r="0" b="0"/>
@@ -28315,14 +28836,14 @@
       </p:sp>
       <p:pic>
         <p:nvPicPr>
-          <p:cNvPr id="990" name="Google Shape;139;p17"/>
+          <p:cNvPr id="1084" name="Google Shape;139;p17"/>
           <p:cNvPicPr>
             <a:picLocks xmlns:a="http://schemas.openxmlformats.org/drawingml/2006/main" noChangeAspect="1"/>
           </p:cNvPicPr>
           <p:nvPr/>
         </p:nvPicPr>
         <p:blipFill rotWithShape="1">
-          <a:blip xmlns:r="http://schemas.openxmlformats.org/officeDocument/2006/relationships" xmlns:a="http://schemas.openxmlformats.org/drawingml/2006/main" r:embed="R2ceabc8b31014ecb">
+          <a:blip xmlns:r="http://schemas.openxmlformats.org/officeDocument/2006/relationships" xmlns:a="http://schemas.openxmlformats.org/drawingml/2006/main" r:embed="R4bbbde5a63e8499f">
             <a:alphaModFix/>
           </a:blip>
           <a:srcRect xmlns:a="http://schemas.openxmlformats.org/drawingml/2006/main" l="0" t="0" r="0" b="0"/>
@@ -28343,14 +28864,14 @@
       </p:pic>
       <p:pic>
         <p:nvPicPr>
-          <p:cNvPr id="991" name="Google Shape;140;p17"/>
+          <p:cNvPr id="1085" name="Google Shape;140;p17"/>
           <p:cNvPicPr>
             <a:picLocks xmlns:a="http://schemas.openxmlformats.org/drawingml/2006/main" noChangeAspect="1"/>
           </p:cNvPicPr>
           <p:nvPr/>
         </p:nvPicPr>
         <p:blipFill rotWithShape="1">
-          <a:blip xmlns:r="http://schemas.openxmlformats.org/officeDocument/2006/relationships" xmlns:a="http://schemas.openxmlformats.org/drawingml/2006/main" r:embed="R1578337995eb44e3">
+          <a:blip xmlns:r="http://schemas.openxmlformats.org/officeDocument/2006/relationships" xmlns:a="http://schemas.openxmlformats.org/drawingml/2006/main" r:embed="Rcb79eb3f801a4a9c">
             <a:alphaModFix/>
           </a:blip>
           <a:srcRect xmlns:a="http://schemas.openxmlformats.org/drawingml/2006/main" l="0" t="0" r="0" b="0"/>
@@ -28620,7 +29141,7 @@
       </p:sp>
       <p:cxnSp>
         <p:nvCxnSpPr>
-          <p:cNvPr id="994" name="Google Shape;143;p17"/>
+          <p:cNvPr id="1088" name="Google Shape;143;p17"/>
           <p:cNvCxnSpPr>
             <a:stCxn xmlns:a="http://schemas.openxmlformats.org/drawingml/2006/main" id="119" idx="3"/>
             <a:endCxn xmlns:a="http://schemas.openxmlformats.org/drawingml/2006/main" id="120" idx="1"/>
@@ -28648,7 +29169,7 @@
       </p:cxnSp>
       <p:cxnSp>
         <p:nvCxnSpPr>
-          <p:cNvPr id="995" name="Google Shape;144;p17"/>
+          <p:cNvPr id="1089" name="Google Shape;144;p17"/>
           <p:cNvCxnSpPr>
             <a:endCxn xmlns:a="http://schemas.openxmlformats.org/drawingml/2006/main" id="128" idx="1"/>
           </p:cNvCxnSpPr>
@@ -28675,7 +29196,7 @@
       </p:cxnSp>
       <p:cxnSp>
         <p:nvCxnSpPr>
-          <p:cNvPr id="996" name="Google Shape;145;p17"/>
+          <p:cNvPr id="1090" name="Google Shape;145;p17"/>
           <p:cNvCxnSpPr>
             <a:endCxn xmlns:a="http://schemas.openxmlformats.org/drawingml/2006/main" id="132" idx="1"/>
           </p:cNvCxnSpPr>
@@ -28702,7 +29223,7 @@
       </p:cxnSp>
       <p:cxnSp>
         <p:nvCxnSpPr>
-          <p:cNvPr id="997" name="Google Shape;146;p17"/>
+          <p:cNvPr id="1091" name="Google Shape;146;p17"/>
           <p:cNvCxnSpPr>
             <a:endCxn xmlns:a="http://schemas.openxmlformats.org/drawingml/2006/main" id="135" idx="3"/>
           </p:cNvCxnSpPr>
@@ -28729,7 +29250,7 @@
       </p:cxnSp>
       <p:cxnSp>
         <p:nvCxnSpPr>
-          <p:cNvPr id="998" name="Google Shape;147;p17"/>
+          <p:cNvPr id="1092" name="Google Shape;147;p17"/>
           <p:cNvCxnSpPr>
             <a:endCxn xmlns:a="http://schemas.openxmlformats.org/drawingml/2006/main" id="135" idx="0"/>
           </p:cNvCxnSpPr>
@@ -28756,7 +29277,7 @@
       </p:cxnSp>
       <p:cxnSp>
         <p:nvCxnSpPr>
-          <p:cNvPr id="999" name="Google Shape;148;p17"/>
+          <p:cNvPr id="1093" name="Google Shape;148;p17"/>
           <p:cNvCxnSpPr>
             <a:stCxn xmlns:a="http://schemas.openxmlformats.org/drawingml/2006/main" id="132" idx="3"/>
             <a:endCxn xmlns:a="http://schemas.openxmlformats.org/drawingml/2006/main" id="133" idx="0"/>
@@ -28784,7 +29305,7 @@
       </p:cxnSp>
       <p:cxnSp>
         <p:nvCxnSpPr>
-          <p:cNvPr id="1000" name="Google Shape;149;p17"/>
+          <p:cNvPr id="1094" name="Google Shape;149;p17"/>
           <p:cNvCxnSpPr>
             <a:stCxn xmlns:a="http://schemas.openxmlformats.org/drawingml/2006/main" id="133" idx="2"/>
             <a:endCxn xmlns:a="http://schemas.openxmlformats.org/drawingml/2006/main" id="131" idx="0"/>
@@ -28812,7 +29333,7 @@
       </p:cxnSp>
       <p:cxnSp>
         <p:nvCxnSpPr>
-          <p:cNvPr id="1001" name="Google Shape;150;p17"/>
+          <p:cNvPr id="1095" name="Google Shape;150;p17"/>
           <p:cNvCxnSpPr>
             <a:stCxn xmlns:a="http://schemas.openxmlformats.org/drawingml/2006/main" id="135" idx="1"/>
             <a:endCxn xmlns:a="http://schemas.openxmlformats.org/drawingml/2006/main" id="136" idx="3"/>
@@ -28840,7 +29361,7 @@
       </p:cxnSp>
       <p:cxnSp>
         <p:nvCxnSpPr>
-          <p:cNvPr id="1002" name="Google Shape;151;p17"/>
+          <p:cNvPr id="1096" name="Google Shape;151;p17"/>
           <p:cNvCxnSpPr>
             <a:stCxn xmlns:a="http://schemas.openxmlformats.org/drawingml/2006/main" id="135" idx="1"/>
             <a:endCxn xmlns:a="http://schemas.openxmlformats.org/drawingml/2006/main" id="137" idx="3"/>
@@ -28868,7 +29389,7 @@
       </p:cxnSp>
       <p:cxnSp>
         <p:nvCxnSpPr>
-          <p:cNvPr id="1003" name="Google Shape;152;p17"/>
+          <p:cNvPr id="1097" name="Google Shape;152;p17"/>
           <p:cNvCxnSpPr/>
           <p:nvPr/>
         </p:nvCxnSpPr>
@@ -28893,7 +29414,7 @@
       </p:cxnSp>
       <p:cxnSp>
         <p:nvCxnSpPr>
-          <p:cNvPr id="1004" name="Google Shape;153;p17"/>
+          <p:cNvPr id="1098" name="Google Shape;153;p17"/>
           <p:cNvCxnSpPr/>
           <p:nvPr/>
         </p:nvCxnSpPr>
@@ -28918,7 +29439,7 @@
       </p:cxnSp>
       <p:cxnSp>
         <p:nvCxnSpPr>
-          <p:cNvPr id="1005" name="Google Shape;154;p17"/>
+          <p:cNvPr id="1099" name="Google Shape;154;p17"/>
           <p:cNvCxnSpPr/>
           <p:nvPr/>
         </p:nvCxnSpPr>
@@ -28943,7 +29464,7 @@
       </p:cxnSp>
       <p:cxnSp>
         <p:nvCxnSpPr>
-          <p:cNvPr id="1006" name="Google Shape;155;p17"/>
+          <p:cNvPr id="1100" name="Google Shape;155;p17"/>
           <p:cNvCxnSpPr/>
           <p:nvPr/>
         </p:nvCxnSpPr>
@@ -28968,7 +29489,7 @@
       </p:cxnSp>
       <p:cxnSp>
         <p:nvCxnSpPr>
-          <p:cNvPr id="1007" name="Google Shape;156;p17"/>
+          <p:cNvPr id="1101" name="Google Shape;156;p17"/>
           <p:cNvCxnSpPr/>
           <p:nvPr/>
         </p:nvCxnSpPr>
@@ -29357,7 +29878,7 @@
           </p:nvPr>
         </p:nvPicPr>
         <p:blipFill rotWithShape="1">
-          <a:blip xmlns:r="http://schemas.openxmlformats.org/officeDocument/2006/relationships" xmlns:a="http://schemas.openxmlformats.org/drawingml/2006/main" r:embed="Rc8f421fc21264d7e">
+          <a:blip xmlns:r="http://schemas.openxmlformats.org/officeDocument/2006/relationships" xmlns:a="http://schemas.openxmlformats.org/drawingml/2006/main" r:embed="R1cae7a89a4784154">
             <a:alphaModFix/>
           </a:blip>
           <a:srcRect xmlns:a="http://schemas.openxmlformats.org/drawingml/2006/main" l="0" t="0" r="0" b="0"/>
@@ -29573,7 +30094,7 @@
           <p:nvPr/>
         </p:nvPicPr>
         <p:blipFill rotWithShape="1">
-          <a:blip xmlns:r="http://schemas.openxmlformats.org/officeDocument/2006/relationships" xmlns:a="http://schemas.openxmlformats.org/drawingml/2006/main" r:embed="R3db648d735a048b5">
+          <a:blip xmlns:r="http://schemas.openxmlformats.org/officeDocument/2006/relationships" xmlns:a="http://schemas.openxmlformats.org/drawingml/2006/main" r:embed="Rf655fd5e8a2e4117">
             <a:alphaModFix/>
           </a:blip>
           <a:srcRect xmlns:a="http://schemas.openxmlformats.org/drawingml/2006/main" l="0" t="0" r="0" b="0"/>
@@ -30304,7 +30825,7 @@
           <p:nvPr/>
         </p:nvPicPr>
         <p:blipFill rotWithShape="1">
-          <a:blip xmlns:r="http://schemas.openxmlformats.org/officeDocument/2006/relationships" xmlns:a="http://schemas.openxmlformats.org/drawingml/2006/main" r:embed="R0199a5bb3aba4670">
+          <a:blip xmlns:r="http://schemas.openxmlformats.org/officeDocument/2006/relationships" xmlns:a="http://schemas.openxmlformats.org/drawingml/2006/main" r:embed="R54e9afadc9eb4ab7">
             <a:alphaModFix/>
           </a:blip>
           <a:srcRect xmlns:a="http://schemas.openxmlformats.org/drawingml/2006/main" l="0" t="0" r="0" b="0"/>
@@ -30332,7 +30853,7 @@
           <p:nvPr/>
         </p:nvPicPr>
         <p:blipFill rotWithShape="1">
-          <a:blip xmlns:r="http://schemas.openxmlformats.org/officeDocument/2006/relationships" xmlns:a="http://schemas.openxmlformats.org/drawingml/2006/main" r:embed="Re284ea0790424350">
+          <a:blip xmlns:r="http://schemas.openxmlformats.org/officeDocument/2006/relationships" xmlns:a="http://schemas.openxmlformats.org/drawingml/2006/main" r:embed="Re64de5e5b5f64f40">
             <a:alphaModFix/>
           </a:blip>
           <a:srcRect xmlns:a="http://schemas.openxmlformats.org/drawingml/2006/main" l="0" t="0" r="0" b="0"/>
@@ -30360,7 +30881,7 @@
           <p:nvPr/>
         </p:nvPicPr>
         <p:blipFill rotWithShape="1">
-          <a:blip xmlns:r="http://schemas.openxmlformats.org/officeDocument/2006/relationships" xmlns:a="http://schemas.openxmlformats.org/drawingml/2006/main" r:embed="Rcb4f5922b13b4f13">
+          <a:blip xmlns:r="http://schemas.openxmlformats.org/officeDocument/2006/relationships" xmlns:a="http://schemas.openxmlformats.org/drawingml/2006/main" r:embed="R8dac25edd3264e82">
             <a:alphaModFix/>
           </a:blip>
           <a:srcRect xmlns:a="http://schemas.openxmlformats.org/drawingml/2006/main" l="0" t="0" r="0" b="0"/>
@@ -30756,7 +31277,7 @@
               <a:buNone/>
             </a:pPr>
             <a:r>
-              <a:t>B0–B6.2 complete · exact-coordinate recovery next</a:t>
+              <a:t>B0–B7.1 complete · verified repair next</a:t>
             </a:r>
           </a:p>
         </p:txBody>

</xml_diff>

<commit_message>
Record B7.2 decision and preregister B8.0
</commit_message>
<xml_diff>
--- a/presentation/ADVLSI2_DRC_CNN_Project_Progress.pptx
+++ b/presentation/ADVLSI2_DRC_CNN_Project_Progress.pptx
@@ -2,49 +2,51 @@
 <file path=ppt/presentation.xml><?xml version="1.0" encoding="utf-8"?>
 <p:presentation xmlns:p="http://schemas.openxmlformats.org/presentationml/2006/main" embedTrueTypeFonts="1" saveSubsetFonts="0">
   <p:sldMasterIdLst>
-    <p:sldMasterId xmlns:r="http://schemas.openxmlformats.org/officeDocument/2006/relationships" id="2147483648" r:id="Rf6646fc1a5044a1a"/>
+    <p:sldMasterId xmlns:r="http://schemas.openxmlformats.org/officeDocument/2006/relationships" id="2147483648" r:id="R2279a7186df24950"/>
   </p:sldMasterIdLst>
   <p:notesMasterIdLst>
-    <p:notesMasterId xmlns:r="http://schemas.openxmlformats.org/officeDocument/2006/relationships" r:id="Rb0171bdc05864930"/>
+    <p:notesMasterId xmlns:r="http://schemas.openxmlformats.org/officeDocument/2006/relationships" r:id="R784407c0e3824091"/>
   </p:notesMasterIdLst>
   <p:sldIdLst>
-    <p:sldId xmlns:r="http://schemas.openxmlformats.org/officeDocument/2006/relationships" id="256" r:id="R473d248b85e3432e"/>
-    <p:sldId xmlns:r="http://schemas.openxmlformats.org/officeDocument/2006/relationships" id="257" r:id="R493242bc866d4bc3"/>
-    <p:sldId xmlns:r="http://schemas.openxmlformats.org/officeDocument/2006/relationships" id="258" r:id="R700f233335824651"/>
-    <p:sldId xmlns:r="http://schemas.openxmlformats.org/officeDocument/2006/relationships" id="259" r:id="Rfd43c99577654f5e"/>
-    <p:sldId xmlns:r="http://schemas.openxmlformats.org/officeDocument/2006/relationships" id="260" r:id="Rfa13f559a9b6430d"/>
-    <p:sldId xmlns:r="http://schemas.openxmlformats.org/officeDocument/2006/relationships" id="261" r:id="Rf7f1a52b45ef4aac"/>
-    <p:sldId xmlns:r="http://schemas.openxmlformats.org/officeDocument/2006/relationships" id="262" r:id="Rc172e0c9def1440f"/>
-    <p:sldId xmlns:r="http://schemas.openxmlformats.org/officeDocument/2006/relationships" id="263" r:id="Rbcae3d58b5a4410c"/>
-    <p:sldId xmlns:r="http://schemas.openxmlformats.org/officeDocument/2006/relationships" id="264" r:id="Re2985ee495c3441e"/>
-    <p:sldId xmlns:r="http://schemas.openxmlformats.org/officeDocument/2006/relationships" id="265" r:id="R503dda376cc24660"/>
-    <p:sldId xmlns:r="http://schemas.openxmlformats.org/officeDocument/2006/relationships" id="266" r:id="R2aac68d777d7490e"/>
-    <p:sldId xmlns:r="http://schemas.openxmlformats.org/officeDocument/2006/relationships" id="267" r:id="Rfa67ed9bfe204425"/>
-    <p:sldId xmlns:r="http://schemas.openxmlformats.org/officeDocument/2006/relationships" id="268" r:id="R52cb85386a4a4ddf"/>
-    <p:sldId xmlns:r="http://schemas.openxmlformats.org/officeDocument/2006/relationships" id="269" r:id="Ra4a603b927a042b6"/>
-    <p:sldId xmlns:r="http://schemas.openxmlformats.org/officeDocument/2006/relationships" id="270" r:id="Re6976dfbc96c46f1"/>
-    <p:sldId xmlns:r="http://schemas.openxmlformats.org/officeDocument/2006/relationships" id="271" r:id="R61fc1015ddb14c74"/>
-    <p:sldId xmlns:r="http://schemas.openxmlformats.org/officeDocument/2006/relationships" id="272" r:id="R78f458a191084229"/>
-    <p:sldId xmlns:r="http://schemas.openxmlformats.org/officeDocument/2006/relationships" id="273" r:id="R50ed91069f57414b"/>
-    <p:sldId xmlns:r="http://schemas.openxmlformats.org/officeDocument/2006/relationships" id="274" r:id="Rcb73719f3d70494f"/>
-    <p:sldId xmlns:r="http://schemas.openxmlformats.org/officeDocument/2006/relationships" id="275" r:id="Rfa08e12c9ae44eb5"/>
-    <p:sldId xmlns:r="http://schemas.openxmlformats.org/officeDocument/2006/relationships" id="276" r:id="R4595022a0d22432a"/>
-    <p:sldId xmlns:r="http://schemas.openxmlformats.org/officeDocument/2006/relationships" id="277" r:id="R15ddde53e61b436a"/>
-    <p:sldId xmlns:r="http://schemas.openxmlformats.org/officeDocument/2006/relationships" id="278" r:id="R8fea7f05cc724ab6"/>
-    <p:sldId xmlns:r="http://schemas.openxmlformats.org/officeDocument/2006/relationships" id="279" r:id="R6bdd30de3fa54412"/>
-    <p:sldId xmlns:r="http://schemas.openxmlformats.org/officeDocument/2006/relationships" id="280" r:id="R50845b6994544489"/>
-    <p:sldId xmlns:r="http://schemas.openxmlformats.org/officeDocument/2006/relationships" id="281" r:id="Re254872c49c143a2"/>
-    <p:sldId xmlns:r="http://schemas.openxmlformats.org/officeDocument/2006/relationships" id="282" r:id="R1ff107fa12db4c5f"/>
-    <p:sldId xmlns:r="http://schemas.openxmlformats.org/officeDocument/2006/relationships" id="283" r:id="Re29547a3707b46b1"/>
-    <p:sldId xmlns:r="http://schemas.openxmlformats.org/officeDocument/2006/relationships" id="284" r:id="R1e5ba12c1a99438c"/>
+    <p:sldId xmlns:r="http://schemas.openxmlformats.org/officeDocument/2006/relationships" id="256" r:id="R347daefdebf543de"/>
+    <p:sldId xmlns:r="http://schemas.openxmlformats.org/officeDocument/2006/relationships" id="257" r:id="R72a6caaf99614d5d"/>
+    <p:sldId xmlns:r="http://schemas.openxmlformats.org/officeDocument/2006/relationships" id="258" r:id="Rc1dc81e41c714633"/>
+    <p:sldId xmlns:r="http://schemas.openxmlformats.org/officeDocument/2006/relationships" id="259" r:id="Rb51b30d198fa4318"/>
+    <p:sldId xmlns:r="http://schemas.openxmlformats.org/officeDocument/2006/relationships" id="260" r:id="Red42f45a915e4063"/>
+    <p:sldId xmlns:r="http://schemas.openxmlformats.org/officeDocument/2006/relationships" id="261" r:id="R58ebfb56aa374993"/>
+    <p:sldId xmlns:r="http://schemas.openxmlformats.org/officeDocument/2006/relationships" id="262" r:id="R536f2e89b8df47fc"/>
+    <p:sldId xmlns:r="http://schemas.openxmlformats.org/officeDocument/2006/relationships" id="263" r:id="Rf60d17a396b64f89"/>
+    <p:sldId xmlns:r="http://schemas.openxmlformats.org/officeDocument/2006/relationships" id="264" r:id="R312a0a90c6874420"/>
+    <p:sldId xmlns:r="http://schemas.openxmlformats.org/officeDocument/2006/relationships" id="265" r:id="R34fbcddfd2f940bf"/>
+    <p:sldId xmlns:r="http://schemas.openxmlformats.org/officeDocument/2006/relationships" id="266" r:id="R8fd97f87a011473d"/>
+    <p:sldId xmlns:r="http://schemas.openxmlformats.org/officeDocument/2006/relationships" id="267" r:id="Rb167da66955b41fd"/>
+    <p:sldId xmlns:r="http://schemas.openxmlformats.org/officeDocument/2006/relationships" id="268" r:id="R68e4f9642e664958"/>
+    <p:sldId xmlns:r="http://schemas.openxmlformats.org/officeDocument/2006/relationships" id="269" r:id="Rc701dabdd86b4eef"/>
+    <p:sldId xmlns:r="http://schemas.openxmlformats.org/officeDocument/2006/relationships" id="270" r:id="Rb7ef5231f50b4e3a"/>
+    <p:sldId xmlns:r="http://schemas.openxmlformats.org/officeDocument/2006/relationships" id="271" r:id="R17614f075b314920"/>
+    <p:sldId xmlns:r="http://schemas.openxmlformats.org/officeDocument/2006/relationships" id="272" r:id="Rb0ef0ce5e4f64e5c"/>
+    <p:sldId xmlns:r="http://schemas.openxmlformats.org/officeDocument/2006/relationships" id="273" r:id="Rd3dde67cea964079"/>
+    <p:sldId xmlns:r="http://schemas.openxmlformats.org/officeDocument/2006/relationships" id="274" r:id="R630ca11a1af64254"/>
+    <p:sldId xmlns:r="http://schemas.openxmlformats.org/officeDocument/2006/relationships" id="275" r:id="Reccb9a8225de42a9"/>
+    <p:sldId xmlns:r="http://schemas.openxmlformats.org/officeDocument/2006/relationships" id="276" r:id="R8d2dfc0e54394368"/>
+    <p:sldId xmlns:r="http://schemas.openxmlformats.org/officeDocument/2006/relationships" id="277" r:id="Ra776e6895a164406"/>
+    <p:sldId xmlns:r="http://schemas.openxmlformats.org/officeDocument/2006/relationships" id="278" r:id="R76e4a584c7a243a5"/>
+    <p:sldId xmlns:r="http://schemas.openxmlformats.org/officeDocument/2006/relationships" id="279" r:id="Rc00f89c5a6f34b60"/>
+    <p:sldId xmlns:r="http://schemas.openxmlformats.org/officeDocument/2006/relationships" id="280" r:id="Rbdd428c06c634b38"/>
+    <p:sldId xmlns:r="http://schemas.openxmlformats.org/officeDocument/2006/relationships" id="281" r:id="R27d40659fddd4cb0"/>
+    <p:sldId xmlns:r="http://schemas.openxmlformats.org/officeDocument/2006/relationships" id="282" r:id="Rbbd1ca2e025a4662"/>
+    <p:sldId xmlns:r="http://schemas.openxmlformats.org/officeDocument/2006/relationships" id="283" r:id="R7d52165e2c414c87"/>
+    <p:sldId xmlns:r="http://schemas.openxmlformats.org/officeDocument/2006/relationships" id="284" r:id="R68f128b31e3a4f39"/>
+    <p:sldId xmlns:r="http://schemas.openxmlformats.org/officeDocument/2006/relationships" id="285" r:id="Rd3f74462bc4d47cc"/>
+    <p:sldId xmlns:r="http://schemas.openxmlformats.org/officeDocument/2006/relationships" id="286" r:id="R6a897dead9064c93"/>
   </p:sldIdLst>
   <p:sldSz cx="12192000" cy="6858000"/>
   <p:notesSz cx="6858000" cy="9144000"/>
   <p:embeddedFontLst>
     <p:embeddedFont>
       <p:font typeface="Play"/>
-      <p:regular xmlns:r="http://schemas.openxmlformats.org/officeDocument/2006/relationships" r:id="R32f3b50f7fc740c9"/>
-      <p:bold xmlns:r="http://schemas.openxmlformats.org/officeDocument/2006/relationships" r:id="R1024a9de4a3547c8"/>
+      <p:regular xmlns:r="http://schemas.openxmlformats.org/officeDocument/2006/relationships" r:id="R3c086c1d4a334846"/>
+      <p:bold xmlns:r="http://schemas.openxmlformats.org/officeDocument/2006/relationships" r:id="R19c1bb8220e7490c"/>
     </p:embeddedFont>
   </p:embeddedFontLst>
 </p:presentation>
@@ -561,6 +563,15 @@
 - results/b7_full_layout/b7_1_summary.json and results/b7_full_layout/README.md; measured 2026-08-15; validation-only policy selection; B9 unopened.</a:t>
             </a:r>
           </a:p>
+          <a:p xmlns:a="http://schemas.openxmlformats.org/drawingml/2006/main">
+            <a:r>
+              <a:t>
+[Sources]
+- results/b7_full_layout/b7_2_cnn_gpu_summary.json; measured 2026-08-20; Tesla T4; B9 unopened.
+- results/b7_full_layout/b7_2_klayout_competitiveness_summary.json; measured 2026-08-20; one warm-up and five KLayout repetitions.
+[/Sources]</a:t>
+            </a:r>
+          </a:p>
         </p:txBody>
       </p:sp>
       <p:sp>
@@ -640,6 +651,18 @@
               <a:t/>
             </a:r>
           </a:p>
+          <a:p xmlns:a="http://schemas.openxmlformats.org/drawingml/2006/main">
+            <a:r>
+              <a:t>
+[Sources]
+- results/b7_full_layout/b7_2_cnn_gpu_summary.json; measured 2026-08-20; Tesla T4; B9 unopened.
+- results/b7_full_layout/b7_2_klayout_competitiveness_summary.json; measured 2026-08-20; one warm-up and five KLayout repetitions.
+[/Sources]
+[Sources]
+- B8_ACTIONABILITY_PROTOCOL.md
+[/Sources]</a:t>
+            </a:r>
+          </a:p>
         </p:txBody>
       </p:sp>
       <p:sp>
@@ -1057,6 +1080,15 @@
 - results/b7_full_layout/b7_1_summary.json and results/b7_full_layout/README.md; measured 2026-08-15; validation-only policy selection; B9 unopened.</a:t>
             </a:r>
           </a:p>
+          <a:p xmlns:a="http://schemas.openxmlformats.org/drawingml/2006/main">
+            <a:r>
+              <a:t>
+[Sources]
+- results/b7_full_layout/b7_2_cnn_gpu_summary.json; measured 2026-08-20; Tesla T4; B9 unopened.
+- results/b7_full_layout/b7_2_klayout_competitiveness_summary.json; measured 2026-08-20; one warm-up and five KLayout repetitions.
+[/Sources]</a:t>
+            </a:r>
+          </a:p>
         </p:txBody>
       </p:sp>
       <p:sp>
@@ -1241,6 +1273,15 @@
 - results/b7_full_layout/b7_1_summary.json and results/b7_full_layout/README.md; measured 2026-08-15; validation-only policy selection; B9 unopened.</a:t>
             </a:r>
           </a:p>
+          <a:p xmlns:a="http://schemas.openxmlformats.org/drawingml/2006/main">
+            <a:r>
+              <a:t>
+[Sources]
+- results/b7_full_layout/b7_2_cnn_gpu_summary.json; measured 2026-08-20; Tesla T4; B9 unopened.
+- results/b7_full_layout/b7_2_klayout_competitiveness_summary.json; measured 2026-08-20; one warm-up and five KLayout repetitions.
+[/Sources]</a:t>
+            </a:r>
+          </a:p>
         </p:txBody>
       </p:sp>
       <p:sp>
@@ -3244,6 +3285,226 @@
 </p:notes>
 </file>
 
+<file path=ppt/notesSlides/notesSlide30.xml><?xml version="1.0" encoding="utf-8"?>
+<p:notes xmlns:p="http://schemas.openxmlformats.org/presentationml/2006/main">
+  <p:cSld>
+    <p:spTree>
+      <p:nvGrpSpPr>
+        <p:cNvPr id="1" name=""/>
+        <p:cNvGrpSpPr/>
+        <p:nvPr/>
+      </p:nvGrpSpPr>
+      <p:grpSpPr>
+        <a:xfrm xmlns:a="http://schemas.openxmlformats.org/drawingml/2006/main"/>
+      </p:grpSpPr>
+      <p:sp>
+        <p:nvSpPr>
+          <p:cNvPr id="2" name="Slide Image Placeholder 1"/>
+          <p:cNvSpPr>
+            <a:spLocks xmlns:a="http://schemas.openxmlformats.org/drawingml/2006/main" noGrp="1"/>
+          </p:cNvSpPr>
+          <p:nvPr>
+            <p:ph type="sldImg" idx="0"/>
+          </p:nvPr>
+        </p:nvSpPr>
+        <p:spPr/>
+      </p:sp>
+      <p:sp>
+        <p:nvSpPr>
+          <p:cNvPr id="3" name="Notes Placeholder 2"/>
+          <p:cNvSpPr>
+            <a:spLocks xmlns:a="http://schemas.openxmlformats.org/drawingml/2006/main" noGrp="1"/>
+          </p:cNvSpPr>
+          <p:nvPr>
+            <p:ph type="body" idx="1"/>
+          </p:nvPr>
+        </p:nvSpPr>
+        <p:spPr/>
+        <p:txBody>
+          <a:bodyPr xmlns:a="http://schemas.openxmlformats.org/drawingml/2006/main"/>
+          <a:lstStyle xmlns:a="http://schemas.openxmlformats.org/drawingml/2006/main"/>
+          <a:p xmlns:a="http://schemas.openxmlformats.org/drawingml/2006/main">
+            <a:pPr marL="0" indent="0" algn="l">
+              <a:spcBef>
+                <a:spcPts val="0"/>
+              </a:spcBef>
+              <a:spcAft>
+                <a:spcPts val="0"/>
+              </a:spcAft>
+              <a:buNone/>
+            </a:pPr>
+            <a:r>
+              <a:t>[Sources]</a:t>
+            </a:r>
+          </a:p>
+          <a:p xmlns:a="http://schemas.openxmlformats.org/drawingml/2006/main">
+            <a:pPr marL="0" indent="0" algn="l">
+              <a:spcBef>
+                <a:spcPts val="0"/>
+              </a:spcBef>
+              <a:spcAft>
+                <a:spcPts val="0"/>
+              </a:spcAft>
+              <a:buNone/>
+            </a:pPr>
+            <a:r>
+              <a:t>- results/b7_full_layout/b7_2_cnn_gpu_summary.json; measured 2026-08-20; Tesla T4; B9 unopened.</a:t>
+            </a:r>
+          </a:p>
+          <a:p xmlns:a="http://schemas.openxmlformats.org/drawingml/2006/main">
+            <a:pPr marL="0" indent="0" algn="l">
+              <a:spcBef>
+                <a:spcPts val="0"/>
+              </a:spcBef>
+              <a:spcAft>
+                <a:spcPts val="0"/>
+              </a:spcAft>
+              <a:buNone/>
+            </a:pPr>
+            <a:r>
+              <a:t>- results/b7_full_layout/b7_2_klayout_competitiveness_summary.json; measured 2026-08-20; one warm-up and five KLayout repetitions.</a:t>
+            </a:r>
+          </a:p>
+          <a:p xmlns:a="http://schemas.openxmlformats.org/drawingml/2006/main">
+            <a:pPr marL="0" indent="0" algn="l">
+              <a:spcBef>
+                <a:spcPts val="0"/>
+              </a:spcBef>
+              <a:spcAft>
+                <a:spcPts val="0"/>
+              </a:spcAft>
+              <a:buNone/>
+            </a:pPr>
+            <a:r>
+              <a:t>[/Sources]</a:t>
+            </a:r>
+          </a:p>
+        </p:txBody>
+      </p:sp>
+      <p:sp>
+        <p:nvSpPr>
+          <p:cNvPr id="4" name="Slide Number Placeholder 3"/>
+          <p:cNvSpPr>
+            <a:spLocks xmlns:a="http://schemas.openxmlformats.org/drawingml/2006/main" noGrp="1"/>
+          </p:cNvSpPr>
+          <p:nvPr>
+            <p:ph type="sldNum" idx="5"/>
+          </p:nvPr>
+        </p:nvSpPr>
+        <p:spPr/>
+        <p:txBody>
+          <a:bodyPr xmlns:a="http://schemas.openxmlformats.org/drawingml/2006/main"/>
+          <a:lstStyle xmlns:a="http://schemas.openxmlformats.org/drawingml/2006/main"/>
+          <a:p xmlns:a="http://schemas.openxmlformats.org/drawingml/2006/main"/>
+        </p:txBody>
+      </p:sp>
+    </p:spTree>
+  </p:cSld>
+  <p:clrMapOvr>
+    <a:masterClrMapping xmlns:a="http://schemas.openxmlformats.org/drawingml/2006/main"/>
+  </p:clrMapOvr>
+</p:notes>
+</file>
+
+<file path=ppt/notesSlides/notesSlide31.xml><?xml version="1.0" encoding="utf-8"?>
+<p:notes xmlns:p="http://schemas.openxmlformats.org/presentationml/2006/main">
+  <p:cSld>
+    <p:spTree>
+      <p:nvGrpSpPr>
+        <p:cNvPr id="1" name=""/>
+        <p:cNvGrpSpPr/>
+        <p:nvPr/>
+      </p:nvGrpSpPr>
+      <p:grpSpPr>
+        <a:xfrm xmlns:a="http://schemas.openxmlformats.org/drawingml/2006/main"/>
+      </p:grpSpPr>
+      <p:sp>
+        <p:nvSpPr>
+          <p:cNvPr id="2" name="Slide Image Placeholder 1"/>
+          <p:cNvSpPr>
+            <a:spLocks xmlns:a="http://schemas.openxmlformats.org/drawingml/2006/main" noGrp="1"/>
+          </p:cNvSpPr>
+          <p:nvPr>
+            <p:ph type="sldImg" idx="0"/>
+          </p:nvPr>
+        </p:nvSpPr>
+        <p:spPr/>
+      </p:sp>
+      <p:sp>
+        <p:nvSpPr>
+          <p:cNvPr id="3" name="Notes Placeholder 2"/>
+          <p:cNvSpPr>
+            <a:spLocks xmlns:a="http://schemas.openxmlformats.org/drawingml/2006/main" noGrp="1"/>
+          </p:cNvSpPr>
+          <p:nvPr>
+            <p:ph type="body" idx="1"/>
+          </p:nvPr>
+        </p:nvSpPr>
+        <p:spPr/>
+        <p:txBody>
+          <a:bodyPr xmlns:a="http://schemas.openxmlformats.org/drawingml/2006/main"/>
+          <a:lstStyle xmlns:a="http://schemas.openxmlformats.org/drawingml/2006/main"/>
+          <a:p xmlns:a="http://schemas.openxmlformats.org/drawingml/2006/main">
+            <a:pPr marL="0" indent="0" algn="l">
+              <a:spcBef>
+                <a:spcPts val="0"/>
+              </a:spcBef>
+              <a:spcAft>
+                <a:spcPts val="0"/>
+              </a:spcAft>
+              <a:buNone/>
+            </a:pPr>
+            <a:r>
+              <a:t>[Sources]</a:t>
+            </a:r>
+          </a:p>
+          <a:p xmlns:a="http://schemas.openxmlformats.org/drawingml/2006/main">
+            <a:r>
+              <a:t>- B8_ACTIONABILITY_PROTOCOL.md</a:t>
+            </a:r>
+          </a:p>
+          <a:p xmlns:a="http://schemas.openxmlformats.org/drawingml/2006/main">
+            <a:r>
+              <a:t>- MODEL_ROADMAP.md</a:t>
+            </a:r>
+          </a:p>
+          <a:p xmlns:a="http://schemas.openxmlformats.org/drawingml/2006/main">
+            <a:r>
+              <a:t>- https://openroad-flow-scripts.readthedocs.io/en/latest/user/InstructionsForAutoTuner.html</a:t>
+            </a:r>
+          </a:p>
+          <a:p xmlns:a="http://schemas.openxmlformats.org/drawingml/2006/main">
+            <a:r>
+              <a:t>[/Sources]</a:t>
+            </a:r>
+          </a:p>
+        </p:txBody>
+      </p:sp>
+      <p:sp>
+        <p:nvSpPr>
+          <p:cNvPr id="4" name="Slide Number Placeholder 3"/>
+          <p:cNvSpPr>
+            <a:spLocks xmlns:a="http://schemas.openxmlformats.org/drawingml/2006/main" noGrp="1"/>
+          </p:cNvSpPr>
+          <p:nvPr>
+            <p:ph type="sldNum" idx="5"/>
+          </p:nvPr>
+        </p:nvSpPr>
+        <p:spPr/>
+        <p:txBody>
+          <a:bodyPr xmlns:a="http://schemas.openxmlformats.org/drawingml/2006/main"/>
+          <a:lstStyle xmlns:a="http://schemas.openxmlformats.org/drawingml/2006/main"/>
+          <a:p xmlns:a="http://schemas.openxmlformats.org/drawingml/2006/main"/>
+        </p:txBody>
+      </p:sp>
+    </p:spTree>
+  </p:cSld>
+  <p:clrMapOvr>
+    <a:masterClrMapping xmlns:a="http://schemas.openxmlformats.org/drawingml/2006/main"/>
+  </p:clrMapOvr>
+</p:notes>
+</file>
+
 <file path=ppt/notesSlides/notesSlide4.xml><?xml version="1.0" encoding="utf-8"?>
 <p:notes xmlns:p="http://schemas.openxmlformats.org/presentationml/2006/main">
   <p:cSld>
@@ -3836,6 +4097,15 @@
               <a:t>
 [Sources]
 - results/b7_full_layout/b7_1_summary.json and results/b7_full_layout/README.md; measured 2026-08-15; validation-only policy selection; B9 unopened.</a:t>
+            </a:r>
+          </a:p>
+          <a:p xmlns:a="http://schemas.openxmlformats.org/drawingml/2006/main">
+            <a:r>
+              <a:t>
+[Sources]
+- results/b7_full_layout/b7_2_cnn_gpu_summary.json; measured 2026-08-20; Tesla T4; B9 unopened.
+- results/b7_full_layout/b7_2_klayout_competitiveness_summary.json; measured 2026-08-20; one warm-up and five KLayout repetitions.
+[/Sources]</a:t>
             </a:r>
           </a:p>
         </p:txBody>
@@ -12606,17 +12876,17 @@
   </p:cSld>
   <p:clrMap bg1="lt1" tx1="dk1" bg2="dk2" tx2="lt2" accent1="accent1" accent2="accent2" accent3="accent3" accent4="accent4" accent5="accent5" accent6="accent6" hlink="hlink" folHlink="folHlink"/>
   <p:sldLayoutIdLst>
-    <p:sldLayoutId xmlns:r="http://schemas.openxmlformats.org/officeDocument/2006/relationships" id="2147483649" r:id="R0c127dc816104192"/>
-    <p:sldLayoutId xmlns:r="http://schemas.openxmlformats.org/officeDocument/2006/relationships" id="2147483650" r:id="R31a69b014d9e49a2"/>
-    <p:sldLayoutId xmlns:r="http://schemas.openxmlformats.org/officeDocument/2006/relationships" id="2147483651" r:id="R7efeb80b2fec4f78"/>
-    <p:sldLayoutId xmlns:r="http://schemas.openxmlformats.org/officeDocument/2006/relationships" id="2147483652" r:id="R757b0c29a6594129"/>
-    <p:sldLayoutId xmlns:r="http://schemas.openxmlformats.org/officeDocument/2006/relationships" id="2147483653" r:id="Ra0b9ca24321e48c4"/>
-    <p:sldLayoutId xmlns:r="http://schemas.openxmlformats.org/officeDocument/2006/relationships" id="2147483654" r:id="Re689639930af49d6"/>
-    <p:sldLayoutId xmlns:r="http://schemas.openxmlformats.org/officeDocument/2006/relationships" id="2147483655" r:id="R179d712a9c34429a"/>
-    <p:sldLayoutId xmlns:r="http://schemas.openxmlformats.org/officeDocument/2006/relationships" id="2147483656" r:id="R5fd02340475c42df"/>
-    <p:sldLayoutId xmlns:r="http://schemas.openxmlformats.org/officeDocument/2006/relationships" id="2147483657" r:id="R7dd1bc142fe2425b"/>
-    <p:sldLayoutId xmlns:r="http://schemas.openxmlformats.org/officeDocument/2006/relationships" id="2147483658" r:id="R834370dc79ab4a55"/>
-    <p:sldLayoutId xmlns:r="http://schemas.openxmlformats.org/officeDocument/2006/relationships" id="2147483659" r:id="R43c2039de99545c9"/>
+    <p:sldLayoutId xmlns:r="http://schemas.openxmlformats.org/officeDocument/2006/relationships" id="2147483649" r:id="R3fcd7575176b4e97"/>
+    <p:sldLayoutId xmlns:r="http://schemas.openxmlformats.org/officeDocument/2006/relationships" id="2147483650" r:id="R15bc5bd81c3b46f5"/>
+    <p:sldLayoutId xmlns:r="http://schemas.openxmlformats.org/officeDocument/2006/relationships" id="2147483651" r:id="Rde4199f0f0cc4d05"/>
+    <p:sldLayoutId xmlns:r="http://schemas.openxmlformats.org/officeDocument/2006/relationships" id="2147483652" r:id="R391a590ca55d4a74"/>
+    <p:sldLayoutId xmlns:r="http://schemas.openxmlformats.org/officeDocument/2006/relationships" id="2147483653" r:id="Rb5c15d4b66c846e1"/>
+    <p:sldLayoutId xmlns:r="http://schemas.openxmlformats.org/officeDocument/2006/relationships" id="2147483654" r:id="Rff16767d2faf429b"/>
+    <p:sldLayoutId xmlns:r="http://schemas.openxmlformats.org/officeDocument/2006/relationships" id="2147483655" r:id="Rdca65dbabe6e4514"/>
+    <p:sldLayoutId xmlns:r="http://schemas.openxmlformats.org/officeDocument/2006/relationships" id="2147483656" r:id="Rb08f3887caac4e47"/>
+    <p:sldLayoutId xmlns:r="http://schemas.openxmlformats.org/officeDocument/2006/relationships" id="2147483657" r:id="R429de0c891fe4810"/>
+    <p:sldLayoutId xmlns:r="http://schemas.openxmlformats.org/officeDocument/2006/relationships" id="2147483658" r:id="R32b4e193f42a44f6"/>
+    <p:sldLayoutId xmlns:r="http://schemas.openxmlformats.org/officeDocument/2006/relationships" id="2147483659" r:id="Rf26b88f1a8274053"/>
   </p:sldLayoutIdLst>
   <p:hf sldNum="0" hdr="0" ftr="0" dt="0"/>
   <p:txStyles>
@@ -13568,7 +13838,7 @@
               <a:buNone/>
             </a:pPr>
             <a:r>
-              <a:t>CNN-based DRC | B0–B7.1 complete · verified repair next</a:t>
+              <a:t>CNN-based DRC | B0–B7.2 complete · B8.0 actionability next</a:t>
             </a:r>
           </a:p>
         </p:txBody>
@@ -13890,7 +14160,7 @@
               <a:buChar char="●"/>
             </a:pPr>
             <a:r>
-              <a:t>DRC/LVS-verified repair suggestions</a:t>
+              <a:t>Cross-design OpenROAD action selection</a:t>
             </a:r>
           </a:p>
         </p:txBody>
@@ -17409,7 +17679,7 @@
               <a:buNone/>
             </a:pPr>
             <a:r>
-              <a:t>Roadmap to the final contribution</a:t>
+              <a:t>Roadmap after the KLayout audit</a:t>
             </a:r>
           </a:p>
         </p:txBody>
@@ -17455,7 +17725,7 @@
               <a:buChar char="●"/>
             </a:pPr>
             <a:r>
-              <a:t>B1  Data integrity + broad layouts — complete</a:t>
+              <a:t>B1–B6  Baselines + localization — complete</a:t>
             </a:r>
           </a:p>
           <a:p xmlns:a="http://schemas.openxmlformats.org/drawingml/2006/main">
@@ -17469,7 +17739,7 @@
               <a:buChar char="●"/>
             </a:pPr>
             <a:r>
-              <a:t>B2  Dual classification baselines — complete</a:t>
+              <a:t>B7.1  Internal full-layout policy — accepted</a:t>
             </a:r>
           </a:p>
           <a:p xmlns:a="http://schemas.openxmlformats.org/drawingml/2006/main">
@@ -17483,21 +17753,7 @@
               <a:buChar char="●"/>
             </a:pPr>
             <a:r>
-              <a:t>B3  Training tuning — complete</a:t>
-            </a:r>
-          </a:p>
-          <a:p xmlns:a="http://schemas.openxmlformats.org/drawingml/2006/main">
-            <a:pPr marL="457200" indent="-342900" algn="l">
-              <a:spcBef>
-                <a:spcPts val="0"/>
-              </a:spcBef>
-              <a:spcAft>
-                <a:spcPts val="0"/>
-              </a:spcAft>
-              <a:buChar char="●"/>
-            </a:pPr>
-            <a:r>
-              <a:t>B4  Architecture tests — complete</a:t>
+              <a:t>B7.2  KLayout audit — detector rejected</a:t>
             </a:r>
           </a:p>
         </p:txBody>
@@ -17543,7 +17799,7 @@
               <a:buChar char="●"/>
             </a:pPr>
             <a:r>
-              <a:t>B5  Classifier tuning — closed</a:t>
+              <a:t>B8.0  Actionability pilot — next</a:t>
             </a:r>
           </a:p>
           <a:p xmlns:a="http://schemas.openxmlformats.org/drawingml/2006/main">
@@ -17557,7 +17813,7 @@
               <a:buChar char="●"/>
             </a:pPr>
             <a:r>
-              <a:t>B6.1  Localization data — done</a:t>
+              <a:t>B8.1  20+ family trajectory dataset — gated</a:t>
             </a:r>
           </a:p>
           <a:p xmlns:a="http://schemas.openxmlformats.org/drawingml/2006/main">
@@ -17571,7 +17827,7 @@
               <a:buChar char="●"/>
             </a:pPr>
             <a:r>
-              <a:t>B6.2  U-Net — accepted</a:t>
+              <a:t>B8.2–B8.3  Controller + AutoTuner comparison</a:t>
             </a:r>
           </a:p>
           <a:p xmlns:a="http://schemas.openxmlformats.org/drawingml/2006/main">
@@ -17585,35 +17841,7 @@
               <a:buChar char="●"/>
             </a:pPr>
             <a:r>
-              <a:t>B7.1  Exact recovery — accepted</a:t>
-            </a:r>
-          </a:p>
-          <a:p xmlns:a="http://schemas.openxmlformats.org/drawingml/2006/main">
-            <a:pPr marL="457200" indent="-342900" algn="l">
-              <a:spcBef>
-                <a:spcPts val="0"/>
-              </a:spcBef>
-              <a:spcAft>
-                <a:spcPts val="0"/>
-              </a:spcAft>
-              <a:buChar char="●"/>
-            </a:pPr>
-            <a:r>
-              <a:t>B8  Verified repair — next</a:t>
-            </a:r>
-          </a:p>
-          <a:p xmlns:a="http://schemas.openxmlformats.org/drawingml/2006/main">
-            <a:pPr marL="457200" indent="-342900" algn="l">
-              <a:spcBef>
-                <a:spcPts val="0"/>
-              </a:spcBef>
-              <a:spcAft>
-                <a:spcPts val="0"/>
-              </a:spcAft>
-              <a:buChar char="●"/>
-            </a:pPr>
-            <a:r>
-              <a:t>B9  Sealed</a:t>
+              <a:t>B9  Sealed final holdout</a:t>
             </a:r>
           </a:p>
         </p:txBody>
@@ -17670,7 +17898,7 @@
                   <a:srgbClr val="404040"/>
                 </a:solidFill>
               </a:rPr>
-              <a:t>B7.1 passed full-layout gates: 95.51% recall, 81.44% precision, and 100% exact-pair precision.</a:t>
+              <a:t>B7.2: KLayout was 162×–256× faster; CNN recall stayed near 95%. Detector tuning is closed.</a:t>
             </a:r>
           </a:p>
         </p:txBody>
@@ -19848,7 +20076,7 @@
                   <a:srgbClr val="73400D"/>
                 </a:solidFill>
               </a:rPr>
-              <a:t>B7.1 passes full-layout gates; B8 now converts exact edge pairs into verified repair proposals.</a:t>
+              <a:t>B7.2 rejects the accelerator; B8.0 now tests whether OpenROAD actions create learnable design-specific headroom.</a:t>
             </a:r>
           </a:p>
         </p:txBody>
@@ -20198,7 +20426,7 @@
           </p:nvPr>
         </p:nvPicPr>
         <p:blipFill rotWithShape="1">
-          <a:blip xmlns:r="http://schemas.openxmlformats.org/officeDocument/2006/relationships" xmlns:a="http://schemas.openxmlformats.org/drawingml/2006/main" r:embed="R738da81614c0421d">
+          <a:blip xmlns:r="http://schemas.openxmlformats.org/officeDocument/2006/relationships" xmlns:a="http://schemas.openxmlformats.org/drawingml/2006/main" r:embed="Rb9979de1c53f4d30">
             <a:alphaModFix/>
           </a:blip>
           <a:srcRect xmlns:a="http://schemas.openxmlformats.org/drawingml/2006/main" l="0" t="0" r="0" b="0"/>
@@ -20226,7 +20454,7 @@
           <p:nvPr/>
         </p:nvPicPr>
         <p:blipFill rotWithShape="1">
-          <a:blip xmlns:r="http://schemas.openxmlformats.org/officeDocument/2006/relationships" xmlns:a="http://schemas.openxmlformats.org/drawingml/2006/main" r:embed="Rd84827508b7b48fc">
+          <a:blip xmlns:r="http://schemas.openxmlformats.org/officeDocument/2006/relationships" xmlns:a="http://schemas.openxmlformats.org/drawingml/2006/main" r:embed="Rd47bc28fac0f4a6a">
             <a:alphaModFix/>
           </a:blip>
           <a:srcRect xmlns:a="http://schemas.openxmlformats.org/drawingml/2006/main" l="0" t="0" r="0" b="0"/>
@@ -27350,7 +27578,7 @@
           <p:nvPr/>
         </p:nvPicPr>
         <p:blipFill rotWithShape="1">
-          <a:blip xmlns:r="http://schemas.openxmlformats.org/officeDocument/2006/relationships" xmlns:a="http://schemas.openxmlformats.org/drawingml/2006/main" r:embed="R4800f316b93b4a2e">
+          <a:blip xmlns:r="http://schemas.openxmlformats.org/officeDocument/2006/relationships" xmlns:a="http://schemas.openxmlformats.org/drawingml/2006/main" r:embed="Ra54efb7df0144ad4">
             <a:alphaModFix/>
           </a:blip>
           <a:srcRect xmlns:a="http://schemas.openxmlformats.org/drawingml/2006/main" l="0" t="0" r="0" b="0"/>
@@ -27378,7 +27606,7 @@
           <p:nvPr/>
         </p:nvPicPr>
         <p:blipFill rotWithShape="1">
-          <a:blip xmlns:r="http://schemas.openxmlformats.org/officeDocument/2006/relationships" xmlns:a="http://schemas.openxmlformats.org/drawingml/2006/main" r:embed="R7fc4999744f747fe">
+          <a:blip xmlns:r="http://schemas.openxmlformats.org/officeDocument/2006/relationships" xmlns:a="http://schemas.openxmlformats.org/drawingml/2006/main" r:embed="Rd6d032509cd6484f">
             <a:alphaModFix/>
           </a:blip>
           <a:srcRect xmlns:a="http://schemas.openxmlformats.org/drawingml/2006/main" l="0" t="0" r="0" b="0"/>
@@ -27668,7 +27896,7 @@
           <p:nvPr/>
         </p:nvPicPr>
         <p:blipFill rotWithShape="1">
-          <a:blip xmlns:r="http://schemas.openxmlformats.org/officeDocument/2006/relationships" xmlns:a="http://schemas.openxmlformats.org/drawingml/2006/main" r:embed="R6e508f4f9e404594">
+          <a:blip xmlns:r="http://schemas.openxmlformats.org/officeDocument/2006/relationships" xmlns:a="http://schemas.openxmlformats.org/drawingml/2006/main" r:embed="R9c5463fd541348bf">
             <a:alphaModFix/>
           </a:blip>
           <a:srcRect xmlns:a="http://schemas.openxmlformats.org/drawingml/2006/main" l="0" t="0" r="0" b="0"/>
@@ -27691,6 +27919,685 @@
     <p:extLst>
       <p:ext uri="{BB962C8B-B14F-4D97-AF65-F5344CB8AC3E}">
         <p14:creationId xmlns:p14="http://schemas.microsoft.com/office/powerpoint/2010/main" val="1113463396"/>
+      </p:ext>
+    </p:extLst>
+  </p:cSld>
+</p:sld>
+</file>
+
+<file path=ppt/slides/slide30.xml><?xml version="1.0" encoding="utf-8"?>
+<p:sld xmlns:p="http://schemas.openxmlformats.org/presentationml/2006/main">
+  <p:cSld>
+    <p:spTree>
+      <p:nvGrpSpPr>
+        <p:cNvPr id="1" name=""/>
+        <p:cNvGrpSpPr/>
+        <p:nvPr/>
+      </p:nvGrpSpPr>
+      <p:grpSpPr>
+        <a:xfrm xmlns:a="http://schemas.openxmlformats.org/drawingml/2006/main"/>
+      </p:grpSpPr>
+      <p:sp>
+        <p:nvSpPr>
+          <p:cNvPr id="202" name="Google Shape;202;p22">
+            <a:extLst xmlns:a="http://schemas.openxmlformats.org/drawingml/2006/main">
+              <a:ext uri="{FF2B5EF4-FFF2-40B4-BE49-F238E27FC236}">
+                <a16:creationId xmlns:a16="http://schemas.microsoft.com/office/drawing/2014/main" id="{C8118EBF-173B-493F-B181-80ED61AEAA88}"/>
+              </a:ext>
+            </a:extLst>
+          </p:cNvPr>
+          <p:cNvSpPr>
+            <a:spLocks xmlns:a="http://schemas.openxmlformats.org/drawingml/2006/main" noGrp="1"/>
+          </p:cNvSpPr>
+          <p:nvPr>
+            <p:ph type="title" idx="0"/>
+          </p:nvPr>
+        </p:nvSpPr>
+        <p:spPr>
+          <a:xfrm xmlns:a="http://schemas.openxmlformats.org/drawingml/2006/main">
+            <a:off x="839788" y="365125"/>
+            <a:ext cx="10515600" cy="1325700"/>
+          </a:xfrm>
+          <a:prstGeom xmlns:a="http://schemas.openxmlformats.org/drawingml/2006/main" prst="rect">
+            <a:avLst/>
+          </a:prstGeom>
+        </p:spPr>
+        <p:txBody>
+          <a:bodyPr xmlns:a="http://schemas.openxmlformats.org/drawingml/2006/main" spcFirstLastPara="1" wrap="square" lIns="91425" tIns="45700" rIns="91425" bIns="45700" anchor="ctr">
+            <a:noAutofit/>
+          </a:bodyPr>
+          <a:lstStyle xmlns:a="http://schemas.openxmlformats.org/drawingml/2006/main"/>
+          <a:p xmlns:a="http://schemas.openxmlformats.org/drawingml/2006/main">
+            <a:pPr marL="0" indent="0" algn="l">
+              <a:spcBef>
+                <a:spcPts val="0"/>
+              </a:spcBef>
+              <a:spcAft>
+                <a:spcPts val="0"/>
+              </a:spcAft>
+              <a:buNone/>
+            </a:pPr>
+            <a:r>
+              <a:t>B7.2 rejects the CNN as an accelerator</a:t>
+            </a:r>
+          </a:p>
+        </p:txBody>
+      </p:sp>
+      <p:sp>
+        <p:nvSpPr>
+          <p:cNvPr id="203" name="Google Shape;203;p22">
+            <a:extLst xmlns:a="http://schemas.openxmlformats.org/drawingml/2006/main">
+              <a:ext uri="{FF2B5EF4-FFF2-40B4-BE49-F238E27FC236}">
+                <a16:creationId xmlns:a16="http://schemas.microsoft.com/office/drawing/2014/main" id="{8C8967A8-AFDD-4A36-BD2A-6A37DA6F4631}"/>
+              </a:ext>
+            </a:extLst>
+          </p:cNvPr>
+          <p:cNvSpPr>
+            <a:spLocks xmlns:a="http://schemas.openxmlformats.org/drawingml/2006/main" noGrp="1"/>
+          </p:cNvSpPr>
+          <p:nvPr>
+            <p:ph type="body" idx="1"/>
+          </p:nvPr>
+        </p:nvSpPr>
+        <p:spPr>
+          <a:xfrm xmlns:a="http://schemas.openxmlformats.org/drawingml/2006/main">
+            <a:off x="839788" y="1681163"/>
+            <a:ext cx="5157900" cy="823800"/>
+          </a:xfrm>
+          <a:prstGeom xmlns:a="http://schemas.openxmlformats.org/drawingml/2006/main" prst="rect">
+            <a:avLst/>
+          </a:prstGeom>
+        </p:spPr>
+        <p:txBody>
+          <a:bodyPr xmlns:a="http://schemas.openxmlformats.org/drawingml/2006/main" spcFirstLastPara="1" wrap="square" lIns="91425" tIns="45700" rIns="91425" bIns="45700" anchor="b">
+            <a:noAutofit/>
+          </a:bodyPr>
+          <a:lstStyle xmlns:a="http://schemas.openxmlformats.org/drawingml/2006/main"/>
+          <a:p xmlns:a="http://schemas.openxmlformats.org/drawingml/2006/main">
+            <a:pPr marL="0" indent="0" algn="l">
+              <a:spcBef>
+                <a:spcPts val="1000"/>
+              </a:spcBef>
+              <a:spcAft>
+                <a:spcPts val="0"/>
+              </a:spcAft>
+              <a:buNone/>
+            </a:pPr>
+            <a:r>
+              <a:t>Validation batch</a:t>
+            </a:r>
+          </a:p>
+        </p:txBody>
+      </p:sp>
+      <p:sp>
+        <p:nvSpPr>
+          <p:cNvPr id="204" name="Google Shape;204;p22">
+            <a:extLst xmlns:a="http://schemas.openxmlformats.org/drawingml/2006/main">
+              <a:ext uri="{FF2B5EF4-FFF2-40B4-BE49-F238E27FC236}">
+                <a16:creationId xmlns:a16="http://schemas.microsoft.com/office/drawing/2014/main" id="{19A9097E-C301-4B04-A28D-C7CF5D1666DA}"/>
+              </a:ext>
+            </a:extLst>
+          </p:cNvPr>
+          <p:cNvSpPr>
+            <a:spLocks xmlns:a="http://schemas.openxmlformats.org/drawingml/2006/main" noGrp="1"/>
+          </p:cNvSpPr>
+          <p:nvPr>
+            <p:ph type="body" idx="2"/>
+          </p:nvPr>
+        </p:nvSpPr>
+        <p:spPr>
+          <a:xfrm xmlns:a="http://schemas.openxmlformats.org/drawingml/2006/main">
+            <a:off x="839788" y="2505075"/>
+            <a:ext cx="5157900" cy="3684600"/>
+          </a:xfrm>
+          <a:prstGeom xmlns:a="http://schemas.openxmlformats.org/drawingml/2006/main" prst="rect">
+            <a:avLst/>
+          </a:prstGeom>
+        </p:spPr>
+        <p:txBody>
+          <a:bodyPr xmlns:a="http://schemas.openxmlformats.org/drawingml/2006/main" spcFirstLastPara="1" wrap="square" lIns="91425" tIns="45700" rIns="91425" bIns="45700" anchor="t">
+            <a:noAutofit/>
+          </a:bodyPr>
+          <a:lstStyle xmlns:a="http://schemas.openxmlformats.org/drawingml/2006/main"/>
+          <a:p xmlns:a="http://schemas.openxmlformats.org/drawingml/2006/main">
+            <a:pPr marL="457200" indent="-342900" algn="l">
+              <a:spcBef>
+                <a:spcPts val="1000"/>
+              </a:spcBef>
+              <a:spcAft>
+                <a:spcPts val="0"/>
+              </a:spcAft>
+              <a:buChar char="●"/>
+            </a:pPr>
+            <a:r>
+              <a:t>CNN total: 4,693.87 s</a:t>
+            </a:r>
+          </a:p>
+          <a:p xmlns:a="http://schemas.openxmlformats.org/drawingml/2006/main">
+            <a:pPr marL="457200" indent="-342900" algn="l">
+              <a:spcBef>
+                <a:spcPts val="0"/>
+              </a:spcBef>
+              <a:spcAft>
+                <a:spcPts val="0"/>
+              </a:spcAft>
+              <a:buChar char="●"/>
+            </a:pPr>
+            <a:r>
+              <a:t>KLayout median: 18.35 s</a:t>
+            </a:r>
+          </a:p>
+          <a:p xmlns:a="http://schemas.openxmlformats.org/drawingml/2006/main">
+            <a:pPr marL="457200" indent="-342900" algn="l">
+              <a:spcBef>
+                <a:spcPts val="0"/>
+              </a:spcBef>
+              <a:spcAft>
+                <a:spcPts val="0"/>
+              </a:spcAft>
+              <a:buChar char="●"/>
+            </a:pPr>
+            <a:r>
+              <a:t>KLayout faster: 255.85×</a:t>
+            </a:r>
+          </a:p>
+          <a:p xmlns:a="http://schemas.openxmlformats.org/drawingml/2006/main">
+            <a:pPr marL="457200" indent="-342900" algn="l">
+              <a:spcBef>
+                <a:spcPts val="0"/>
+              </a:spcBef>
+              <a:spcAft>
+                <a:spcPts val="0"/>
+              </a:spcAft>
+              <a:buChar char="●"/>
+            </a:pPr>
+            <a:r>
+              <a:t>CNN recall: 95.33%</a:t>
+            </a:r>
+          </a:p>
+        </p:txBody>
+      </p:sp>
+      <p:sp>
+        <p:nvSpPr>
+          <p:cNvPr id="205" name="Google Shape;205;p22">
+            <a:extLst xmlns:a="http://schemas.openxmlformats.org/drawingml/2006/main">
+              <a:ext uri="{FF2B5EF4-FFF2-40B4-BE49-F238E27FC236}">
+                <a16:creationId xmlns:a16="http://schemas.microsoft.com/office/drawing/2014/main" id="{1E0BEAE3-F26D-4391-B700-136E11ECA92F}"/>
+              </a:ext>
+            </a:extLst>
+          </p:cNvPr>
+          <p:cNvSpPr>
+            <a:spLocks xmlns:a="http://schemas.openxmlformats.org/drawingml/2006/main" noGrp="1"/>
+          </p:cNvSpPr>
+          <p:nvPr>
+            <p:ph type="body" idx="3"/>
+          </p:nvPr>
+        </p:nvSpPr>
+        <p:spPr>
+          <a:xfrm xmlns:a="http://schemas.openxmlformats.org/drawingml/2006/main">
+            <a:off x="6172200" y="1681163"/>
+            <a:ext cx="5183100" cy="823800"/>
+          </a:xfrm>
+          <a:prstGeom xmlns:a="http://schemas.openxmlformats.org/drawingml/2006/main" prst="rect">
+            <a:avLst/>
+          </a:prstGeom>
+        </p:spPr>
+        <p:txBody>
+          <a:bodyPr xmlns:a="http://schemas.openxmlformats.org/drawingml/2006/main" spcFirstLastPara="1" wrap="square" lIns="91425" tIns="45700" rIns="91425" bIns="45700" anchor="b">
+            <a:noAutofit/>
+          </a:bodyPr>
+          <a:lstStyle xmlns:a="http://schemas.openxmlformats.org/drawingml/2006/main"/>
+          <a:p xmlns:a="http://schemas.openxmlformats.org/drawingml/2006/main">
+            <a:pPr marL="0" indent="0" algn="l">
+              <a:spcBef>
+                <a:spcPts val="1000"/>
+              </a:spcBef>
+              <a:spcAft>
+                <a:spcPts val="0"/>
+              </a:spcAft>
+              <a:buNone/>
+            </a:pPr>
+            <a:r>
+              <a:t>Development confirmation</a:t>
+            </a:r>
+          </a:p>
+        </p:txBody>
+      </p:sp>
+      <p:sp>
+        <p:nvSpPr>
+          <p:cNvPr id="206" name="Google Shape;206;p22">
+            <a:extLst xmlns:a="http://schemas.openxmlformats.org/drawingml/2006/main">
+              <a:ext uri="{FF2B5EF4-FFF2-40B4-BE49-F238E27FC236}">
+                <a16:creationId xmlns:a16="http://schemas.microsoft.com/office/drawing/2014/main" id="{76F59418-2FDB-4369-B235-930A4716F3F6}"/>
+              </a:ext>
+            </a:extLst>
+          </p:cNvPr>
+          <p:cNvSpPr>
+            <a:spLocks xmlns:a="http://schemas.openxmlformats.org/drawingml/2006/main" noGrp="1"/>
+          </p:cNvSpPr>
+          <p:nvPr>
+            <p:ph type="body" idx="4"/>
+          </p:nvPr>
+        </p:nvSpPr>
+        <p:spPr>
+          <a:xfrm xmlns:a="http://schemas.openxmlformats.org/drawingml/2006/main">
+            <a:off x="6172200" y="2505075"/>
+            <a:ext cx="5183100" cy="3684600"/>
+          </a:xfrm>
+          <a:prstGeom xmlns:a="http://schemas.openxmlformats.org/drawingml/2006/main" prst="rect">
+            <a:avLst/>
+          </a:prstGeom>
+        </p:spPr>
+        <p:txBody>
+          <a:bodyPr xmlns:a="http://schemas.openxmlformats.org/drawingml/2006/main" spcFirstLastPara="1" wrap="square" lIns="91425" tIns="45700" rIns="91425" bIns="45700" anchor="t">
+            <a:noAutofit/>
+          </a:bodyPr>
+          <a:lstStyle xmlns:a="http://schemas.openxmlformats.org/drawingml/2006/main"/>
+          <a:p xmlns:a="http://schemas.openxmlformats.org/drawingml/2006/main">
+            <a:pPr marL="457200" indent="-342900" algn="l">
+              <a:spcBef>
+                <a:spcPts val="1000"/>
+              </a:spcBef>
+              <a:spcAft>
+                <a:spcPts val="0"/>
+              </a:spcAft>
+              <a:buChar char="●"/>
+            </a:pPr>
+            <a:r>
+              <a:t>CNN total: 1,392.87 s</a:t>
+            </a:r>
+          </a:p>
+          <a:p xmlns:a="http://schemas.openxmlformats.org/drawingml/2006/main">
+            <a:pPr marL="457200" indent="-342900" algn="l">
+              <a:spcBef>
+                <a:spcPts val="0"/>
+              </a:spcBef>
+              <a:spcAft>
+                <a:spcPts val="0"/>
+              </a:spcAft>
+              <a:buChar char="●"/>
+            </a:pPr>
+            <a:r>
+              <a:t>KLayout median: 8.59 s</a:t>
+            </a:r>
+          </a:p>
+          <a:p xmlns:a="http://schemas.openxmlformats.org/drawingml/2006/main">
+            <a:pPr marL="457200" indent="-342900" algn="l">
+              <a:spcBef>
+                <a:spcPts val="0"/>
+              </a:spcBef>
+              <a:spcAft>
+                <a:spcPts val="0"/>
+              </a:spcAft>
+              <a:buChar char="●"/>
+            </a:pPr>
+            <a:r>
+              <a:t>KLayout faster: 162.21×</a:t>
+            </a:r>
+          </a:p>
+          <a:p xmlns:a="http://schemas.openxmlformats.org/drawingml/2006/main">
+            <a:pPr marL="457200" indent="-342900" algn="l">
+              <a:spcBef>
+                <a:spcPts val="0"/>
+              </a:spcBef>
+              <a:spcAft>
+                <a:spcPts val="0"/>
+              </a:spcAft>
+              <a:buChar char="●"/>
+            </a:pPr>
+            <a:r>
+              <a:t>CNN recall: 95.51%</a:t>
+            </a:r>
+          </a:p>
+        </p:txBody>
+      </p:sp>
+    </p:spTree>
+    <p:extLst>
+      <p:ext uri="{BB962C8B-B14F-4D97-AF65-F5344CB8AC3E}">
+        <p14:creationId xmlns:p14="http://schemas.microsoft.com/office/powerpoint/2010/main" val="1161288531"/>
+      </p:ext>
+    </p:extLst>
+  </p:cSld>
+</p:sld>
+</file>
+
+<file path=ppt/slides/slide31.xml><?xml version="1.0" encoding="utf-8"?>
+<p:sld xmlns:p="http://schemas.openxmlformats.org/presentationml/2006/main">
+  <p:cSld>
+    <p:spTree>
+      <p:nvGrpSpPr>
+        <p:cNvPr id="1" name=""/>
+        <p:cNvGrpSpPr/>
+        <p:nvPr/>
+      </p:nvGrpSpPr>
+      <p:grpSpPr>
+        <a:xfrm xmlns:a="http://schemas.openxmlformats.org/drawingml/2006/main"/>
+      </p:grpSpPr>
+      <p:sp>
+        <p:nvSpPr>
+          <p:cNvPr id="291" name="Google Shape;291;p27">
+            <a:extLst xmlns:a="http://schemas.openxmlformats.org/drawingml/2006/main">
+              <a:ext uri="{FF2B5EF4-FFF2-40B4-BE49-F238E27FC236}">
+                <a16:creationId xmlns:a16="http://schemas.microsoft.com/office/drawing/2014/main" id="{25D4AAC7-00D9-4840-A8F1-3ED0BFDF0B07}"/>
+              </a:ext>
+            </a:extLst>
+          </p:cNvPr>
+          <p:cNvSpPr>
+            <a:spLocks xmlns:a="http://schemas.openxmlformats.org/drawingml/2006/main" noGrp="1"/>
+          </p:cNvSpPr>
+          <p:nvPr>
+            <p:ph type="title" idx="0"/>
+          </p:nvPr>
+        </p:nvSpPr>
+        <p:spPr>
+          <a:xfrm xmlns:a="http://schemas.openxmlformats.org/drawingml/2006/main">
+            <a:off x="838200" y="365125"/>
+            <a:ext cx="10515600" cy="1325700"/>
+          </a:xfrm>
+          <a:prstGeom xmlns:a="http://schemas.openxmlformats.org/drawingml/2006/main" prst="rect">
+            <a:avLst/>
+          </a:prstGeom>
+        </p:spPr>
+        <p:txBody>
+          <a:bodyPr xmlns:a="http://schemas.openxmlformats.org/drawingml/2006/main" spcFirstLastPara="1" wrap="square" lIns="91425" tIns="45700" rIns="91425" bIns="45700" anchor="ctr">
+            <a:noAutofit/>
+          </a:bodyPr>
+          <a:lstStyle xmlns:a="http://schemas.openxmlformats.org/drawingml/2006/main"/>
+          <a:p xmlns:a="http://schemas.openxmlformats.org/drawingml/2006/main">
+            <a:pPr marL="0" indent="0" algn="l">
+              <a:spcBef>
+                <a:spcPts val="0"/>
+              </a:spcBef>
+              <a:spcAft>
+                <a:spcPts val="0"/>
+              </a:spcAft>
+              <a:buNone/>
+            </a:pPr>
+            <a:r>
+              <a:t>B8.0 must prove there is an ML problem</a:t>
+            </a:r>
+          </a:p>
+        </p:txBody>
+      </p:sp>
+      <p:sp>
+        <p:nvSpPr>
+          <p:cNvPr id="292" name="Google Shape;292;p27">
+            <a:extLst xmlns:a="http://schemas.openxmlformats.org/drawingml/2006/main">
+              <a:ext uri="{FF2B5EF4-FFF2-40B4-BE49-F238E27FC236}">
+                <a16:creationId xmlns:a16="http://schemas.microsoft.com/office/drawing/2014/main" id="{73803BE1-6414-41AF-9F58-47BFF83C574F}"/>
+              </a:ext>
+            </a:extLst>
+          </p:cNvPr>
+          <p:cNvSpPr>
+            <a:spLocks xmlns:a="http://schemas.openxmlformats.org/drawingml/2006/main" noGrp="1"/>
+          </p:cNvSpPr>
+          <p:nvPr>
+            <p:ph type="body" idx="1"/>
+          </p:nvPr>
+        </p:nvSpPr>
+        <p:spPr>
+          <a:xfrm xmlns:a="http://schemas.openxmlformats.org/drawingml/2006/main">
+            <a:off x="838200" y="1825625"/>
+            <a:ext cx="5181600" cy="4351200"/>
+          </a:xfrm>
+          <a:prstGeom xmlns:a="http://schemas.openxmlformats.org/drawingml/2006/main" prst="rect">
+            <a:avLst/>
+          </a:prstGeom>
+        </p:spPr>
+        <p:txBody>
+          <a:bodyPr xmlns:a="http://schemas.openxmlformats.org/drawingml/2006/main" spcFirstLastPara="1" wrap="square" lIns="91425" tIns="45700" rIns="91425" bIns="45700" anchor="t">
+            <a:noAutofit/>
+          </a:bodyPr>
+          <a:lstStyle xmlns:a="http://schemas.openxmlformats.org/drawingml/2006/main"/>
+          <a:p xmlns:a="http://schemas.openxmlformats.org/drawingml/2006/main">
+            <a:pPr marL="457200" indent="-342900" algn="l">
+              <a:spcBef>
+                <a:spcPts val="1000"/>
+              </a:spcBef>
+              <a:spcAft>
+                <a:spcPts val="0"/>
+              </a:spcAft>
+              <a:buChar char="●"/>
+            </a:pPr>
+            <a:r>
+              <a:t>Frozen pilot</a:t>
+            </a:r>
+          </a:p>
+          <a:p xmlns:a="http://schemas.openxmlformats.org/drawingml/2006/main">
+            <a:pPr marL="457200" indent="-342900" algn="l">
+              <a:spcBef>
+                <a:spcPts val="0"/>
+              </a:spcBef>
+              <a:spcAft>
+                <a:spcPts val="0"/>
+              </a:spcAft>
+              <a:buChar char="●"/>
+            </a:pPr>
+            <a:r>
+              <a:t>7 Sky130HD design families</a:t>
+            </a:r>
+          </a:p>
+          <a:p xmlns:a="http://schemas.openxmlformats.org/drawingml/2006/main">
+            <a:pPr marL="457200" indent="-342900" algn="l">
+              <a:spcBef>
+                <a:spcPts val="0"/>
+              </a:spcBef>
+              <a:spcAft>
+                <a:spcPts val="0"/>
+              </a:spcAft>
+              <a:buChar char="●"/>
+            </a:pPr>
+            <a:r>
+              <a:t>9 action configurations</a:t>
+            </a:r>
+          </a:p>
+          <a:p xmlns:a="http://schemas.openxmlformats.org/drawingml/2006/main">
+            <a:pPr marL="457200" indent="-342900" algn="l">
+              <a:spcBef>
+                <a:spcPts val="0"/>
+              </a:spcBef>
+              <a:spcAft>
+                <a:spcPts val="0"/>
+              </a:spcAft>
+              <a:buChar char="●"/>
+            </a:pPr>
+            <a:r>
+              <a:t>2 paired seeds</a:t>
+            </a:r>
+          </a:p>
+          <a:p xmlns:a="http://schemas.openxmlformats.org/drawingml/2006/main">
+            <a:pPr marL="457200" indent="-342900" algn="l">
+              <a:spcBef>
+                <a:spcPts val="0"/>
+              </a:spcBef>
+              <a:spcAft>
+                <a:spcPts val="0"/>
+              </a:spcAft>
+              <a:buChar char="●"/>
+            </a:pPr>
+            <a:r>
+              <a:t>126 full flows</a:t>
+            </a:r>
+          </a:p>
+        </p:txBody>
+      </p:sp>
+      <p:sp>
+        <p:nvSpPr>
+          <p:cNvPr id="293" name="Google Shape;293;p27">
+            <a:extLst xmlns:a="http://schemas.openxmlformats.org/drawingml/2006/main">
+              <a:ext uri="{FF2B5EF4-FFF2-40B4-BE49-F238E27FC236}">
+                <a16:creationId xmlns:a16="http://schemas.microsoft.com/office/drawing/2014/main" id="{CEEA99AB-591A-4C2A-B740-D5B689FA2F01}"/>
+              </a:ext>
+            </a:extLst>
+          </p:cNvPr>
+          <p:cNvSpPr>
+            <a:spLocks xmlns:a="http://schemas.openxmlformats.org/drawingml/2006/main" noGrp="1"/>
+          </p:cNvSpPr>
+          <p:nvPr>
+            <p:ph type="body" idx="2"/>
+          </p:nvPr>
+        </p:nvSpPr>
+        <p:spPr>
+          <a:xfrm xmlns:a="http://schemas.openxmlformats.org/drawingml/2006/main">
+            <a:off x="6172200" y="1825625"/>
+            <a:ext cx="5181600" cy="4351200"/>
+          </a:xfrm>
+          <a:prstGeom xmlns:a="http://schemas.openxmlformats.org/drawingml/2006/main" prst="rect">
+            <a:avLst/>
+          </a:prstGeom>
+        </p:spPr>
+        <p:txBody>
+          <a:bodyPr xmlns:a="http://schemas.openxmlformats.org/drawingml/2006/main" spcFirstLastPara="1" wrap="square" lIns="91425" tIns="45700" rIns="91425" bIns="45700" anchor="t">
+            <a:noAutofit/>
+          </a:bodyPr>
+          <a:lstStyle xmlns:a="http://schemas.openxmlformats.org/drawingml/2006/main"/>
+          <a:p xmlns:a="http://schemas.openxmlformats.org/drawingml/2006/main">
+            <a:pPr marL="457200" indent="-342900" algn="l">
+              <a:spcBef>
+                <a:spcPts val="1000"/>
+              </a:spcBef>
+              <a:spcAft>
+                <a:spcPts val="0"/>
+              </a:spcAft>
+              <a:buChar char="●"/>
+            </a:pPr>
+            <a:r>
+              <a:t>Continue only if</a:t>
+            </a:r>
+          </a:p>
+          <a:p xmlns:a="http://schemas.openxmlformats.org/drawingml/2006/main">
+            <a:pPr marL="457200" indent="-342900" algn="l">
+              <a:spcBef>
+                <a:spcPts val="0"/>
+              </a:spcBef>
+              <a:spcAft>
+                <a:spcPts val="0"/>
+              </a:spcAft>
+              <a:buChar char="●"/>
+            </a:pPr>
+            <a:r>
+              <a:t>Actions materially change outcomes</a:t>
+            </a:r>
+          </a:p>
+          <a:p xmlns:a="http://schemas.openxmlformats.org/drawingml/2006/main">
+            <a:pPr marL="457200" indent="-342900" algn="l">
+              <a:spcBef>
+                <a:spcPts val="0"/>
+              </a:spcBef>
+              <a:spcAft>
+                <a:spcPts val="0"/>
+              </a:spcAft>
+              <a:buChar char="●"/>
+            </a:pPr>
+            <a:r>
+              <a:t>Winners differ by design</a:t>
+            </a:r>
+          </a:p>
+          <a:p xmlns:a="http://schemas.openxmlformats.org/drawingml/2006/main">
+            <a:pPr marL="457200" indent="-342900" algn="l">
+              <a:spcBef>
+                <a:spcPts val="0"/>
+              </a:spcBef>
+              <a:spcAft>
+                <a:spcPts val="0"/>
+              </a:spcAft>
+              <a:buChar char="●"/>
+            </a:pPr>
+            <a:r>
+              <a:t>Oracle beats the best fixed action</a:t>
+            </a:r>
+          </a:p>
+          <a:p xmlns:a="http://schemas.openxmlformats.org/drawingml/2006/main">
+            <a:pPr marL="457200" indent="-342900" algn="l">
+              <a:spcBef>
+                <a:spcPts val="0"/>
+              </a:spcBef>
+              <a:spcAft>
+                <a:spcPts val="0"/>
+              </a:spcAft>
+              <a:buChar char="●"/>
+            </a:pPr>
+            <a:r>
+              <a:t>Signal survives seeds</a:t>
+            </a:r>
+          </a:p>
+          <a:p xmlns:a="http://schemas.openxmlformats.org/drawingml/2006/main">
+            <a:pPr marL="457200" indent="-342900" algn="l">
+              <a:spcBef>
+                <a:spcPts val="0"/>
+              </a:spcBef>
+              <a:spcAft>
+                <a:spcPts val="0"/>
+              </a:spcAft>
+              <a:buChar char="●"/>
+            </a:pPr>
+            <a:r>
+              <a:t>Pre-action features predict rank</a:t>
+            </a:r>
+          </a:p>
+        </p:txBody>
+      </p:sp>
+      <p:sp>
+        <p:nvSpPr>
+          <p:cNvPr id="294" name="Google Shape;294;p27">
+            <a:extLst xmlns:a="http://schemas.openxmlformats.org/drawingml/2006/main">
+              <a:ext uri="{FF2B5EF4-FFF2-40B4-BE49-F238E27FC236}">
+                <a16:creationId xmlns:a16="http://schemas.microsoft.com/office/drawing/2014/main" id="{5875FAD4-2283-450C-884E-7D46ABE7F997}"/>
+              </a:ext>
+            </a:extLst>
+          </p:cNvPr>
+          <p:cNvSpPr>
+            <a:spLocks xmlns:a="http://schemas.openxmlformats.org/drawingml/2006/main" noGrp="1"/>
+          </p:cNvSpPr>
+          <p:nvPr/>
+        </p:nvSpPr>
+        <p:spPr>
+          <a:xfrm xmlns:a="http://schemas.openxmlformats.org/drawingml/2006/main">
+            <a:off x="1397000" y="5651500"/>
+            <a:ext cx="9398100" cy="609600"/>
+          </a:xfrm>
+          <a:prstGeom xmlns:a="http://schemas.openxmlformats.org/drawingml/2006/main" prst="roundRect">
+            <a:avLst>
+              <a:gd name="adj" fmla="val 16667"/>
+            </a:avLst>
+          </a:prstGeom>
+          <a:solidFill xmlns:a="http://schemas.openxmlformats.org/drawingml/2006/main">
+            <a:srgbClr val="F2F2F2"/>
+          </a:solidFill>
+          <a:ln xmlns:a="http://schemas.openxmlformats.org/drawingml/2006/main">
+            <a:noFill/>
+          </a:ln>
+        </p:spPr>
+        <p:txBody>
+          <a:bodyPr xmlns:a="http://schemas.openxmlformats.org/drawingml/2006/main" spcFirstLastPara="1" wrap="square" lIns="91425" tIns="91425" rIns="91425" bIns="91425" anchor="ctr">
+            <a:noAutofit/>
+          </a:bodyPr>
+          <a:lstStyle xmlns:a="http://schemas.openxmlformats.org/drawingml/2006/main"/>
+          <a:p xmlns:a="http://schemas.openxmlformats.org/drawingml/2006/main">
+            <a:pPr marL="0" indent="0" algn="ctr">
+              <a:spcBef>
+                <a:spcPts val="0"/>
+              </a:spcBef>
+              <a:spcAft>
+                <a:spcPts val="0"/>
+              </a:spcAft>
+              <a:buNone/>
+            </a:pPr>
+            <a:r>
+              <a:rPr sz="1700">
+                <a:solidFill>
+                  <a:srgbClr val="404040"/>
+                </a:solidFill>
+              </a:rPr>
+              <a:t>Novelty: one cross-design recommendation versus per-design AutoTuner search at the same full-flow budget.</a:t>
+            </a:r>
+          </a:p>
+        </p:txBody>
+      </p:sp>
+    </p:spTree>
+    <p:extLst>
+      <p:ext uri="{BB962C8B-B14F-4D97-AF65-F5344CB8AC3E}">
+        <p14:creationId xmlns:p14="http://schemas.microsoft.com/office/powerpoint/2010/main" val="1941643723"/>
       </p:ext>
     </p:extLst>
   </p:cSld>
@@ -27981,7 +28888,7 @@
       </p:sp>
       <p:pic>
         <p:nvPicPr>
-          <p:cNvPr id="1065" name="Google Shape;119;p17"/>
+          <p:cNvPr id="1159" name="Google Shape;119;p17"/>
           <p:cNvPicPr>
             <a:picLocks xmlns:a="http://schemas.openxmlformats.org/drawingml/2006/main" noChangeAspect="1"/>
           </p:cNvPicPr>
@@ -27990,7 +28897,7 @@
           </p:nvPr>
         </p:nvPicPr>
         <p:blipFill rotWithShape="1">
-          <a:blip xmlns:r="http://schemas.openxmlformats.org/officeDocument/2006/relationships" xmlns:a="http://schemas.openxmlformats.org/drawingml/2006/main" r:embed="Rf7227624e8184563">
+          <a:blip xmlns:r="http://schemas.openxmlformats.org/officeDocument/2006/relationships" xmlns:a="http://schemas.openxmlformats.org/drawingml/2006/main" r:embed="Rc2d29d280dd940be">
             <a:alphaModFix/>
           </a:blip>
           <a:srcRect xmlns:a="http://schemas.openxmlformats.org/drawingml/2006/main" l="0" t="0" r="0" b="0"/>
@@ -28015,14 +28922,14 @@
       </p:pic>
       <p:pic>
         <p:nvPicPr>
-          <p:cNvPr id="1066" name="Google Shape;120;p17"/>
+          <p:cNvPr id="1160" name="Google Shape;120;p17"/>
           <p:cNvPicPr>
             <a:picLocks xmlns:a="http://schemas.openxmlformats.org/drawingml/2006/main" noChangeAspect="1"/>
           </p:cNvPicPr>
           <p:nvPr/>
         </p:nvPicPr>
         <p:blipFill rotWithShape="1">
-          <a:blip xmlns:r="http://schemas.openxmlformats.org/officeDocument/2006/relationships" xmlns:a="http://schemas.openxmlformats.org/drawingml/2006/main" r:embed="R11e36e435f8b4468">
+          <a:blip xmlns:r="http://schemas.openxmlformats.org/officeDocument/2006/relationships" xmlns:a="http://schemas.openxmlformats.org/drawingml/2006/main" r:embed="R91538222dbc34f53">
             <a:alphaModFix/>
           </a:blip>
           <a:srcRect xmlns:a="http://schemas.openxmlformats.org/drawingml/2006/main" l="0" t="0" r="0" b="0"/>
@@ -28047,14 +28954,14 @@
       </p:pic>
       <p:pic>
         <p:nvPicPr>
-          <p:cNvPr id="1067" name="Google Shape;122;p17"/>
+          <p:cNvPr id="1161" name="Google Shape;122;p17"/>
           <p:cNvPicPr>
             <a:picLocks xmlns:a="http://schemas.openxmlformats.org/drawingml/2006/main" noChangeAspect="1"/>
           </p:cNvPicPr>
           <p:nvPr/>
         </p:nvPicPr>
         <p:blipFill rotWithShape="1">
-          <a:blip xmlns:r="http://schemas.openxmlformats.org/officeDocument/2006/relationships" xmlns:a="http://schemas.openxmlformats.org/drawingml/2006/main" r:embed="R1be146bc5d2a40c8">
+          <a:blip xmlns:r="http://schemas.openxmlformats.org/officeDocument/2006/relationships" xmlns:a="http://schemas.openxmlformats.org/drawingml/2006/main" r:embed="R1c718f53ce7f4839">
             <a:alphaModFix/>
           </a:blip>
           <a:srcRect xmlns:a="http://schemas.openxmlformats.org/drawingml/2006/main" l="0" t="0" r="0" b="0"/>
@@ -28344,14 +29251,14 @@
       </p:sp>
       <p:pic>
         <p:nvPicPr>
-          <p:cNvPr id="1073" name="Google Shape;128;p17"/>
+          <p:cNvPr id="1167" name="Google Shape;128;p17"/>
           <p:cNvPicPr>
             <a:picLocks xmlns:a="http://schemas.openxmlformats.org/drawingml/2006/main" noChangeAspect="1"/>
           </p:cNvPicPr>
           <p:nvPr/>
         </p:nvPicPr>
         <p:blipFill rotWithShape="1">
-          <a:blip xmlns:r="http://schemas.openxmlformats.org/officeDocument/2006/relationships" xmlns:a="http://schemas.openxmlformats.org/drawingml/2006/main" r:embed="R11e36e435f8b4468">
+          <a:blip xmlns:r="http://schemas.openxmlformats.org/officeDocument/2006/relationships" xmlns:a="http://schemas.openxmlformats.org/drawingml/2006/main" r:embed="R91538222dbc34f53">
             <a:alphaModFix/>
           </a:blip>
           <a:srcRect xmlns:a="http://schemas.openxmlformats.org/drawingml/2006/main" l="0" t="0" r="0" b="0"/>
@@ -28376,7 +29283,7 @@
       </p:pic>
       <p:cxnSp>
         <p:nvCxnSpPr>
-          <p:cNvPr id="1074" name="Google Shape;129;p17"/>
+          <p:cNvPr id="1168" name="Google Shape;129;p17"/>
           <p:cNvCxnSpPr/>
           <p:nvPr/>
         </p:nvCxnSpPr>
@@ -28401,7 +29308,7 @@
       </p:cxnSp>
       <p:cxnSp>
         <p:nvCxnSpPr>
-          <p:cNvPr id="1075" name="Google Shape;130;p17"/>
+          <p:cNvPr id="1169" name="Google Shape;130;p17"/>
           <p:cNvCxnSpPr/>
           <p:nvPr/>
         </p:nvCxnSpPr>
@@ -28426,14 +29333,14 @@
       </p:cxnSp>
       <p:pic>
         <p:nvPicPr>
-          <p:cNvPr id="1076" name="Google Shape;131;p17"/>
+          <p:cNvPr id="1170" name="Google Shape;131;p17"/>
           <p:cNvPicPr>
             <a:picLocks xmlns:a="http://schemas.openxmlformats.org/drawingml/2006/main" noChangeAspect="1"/>
           </p:cNvPicPr>
           <p:nvPr/>
         </p:nvPicPr>
         <p:blipFill rotWithShape="1">
-          <a:blip xmlns:r="http://schemas.openxmlformats.org/officeDocument/2006/relationships" xmlns:a="http://schemas.openxmlformats.org/drawingml/2006/main" r:embed="Rb5dc3840d1354e31">
+          <a:blip xmlns:r="http://schemas.openxmlformats.org/officeDocument/2006/relationships" xmlns:a="http://schemas.openxmlformats.org/drawingml/2006/main" r:embed="R0b1af58e2fd54a0f">
             <a:alphaModFix/>
           </a:blip>
           <a:srcRect xmlns:a="http://schemas.openxmlformats.org/drawingml/2006/main" l="0" t="0" r="0" b="0"/>
@@ -28719,14 +29626,14 @@
       </p:sp>
       <p:pic>
         <p:nvPicPr>
-          <p:cNvPr id="1081" name="Google Shape;136;p17"/>
+          <p:cNvPr id="1175" name="Google Shape;136;p17"/>
           <p:cNvPicPr>
             <a:picLocks xmlns:a="http://schemas.openxmlformats.org/drawingml/2006/main" noChangeAspect="1"/>
           </p:cNvPicPr>
           <p:nvPr/>
         </p:nvPicPr>
         <p:blipFill rotWithShape="1">
-          <a:blip xmlns:r="http://schemas.openxmlformats.org/officeDocument/2006/relationships" xmlns:a="http://schemas.openxmlformats.org/drawingml/2006/main" r:embed="Rbce8fa76fe8a4605">
+          <a:blip xmlns:r="http://schemas.openxmlformats.org/officeDocument/2006/relationships" xmlns:a="http://schemas.openxmlformats.org/drawingml/2006/main" r:embed="R8e2a439892534de6">
             <a:alphaModFix/>
           </a:blip>
           <a:srcRect xmlns:a="http://schemas.openxmlformats.org/drawingml/2006/main" l="0" t="0" r="0" b="0"/>
@@ -28747,14 +29654,14 @@
       </p:pic>
       <p:pic>
         <p:nvPicPr>
-          <p:cNvPr id="1082" name="Google Shape;137;p17"/>
+          <p:cNvPr id="1176" name="Google Shape;137;p17"/>
           <p:cNvPicPr>
             <a:picLocks xmlns:a="http://schemas.openxmlformats.org/drawingml/2006/main" noChangeAspect="1"/>
           </p:cNvPicPr>
           <p:nvPr/>
         </p:nvPicPr>
         <p:blipFill rotWithShape="1">
-          <a:blip xmlns:r="http://schemas.openxmlformats.org/officeDocument/2006/relationships" xmlns:a="http://schemas.openxmlformats.org/drawingml/2006/main" r:embed="R3ebab1fa521744bd">
+          <a:blip xmlns:r="http://schemas.openxmlformats.org/officeDocument/2006/relationships" xmlns:a="http://schemas.openxmlformats.org/drawingml/2006/main" r:embed="Rbf3a3a495c3f4def">
             <a:alphaModFix/>
           </a:blip>
           <a:srcRect xmlns:a="http://schemas.openxmlformats.org/drawingml/2006/main" l="0" t="0" r="0" b="0"/>
@@ -28836,14 +29743,14 @@
       </p:sp>
       <p:pic>
         <p:nvPicPr>
-          <p:cNvPr id="1084" name="Google Shape;139;p17"/>
+          <p:cNvPr id="1178" name="Google Shape;139;p17"/>
           <p:cNvPicPr>
             <a:picLocks xmlns:a="http://schemas.openxmlformats.org/drawingml/2006/main" noChangeAspect="1"/>
           </p:cNvPicPr>
           <p:nvPr/>
         </p:nvPicPr>
         <p:blipFill rotWithShape="1">
-          <a:blip xmlns:r="http://schemas.openxmlformats.org/officeDocument/2006/relationships" xmlns:a="http://schemas.openxmlformats.org/drawingml/2006/main" r:embed="R4bbbde5a63e8499f">
+          <a:blip xmlns:r="http://schemas.openxmlformats.org/officeDocument/2006/relationships" xmlns:a="http://schemas.openxmlformats.org/drawingml/2006/main" r:embed="R4325f400acb84301">
             <a:alphaModFix/>
           </a:blip>
           <a:srcRect xmlns:a="http://schemas.openxmlformats.org/drawingml/2006/main" l="0" t="0" r="0" b="0"/>
@@ -28864,14 +29771,14 @@
       </p:pic>
       <p:pic>
         <p:nvPicPr>
-          <p:cNvPr id="1085" name="Google Shape;140;p17"/>
+          <p:cNvPr id="1179" name="Google Shape;140;p17"/>
           <p:cNvPicPr>
             <a:picLocks xmlns:a="http://schemas.openxmlformats.org/drawingml/2006/main" noChangeAspect="1"/>
           </p:cNvPicPr>
           <p:nvPr/>
         </p:nvPicPr>
         <p:blipFill rotWithShape="1">
-          <a:blip xmlns:r="http://schemas.openxmlformats.org/officeDocument/2006/relationships" xmlns:a="http://schemas.openxmlformats.org/drawingml/2006/main" r:embed="Rcb79eb3f801a4a9c">
+          <a:blip xmlns:r="http://schemas.openxmlformats.org/officeDocument/2006/relationships" xmlns:a="http://schemas.openxmlformats.org/drawingml/2006/main" r:embed="Rbff0af5e907e40e5">
             <a:alphaModFix/>
           </a:blip>
           <a:srcRect xmlns:a="http://schemas.openxmlformats.org/drawingml/2006/main" l="0" t="0" r="0" b="0"/>
@@ -29141,7 +30048,7 @@
       </p:sp>
       <p:cxnSp>
         <p:nvCxnSpPr>
-          <p:cNvPr id="1088" name="Google Shape;143;p17"/>
+          <p:cNvPr id="1182" name="Google Shape;143;p17"/>
           <p:cNvCxnSpPr>
             <a:stCxn xmlns:a="http://schemas.openxmlformats.org/drawingml/2006/main" id="119" idx="3"/>
             <a:endCxn xmlns:a="http://schemas.openxmlformats.org/drawingml/2006/main" id="120" idx="1"/>
@@ -29169,7 +30076,7 @@
       </p:cxnSp>
       <p:cxnSp>
         <p:nvCxnSpPr>
-          <p:cNvPr id="1089" name="Google Shape;144;p17"/>
+          <p:cNvPr id="1183" name="Google Shape;144;p17"/>
           <p:cNvCxnSpPr>
             <a:endCxn xmlns:a="http://schemas.openxmlformats.org/drawingml/2006/main" id="128" idx="1"/>
           </p:cNvCxnSpPr>
@@ -29196,7 +30103,7 @@
       </p:cxnSp>
       <p:cxnSp>
         <p:nvCxnSpPr>
-          <p:cNvPr id="1090" name="Google Shape;145;p17"/>
+          <p:cNvPr id="1184" name="Google Shape;145;p17"/>
           <p:cNvCxnSpPr>
             <a:endCxn xmlns:a="http://schemas.openxmlformats.org/drawingml/2006/main" id="132" idx="1"/>
           </p:cNvCxnSpPr>
@@ -29223,7 +30130,7 @@
       </p:cxnSp>
       <p:cxnSp>
         <p:nvCxnSpPr>
-          <p:cNvPr id="1091" name="Google Shape;146;p17"/>
+          <p:cNvPr id="1185" name="Google Shape;146;p17"/>
           <p:cNvCxnSpPr>
             <a:endCxn xmlns:a="http://schemas.openxmlformats.org/drawingml/2006/main" id="135" idx="3"/>
           </p:cNvCxnSpPr>
@@ -29250,7 +30157,7 @@
       </p:cxnSp>
       <p:cxnSp>
         <p:nvCxnSpPr>
-          <p:cNvPr id="1092" name="Google Shape;147;p17"/>
+          <p:cNvPr id="1186" name="Google Shape;147;p17"/>
           <p:cNvCxnSpPr>
             <a:endCxn xmlns:a="http://schemas.openxmlformats.org/drawingml/2006/main" id="135" idx="0"/>
           </p:cNvCxnSpPr>
@@ -29277,7 +30184,7 @@
       </p:cxnSp>
       <p:cxnSp>
         <p:nvCxnSpPr>
-          <p:cNvPr id="1093" name="Google Shape;148;p17"/>
+          <p:cNvPr id="1187" name="Google Shape;148;p17"/>
           <p:cNvCxnSpPr>
             <a:stCxn xmlns:a="http://schemas.openxmlformats.org/drawingml/2006/main" id="132" idx="3"/>
             <a:endCxn xmlns:a="http://schemas.openxmlformats.org/drawingml/2006/main" id="133" idx="0"/>
@@ -29305,7 +30212,7 @@
       </p:cxnSp>
       <p:cxnSp>
         <p:nvCxnSpPr>
-          <p:cNvPr id="1094" name="Google Shape;149;p17"/>
+          <p:cNvPr id="1188" name="Google Shape;149;p17"/>
           <p:cNvCxnSpPr>
             <a:stCxn xmlns:a="http://schemas.openxmlformats.org/drawingml/2006/main" id="133" idx="2"/>
             <a:endCxn xmlns:a="http://schemas.openxmlformats.org/drawingml/2006/main" id="131" idx="0"/>
@@ -29333,7 +30240,7 @@
       </p:cxnSp>
       <p:cxnSp>
         <p:nvCxnSpPr>
-          <p:cNvPr id="1095" name="Google Shape;150;p17"/>
+          <p:cNvPr id="1189" name="Google Shape;150;p17"/>
           <p:cNvCxnSpPr>
             <a:stCxn xmlns:a="http://schemas.openxmlformats.org/drawingml/2006/main" id="135" idx="1"/>
             <a:endCxn xmlns:a="http://schemas.openxmlformats.org/drawingml/2006/main" id="136" idx="3"/>
@@ -29361,7 +30268,7 @@
       </p:cxnSp>
       <p:cxnSp>
         <p:nvCxnSpPr>
-          <p:cNvPr id="1096" name="Google Shape;151;p17"/>
+          <p:cNvPr id="1190" name="Google Shape;151;p17"/>
           <p:cNvCxnSpPr>
             <a:stCxn xmlns:a="http://schemas.openxmlformats.org/drawingml/2006/main" id="135" idx="1"/>
             <a:endCxn xmlns:a="http://schemas.openxmlformats.org/drawingml/2006/main" id="137" idx="3"/>
@@ -29389,7 +30296,7 @@
       </p:cxnSp>
       <p:cxnSp>
         <p:nvCxnSpPr>
-          <p:cNvPr id="1097" name="Google Shape;152;p17"/>
+          <p:cNvPr id="1191" name="Google Shape;152;p17"/>
           <p:cNvCxnSpPr/>
           <p:nvPr/>
         </p:nvCxnSpPr>
@@ -29414,7 +30321,7 @@
       </p:cxnSp>
       <p:cxnSp>
         <p:nvCxnSpPr>
-          <p:cNvPr id="1098" name="Google Shape;153;p17"/>
+          <p:cNvPr id="1192" name="Google Shape;153;p17"/>
           <p:cNvCxnSpPr/>
           <p:nvPr/>
         </p:nvCxnSpPr>
@@ -29439,7 +30346,7 @@
       </p:cxnSp>
       <p:cxnSp>
         <p:nvCxnSpPr>
-          <p:cNvPr id="1099" name="Google Shape;154;p17"/>
+          <p:cNvPr id="1193" name="Google Shape;154;p17"/>
           <p:cNvCxnSpPr/>
           <p:nvPr/>
         </p:nvCxnSpPr>
@@ -29464,7 +30371,7 @@
       </p:cxnSp>
       <p:cxnSp>
         <p:nvCxnSpPr>
-          <p:cNvPr id="1100" name="Google Shape;155;p17"/>
+          <p:cNvPr id="1194" name="Google Shape;155;p17"/>
           <p:cNvCxnSpPr/>
           <p:nvPr/>
         </p:nvCxnSpPr>
@@ -29489,7 +30396,7 @@
       </p:cxnSp>
       <p:cxnSp>
         <p:nvCxnSpPr>
-          <p:cNvPr id="1101" name="Google Shape;156;p17"/>
+          <p:cNvPr id="1195" name="Google Shape;156;p17"/>
           <p:cNvCxnSpPr/>
           <p:nvPr/>
         </p:nvCxnSpPr>
@@ -29878,7 +30785,7 @@
           </p:nvPr>
         </p:nvPicPr>
         <p:blipFill rotWithShape="1">
-          <a:blip xmlns:r="http://schemas.openxmlformats.org/officeDocument/2006/relationships" xmlns:a="http://schemas.openxmlformats.org/drawingml/2006/main" r:embed="R1cae7a89a4784154">
+          <a:blip xmlns:r="http://schemas.openxmlformats.org/officeDocument/2006/relationships" xmlns:a="http://schemas.openxmlformats.org/drawingml/2006/main" r:embed="R4031a9b769ba41d9">
             <a:alphaModFix/>
           </a:blip>
           <a:srcRect xmlns:a="http://schemas.openxmlformats.org/drawingml/2006/main" l="0" t="0" r="0" b="0"/>
@@ -30094,7 +31001,7 @@
           <p:nvPr/>
         </p:nvPicPr>
         <p:blipFill rotWithShape="1">
-          <a:blip xmlns:r="http://schemas.openxmlformats.org/officeDocument/2006/relationships" xmlns:a="http://schemas.openxmlformats.org/drawingml/2006/main" r:embed="Rf655fd5e8a2e4117">
+          <a:blip xmlns:r="http://schemas.openxmlformats.org/officeDocument/2006/relationships" xmlns:a="http://schemas.openxmlformats.org/drawingml/2006/main" r:embed="R43f8fbc6d35e43dd">
             <a:alphaModFix/>
           </a:blip>
           <a:srcRect xmlns:a="http://schemas.openxmlformats.org/drawingml/2006/main" l="0" t="0" r="0" b="0"/>
@@ -30825,7 +31732,7 @@
           <p:nvPr/>
         </p:nvPicPr>
         <p:blipFill rotWithShape="1">
-          <a:blip xmlns:r="http://schemas.openxmlformats.org/officeDocument/2006/relationships" xmlns:a="http://schemas.openxmlformats.org/drawingml/2006/main" r:embed="R54e9afadc9eb4ab7">
+          <a:blip xmlns:r="http://schemas.openxmlformats.org/officeDocument/2006/relationships" xmlns:a="http://schemas.openxmlformats.org/drawingml/2006/main" r:embed="Rd9dbe3d2b47140b6">
             <a:alphaModFix/>
           </a:blip>
           <a:srcRect xmlns:a="http://schemas.openxmlformats.org/drawingml/2006/main" l="0" t="0" r="0" b="0"/>
@@ -30853,7 +31760,7 @@
           <p:nvPr/>
         </p:nvPicPr>
         <p:blipFill rotWithShape="1">
-          <a:blip xmlns:r="http://schemas.openxmlformats.org/officeDocument/2006/relationships" xmlns:a="http://schemas.openxmlformats.org/drawingml/2006/main" r:embed="Re64de5e5b5f64f40">
+          <a:blip xmlns:r="http://schemas.openxmlformats.org/officeDocument/2006/relationships" xmlns:a="http://schemas.openxmlformats.org/drawingml/2006/main" r:embed="R79a641dc97b14bd8">
             <a:alphaModFix/>
           </a:blip>
           <a:srcRect xmlns:a="http://schemas.openxmlformats.org/drawingml/2006/main" l="0" t="0" r="0" b="0"/>
@@ -30881,7 +31788,7 @@
           <p:nvPr/>
         </p:nvPicPr>
         <p:blipFill rotWithShape="1">
-          <a:blip xmlns:r="http://schemas.openxmlformats.org/officeDocument/2006/relationships" xmlns:a="http://schemas.openxmlformats.org/drawingml/2006/main" r:embed="R8dac25edd3264e82">
+          <a:blip xmlns:r="http://schemas.openxmlformats.org/officeDocument/2006/relationships" xmlns:a="http://schemas.openxmlformats.org/drawingml/2006/main" r:embed="R1278364a63194f65">
             <a:alphaModFix/>
           </a:blip>
           <a:srcRect xmlns:a="http://schemas.openxmlformats.org/drawingml/2006/main" l="0" t="0" r="0" b="0"/>
@@ -31277,7 +32184,7 @@
               <a:buNone/>
             </a:pPr>
             <a:r>
-              <a:t>B0–B7.1 complete · verified repair next</a:t>
+              <a:t>B0–B7.2 complete · B8.0 actionability next</a:t>
             </a:r>
           </a:p>
         </p:txBody>

</xml_diff>